<commit_message>
Expand Kong evaluation assurance and migration evidence
</commit_message>
<xml_diff>
--- a/presentations/kong-platform-journey-guided.pptx
+++ b/presentations/kong-platform-journey-guided.pptx
@@ -2,37 +2,37 @@
 <file path=ppt/presentation.xml><?xml version="1.0" encoding="utf-8"?>
 <p:presentation xmlns:p="http://schemas.openxmlformats.org/presentationml/2006/main">
   <p:sldMasterIdLst>
-    <p:sldMasterId xmlns:r="http://schemas.openxmlformats.org/officeDocument/2006/relationships" id="2147483648" r:id="R4b62eac0a0cd43bc"/>
+    <p:sldMasterId xmlns:r="http://schemas.openxmlformats.org/officeDocument/2006/relationships" id="2147483648" r:id="R60c804bd99cd4a7a"/>
   </p:sldMasterIdLst>
   <p:notesMasterIdLst>
-    <p:notesMasterId xmlns:r="http://schemas.openxmlformats.org/officeDocument/2006/relationships" r:id="Refe22afccc0d4e1a"/>
+    <p:notesMasterId xmlns:r="http://schemas.openxmlformats.org/officeDocument/2006/relationships" r:id="R8ea8645e99654ead"/>
   </p:notesMasterIdLst>
   <p:sldIdLst>
-    <p:sldId xmlns:r="http://schemas.openxmlformats.org/officeDocument/2006/relationships" id="256" r:id="Rc6a22fd6916c46a5"/>
-    <p:sldId xmlns:r="http://schemas.openxmlformats.org/officeDocument/2006/relationships" id="257" r:id="Ra7e3628821c34229"/>
-    <p:sldId xmlns:r="http://schemas.openxmlformats.org/officeDocument/2006/relationships" id="258" r:id="Re8002fe98f9a42d1"/>
-    <p:sldId xmlns:r="http://schemas.openxmlformats.org/officeDocument/2006/relationships" id="259" r:id="Rc80315ab95cf42b1"/>
-    <p:sldId xmlns:r="http://schemas.openxmlformats.org/officeDocument/2006/relationships" id="260" r:id="R5c6b2909eb3e4df9"/>
-    <p:sldId xmlns:r="http://schemas.openxmlformats.org/officeDocument/2006/relationships" id="261" r:id="R5c1cd965b7ff4d7b"/>
-    <p:sldId xmlns:r="http://schemas.openxmlformats.org/officeDocument/2006/relationships" id="262" r:id="Rc5f2f188bebf49fd"/>
-    <p:sldId xmlns:r="http://schemas.openxmlformats.org/officeDocument/2006/relationships" id="263" r:id="Re9eed9a85c4a48d3"/>
-    <p:sldId xmlns:r="http://schemas.openxmlformats.org/officeDocument/2006/relationships" id="264" r:id="R750b450220544c72"/>
-    <p:sldId xmlns:r="http://schemas.openxmlformats.org/officeDocument/2006/relationships" id="265" r:id="R57e1cabdedf149e4"/>
-    <p:sldId xmlns:r="http://schemas.openxmlformats.org/officeDocument/2006/relationships" id="266" r:id="R846a6820178b4e14"/>
-    <p:sldId xmlns:r="http://schemas.openxmlformats.org/officeDocument/2006/relationships" id="267" r:id="Rb255afcb79a748fc"/>
-    <p:sldId xmlns:r="http://schemas.openxmlformats.org/officeDocument/2006/relationships" id="268" r:id="R37b6d047d744418a"/>
-    <p:sldId xmlns:r="http://schemas.openxmlformats.org/officeDocument/2006/relationships" id="269" r:id="R9b550ffc8dad46a3"/>
-    <p:sldId xmlns:r="http://schemas.openxmlformats.org/officeDocument/2006/relationships" id="270" r:id="R1160fb4fb332414e"/>
-    <p:sldId xmlns:r="http://schemas.openxmlformats.org/officeDocument/2006/relationships" id="271" r:id="Rc2f0d51e11b5401b"/>
-    <p:sldId xmlns:r="http://schemas.openxmlformats.org/officeDocument/2006/relationships" id="272" r:id="R1b5e7818dade4164"/>
-    <p:sldId xmlns:r="http://schemas.openxmlformats.org/officeDocument/2006/relationships" id="273" r:id="Rb1592122740b4f1e"/>
-    <p:sldId xmlns:r="http://schemas.openxmlformats.org/officeDocument/2006/relationships" id="274" r:id="R1b496fcf14bb44f8"/>
-    <p:sldId xmlns:r="http://schemas.openxmlformats.org/officeDocument/2006/relationships" id="275" r:id="R4c87fe7f9aeb4b65"/>
-    <p:sldId xmlns:r="http://schemas.openxmlformats.org/officeDocument/2006/relationships" id="276" r:id="R99acaf84a52e4c79"/>
-    <p:sldId xmlns:r="http://schemas.openxmlformats.org/officeDocument/2006/relationships" id="277" r:id="R8e1755772fd54b80"/>
-    <p:sldId xmlns:r="http://schemas.openxmlformats.org/officeDocument/2006/relationships" id="278" r:id="R148767c57b5d446b"/>
-    <p:sldId xmlns:r="http://schemas.openxmlformats.org/officeDocument/2006/relationships" id="279" r:id="R3cc1731bb15940fb"/>
-    <p:sldId xmlns:r="http://schemas.openxmlformats.org/officeDocument/2006/relationships" id="280" r:id="R92122c1c0de34d4d"/>
+    <p:sldId xmlns:r="http://schemas.openxmlformats.org/officeDocument/2006/relationships" id="256" r:id="R60417037ab624d4e"/>
+    <p:sldId xmlns:r="http://schemas.openxmlformats.org/officeDocument/2006/relationships" id="257" r:id="R2c199ce8f9684364"/>
+    <p:sldId xmlns:r="http://schemas.openxmlformats.org/officeDocument/2006/relationships" id="258" r:id="R48ce7bd25dec4235"/>
+    <p:sldId xmlns:r="http://schemas.openxmlformats.org/officeDocument/2006/relationships" id="259" r:id="Re4762e8e39b04711"/>
+    <p:sldId xmlns:r="http://schemas.openxmlformats.org/officeDocument/2006/relationships" id="260" r:id="R16fd0fd65f784461"/>
+    <p:sldId xmlns:r="http://schemas.openxmlformats.org/officeDocument/2006/relationships" id="261" r:id="Re445c32833474ff5"/>
+    <p:sldId xmlns:r="http://schemas.openxmlformats.org/officeDocument/2006/relationships" id="262" r:id="R08461cd261c94f1e"/>
+    <p:sldId xmlns:r="http://schemas.openxmlformats.org/officeDocument/2006/relationships" id="263" r:id="Rffb9be0cbc5f4415"/>
+    <p:sldId xmlns:r="http://schemas.openxmlformats.org/officeDocument/2006/relationships" id="264" r:id="Rf781b49f08324795"/>
+    <p:sldId xmlns:r="http://schemas.openxmlformats.org/officeDocument/2006/relationships" id="265" r:id="R5bb1afb818294251"/>
+    <p:sldId xmlns:r="http://schemas.openxmlformats.org/officeDocument/2006/relationships" id="266" r:id="R6790b2e26b3a419a"/>
+    <p:sldId xmlns:r="http://schemas.openxmlformats.org/officeDocument/2006/relationships" id="267" r:id="R9804fcbc98614d06"/>
+    <p:sldId xmlns:r="http://schemas.openxmlformats.org/officeDocument/2006/relationships" id="268" r:id="R10e24505592b4505"/>
+    <p:sldId xmlns:r="http://schemas.openxmlformats.org/officeDocument/2006/relationships" id="269" r:id="Rcd5635638bcd45b5"/>
+    <p:sldId xmlns:r="http://schemas.openxmlformats.org/officeDocument/2006/relationships" id="270" r:id="Rd58c9f084f0b46b5"/>
+    <p:sldId xmlns:r="http://schemas.openxmlformats.org/officeDocument/2006/relationships" id="271" r:id="Rec23cc3e4a1e43dc"/>
+    <p:sldId xmlns:r="http://schemas.openxmlformats.org/officeDocument/2006/relationships" id="272" r:id="Rb5ae40211be346ad"/>
+    <p:sldId xmlns:r="http://schemas.openxmlformats.org/officeDocument/2006/relationships" id="273" r:id="R803f531d739240e5"/>
+    <p:sldId xmlns:r="http://schemas.openxmlformats.org/officeDocument/2006/relationships" id="274" r:id="R9ad9ab9f0b6a4e70"/>
+    <p:sldId xmlns:r="http://schemas.openxmlformats.org/officeDocument/2006/relationships" id="275" r:id="Rf59d9b1dddb24942"/>
+    <p:sldId xmlns:r="http://schemas.openxmlformats.org/officeDocument/2006/relationships" id="276" r:id="Rb14b10d23ac14a3a"/>
+    <p:sldId xmlns:r="http://schemas.openxmlformats.org/officeDocument/2006/relationships" id="277" r:id="R30310c1fae894f85"/>
+    <p:sldId xmlns:r="http://schemas.openxmlformats.org/officeDocument/2006/relationships" id="278" r:id="R4dc361fa1cda4753"/>
+    <p:sldId xmlns:r="http://schemas.openxmlformats.org/officeDocument/2006/relationships" id="279" r:id="R6eefa3814d5a4a13"/>
+    <p:sldId xmlns:r="http://schemas.openxmlformats.org/officeDocument/2006/relationships" id="280" r:id="Re9286a7dffdd4137"/>
   </p:sldIdLst>
   <p:sldSz cx="12192000" cy="6858000"/>
   <p:notesSz cx="6858000" cy="9144000"/>
@@ -1536,7 +1536,7 @@
           </a:p>
           <a:p xmlns:a="http://schemas.openxmlformats.org/drawingml/2006/main">
             <a:r>
-              <a:t>Sequence migration by evidence complexity rather than package count.</a:t>
+              <a:t>Use one stable-edge and evidence-gate doctrine while preserving the different migration units and state boundaries of Mule and Apigee.</a:t>
             </a:r>
           </a:p>
           <a:p xmlns:a="http://schemas.openxmlformats.org/drawingml/2006/main">
@@ -1551,7 +1551,7 @@
           </a:p>
           <a:p xmlns:a="http://schemas.openxmlformats.org/drawingml/2006/main">
             <a:r>
-              <a:t>M0 establishes inventory and safety; M1 handles gateway-dominant work; M2 proves representative hard integrations; M3 establishes the domain factory; M4 resolves the connector and batch tail; M5 retires the shared runtime only after dependency zero.</a:t>
+              <a:t>For Mule, M0 establishes inventory and safety; M1 handles gateway-dominant work; M2 proves representative hard integrations; M3 establishes the domain factory; M4 resolves the connector and batch tail; and M5 retires the shared runtime only after dependency zero. For Apigee, A0 inventories the complete object/state graph; A1 classifies semantic disposition; A2 builds a reversible target; A3 proves a hard representative slice; A4 runs bounded coexistence; A5 collects production-canary evidence; and A6 closes technical, operating, recovery, data, support, and commercial dependency zero.</a:t>
             </a:r>
           </a:p>
           <a:p xmlns:a="http://schemas.openxmlformats.org/drawingml/2006/main">
@@ -1566,7 +1566,7 @@
           </a:p>
           <a:p xmlns:a="http://schemas.openxmlformats.org/drawingml/2006/main">
             <a:r>
-              <a:t>Adopt entry/exit evidence as the wave control, not elapsed time or migrated object count.</a:t>
+              <a:t>Confirm the actual source archetype, choose the relevant rail, and adopt entry/exit evidence rather than elapsed time, package count, or exported proxy count. Assign migration architecture, API product, IAM/security, SRE, domain, FinOps/sourcing, and independent-review roles.</a:t>
             </a:r>
           </a:p>
           <a:p xmlns:a="http://schemas.openxmlformats.org/drawingml/2006/main">
@@ -1596,7 +1596,7 @@
           </a:p>
           <a:p xmlns:a="http://schemas.openxmlformats.org/drawingml/2006/main">
             <a:r>
-              <a:t>These phases are scenario planning. They do not assert current programme progress or duration.</a:t>
+              <a:t>These phases are proposed and not run. They do not assert current programme progress, duration, object count, converter success, or semantic parity. The terminology crosswalk supplies nearest analogues only; each mapping still requires behavior, state, lifecycle, authority, evidence, and ownership proof.</a:t>
             </a:r>
           </a:p>
           <a:p xmlns:a="http://schemas.openxmlformats.org/drawingml/2006/main">
@@ -1611,7 +1611,42 @@
           </a:p>
           <a:p xmlns:a="http://schemas.openxmlformats.org/drawingml/2006/main">
             <a:r>
-              <a:t>- docs/35-mule-migration-strategy.md</a:t>
+              <a:t>- 35-mule-migration-strategy.md</a:t>
+            </a:r>
+          </a:p>
+          <a:p xmlns:a="http://schemas.openxmlformats.org/drawingml/2006/main">
+            <a:r>
+              <a:t>- 50-apigee-migration-strategy.md#proposed-a0a6-migration-roadmap</a:t>
+            </a:r>
+          </a:p>
+          <a:p xmlns:a="http://schemas.openxmlformats.org/drawingml/2006/main">
+            <a:r>
+              <a:t>- 48-kong-guided-evaluation.md</a:t>
+            </a:r>
+          </a:p>
+          <a:p xmlns:a="http://schemas.openxmlformats.org/drawingml/2006/main">
+            <a:r>
+              <a:t>- ../research/glossary.md#kong-terminology-crosswalk</a:t>
+            </a:r>
+          </a:p>
+          <a:p xmlns:a="http://schemas.openxmlformats.org/drawingml/2006/main">
+            <a:r>
+              <a:t>- https://docs.mulesoft.com/gateway/latest/</a:t>
+            </a:r>
+          </a:p>
+          <a:p xmlns:a="http://schemas.openxmlformats.org/drawingml/2006/main">
+            <a:r>
+              <a:t>- https://docs.cloud.google.com/apigee/docs/api-platform/fundamentals/download-api-proxies</a:t>
+            </a:r>
+          </a:p>
+          <a:p xmlns:a="http://schemas.openxmlformats.org/drawingml/2006/main">
+            <a:r>
+              <a:t>- https://docs.cloud.google.com/apigee/docs/api-platform/reference/api-proxy-configuration-reference</a:t>
+            </a:r>
+          </a:p>
+          <a:p xmlns:a="http://schemas.openxmlformats.org/drawingml/2006/main">
+            <a:r>
+              <a:t>- https://developer.konghq.com/gateway/deployment-topologies/</a:t>
             </a:r>
           </a:p>
         </p:txBody>
@@ -1856,7 +1891,7 @@
           </a:p>
           <a:p xmlns:a="http://schemas.openxmlformats.org/drawingml/2006/main">
             <a:r>
-              <a:t>This is not a larger feature demonstration. Each workstream needs a representative environment, named owner, test method, measure, acceptance artifact, threshold and stop condition. The agentic-gateway study remains separate so emerging capabilities do not inflate confidence in the core gateway.</a:t>
+              <a:t>This is not a larger feature demonstration. GEP-01–06 prove the target, APIOps, regional resilience, enterprise IAM, separate agentic study, and evidence-gated recommendation. GEP-07 is a separate security-adjunct feasibility line for Kong plus Traceable against the security team’s Mule baseline. Each workstream needs a representative environment, public role owner, exact BOM, method, measure, acceptance artifact, threshold, independent reviewer, and stop condition.</a:t>
             </a:r>
           </a:p>
           <a:p xmlns:a="http://schemas.openxmlformats.org/drawingml/2006/main">
@@ -1871,7 +1906,7 @@
           </a:p>
           <a:p xmlns:a="http://schemas.openxmlformats.org/drawingml/2006/main">
             <a:r>
-              <a:t>Approve these six workstreams, their owners, capacity and evidence budget—not production scale.</a:t>
+              <a:t>Approve these seven workstreams, their role owners, capacity, evidence budget, reviewers, and stop authority—not production scale and not a Traceable production recommendation.</a:t>
             </a:r>
           </a:p>
           <a:p xmlns:a="http://schemas.openxmlformats.org/drawingml/2006/main">
@@ -1901,7 +1936,7 @@
           </a:p>
           <a:p xmlns:a="http://schemas.openxmlformats.org/drawingml/2006/main">
             <a:r>
-              <a:t>These are required proof activities, not completed results. Verify the Kong Enterprise 3.14 edition, licensing and support status before claiming any capability; retain explicit not-run states.</a:t>
+              <a:t>These are required proof activities, not completed results. For GEP-07, current documentation supports only an `E1` plugin/agent feasibility path. It does not certify the exact Kong Enterprise 3.14 patch, plugin/TPA/EDS BOM, topology, entitlement, support, performance, protocol/payload/streaming coverage, data handling, fail behavior, comparative parity, lifecycle, cost, or production outcome.</a:t>
             </a:r>
           </a:p>
           <a:p xmlns:a="http://schemas.openxmlformats.org/drawingml/2006/main">
@@ -1916,7 +1951,42 @@
           </a:p>
           <a:p xmlns:a="http://schemas.openxmlformats.org/drawingml/2006/main">
             <a:r>
-              <a:t>- docs/48-kong-guided-evaluation.md#six-workstream-target-aligned-proof-programme</a:t>
+              <a:t>- 48-kong-guided-evaluation.md#seven-workstream-target-aligned-proof-programme</a:t>
+            </a:r>
+          </a:p>
+          <a:p xmlns:a="http://schemas.openxmlformats.org/drawingml/2006/main">
+            <a:r>
+              <a:t>- 48-kong-guided-evaluation.md#traceable-by-harness-security-adjunct-feasibility</a:t>
+            </a:r>
+          </a:p>
+          <a:p xmlns:a="http://schemas.openxmlformats.org/drawingml/2006/main">
+            <a:r>
+              <a:t>- https://developer.konghq.com/gateway/version-support-policy/</a:t>
+            </a:r>
+          </a:p>
+          <a:p xmlns:a="http://schemas.openxmlformats.org/drawingml/2006/main">
+            <a:r>
+              <a:t>- https://developer.konghq.com/gateway/hybrid-mode/</a:t>
+            </a:r>
+          </a:p>
+          <a:p xmlns:a="http://schemas.openxmlformats.org/drawingml/2006/main">
+            <a:r>
+              <a:t>- https://developer.konghq.com/gateway/monitoring/</a:t>
+            </a:r>
+          </a:p>
+          <a:p xmlns:a="http://schemas.openxmlformats.org/drawingml/2006/main">
+            <a:r>
+              <a:t>- https://developer.konghq.com/ai-gateway/</a:t>
+            </a:r>
+          </a:p>
+          <a:p xmlns:a="http://schemas.openxmlformats.org/drawingml/2006/main">
+            <a:r>
+              <a:t>- https://docs.traceable.ai/docs/kong</a:t>
+            </a:r>
+          </a:p>
+          <a:p xmlns:a="http://schemas.openxmlformats.org/drawingml/2006/main">
+            <a:r>
+              <a:t>- https://developer.konghq.com/plugins/harness-waap/</a:t>
             </a:r>
           </a:p>
         </p:txBody>
@@ -2306,7 +2376,7 @@
           </a:p>
           <a:p xmlns:a="http://schemas.openxmlformats.org/drawingml/2006/main">
             <a:r>
-              <a:t>Capacity and evidence safety matter, but so do adoption, operating sustainability, exit readiness and accurate estate ownership. Telemetry must stay off the critical path, gaps must be quantified, and prohibited fields must remain absent.</a:t>
+              <a:t>Capacity and evidence safety matter, but so do adoption, operating sustainability, exit readiness and accurate estate ownership. KO-7 is an outcome: administrative/configuration audit, request and security-decision correlation, business evidence, quantified produced/queued/dropped/delivered gaps, and prohibited-field control. Traceable may be one candidate mechanism, but no product name can make KO-7 pass.</a:t>
             </a:r>
           </a:p>
           <a:p xmlns:a="http://schemas.openxmlformats.org/drawingml/2006/main">
@@ -2321,7 +2391,7 @@
           </a:p>
           <a:p xmlns:a="http://schemas.openxmlformats.org/drawingml/2006/main">
             <a:r>
-              <a:t>Confirm which outcome is currently the likely scale blocker and who owns its evidence.</a:t>
+              <a:t>Confirm which outcome is currently the likely scale blocker, which public role owns it, and whether any Traceable dependency is being treated as a mechanism to prove rather than an achieved outcome.</a:t>
             </a:r>
           </a:p>
           <a:p xmlns:a="http://schemas.openxmlformats.org/drawingml/2006/main">
@@ -2351,7 +2421,7 @@
           </a:p>
           <a:p xmlns:a="http://schemas.openxmlformats.org/drawingml/2006/main">
             <a:r>
-              <a:t>These are acceptance categories; no result is asserted on this slide.</a:t>
+              <a:t>These are acceptance categories; no result is asserted on this slide. GEP-07 evidence may inform KO-7 only inside its exact tested boundary and cannot substitute for configuration audit, signal-gap accounting, business correlation, or enterprise evidence controls.</a:t>
             </a:r>
           </a:p>
           <a:p xmlns:a="http://schemas.openxmlformats.org/drawingml/2006/main">
@@ -2366,7 +2436,37 @@
           </a:p>
           <a:p xmlns:a="http://schemas.openxmlformats.org/drawingml/2006/main">
             <a:r>
-              <a:t>- docs/47-kong-enterprise-platform-strategy.md</a:t>
+              <a:t>- 47-kong-enterprise-platform-strategy.md</a:t>
+            </a:r>
+          </a:p>
+          <a:p xmlns:a="http://schemas.openxmlformats.org/drawingml/2006/main">
+            <a:r>
+              <a:t>- 48-kong-guided-evaluation.md</a:t>
+            </a:r>
+          </a:p>
+          <a:p xmlns:a="http://schemas.openxmlformats.org/drawingml/2006/main">
+            <a:r>
+              <a:t>- 48-kong-guided-evaluation.md#traceable-by-harness-security-adjunct-feasibility</a:t>
+            </a:r>
+          </a:p>
+          <a:p xmlns:a="http://schemas.openxmlformats.org/drawingml/2006/main">
+            <a:r>
+              <a:t>- https://developer.konghq.com/gateway/hybrid-mode/</a:t>
+            </a:r>
+          </a:p>
+          <a:p xmlns:a="http://schemas.openxmlformats.org/drawingml/2006/main">
+            <a:r>
+              <a:t>- https://developer.konghq.com/gateway/monitoring/</a:t>
+            </a:r>
+          </a:p>
+          <a:p xmlns:a="http://schemas.openxmlformats.org/drawingml/2006/main">
+            <a:r>
+              <a:t>- https://docs.traceable.ai/docs/kong</a:t>
+            </a:r>
+          </a:p>
+          <a:p xmlns:a="http://schemas.openxmlformats.org/drawingml/2006/main">
+            <a:r>
+              <a:t>- https://developer.konghq.com/plugins/harness-waap/</a:t>
             </a:r>
           </a:p>
         </p:txBody>
@@ -2591,7 +2691,7 @@
           </a:p>
           <a:p xmlns:a="http://schemas.openxmlformats.org/drawingml/2006/main">
             <a:r>
-              <a:t>Preserve the source document's architectural comparison without turning it into a dense main-story slide.</a:t>
+              <a:t>Preserve the sanitized supplied evaluation’s architectural comparison while making the new multicloud, scalability, and robustness obligations explicit.</a:t>
             </a:r>
           </a:p>
           <a:p xmlns:a="http://schemas.openxmlformats.org/drawingml/2006/main">
@@ -2606,7 +2706,7 @@
           </a:p>
           <a:p xmlns:a="http://schemas.openxmlformats.org/drawingml/2006/main">
             <a:r>
-              <a:t>The supplied labels are shown explicitly as supplied assessments. Official documentation supports the high-level deployment models, but the relative ratings require an evidence rubric and versioned testing.</a:t>
+              <a:t>The supplied labels remain stakeholder assessments preserved in docs/48. Official documentation supports high-level deployment mechanisms, not relative outcomes. GEC-19 keeps scalability and robustness explicitly unscored until equivalent target-shaped load, saturation, clean-node scale, failure, recovery, and reconciliation evidence exists. Multicloud must separate runtime placement from management dependency, sovereignty, failure independence, support, and operating cost.</a:t>
             </a:r>
           </a:p>
           <a:p xmlns:a="http://schemas.openxmlformats.org/drawingml/2006/main">
@@ -2621,7 +2721,7 @@
           </a:p>
           <a:p xmlns:a="http://schemas.openxmlformats.org/drawingml/2006/main">
             <a:r>
-              <a:t>Use this table to identify proof questions, not to re-litigate the feature list in the room.</a:t>
+              <a:t>Use this table to assign symmetric architecture/SRE proof questions, not to add favorable labels or ratings in the room.</a:t>
             </a:r>
           </a:p>
           <a:p xmlns:a="http://schemas.openxmlformats.org/drawingml/2006/main">
@@ -2651,7 +2751,7 @@
           </a:p>
           <a:p xmlns:a="http://schemas.openxmlformats.org/drawingml/2006/main">
             <a:r>
-              <a:t>Qualitative ratings are not independently validated and may change by edition and release.</a:t>
+              <a:t>Qualitative ratings are not independently validated and may change by exact edition, release, topology, entitlement, workload, region, dependency, and operating model. “Multicloud” and “scalable” are not scoreable yes/no features.</a:t>
             </a:r>
           </a:p>
           <a:p xmlns:a="http://schemas.openxmlformats.org/drawingml/2006/main">
@@ -2666,7 +2766,22 @@
           </a:p>
           <a:p xmlns:a="http://schemas.openxmlformats.org/drawingml/2006/main">
             <a:r>
-              <a:t>- docs/48-kong-guided-evaluation.md#supplied-comparison-input-architecture-and-delivery</a:t>
+              <a:t>- 48-kong-guided-evaluation.md#supplied-comparison-input-architecture-and-delivery</a:t>
+            </a:r>
+          </a:p>
+          <a:p xmlns:a="http://schemas.openxmlformats.org/drawingml/2006/main">
+            <a:r>
+              <a:t>- 48-kong-guided-evaluation.md#meeting-feedback-assurance-crosswalk</a:t>
+            </a:r>
+          </a:p>
+          <a:p xmlns:a="http://schemas.openxmlformats.org/drawingml/2006/main">
+            <a:r>
+              <a:t>- 48-kong-guided-evaluation.md#proposed-governed-re-score</a:t>
+            </a:r>
+          </a:p>
+          <a:p xmlns:a="http://schemas.openxmlformats.org/drawingml/2006/main">
+            <a:r>
+              <a:t>- https://developer.konghq.com/gateway/deployment-topologies/</a:t>
             </a:r>
           </a:p>
           <a:p xmlns:a="http://schemas.openxmlformats.org/drawingml/2006/main">
@@ -2676,12 +2791,22 @@
           </a:p>
           <a:p xmlns:a="http://schemas.openxmlformats.org/drawingml/2006/main">
             <a:r>
+              <a:t>- https://developer.konghq.com/ai-gateway/</a:t>
+            </a:r>
+          </a:p>
+          <a:p xmlns:a="http://schemas.openxmlformats.org/drawingml/2006/main">
+            <a:r>
               <a:t>- https://docs.cloud.google.com/apigee/docs/hybrid/v1.16/what-is-hybrid</a:t>
             </a:r>
           </a:p>
           <a:p xmlns:a="http://schemas.openxmlformats.org/drawingml/2006/main">
             <a:r>
               <a:t>- https://docs.mulesoft.com/gateway/latest/</a:t>
+            </a:r>
+          </a:p>
+          <a:p xmlns:a="http://schemas.openxmlformats.org/drawingml/2006/main">
+            <a:r>
+              <a:t>- https://learn.microsoft.com/en-us/azure/api-management/self-hosted-gateway-overview</a:t>
             </a:r>
           </a:p>
         </p:txBody>
@@ -2756,7 +2881,7 @@
           </a:p>
           <a:p xmlns:a="http://schemas.openxmlformats.org/drawingml/2006/main">
             <a:r>
-              <a:t>Preserve the management and experience claims while making their evidence status explicit.</a:t>
+              <a:t>Preserve the management and experience claims while making emerging AI and third-party security-adjunct evidence boundaries explicit.</a:t>
             </a:r>
           </a:p>
           <a:p xmlns:a="http://schemas.openxmlformats.org/drawingml/2006/main">
@@ -2771,7 +2896,7 @@
           </a:p>
           <a:p xmlns:a="http://schemas.openxmlformats.org/drawingml/2006/main">
             <a:r>
-              <a:t>Lifecycle, governance, portal, developer experience, AI, customization, and best-fit claims must be tested against the required use cases. AI capabilities are changing rapidly and should always be dated and versioned.</a:t>
+              <a:t>Lifecycle, governance, portal, developer experience, AI, customization, and best-fit claims must be tested against required use cases. GEC-20 records Kong-plus-Traceable as documented feasibility only: a plugin/agent path does not prove exact 3.14 support, security effectiveness, traceability, data safety, performance, scaling, comparative parity, cost, or safe lifecycle behavior.</a:t>
             </a:r>
           </a:p>
           <a:p xmlns:a="http://schemas.openxmlformats.org/drawingml/2006/main">
@@ -2786,7 +2911,7 @@
           </a:p>
           <a:p xmlns:a="http://schemas.openxmlformats.org/drawingml/2006/main">
             <a:r>
-              <a:t>Move every unverified adjective into the proof backlog with an owner and artifact.</a:t>
+              <a:t>Move every unverified adjective into the proof backlog with a public role owner, exact option/BOM, artifact, reviewer, and stop rule. Confirm that Traceable remains GEP-07 rather than a gateway option or score.</a:t>
             </a:r>
           </a:p>
           <a:p xmlns:a="http://schemas.openxmlformats.org/drawingml/2006/main">
@@ -2816,7 +2941,7 @@
           </a:p>
           <a:p xmlns:a="http://schemas.openxmlformats.org/drawingml/2006/main">
             <a:r>
-              <a:t>Product capability and commercial terms are edition- and date-dependent.</a:t>
+              <a:t>Product, plugin, agent, entitlement, support, and commercial terms are edition-, version-, topology-, and date-dependent. Current Traceable/Kong documentation is `E1` mechanism evidence only.</a:t>
             </a:r>
           </a:p>
           <a:p xmlns:a="http://schemas.openxmlformats.org/drawingml/2006/main">
@@ -2831,7 +2956,17 @@
           </a:p>
           <a:p xmlns:a="http://schemas.openxmlformats.org/drawingml/2006/main">
             <a:r>
-              <a:t>- docs/48-kong-guided-evaluation.md#supplied-comparison-input-management-experience-and-ai</a:t>
+              <a:t>- 48-kong-guided-evaluation.md#supplied-comparison-input-management-experience-and-ai</a:t>
+            </a:r>
+          </a:p>
+          <a:p xmlns:a="http://schemas.openxmlformats.org/drawingml/2006/main">
+            <a:r>
+              <a:t>- 48-kong-guided-evaluation.md#traceable-by-harness-security-adjunct-feasibility</a:t>
+            </a:r>
+          </a:p>
+          <a:p xmlns:a="http://schemas.openxmlformats.org/drawingml/2006/main">
+            <a:r>
+              <a:t>- https://developer.konghq.com/gateway/deployment-topologies/</a:t>
             </a:r>
           </a:p>
           <a:p xmlns:a="http://schemas.openxmlformats.org/drawingml/2006/main">
@@ -2841,12 +2976,32 @@
           </a:p>
           <a:p xmlns:a="http://schemas.openxmlformats.org/drawingml/2006/main">
             <a:r>
+              <a:t>- https://docs.traceable.ai/docs/kong</a:t>
+            </a:r>
+          </a:p>
+          <a:p xmlns:a="http://schemas.openxmlformats.org/drawingml/2006/main">
+            <a:r>
+              <a:t>- https://developer.konghq.com/plugins/harness-waap/</a:t>
+            </a:r>
+          </a:p>
+          <a:p xmlns:a="http://schemas.openxmlformats.org/drawingml/2006/main">
+            <a:r>
+              <a:t>- https://docs.traceable.ai/docs/tracing-agents-rule-evaluation-for-protection</a:t>
+            </a:r>
+          </a:p>
+          <a:p xmlns:a="http://schemas.openxmlformats.org/drawingml/2006/main">
+            <a:r>
+              <a:t>- https://docs.cloud.google.com/apigee/docs/hybrid/v1.16/what-is-hybrid</a:t>
+            </a:r>
+          </a:p>
+          <a:p xmlns:a="http://schemas.openxmlformats.org/drawingml/2006/main">
+            <a:r>
               <a:t>- https://docs.mulesoft.com/gateway/latest/</a:t>
             </a:r>
           </a:p>
           <a:p xmlns:a="http://schemas.openxmlformats.org/drawingml/2006/main">
             <a:r>
-              <a:t>- https://docs.cloud.google.com/apigee/docs/hybrid/v1.16/what-is-hybrid</a:t>
+              <a:t>- https://learn.microsoft.com/en-us/azure/api-management/self-hosted-gateway-overview</a:t>
             </a:r>
           </a:p>
         </p:txBody>
@@ -2921,7 +3076,7 @@
           </a:p>
           <a:p xmlns:a="http://schemas.openxmlformats.org/drawingml/2006/main">
             <a:r>
-              <a:t>Expose the economic and exit claims as proof obligations rather than conclusions.</a:t>
+              <a:t>Expose pricing, operating-duty, adjunct-cost, lock-in, and exit claims as separate proof obligations rather than conclusions.</a:t>
             </a:r>
           </a:p>
           <a:p xmlns:a="http://schemas.openxmlformats.org/drawingml/2006/main">
@@ -2936,7 +3091,7 @@
           </a:p>
           <a:p xmlns:a="http://schemas.openxmlformats.org/drawingml/2006/main">
             <a:r>
-              <a:t>Cost and lock-in cannot be inferred from topology. They require quotes, platform labor, HA/DR, support, observability, portal/product tooling, network and egress, migration effort, and an exit rehearsal.</a:t>
+              <a:t>Public price pages define meters or quote boundaries, not a comparable price rank. Fully allocated TCO requires exact options and quotes plus infrastructure, PostgreSQL, PKI, platform/SRE/on-call labor, HA/DR, telemetry, portal/product tooling, network/egress, plugins and security adjuncts, support, migration, dual run, incident exposure, custody switch, and clean exit. Lock-in requires an observed representative non-source rebuild and a ledger of configuration/policy, identity/product state, data/analytics, plugin, procedure, support, and commercial dependencies.</a:t>
             </a:r>
           </a:p>
           <a:p xmlns:a="http://schemas.openxmlformats.org/drawingml/2006/main">
@@ -2951,7 +3106,7 @@
           </a:p>
           <a:p xmlns:a="http://schemas.openxmlformats.org/drawingml/2006/main">
             <a:r>
-              <a:t>Assign owners and artifacts for TCO, custody and exit evidence.</a:t>
+              <a:t>Assign public FinOps, sourcing, platform/SRE, security-adjunct, migration, and independent-review roles for the normalized low/base/high model, rebuild, custody switch, and clean-exit evidence.</a:t>
             </a:r>
           </a:p>
           <a:p xmlns:a="http://schemas.openxmlformats.org/drawingml/2006/main">
@@ -2981,7 +3136,7 @@
           </a:p>
           <a:p xmlns:a="http://schemas.openxmlformats.org/drawingml/2006/main">
             <a:r>
-              <a:t>Commercial terms and estate leverage are organization- and date-specific.</a:t>
+              <a:t>Commercial terms and estate leverage are organization- and date-specific. Do not publish restricted quotes. The public record should expose meter/quote boundaries, assumptions, role ownership, evidence state, and disposition only. Operating accountability is not a legal-liability verdict.</a:t>
             </a:r>
           </a:p>
           <a:p xmlns:a="http://schemas.openxmlformats.org/drawingml/2006/main">
@@ -2996,7 +3151,42 @@
           </a:p>
           <a:p xmlns:a="http://schemas.openxmlformats.org/drawingml/2006/main">
             <a:r>
-              <a:t>- docs/48-kong-guided-evaluation.md#supplied-comparison-input-economics-and-evidence-ceiling</a:t>
+              <a:t>- 48-kong-guided-evaluation.md#supplied-comparison-input-economics-and-evidence-ceiling</a:t>
+            </a:r>
+          </a:p>
+          <a:p xmlns:a="http://schemas.openxmlformats.org/drawingml/2006/main">
+            <a:r>
+              <a:t>- 48-kong-guided-evaluation.md#proposed-governed-re-score</a:t>
+            </a:r>
+          </a:p>
+          <a:p xmlns:a="http://schemas.openxmlformats.org/drawingml/2006/main">
+            <a:r>
+              <a:t>- https://konghq.com/pricing</a:t>
+            </a:r>
+          </a:p>
+          <a:p xmlns:a="http://schemas.openxmlformats.org/drawingml/2006/main">
+            <a:r>
+              <a:t>- https://cloud.google.com/apigee/pricing</a:t>
+            </a:r>
+          </a:p>
+          <a:p xmlns:a="http://schemas.openxmlformats.org/drawingml/2006/main">
+            <a:r>
+              <a:t>- https://www.mulesoft.com/anypoint-pricing</a:t>
+            </a:r>
+          </a:p>
+          <a:p xmlns:a="http://schemas.openxmlformats.org/drawingml/2006/main">
+            <a:r>
+              <a:t>- https://developer.konghq.com/gateway/deployment-topologies/</a:t>
+            </a:r>
+          </a:p>
+          <a:p xmlns:a="http://schemas.openxmlformats.org/drawingml/2006/main">
+            <a:r>
+              <a:t>- https://docs.cloud.google.com/apigee/docs/hybrid/v1.16/what-is-hybrid</a:t>
+            </a:r>
+          </a:p>
+          <a:p xmlns:a="http://schemas.openxmlformats.org/drawingml/2006/main">
+            <a:r>
+              <a:t>- https://docs.traceable.ai/docs/kong</a:t>
             </a:r>
           </a:p>
         </p:txBody>
@@ -3071,7 +3261,7 @@
           </a:p>
           <a:p xmlns:a="http://schemas.openxmlformats.org/drawingml/2006/main">
             <a:r>
-              <a:t>Provide an auditable record of the source scorecard without elevating it above its evidence level.</a:t>
+              <a:t>Provide an auditable record of the source scorecard while making the unfinished governed recalculation visible.</a:t>
             </a:r>
           </a:p>
           <a:p xmlns:a="http://schemas.openxmlformats.org/drawingml/2006/main">
@@ -3086,7 +3276,7 @@
           </a:p>
           <a:p xmlns:a="http://schemas.openxmlformats.org/drawingml/2006/main">
             <a:r>
-              <a:t>The inputs are copied from the supplied document. Recalculating weight times rating yields 93 for Kong, 85.5 for Apigee and 77 for MuleSoft. This appendix preserves transparency and makes the evidence backlog explicit.</a:t>
+              <a:t>The inputs are preserved from the sanitized supplied evaluation. Recalculating weight times rating yields 93 for Kong, 85.5 for Apigee, and 77 for MuleSoft. Those values remain historical stakeholder input. `GRS-01`–`GRS-06` adds multicloud, scalability/robustness, security/IAM/traceability, reversibility/vendor dependency, fully allocated TCO, and control-plane operating responsibility to a future governed specification; every added weight and rating remains `TBD`.</a:t>
             </a:r>
           </a:p>
           <a:p xmlns:a="http://schemas.openxmlformats.org/drawingml/2006/main">
@@ -3101,7 +3291,7 @@
           </a:p>
           <a:p xmlns:a="http://schemas.openxmlformats.org/drawingml/2006/main">
             <a:r>
-              <a:t>If the scorecard remains a governance artifact, add confidence, sensitivity and accountable sign-off.</a:t>
+              <a:t>If the scorecard remains a governance artifact, approve exact options, mandatory gates, the scoring rubric, score-capable common evidence, dimensions and weights/ranges, confidence/unknown treatment, role-based scorers and approvers, sensitivity, lower/upper bounds, maximum regret, dissent, and independent sign-off. Do not calculate a new total in the room.</a:t>
             </a:r>
           </a:p>
           <a:p xmlns:a="http://schemas.openxmlformats.org/drawingml/2006/main">
@@ -3131,7 +3321,7 @@
           </a:p>
           <a:p xmlns:a="http://schemas.openxmlformats.org/drawingml/2006/main">
             <a:r>
-              <a:t>Scores are illustrative author inputs, not an independent benchmark or production outcome.</a:t>
+              <a:t>Scores are illustrative stakeholder inputs, not an independent benchmark or production outcome. The pending re-score cannot be tuned to preserve a preferred order, and unknown evidence cannot silently become zero or earn points.</a:t>
             </a:r>
           </a:p>
           <a:p xmlns:a="http://schemas.openxmlformats.org/drawingml/2006/main">
@@ -3146,7 +3336,42 @@
           </a:p>
           <a:p xmlns:a="http://schemas.openxmlformats.org/drawingml/2006/main">
             <a:r>
-              <a:t>- docs/48-kong-guided-evaluation.md#supplied-scoring-audit</a:t>
+              <a:t>- 48-kong-guided-evaluation.md#supplied-scoring-audit</a:t>
+            </a:r>
+          </a:p>
+          <a:p xmlns:a="http://schemas.openxmlformats.org/drawingml/2006/main">
+            <a:r>
+              <a:t>- 48-kong-guided-evaluation.md#proposed-governed-re-score</a:t>
+            </a:r>
+          </a:p>
+          <a:p xmlns:a="http://schemas.openxmlformats.org/drawingml/2006/main">
+            <a:r>
+              <a:t>- ../decision-matrix/scoring-guide.md</a:t>
+            </a:r>
+          </a:p>
+          <a:p xmlns:a="http://schemas.openxmlformats.org/drawingml/2006/main">
+            <a:r>
+              <a:t>- https://developer.konghq.com/gateway/deployment-topologies/</a:t>
+            </a:r>
+          </a:p>
+          <a:p xmlns:a="http://schemas.openxmlformats.org/drawingml/2006/main">
+            <a:r>
+              <a:t>- https://developer.konghq.com/ai-gateway/</a:t>
+            </a:r>
+          </a:p>
+          <a:p xmlns:a="http://schemas.openxmlformats.org/drawingml/2006/main">
+            <a:r>
+              <a:t>- https://docs.cloud.google.com/apigee/docs/hybrid/v1.16/what-is-hybrid</a:t>
+            </a:r>
+          </a:p>
+          <a:p xmlns:a="http://schemas.openxmlformats.org/drawingml/2006/main">
+            <a:r>
+              <a:t>- https://docs.mulesoft.com/gateway/latest/</a:t>
+            </a:r>
+          </a:p>
+          <a:p xmlns:a="http://schemas.openxmlformats.org/drawingml/2006/main">
+            <a:r>
+              <a:t>- https://learn.microsoft.com/en-us/azure/api-management/self-hosted-gateway-overview</a:t>
             </a:r>
           </a:p>
         </p:txBody>
@@ -3221,7 +3446,7 @@
           </a:p>
           <a:p xmlns:a="http://schemas.openxmlformats.org/drawingml/2006/main">
             <a:r>
-              <a:t>Make the decision model transparent before showing a result.</a:t>
+              <a:t>Make the historical weighting model transparent and expose the dimensions required for a governed re-score.</a:t>
             </a:r>
           </a:p>
           <a:p xmlns:a="http://schemas.openxmlformats.org/drawingml/2006/main">
@@ -3236,7 +3461,7 @@
           </a:p>
           <a:p xmlns:a="http://schemas.openxmlformats.org/drawingml/2006/main">
             <a:r>
-              <a:t>Eight weighted categories sum to 100%. Developer experience and multicloud appear in the narrative but not as distinct weights. Migration effort and operating labor are also absent, so the score is a directional preference model, not a full business case.</a:t>
+              <a:t>Eight supplied categories sum to 100%, and Kubernetes plus GitOps carry 35%. Multicloud, robustness, reversibility/vendor dependency, fully allocated TCO, and control-plane operating responsibility are absent or compressed in that simplified model, but they are already present in the canonical 120-criterion matrix. The proposed `GRS-01`–`GRS-06` specification exposes them without duplicating the taxonomy. Its weights and ratings remain `TBD`.</a:t>
             </a:r>
           </a:p>
           <a:p xmlns:a="http://schemas.openxmlformats.org/drawingml/2006/main">
@@ -3251,7 +3476,7 @@
           </a:p>
           <a:p xmlns:a="http://schemas.openxmlformats.org/drawingml/2006/main">
             <a:r>
-              <a:t>Confirm the weights and add sensitivity ranges before using them as an approval mechanism.</a:t>
+              <a:t>Approve the re-score dimensions, exact-option boundary, mandatory gates, evidence floor, role-based scorer and approver panel, weight ranges, confidence treatment, sensitivity method, dissent rule, and permitted decision use. Do not assign ratings in this meeting.</a:t>
             </a:r>
           </a:p>
           <a:p xmlns:a="http://schemas.openxmlformats.org/drawingml/2006/main">
@@ -3281,7 +3506,7 @@
           </a:p>
           <a:p xmlns:a="http://schemas.openxmlformats.org/drawingml/2006/main">
             <a:r>
-              <a:t>Ratings lack a documented rubric, named scorers, evidence confidence, product edition and sensitivity analysis.</a:t>
+              <a:t>The proposed re-score is pending, not a revised ranking. Ratings still lack an approved rubric, score-capable evidence, exact options, scorer panel, confidence, common-evidence treatment, bounds, maximum-regret analysis, and sensitivity approval.</a:t>
             </a:r>
           </a:p>
           <a:p xmlns:a="http://schemas.openxmlformats.org/drawingml/2006/main">
@@ -3296,7 +3521,32 @@
           </a:p>
           <a:p xmlns:a="http://schemas.openxmlformats.org/drawingml/2006/main">
             <a:r>
-              <a:t>- docs/48-kong-guided-evaluation.md#supplied-weighting-model</a:t>
+              <a:t>- 48-kong-guided-evaluation.md#supplied-weighting-model</a:t>
+            </a:r>
+          </a:p>
+          <a:p xmlns:a="http://schemas.openxmlformats.org/drawingml/2006/main">
+            <a:r>
+              <a:t>- 48-kong-guided-evaluation.md#meeting-feedback-assurance-crosswalk</a:t>
+            </a:r>
+          </a:p>
+          <a:p xmlns:a="http://schemas.openxmlformats.org/drawingml/2006/main">
+            <a:r>
+              <a:t>- 48-kong-guided-evaluation.md#proposed-governed-re-score</a:t>
+            </a:r>
+          </a:p>
+          <a:p xmlns:a="http://schemas.openxmlformats.org/drawingml/2006/main">
+            <a:r>
+              <a:t>- ../decision-matrix/scoring-guide.md</a:t>
+            </a:r>
+          </a:p>
+          <a:p xmlns:a="http://schemas.openxmlformats.org/drawingml/2006/main">
+            <a:r>
+              <a:t>- https://developer.konghq.com/gateway/deployment-topologies/</a:t>
+            </a:r>
+          </a:p>
+          <a:p xmlns:a="http://schemas.openxmlformats.org/drawingml/2006/main">
+            <a:r>
+              <a:t>- https://developer.konghq.com/gateway/hybrid-mode/</a:t>
             </a:r>
           </a:p>
         </p:txBody>
@@ -3556,7 +3806,7 @@
           </a:p>
           <a:p xmlns:a="http://schemas.openxmlformats.org/drawingml/2006/main">
             <a:r>
-              <a:t>The Kong total is 93. The same formula yields 85.5 for Apigee and 77 for MuleSoft, rather than 87 and 78 in the source results table. The ordering is unchanged, but the arithmetic and evidence limits matter.</a:t>
+              <a:t>The historical inputs recalculate to 93 for Kong, 85.5 for Apigee, and 77 for MuleSoft rather than 87 and 78 in the source results table. Preserve those inputs and the correction for audit. Do not publish an expanded total until `GRS-01`–`GRS-06`, exact options, mandatory gates, rubric, score-capable evidence, weights, confidence, scorer panel, sensitivity, bounds, regret treatment, and dissent are approved.</a:t>
             </a:r>
           </a:p>
           <a:p xmlns:a="http://schemas.openxmlformats.org/drawingml/2006/main">
@@ -3571,7 +3821,7 @@
           </a:p>
           <a:p xmlns:a="http://schemas.openxmlformats.org/drawingml/2006/main">
             <a:r>
-              <a:t>Treat the result as a directional preference to test, not a selection proof.</a:t>
+              <a:t>Confirm that the historical score remains directional preference input only, then assign role ownership for a governed recalculation that is allowed to change—not preserve—the order.</a:t>
             </a:r>
           </a:p>
           <a:p xmlns:a="http://schemas.openxmlformats.org/drawingml/2006/main">
@@ -3601,7 +3851,7 @@
           </a:p>
           <a:p xmlns:a="http://schemas.openxmlformats.org/drawingml/2006/main">
             <a:r>
-              <a:t>No sensitivity analysis or confidence adjustment has been applied. Exact scores should stay out of external claims.</a:t>
+              <a:t>No governed recalculation has been run. The added dimensions still have `TBD` weights and ratings, and the historical scores should not be presented as an independent benchmark, confidence percentage, or production-fit result.</a:t>
             </a:r>
           </a:p>
           <a:p xmlns:a="http://schemas.openxmlformats.org/drawingml/2006/main">
@@ -3616,7 +3866,37 @@
           </a:p>
           <a:p xmlns:a="http://schemas.openxmlformats.org/drawingml/2006/main">
             <a:r>
-              <a:t>- docs/48-kong-guided-evaluation.md#supplied-scoring-audit</a:t>
+              <a:t>- 48-kong-guided-evaluation.md#supplied-scoring-audit</a:t>
+            </a:r>
+          </a:p>
+          <a:p xmlns:a="http://schemas.openxmlformats.org/drawingml/2006/main">
+            <a:r>
+              <a:t>- 48-kong-guided-evaluation.md#proposed-governed-re-score</a:t>
+            </a:r>
+          </a:p>
+          <a:p xmlns:a="http://schemas.openxmlformats.org/drawingml/2006/main">
+            <a:r>
+              <a:t>- ../decision-matrix/scoring-guide.md</a:t>
+            </a:r>
+          </a:p>
+          <a:p xmlns:a="http://schemas.openxmlformats.org/drawingml/2006/main">
+            <a:r>
+              <a:t>- https://developer.konghq.com/gateway/deployment-topologies/</a:t>
+            </a:r>
+          </a:p>
+          <a:p xmlns:a="http://schemas.openxmlformats.org/drawingml/2006/main">
+            <a:r>
+              <a:t>- https://docs.cloud.google.com/apigee/docs/hybrid/v1.16/what-is-hybrid</a:t>
+            </a:r>
+          </a:p>
+          <a:p xmlns:a="http://schemas.openxmlformats.org/drawingml/2006/main">
+            <a:r>
+              <a:t>- https://docs.mulesoft.com/gateway/latest/</a:t>
+            </a:r>
+          </a:p>
+          <a:p xmlns:a="http://schemas.openxmlformats.org/drawingml/2006/main">
+            <a:r>
+              <a:t>- https://learn.microsoft.com/en-us/azure/api-management/self-hosted-gateway-overview</a:t>
             </a:r>
           </a:p>
         </p:txBody>
@@ -3996,7 +4276,7 @@
           </a:p>
           <a:p xmlns:a="http://schemas.openxmlformats.org/drawingml/2006/main">
             <a:r>
-              <a:t>Make the cost side of the target operating boundary visible.</a:t>
+              <a:t>Make the accountability, risk, and fully allocated cost side of the target operating boundary visible without making an unsupported legal conclusion.</a:t>
             </a:r>
           </a:p>
           <a:p xmlns:a="http://schemas.openxmlformats.org/drawingml/2006/main">
@@ -4011,7 +4291,7 @@
           </a:p>
           <a:p xmlns:a="http://schemas.openxmlformats.org/drawingml/2006/main">
             <a:r>
-              <a:t>The same custody that makes self-managed Kong attractive also creates permanent CP, database, PKI, upgrade, restore and 24×7 obligations. Those duties must have named owners and funded capacity.</a:t>
+              <a:t>The same custody that makes self-managed Kong attractive transfers permanent CP, PostgreSQL, PKI, Admin API, plugin/license, audit, upgrade, restore, support, and 24×7 service duties to enterprise roles. Cached data-plane service narrows one failure consequence; it does not remove control-plane recovery, urgent mutation/revocation, clean-node scale, reconciliation, or service accountability.</a:t>
             </a:r>
           </a:p>
           <a:p xmlns:a="http://schemas.openxmlformats.org/drawingml/2006/main">
@@ -4026,7 +4306,7 @@
           </a:p>
           <a:p xmlns:a="http://schemas.openxmlformats.org/drawingml/2006/main">
             <a:r>
-              <a:t>Confirm whether these duties belong inside the enterprise platform operating model.</a:t>
+              <a:t>Confirm whether platform product, database/SRE, PKI/security, release engineering, service management, sourcing/FinOps, and support roles accept the duty, capacity, objectives, evidence, and escalation path.</a:t>
             </a:r>
           </a:p>
           <a:p xmlns:a="http://schemas.openxmlformats.org/drawingml/2006/main">
@@ -4056,7 +4336,7 @@
           </a:p>
           <a:p xmlns:a="http://schemas.openxmlformats.org/drawingml/2006/main">
             <a:r>
-              <a:t>Control-plane outage continuity does not imply mutation, revocation or recovery guarantees; those are separate tests.</a:t>
+              <a:t>This is an operating-accountability and risk-exposure statement. Contractual allocation depends on exact support and commercial evidence; legal liability requires counsel in the approved restricted process. Control-plane continuity does not imply mutation, revocation, clean-node admission, or recovery guarantees.</a:t>
             </a:r>
           </a:p>
           <a:p xmlns:a="http://schemas.openxmlformats.org/drawingml/2006/main">
@@ -4071,12 +4351,27 @@
           </a:p>
           <a:p xmlns:a="http://schemas.openxmlformats.org/drawingml/2006/main">
             <a:r>
+              <a:t>- 47-kong-enterprise-platform-strategy.md</a:t>
+            </a:r>
+          </a:p>
+          <a:p xmlns:a="http://schemas.openxmlformats.org/drawingml/2006/main">
+            <a:r>
+              <a:t>- 48-kong-guided-evaluation.md</a:t>
+            </a:r>
+          </a:p>
+          <a:p xmlns:a="http://schemas.openxmlformats.org/drawingml/2006/main">
+            <a:r>
+              <a:t>- ../research/glossary.md#kong-terminology-crosswalk</a:t>
+            </a:r>
+          </a:p>
+          <a:p xmlns:a="http://schemas.openxmlformats.org/drawingml/2006/main">
+            <a:r>
               <a:t>- https://developer.konghq.com/gateway/hybrid-mode/</a:t>
             </a:r>
           </a:p>
           <a:p xmlns:a="http://schemas.openxmlformats.org/drawingml/2006/main">
             <a:r>
-              <a:t>- docs/47-kong-enterprise-platform-strategy.md</a:t>
+              <a:t>- https://developer.konghq.com/gateway/version-support-policy/</a:t>
             </a:r>
           </a:p>
         </p:txBody>
@@ -4299,7 +4594,7 @@
   </p:cSld>
   <p:clrMap bg1="lt1" tx1="dk1" bg2="lt2" tx2="dk2" accent1="accent1" accent2="accent2" accent3="accent3" accent4="accent4" accent5="accent5" accent6="accent6" hlink="hlink" folHlink="folHlink"/>
   <p:sldLayoutIdLst>
-    <p:sldLayoutId xmlns:r="http://schemas.openxmlformats.org/officeDocument/2006/relationships" id="2147483649" r:id="R67ba9097afc64f3f"/>
+    <p:sldLayoutId xmlns:r="http://schemas.openxmlformats.org/officeDocument/2006/relationships" id="2147483649" r:id="R919bba39c6d941da"/>
   </p:sldLayoutIdLst>
   <p:txStyles>
     <p:titleStyle>
@@ -5601,7 +5896,7 @@
                 <a:solidFill>
                   <a:srgbClr val="666762"/>
                 </a:solidFill>
-                <a:hlinkClick xmlns:r="http://schemas.openxmlformats.org/officeDocument/2006/relationships" r:id="Rbbf0e434237d45b8"/>
+                <a:hlinkClick xmlns:r="http://schemas.openxmlformats.org/officeDocument/2006/relationships" r:id="R063df1eeff244169"/>
               </a:rPr>
               <a:t>Repo reference</a:t>
             </a:r>
@@ -5618,7 +5913,7 @@
                 <a:solidFill>
                   <a:srgbClr val="666762"/>
                 </a:solidFill>
-                <a:hlinkClick xmlns:r="http://schemas.openxmlformats.org/officeDocument/2006/relationships" r:id="Rfe537a1e1a0844bf"/>
+                <a:hlinkClick xmlns:r="http://schemas.openxmlformats.org/officeDocument/2006/relationships" r:id="Rabfc1b3f59d745bf"/>
               </a:rPr>
               <a:t>Official docs</a:t>
             </a:r>
@@ -5979,7 +6274,7 @@
                 <a:solidFill>
                   <a:srgbClr val="666762"/>
                 </a:solidFill>
-                <a:hlinkClick xmlns:r="http://schemas.openxmlformats.org/officeDocument/2006/relationships" r:id="R0a801d7f63804d41"/>
+                <a:hlinkClick xmlns:r="http://schemas.openxmlformats.org/officeDocument/2006/relationships" r:id="Rf1f8380c03b349e3"/>
               </a:rPr>
               <a:t>Repo reference</a:t>
             </a:r>
@@ -5996,7 +6291,7 @@
                 <a:solidFill>
                   <a:srgbClr val="666762"/>
                 </a:solidFill>
-                <a:hlinkClick xmlns:r="http://schemas.openxmlformats.org/officeDocument/2006/relationships" r:id="R1d3dcd7ae7b94e35"/>
+                <a:hlinkClick xmlns:r="http://schemas.openxmlformats.org/officeDocument/2006/relationships" r:id="R6ce6f9e3429549b3"/>
               </a:rPr>
               <a:t>Official docs</a:t>
             </a:r>
@@ -7285,7 +7580,7 @@
                 <a:solidFill>
                   <a:srgbClr val="666762"/>
                 </a:solidFill>
-                <a:hlinkClick xmlns:r="http://schemas.openxmlformats.org/officeDocument/2006/relationships" r:id="Rced0b2ba97b540b7"/>
+                <a:hlinkClick xmlns:r="http://schemas.openxmlformats.org/officeDocument/2006/relationships" r:id="Rafbb0ef3c20f4602"/>
               </a:rPr>
               <a:t>Repo reference</a:t>
             </a:r>
@@ -7302,7 +7597,7 @@
                 <a:solidFill>
                   <a:srgbClr val="666762"/>
                 </a:solidFill>
-                <a:hlinkClick xmlns:r="http://schemas.openxmlformats.org/officeDocument/2006/relationships" r:id="R52c80b63c6294c51"/>
+                <a:hlinkClick xmlns:r="http://schemas.openxmlformats.org/officeDocument/2006/relationships" r:id="R43d221ddfb2240a0"/>
               </a:rPr>
               <a:t>Official docs</a:t>
             </a:r>
@@ -8078,7 +8373,7 @@
       </p:sp>
       <p:cxnSp>
         <p:nvCxnSpPr>
-          <p:cNvPr id="194" name=""/>
+          <p:cNvPr id="263" name=""/>
           <p:cNvCxnSpPr>
             <a:stCxn xmlns:a="http://schemas.openxmlformats.org/drawingml/2006/main" id="9" idx="3"/>
             <a:endCxn xmlns:a="http://schemas.openxmlformats.org/drawingml/2006/main" id="12" idx="1"/>
@@ -8104,7 +8399,7 @@
       </p:cxnSp>
       <p:cxnSp>
         <p:nvCxnSpPr>
-          <p:cNvPr id="195" name=""/>
+          <p:cNvPr id="264" name=""/>
           <p:cNvCxnSpPr>
             <a:stCxn xmlns:a="http://schemas.openxmlformats.org/drawingml/2006/main" id="12" idx="3"/>
             <a:endCxn xmlns:a="http://schemas.openxmlformats.org/drawingml/2006/main" id="15" idx="1"/>
@@ -8130,7 +8425,7 @@
       </p:cxnSp>
       <p:cxnSp>
         <p:nvCxnSpPr>
-          <p:cNvPr id="196" name=""/>
+          <p:cNvPr id="265" name=""/>
           <p:cNvCxnSpPr>
             <a:stCxn xmlns:a="http://schemas.openxmlformats.org/drawingml/2006/main" id="15" idx="3"/>
             <a:endCxn xmlns:a="http://schemas.openxmlformats.org/drawingml/2006/main" id="18" idx="1"/>
@@ -9112,7 +9407,7 @@
                 <a:solidFill>
                   <a:srgbClr val="666762"/>
                 </a:solidFill>
-                <a:hlinkClick xmlns:r="http://schemas.openxmlformats.org/officeDocument/2006/relationships" r:id="R523210e31ed74dd5"/>
+                <a:hlinkClick xmlns:r="http://schemas.openxmlformats.org/officeDocument/2006/relationships" r:id="Rd2d3cea478524721"/>
               </a:rPr>
               <a:t>Repo reference</a:t>
             </a:r>
@@ -9129,7 +9424,7 @@
                 <a:solidFill>
                   <a:srgbClr val="666762"/>
                 </a:solidFill>
-                <a:hlinkClick xmlns:r="http://schemas.openxmlformats.org/officeDocument/2006/relationships" r:id="R51ee73d822b94c21"/>
+                <a:hlinkClick xmlns:r="http://schemas.openxmlformats.org/officeDocument/2006/relationships" r:id="R539c58432d4744c9"/>
               </a:rPr>
               <a:t>Official docs</a:t>
             </a:r>
@@ -10764,7 +11059,7 @@
                 <a:solidFill>
                   <a:srgbClr val="666762"/>
                 </a:solidFill>
-                <a:hlinkClick xmlns:r="http://schemas.openxmlformats.org/officeDocument/2006/relationships" r:id="Re66eedb839c54273"/>
+                <a:hlinkClick xmlns:r="http://schemas.openxmlformats.org/officeDocument/2006/relationships" r:id="Ra2b5e1c4e28a46a7"/>
               </a:rPr>
               <a:t>Repo reference</a:t>
             </a:r>
@@ -10781,7 +11076,7 @@
                 <a:solidFill>
                   <a:srgbClr val="666762"/>
                 </a:solidFill>
-                <a:hlinkClick xmlns:r="http://schemas.openxmlformats.org/officeDocument/2006/relationships" r:id="R00a9e463814e48f4"/>
+                <a:hlinkClick xmlns:r="http://schemas.openxmlformats.org/officeDocument/2006/relationships" r:id="Rf70857b4e97e4c7d"/>
               </a:rPr>
               <a:t>Official docs</a:t>
             </a:r>
@@ -13008,7 +13303,7 @@
                 <a:solidFill>
                   <a:srgbClr val="666762"/>
                 </a:solidFill>
-                <a:hlinkClick xmlns:r="http://schemas.openxmlformats.org/officeDocument/2006/relationships" r:id="R7aa7d65826ad432c"/>
+                <a:hlinkClick xmlns:r="http://schemas.openxmlformats.org/officeDocument/2006/relationships" r:id="Rf626b329861a487b"/>
               </a:rPr>
               <a:t>Repo reference</a:t>
             </a:r>
@@ -13025,7 +13320,7 @@
                 <a:solidFill>
                   <a:srgbClr val="666762"/>
                 </a:solidFill>
-                <a:hlinkClick xmlns:r="http://schemas.openxmlformats.org/officeDocument/2006/relationships" r:id="R1e11eac9486c4b0b"/>
+                <a:hlinkClick xmlns:r="http://schemas.openxmlformats.org/officeDocument/2006/relationships" r:id="R712569a5a4d54fb7"/>
               </a:rPr>
               <a:t>Official docs</a:t>
             </a:r>
@@ -14971,7 +15266,7 @@
                 <a:solidFill>
                   <a:srgbClr val="666762"/>
                 </a:solidFill>
-                <a:hlinkClick xmlns:r="http://schemas.openxmlformats.org/officeDocument/2006/relationships" r:id="R2da00fdd75884681"/>
+                <a:hlinkClick xmlns:r="http://schemas.openxmlformats.org/officeDocument/2006/relationships" r:id="R1263daf97d134853"/>
               </a:rPr>
               <a:t>Repo reference</a:t>
             </a:r>
@@ -14988,7 +15283,7 @@
                 <a:solidFill>
                   <a:srgbClr val="666762"/>
                 </a:solidFill>
-                <a:hlinkClick xmlns:r="http://schemas.openxmlformats.org/officeDocument/2006/relationships" r:id="Rc4928489af994148"/>
+                <a:hlinkClick xmlns:r="http://schemas.openxmlformats.org/officeDocument/2006/relationships" r:id="R4bbe7096d3104c54"/>
               </a:rPr>
               <a:t>Official docs</a:t>
             </a:r>
@@ -15845,7 +16140,7 @@
       </p:sp>
       <p:cxnSp>
         <p:nvCxnSpPr>
-          <p:cNvPr id="223" name=""/>
+          <p:cNvPr id="307" name=""/>
           <p:cNvCxnSpPr>
             <a:stCxn xmlns:a="http://schemas.openxmlformats.org/drawingml/2006/main" id="9" idx="3"/>
             <a:endCxn xmlns:a="http://schemas.openxmlformats.org/drawingml/2006/main" id="12" idx="1"/>
@@ -15871,7 +16166,7 @@
       </p:cxnSp>
       <p:cxnSp>
         <p:nvCxnSpPr>
-          <p:cNvPr id="224" name=""/>
+          <p:cNvPr id="308" name=""/>
           <p:cNvCxnSpPr>
             <a:stCxn xmlns:a="http://schemas.openxmlformats.org/drawingml/2006/main" id="12" idx="3"/>
             <a:endCxn xmlns:a="http://schemas.openxmlformats.org/drawingml/2006/main" id="15" idx="1"/>
@@ -15899,7 +16194,7 @@
       </p:cxnSp>
       <p:cxnSp>
         <p:nvCxnSpPr>
-          <p:cNvPr id="225" name=""/>
+          <p:cNvPr id="309" name=""/>
           <p:cNvCxnSpPr>
             <a:stCxn xmlns:a="http://schemas.openxmlformats.org/drawingml/2006/main" id="12" idx="3"/>
             <a:endCxn xmlns:a="http://schemas.openxmlformats.org/drawingml/2006/main" id="18" idx="1"/>
@@ -15927,7 +16222,7 @@
       </p:cxnSp>
       <p:cxnSp>
         <p:nvCxnSpPr>
-          <p:cNvPr id="226" name=""/>
+          <p:cNvPr id="310" name=""/>
           <p:cNvCxnSpPr>
             <a:stCxn xmlns:a="http://schemas.openxmlformats.org/drawingml/2006/main" id="15" idx="3"/>
             <a:endCxn xmlns:a="http://schemas.openxmlformats.org/drawingml/2006/main" id="21" idx="1"/>
@@ -15955,7 +16250,7 @@
       </p:cxnSp>
       <p:cxnSp>
         <p:nvCxnSpPr>
-          <p:cNvPr id="227" name=""/>
+          <p:cNvPr id="311" name=""/>
           <p:cNvCxnSpPr>
             <a:stCxn xmlns:a="http://schemas.openxmlformats.org/drawingml/2006/main" id="18" idx="3"/>
             <a:endCxn xmlns:a="http://schemas.openxmlformats.org/drawingml/2006/main" id="21" idx="1"/>
@@ -16336,7 +16631,7 @@
                 <a:ea typeface="Arial"/>
                 <a:cs typeface="Arial"/>
               </a:rPr>
-              <a:t>Migration advances on evidence—not time</a:t>
+              <a:t>Mule and Apigee migration advance on evidence—not time</a:t>
             </a:r>
           </a:p>
         </p:txBody>
@@ -16395,7 +16690,30 @@
                 <a:ea typeface="Arial"/>
                 <a:cs typeface="Arial"/>
               </a:rPr>
-              <a:t>A scenario planning sequence—not current programme status.</a:t>
+              <a:t>Mule M0–M5 and </a:t>
+            </a:r>
+            <a:r>
+              <a:rPr sz="1575" b="0" i="0">
+                <a:solidFill>
+                  <a:srgbClr val="686A66"/>
+                </a:solidFill>
+                <a:latin typeface="Arial"/>
+                <a:ea typeface="Arial"/>
+                <a:cs typeface="Arial"/>
+                <a:hlinkClick xmlns:r="http://schemas.openxmlformats.org/officeDocument/2006/relationships" r:id="R62e375ce0497439d"/>
+              </a:rPr>
+              <a:t>Apigee A0–A6</a:t>
+            </a:r>
+            <a:r>
+              <a:rPr sz="1575" b="0" i="0">
+                <a:solidFill>
+                  <a:srgbClr val="686A66"/>
+                </a:solidFill>
+                <a:latin typeface="Arial"/>
+                <a:ea typeface="Arial"/>
+                <a:cs typeface="Arial"/>
+              </a:rPr>
+              <a:t> share stable-edge, coexistence, route-back and dependency-zero gates.</a:t>
             </a:r>
           </a:p>
         </p:txBody>
@@ -16486,7 +16804,7 @@
                 <a:solidFill>
                   <a:srgbClr val="666762"/>
                 </a:solidFill>
-                <a:hlinkClick xmlns:r="http://schemas.openxmlformats.org/officeDocument/2006/relationships" r:id="R1022742dc6a645c1"/>
+                <a:hlinkClick xmlns:r="http://schemas.openxmlformats.org/officeDocument/2006/relationships" r:id="R1c28582fbaff48e4"/>
               </a:rPr>
               <a:t>Repo reference</a:t>
             </a:r>
@@ -16503,7 +16821,7 @@
                 <a:solidFill>
                   <a:srgbClr val="666762"/>
                 </a:solidFill>
-                <a:hlinkClick xmlns:r="http://schemas.openxmlformats.org/officeDocument/2006/relationships" r:id="R97cd161f45374955"/>
+                <a:hlinkClick xmlns:r="http://schemas.openxmlformats.org/officeDocument/2006/relationships" r:id="R7f21fb6e85534687"/>
               </a:rPr>
               <a:t>Official docs</a:t>
             </a:r>
@@ -16623,7 +16941,7 @@
                 <a:ea typeface="Consolas"/>
                 <a:cs typeface="Consolas"/>
               </a:rPr>
-              <a:t>M0</a:t>
+              <a:t>M0/A0</a:t>
             </a:r>
           </a:p>
         </p:txBody>
@@ -16682,7 +17000,7 @@
                 <a:ea typeface="Georgia"/>
                 <a:cs typeface="Georgia"/>
               </a:rPr>
-              <a:t>Inventory + safety</a:t>
+              <a:t>Inventory + freeze</a:t>
             </a:r>
           </a:p>
         </p:txBody>
@@ -16831,7 +17149,31 @@
                 <a:ea typeface="Arial"/>
                 <a:cs typeface="Arial"/>
               </a:rPr>
-              <a:t>owners + runtime access</a:t>
+              <a:t>Mule duty + state</a:t>
+            </a:r>
+          </a:p>
+          <a:p xmlns:a="http://schemas.openxmlformats.org/drawingml/2006/main">
+            <a:pPr algn="l">
+              <a:buNone/>
+              <a:defRPr sz="1200" b="0" i="0">
+                <a:solidFill>
+                  <a:srgbClr val="111111"/>
+                </a:solidFill>
+                <a:latin typeface="Arial"/>
+                <a:ea typeface="Arial"/>
+                <a:cs typeface="Arial"/>
+              </a:defRPr>
+            </a:pPr>
+            <a:r>
+              <a:rPr sz="1200" b="0" i="0">
+                <a:solidFill>
+                  <a:srgbClr val="111111"/>
+                </a:solidFill>
+                <a:latin typeface="Arial"/>
+                <a:ea typeface="Arial"/>
+                <a:cs typeface="Arial"/>
+              </a:rPr>
+              <a:t>Apigee object graph</a:t>
             </a:r>
           </a:p>
         </p:txBody>
@@ -16949,7 +17291,7 @@
                 <a:ea typeface="Arial"/>
                 <a:cs typeface="Arial"/>
               </a:rPr>
-              <a:t>traffic / state / schedule reconciled</a:t>
+              <a:t>reconciled denominator</a:t>
             </a:r>
           </a:p>
         </p:txBody>
@@ -17039,7 +17381,7 @@
                 <a:ea typeface="Consolas"/>
                 <a:cs typeface="Consolas"/>
               </a:rPr>
-              <a:t>M1</a:t>
+              <a:t>M1/A1</a:t>
             </a:r>
           </a:p>
         </p:txBody>
@@ -17098,7 +17440,7 @@
                 <a:ea typeface="Georgia"/>
                 <a:cs typeface="Georgia"/>
               </a:rPr>
-              <a:t>Gateway-</a:t>
+              <a:t>Classify</a:t>
             </a:r>
           </a:p>
           <a:p xmlns:a="http://schemas.openxmlformats.org/drawingml/2006/main">
@@ -17122,7 +17464,7 @@
                 <a:ea typeface="Georgia"/>
                 <a:cs typeface="Georgia"/>
               </a:rPr>
-              <a:t>dominant</a:t>
+              <a:t>semantics</a:t>
             </a:r>
           </a:p>
         </p:txBody>
@@ -17271,7 +17613,7 @@
                 <a:ea typeface="Arial"/>
                 <a:cs typeface="Arial"/>
               </a:rPr>
-              <a:t>pattern + active digest</a:t>
+              <a:t>policy + behavior map</a:t>
             </a:r>
           </a:p>
         </p:txBody>
@@ -17389,7 +17731,7 @@
                 <a:ea typeface="Arial"/>
                 <a:cs typeface="Arial"/>
               </a:rPr>
-              <a:t>parity + restart + rollback</a:t>
+              <a:t>owner + destination</a:t>
             </a:r>
           </a:p>
         </p:txBody>
@@ -17479,7 +17821,7 @@
                 <a:ea typeface="Consolas"/>
                 <a:cs typeface="Consolas"/>
               </a:rPr>
-              <a:t>M2</a:t>
+              <a:t>M2/A2</a:t>
             </a:r>
           </a:p>
         </p:txBody>
@@ -17538,7 +17880,7 @@
                 <a:ea typeface="Georgia"/>
                 <a:cs typeface="Georgia"/>
               </a:rPr>
-              <a:t>Representative</a:t>
+              <a:t>Reversible</a:t>
             </a:r>
           </a:p>
           <a:p xmlns:a="http://schemas.openxmlformats.org/drawingml/2006/main">
@@ -17562,7 +17904,7 @@
                 <a:ea typeface="Georgia"/>
                 <a:cs typeface="Georgia"/>
               </a:rPr>
-              <a:t>integrations</a:t>
+              <a:t>foundation</a:t>
             </a:r>
           </a:p>
         </p:txBody>
@@ -17711,7 +18053,7 @@
                 <a:ea typeface="Arial"/>
                 <a:cs typeface="Arial"/>
               </a:rPr>
-              <a:t>idempotency + target runtime</a:t>
+              <a:t>BOM + APIOps + IAM</a:t>
             </a:r>
           </a:p>
         </p:txBody>
@@ -17829,7 +18171,7 @@
                 <a:ea typeface="Arial"/>
                 <a:cs typeface="Arial"/>
               </a:rPr>
-              <a:t>semantics + recovery accepted</a:t>
+              <a:t>restore + route-back</a:t>
             </a:r>
           </a:p>
         </p:txBody>
@@ -17919,7 +18261,7 @@
                 <a:ea typeface="Consolas"/>
                 <a:cs typeface="Consolas"/>
               </a:rPr>
-              <a:t>M3</a:t>
+              <a:t>M3/A3</a:t>
             </a:r>
           </a:p>
         </p:txBody>
@@ -17978,7 +18320,31 @@
                 <a:ea typeface="Georgia"/>
                 <a:cs typeface="Georgia"/>
               </a:rPr>
-              <a:t>Domain factory</a:t>
+              <a:t>Representative</a:t>
+            </a:r>
+          </a:p>
+          <a:p xmlns:a="http://schemas.openxmlformats.org/drawingml/2006/main">
+            <a:pPr algn="l">
+              <a:buNone/>
+              <a:defRPr sz="1725" b="0" i="0">
+                <a:solidFill>
+                  <a:srgbClr val="111111"/>
+                </a:solidFill>
+                <a:latin typeface="Georgia"/>
+                <a:ea typeface="Georgia"/>
+                <a:cs typeface="Georgia"/>
+              </a:defRPr>
+            </a:pPr>
+            <a:r>
+              <a:rPr sz="1725" b="0" i="0">
+                <a:solidFill>
+                  <a:srgbClr val="111111"/>
+                </a:solidFill>
+                <a:latin typeface="Georgia"/>
+                <a:ea typeface="Georgia"/>
+                <a:cs typeface="Georgia"/>
+              </a:rPr>
+              <a:t>parity</a:t>
             </a:r>
           </a:p>
         </p:txBody>
@@ -18127,7 +18493,7 @@
                 <a:ea typeface="Arial"/>
                 <a:cs typeface="Arial"/>
               </a:rPr>
-              <a:t>funded owners + automation</a:t>
+              <a:t>hard slice + corpus</a:t>
             </a:r>
           </a:p>
         </p:txBody>
@@ -18245,7 +18611,7 @@
                 <a:ea typeface="Arial"/>
                 <a:cs typeface="Arial"/>
               </a:rPr>
-              <a:t>ownership transferred</a:t>
+              <a:t>security + state + SLO</a:t>
             </a:r>
           </a:p>
         </p:txBody>
@@ -18335,7 +18701,7 @@
                 <a:ea typeface="Consolas"/>
                 <a:cs typeface="Consolas"/>
               </a:rPr>
-              <a:t>M4</a:t>
+              <a:t>M4/A4</a:t>
             </a:r>
           </a:p>
         </p:txBody>
@@ -18394,7 +18760,7 @@
                 <a:ea typeface="Georgia"/>
                 <a:cs typeface="Georgia"/>
               </a:rPr>
-              <a:t>Connector +</a:t>
+              <a:t>Bounded</a:t>
             </a:r>
           </a:p>
           <a:p xmlns:a="http://schemas.openxmlformats.org/drawingml/2006/main">
@@ -18418,7 +18784,7 @@
                 <a:ea typeface="Georgia"/>
                 <a:cs typeface="Georgia"/>
               </a:rPr>
-              <a:t>batch tail</a:t>
+              <a:t>coexistence</a:t>
             </a:r>
           </a:p>
         </p:txBody>
@@ -18567,7 +18933,7 @@
                 <a:ea typeface="Arial"/>
                 <a:cs typeface="Arial"/>
               </a:rPr>
-              <a:t>replace / retain decision</a:t>
+              <a:t>cohort + identity/state</a:t>
             </a:r>
           </a:p>
         </p:txBody>
@@ -18685,7 +19051,7 @@
                 <a:ea typeface="Arial"/>
                 <a:cs typeface="Arial"/>
               </a:rPr>
-              <a:t>exception bounded or removed</a:t>
+              <a:t>reconcile + timed rollback</a:t>
             </a:r>
           </a:p>
         </p:txBody>
@@ -18751,7 +19117,7 @@
         </p:spPr>
         <p:txBody>
           <a:bodyPr xmlns:a="http://schemas.openxmlformats.org/drawingml/2006/main" wrap="square" lIns="0" tIns="0" rIns="0" bIns="0" anchor="t">
-            <a:normAutofit fontScale="100000"/>
+            <a:normAutofit fontScale="96144"/>
           </a:bodyPr>
           <a:lstStyle xmlns:a="http://schemas.openxmlformats.org/drawingml/2006/main"/>
           <a:p xmlns:a="http://schemas.openxmlformats.org/drawingml/2006/main">
@@ -18775,7 +19141,7 @@
                 <a:ea typeface="Consolas"/>
                 <a:cs typeface="Consolas"/>
               </a:rPr>
-              <a:t>M5</a:t>
+              <a:t>M5/A5+</a:t>
             </a:r>
           </a:p>
         </p:txBody>
@@ -18810,7 +19176,7 @@
         </p:spPr>
         <p:txBody>
           <a:bodyPr xmlns:a="http://schemas.openxmlformats.org/drawingml/2006/main" wrap="square" lIns="0" tIns="0" rIns="0" bIns="0" anchor="t">
-            <a:normAutofit fontScale="100000"/>
+            <a:normAutofit fontScale="97472"/>
           </a:bodyPr>
           <a:lstStyle xmlns:a="http://schemas.openxmlformats.org/drawingml/2006/main"/>
           <a:p xmlns:a="http://schemas.openxmlformats.org/drawingml/2006/main">
@@ -18834,7 +19200,7 @@
                 <a:ea typeface="Georgia"/>
                 <a:cs typeface="Georgia"/>
               </a:rPr>
-              <a:t>Retire shared</a:t>
+              <a:t>Canary → A6</a:t>
             </a:r>
           </a:p>
           <a:p xmlns:a="http://schemas.openxmlformats.org/drawingml/2006/main">
@@ -18858,7 +19224,7 @@
                 <a:ea typeface="Georgia"/>
                 <a:cs typeface="Georgia"/>
               </a:rPr>
-              <a:t>runtime</a:t>
+              <a:t>dependency zero</a:t>
             </a:r>
           </a:p>
         </p:txBody>
@@ -19007,7 +19373,7 @@
                 <a:ea typeface="Arial"/>
                 <a:cs typeface="Arial"/>
               </a:rPr>
-              <a:t>traffic zero + archives</a:t>
+              <a:t>representative operating evidence</a:t>
             </a:r>
           </a:p>
         </p:txBody>
@@ -19125,7 +19491,7 @@
                 <a:ea typeface="Arial"/>
                 <a:cs typeface="Arial"/>
               </a:rPr>
-              <a:t>dependency zero</a:t>
+              <a:t>all source duties closed</a:t>
             </a:r>
           </a:p>
         </p:txBody>
@@ -19160,7 +19526,7 @@
         </p:spPr>
         <p:txBody>
           <a:bodyPr xmlns:a="http://schemas.openxmlformats.org/drawingml/2006/main" wrap="square" lIns="0" tIns="0" rIns="0" bIns="0" anchor="t">
-            <a:normAutofit fontScale="100000"/>
+            <a:normAutofit fontScale="90246"/>
           </a:bodyPr>
           <a:lstStyle xmlns:a="http://schemas.openxmlformats.org/drawingml/2006/main"/>
           <a:p xmlns:a="http://schemas.openxmlformats.org/drawingml/2006/main">
@@ -19184,7 +19550,7 @@
                 <a:ea typeface="Georgia"/>
                 <a:cs typeface="Georgia"/>
               </a:rPr>
-              <a:t>No wave advances because the calendar moved.</a:t>
+              <a:t>No path advances because the calendar moved—or a proxy bundle exported.</a:t>
             </a:r>
           </a:p>
         </p:txBody>
@@ -19543,7 +19909,7 @@
                 <a:solidFill>
                   <a:srgbClr val="666762"/>
                 </a:solidFill>
-                <a:hlinkClick xmlns:r="http://schemas.openxmlformats.org/officeDocument/2006/relationships" r:id="Re9a24bf5ed534727"/>
+                <a:hlinkClick xmlns:r="http://schemas.openxmlformats.org/officeDocument/2006/relationships" r:id="Rd0140178fd474b49"/>
               </a:rPr>
               <a:t>Repo reference</a:t>
             </a:r>
@@ -19560,7 +19926,7 @@
                 <a:solidFill>
                   <a:srgbClr val="666762"/>
                 </a:solidFill>
-                <a:hlinkClick xmlns:r="http://schemas.openxmlformats.org/officeDocument/2006/relationships" r:id="Rce6543ac207849c1"/>
+                <a:hlinkClick xmlns:r="http://schemas.openxmlformats.org/officeDocument/2006/relationships" r:id="Re4a0a24c3f964747"/>
               </a:rPr>
               <a:t>Official docs</a:t>
             </a:r>
@@ -20751,7 +21117,7 @@
                 <a:ea typeface="Arial"/>
                 <a:cs typeface="Arial"/>
               </a:rPr>
-              <a:t>Six workstreams convert a functional baseline into decision-grade evidence.</a:t>
+              <a:t>Seven workstreams convert the local baseline into decision-grade target evidence.</a:t>
             </a:r>
           </a:p>
         </p:txBody>
@@ -20842,7 +21208,7 @@
                 <a:solidFill>
                   <a:srgbClr val="666762"/>
                 </a:solidFill>
-                <a:hlinkClick xmlns:r="http://schemas.openxmlformats.org/officeDocument/2006/relationships" r:id="R4209fdf0f1a6407e"/>
+                <a:hlinkClick xmlns:r="http://schemas.openxmlformats.org/officeDocument/2006/relationships" r:id="R18ea84ca327940c5"/>
               </a:rPr>
               <a:t>Repo reference</a:t>
             </a:r>
@@ -20859,7 +21225,7 @@
                 <a:solidFill>
                   <a:srgbClr val="666762"/>
                 </a:solidFill>
-                <a:hlinkClick xmlns:r="http://schemas.openxmlformats.org/officeDocument/2006/relationships" r:id="R6ff692ef042d4ad1"/>
+                <a:hlinkClick xmlns:r="http://schemas.openxmlformats.org/officeDocument/2006/relationships" r:id="R221a2808b8c54ac9"/>
               </a:rPr>
               <a:t>Official docs</a:t>
             </a:r>
@@ -21929,7 +22295,7 @@
                 <a:ea typeface="Consolas"/>
                 <a:cs typeface="Consolas"/>
               </a:rPr>
-              <a:t>AGENTIC + DECISION</a:t>
+              <a:t>AGENTIC + SECURITY + DECISION</a:t>
             </a:r>
           </a:p>
         </p:txBody>
@@ -22203,7 +22569,7 @@
         </p:spPr>
         <p:txBody>
           <a:bodyPr xmlns:a="http://schemas.openxmlformats.org/drawingml/2006/main" wrap="square" lIns="0" tIns="0" rIns="0" bIns="0" anchor="t">
-            <a:normAutofit fontScale="100000"/>
+            <a:normAutofit fontScale="95441"/>
           </a:bodyPr>
           <a:lstStyle xmlns:a="http://schemas.openxmlformats.org/drawingml/2006/main"/>
           <a:p xmlns:a="http://schemas.openxmlformats.org/drawingml/2006/main">
@@ -22227,7 +22593,7 @@
                 <a:ea typeface="Consolas"/>
                 <a:cs typeface="Consolas"/>
               </a:rPr>
-              <a:t>06</a:t>
+              <a:t>06 / 07</a:t>
             </a:r>
           </a:p>
         </p:txBody>
@@ -22286,7 +22652,7 @@
                 <a:ea typeface="Georgia"/>
                 <a:cs typeface="Georgia"/>
               </a:rPr>
-              <a:t>Evidence-gated recommendation</a:t>
+              <a:t>Decision gate + security adjunct</a:t>
             </a:r>
           </a:p>
         </p:txBody>
@@ -22345,7 +22711,7 @@
                 <a:ea typeface="Arial"/>
                 <a:cs typeface="Arial"/>
               </a:rPr>
-              <a:t>Base production scope on executed results and reviewable artifacts—not documented capability.</a:t>
+              <a:t>GEP-06 binds scope to executed evidence. GEP-07 proves Kong + Traceable behavior, overhead, privacy, support and safe uninstall.</a:t>
             </a:r>
           </a:p>
         </p:txBody>
@@ -22435,7 +22801,7 @@
                 <a:ea typeface="Arial"/>
                 <a:cs typeface="Arial"/>
               </a:rPr>
-              <a:t>Documented capability creates a hypothesis; executed evidence changes the decision.</a:t>
+              <a:t>Traceable documents a plugin/agent path; only execution can establish production fit.</a:t>
             </a:r>
           </a:p>
         </p:txBody>
@@ -22794,7 +23160,7 @@
                 <a:solidFill>
                   <a:srgbClr val="666762"/>
                 </a:solidFill>
-                <a:hlinkClick xmlns:r="http://schemas.openxmlformats.org/officeDocument/2006/relationships" r:id="R21bf07e7b8524a3a"/>
+                <a:hlinkClick xmlns:r="http://schemas.openxmlformats.org/officeDocument/2006/relationships" r:id="Rd5102ee8f65a423c"/>
               </a:rPr>
               <a:t>Repo reference</a:t>
             </a:r>
@@ -22811,7 +23177,7 @@
                 <a:solidFill>
                   <a:srgbClr val="666762"/>
                 </a:solidFill>
-                <a:hlinkClick xmlns:r="http://schemas.openxmlformats.org/officeDocument/2006/relationships" r:id="Re3b90cdc619542e5"/>
+                <a:hlinkClick xmlns:r="http://schemas.openxmlformats.org/officeDocument/2006/relationships" r:id="Rb4a02421c0ce42e8"/>
               </a:rPr>
               <a:t>Official docs</a:t>
             </a:r>
@@ -25166,7 +25532,7 @@
                 <a:solidFill>
                   <a:srgbClr val="666762"/>
                 </a:solidFill>
-                <a:hlinkClick xmlns:r="http://schemas.openxmlformats.org/officeDocument/2006/relationships" r:id="R9a847bc6e3494304"/>
+                <a:hlinkClick xmlns:r="http://schemas.openxmlformats.org/officeDocument/2006/relationships" r:id="R1adb478676e24d4f"/>
               </a:rPr>
               <a:t>Repo reference</a:t>
             </a:r>
@@ -25183,7 +25549,7 @@
                 <a:solidFill>
                   <a:srgbClr val="666762"/>
                 </a:solidFill>
-                <a:hlinkClick xmlns:r="http://schemas.openxmlformats.org/officeDocument/2006/relationships" r:id="R9cbef054e21c4756"/>
+                <a:hlinkClick xmlns:r="http://schemas.openxmlformats.org/officeDocument/2006/relationships" r:id="Ra49e7b2f39b04741"/>
               </a:rPr>
               <a:t>Official docs</a:t>
             </a:r>
@@ -26718,7 +27084,7 @@
                 <a:ea typeface="Arial"/>
                 <a:cs typeface="Arial"/>
               </a:rPr>
-              <a:t>A technically healthy gateway can still fail the enterprise outcome gate.</a:t>
+              <a:t>Capacity, security traceability, adoption, toil, exit and estate truth all gate scale.</a:t>
             </a:r>
           </a:p>
         </p:txBody>
@@ -26809,7 +27175,7 @@
                 <a:solidFill>
                   <a:srgbClr val="666762"/>
                 </a:solidFill>
-                <a:hlinkClick xmlns:r="http://schemas.openxmlformats.org/officeDocument/2006/relationships" r:id="R067ace37372f4444"/>
+                <a:hlinkClick xmlns:r="http://schemas.openxmlformats.org/officeDocument/2006/relationships" r:id="R3bf9810ed14d46cb"/>
               </a:rPr>
               <a:t>Repo reference</a:t>
             </a:r>
@@ -26826,7 +27192,7 @@
                 <a:solidFill>
                   <a:srgbClr val="666762"/>
                 </a:solidFill>
-                <a:hlinkClick xmlns:r="http://schemas.openxmlformats.org/officeDocument/2006/relationships" r:id="Rab5bb13600e0468a"/>
+                <a:hlinkClick xmlns:r="http://schemas.openxmlformats.org/officeDocument/2006/relationships" r:id="R7bc13b7db82d40b0"/>
               </a:rPr>
               <a:t>Official docs</a:t>
             </a:r>
@@ -27279,7 +27645,7 @@
                 <a:ea typeface="Georgia"/>
                 <a:cs typeface="Georgia"/>
               </a:rPr>
-              <a:t>Evidence safety</a:t>
+              <a:t>Security traceability</a:t>
             </a:r>
           </a:p>
         </p:txBody>
@@ -27369,7 +27735,7 @@
                 <a:ea typeface="Arial"/>
                 <a:cs typeface="Arial"/>
               </a:rPr>
-              <a:t>off-path telemetry · quantified gaps · no prohibited fields</a:t>
+              <a:t>config + request + security correlation · quantified gaps · no prohibited fields</a:t>
             </a:r>
           </a:p>
         </p:txBody>
@@ -28751,7 +29117,7 @@
                 <a:solidFill>
                   <a:srgbClr val="666762"/>
                 </a:solidFill>
-                <a:hlinkClick xmlns:r="http://schemas.openxmlformats.org/officeDocument/2006/relationships" r:id="R68631eaad1bf4d4a"/>
+                <a:hlinkClick xmlns:r="http://schemas.openxmlformats.org/officeDocument/2006/relationships" r:id="R9d6a043af80d4a02"/>
               </a:rPr>
               <a:t>Repo reference</a:t>
             </a:r>
@@ -28768,7 +29134,7 @@
                 <a:solidFill>
                   <a:srgbClr val="666762"/>
                 </a:solidFill>
-                <a:hlinkClick xmlns:r="http://schemas.openxmlformats.org/officeDocument/2006/relationships" r:id="Rb799a19b5ac44ed8"/>
+                <a:hlinkClick xmlns:r="http://schemas.openxmlformats.org/officeDocument/2006/relationships" r:id="R3840573ea64c4e76"/>
               </a:rPr>
               <a:t>Official docs</a:t>
             </a:r>
@@ -29190,7 +29556,7 @@
       </p:sp>
       <p:cxnSp>
         <p:nvCxnSpPr>
-          <p:cNvPr id="205" name=""/>
+          <p:cNvPr id="286" name=""/>
           <p:cNvCxnSpPr>
             <a:stCxn xmlns:a="http://schemas.openxmlformats.org/drawingml/2006/main" id="9" idx="1"/>
             <a:endCxn xmlns:a="http://schemas.openxmlformats.org/drawingml/2006/main" id="12" idx="3"/>
@@ -29395,7 +29761,7 @@
       </p:sp>
       <p:cxnSp>
         <p:nvCxnSpPr>
-          <p:cNvPr id="209" name=""/>
+          <p:cNvPr id="290" name=""/>
           <p:cNvCxnSpPr>
             <a:stCxn xmlns:a="http://schemas.openxmlformats.org/drawingml/2006/main" id="9" idx="1"/>
             <a:endCxn xmlns:a="http://schemas.openxmlformats.org/drawingml/2006/main" id="16" idx="3"/>
@@ -29600,7 +29966,7 @@
       </p:sp>
       <p:cxnSp>
         <p:nvCxnSpPr>
-          <p:cNvPr id="213" name=""/>
+          <p:cNvPr id="294" name=""/>
           <p:cNvCxnSpPr>
             <a:stCxn xmlns:a="http://schemas.openxmlformats.org/drawingml/2006/main" id="9" idx="3"/>
             <a:endCxn xmlns:a="http://schemas.openxmlformats.org/drawingml/2006/main" id="20" idx="1"/>
@@ -29805,7 +30171,7 @@
       </p:sp>
       <p:cxnSp>
         <p:nvCxnSpPr>
-          <p:cNvPr id="217" name=""/>
+          <p:cNvPr id="298" name=""/>
           <p:cNvCxnSpPr>
             <a:stCxn xmlns:a="http://schemas.openxmlformats.org/drawingml/2006/main" id="9" idx="3"/>
             <a:endCxn xmlns:a="http://schemas.openxmlformats.org/drawingml/2006/main" id="24" idx="1"/>
@@ -30094,7 +30460,7 @@
                 <a:ea typeface="Arial"/>
                 <a:cs typeface="Arial"/>
               </a:rPr>
-              <a:t>Comparison input — architecture and delivery</a:t>
+              <a:t>Comparison input — architecture, multicloud and robustness</a:t>
             </a:r>
           </a:p>
         </p:txBody>
@@ -30153,7 +30519,7 @@
                 <a:ea typeface="Arial"/>
                 <a:cs typeface="Arial"/>
               </a:rPr>
-              <a:t>Condensed from the supplied document; validate qualitative labels against versions and evidence.</a:t>
+              <a:t>Supplied labels stay visible; scalability and recovery remain unscored until equivalent execution.</a:t>
             </a:r>
           </a:p>
         </p:txBody>
@@ -30244,7 +30610,7 @@
                 <a:solidFill>
                   <a:srgbClr val="666762"/>
                 </a:solidFill>
-                <a:hlinkClick xmlns:r="http://schemas.openxmlformats.org/officeDocument/2006/relationships" r:id="Rd3188f8e04384b28"/>
+                <a:hlinkClick xmlns:r="http://schemas.openxmlformats.org/officeDocument/2006/relationships" r:id="Rb24633c9f3f440e9"/>
               </a:rPr>
               <a:t>Repo reference</a:t>
             </a:r>
@@ -30261,7 +30627,7 @@
                 <a:solidFill>
                   <a:srgbClr val="666762"/>
                 </a:solidFill>
-                <a:hlinkClick xmlns:r="http://schemas.openxmlformats.org/officeDocument/2006/relationships" r:id="Rd3bcecb3cb084b48"/>
+                <a:hlinkClick xmlns:r="http://schemas.openxmlformats.org/officeDocument/2006/relationships" r:id="R0cd94291b15244a6"/>
               </a:rPr>
               <a:t>Official docs</a:t>
             </a:r>
@@ -30541,7 +30907,7 @@
                     <a:lstStyle/>
                     <a:p>
                       <a:r>
-                        <a:t>Kubernetes</a:t>
+                        <a:t>Kubernetes / GitOps</a:t>
                       </a:r>
                     </a:p>
                   </a:txBody>
@@ -30565,7 +30931,7 @@
                     <a:lstStyle/>
                     <a:p>
                       <a:r>
-                        <a:t>Supplied: Very Good</a:t>
+                        <a:t>Hybrid runtime / tools</a:t>
                       </a:r>
                     </a:p>
                   </a:txBody>
@@ -30577,7 +30943,7 @@
                     <a:lstStyle/>
                     <a:p>
                       <a:r>
-                        <a:t>Supplied: Good</a:t>
+                        <a:t>Supplied: Good / Moderate</a:t>
                       </a:r>
                     </a:p>
                   </a:txBody>
@@ -30589,69 +30955,7 @@
                     <a:lstStyle/>
                     <a:p>
                       <a:r>
-                        <a:t>Run representative proof</a:t>
-                      </a:r>
-                    </a:p>
-                  </a:txBody>
-                  <a:tcPr marL="91440" marR="91440" marT="45720" marB="45720"/>
-                </a:tc>
-              </a:tr>
-              <a:tr h="538843">
-                <a:tc>
-                  <a:txBody>
-                    <a:bodyPr/>
-                    <a:lstStyle/>
-                    <a:p>
-                      <a:r>
-                        <a:t>GitOps</a:t>
-                      </a:r>
-                    </a:p>
-                  </a:txBody>
-                  <a:tcPr marL="91440" marR="91440" marT="45720" marB="45720"/>
-                </a:tc>
-                <a:tc>
-                  <a:txBody>
-                    <a:bodyPr/>
-                    <a:lstStyle/>
-                    <a:p>
-                      <a:r>
-                        <a:t>Supplied: Excellent</a:t>
-                      </a:r>
-                    </a:p>
-                  </a:txBody>
-                  <a:tcPr marL="91440" marR="91440" marT="45720" marB="45720"/>
-                </a:tc>
-                <a:tc>
-                  <a:txBody>
-                    <a:bodyPr/>
-                    <a:lstStyle/>
-                    <a:p>
-                      <a:r>
-                        <a:t>Supplied: Moderate</a:t>
-                      </a:r>
-                    </a:p>
-                  </a:txBody>
-                  <a:tcPr marL="91440" marR="91440" marT="45720" marB="45720"/>
-                </a:tc>
-                <a:tc>
-                  <a:txBody>
-                    <a:bodyPr/>
-                    <a:lstStyle/>
-                    <a:p>
-                      <a:r>
-                        <a:t>Supplied: Moderate</a:t>
-                      </a:r>
-                    </a:p>
-                  </a:txBody>
-                  <a:tcPr marL="91440" marR="91440" marT="45720" marB="45720"/>
-                </a:tc>
-                <a:tc>
-                  <a:txBody>
-                    <a:bodyPr/>
-                    <a:lstStyle/>
-                    <a:p>
-                      <a:r>
-                        <a:t>Measure repeatability</a:t>
+                        <a:t>Versioned delivery proof</a:t>
                       </a:r>
                     </a:p>
                   </a:txBody>
@@ -30677,7 +30981,7 @@
                     <a:lstStyle/>
                     <a:p>
                       <a:r>
-                        <a:t>OTel / Prometheus ecosystem</a:t>
+                        <a:t>OTel / Prometheus</a:t>
                       </a:r>
                     </a:p>
                   </a:txBody>
@@ -30782,6 +31086,68 @@
                   <a:tcPr marL="91440" marR="91440" marT="45720" marB="45720"/>
                 </a:tc>
               </a:tr>
+              <a:tr h="538843">
+                <a:tc>
+                  <a:txBody>
+                    <a:bodyPr/>
+                    <a:lstStyle/>
+                    <a:p>
+                      <a:r>
+                        <a:t>Scalability / robustness</a:t>
+                      </a:r>
+                    </a:p>
+                  </a:txBody>
+                  <a:tcPr marL="91440" marR="91440" marT="45720" marB="45720"/>
+                </a:tc>
+                <a:tc>
+                  <a:txBody>
+                    <a:bodyPr/>
+                    <a:lstStyle/>
+                    <a:p>
+                      <a:r>
+                        <a:t>Not supplied</a:t>
+                      </a:r>
+                    </a:p>
+                  </a:txBody>
+                  <a:tcPr marL="91440" marR="91440" marT="45720" marB="45720"/>
+                </a:tc>
+                <a:tc>
+                  <a:txBody>
+                    <a:bodyPr/>
+                    <a:lstStyle/>
+                    <a:p>
+                      <a:r>
+                        <a:t>Not supplied</a:t>
+                      </a:r>
+                    </a:p>
+                  </a:txBody>
+                  <a:tcPr marL="91440" marR="91440" marT="45720" marB="45720"/>
+                </a:tc>
+                <a:tc>
+                  <a:txBody>
+                    <a:bodyPr/>
+                    <a:lstStyle/>
+                    <a:p>
+                      <a:r>
+                        <a:t>Not supplied</a:t>
+                      </a:r>
+                    </a:p>
+                  </a:txBody>
+                  <a:tcPr marL="91440" marR="91440" marT="45720" marB="45720"/>
+                </a:tc>
+                <a:tc>
+                  <a:txBody>
+                    <a:bodyPr/>
+                    <a:lstStyle/>
+                    <a:p>
+                      <a:r>
+                        <a:t>Load + failure + recovery</a:t>
+                      </a:r>
+                    </a:p>
+                  </a:txBody>
+                  <a:tcPr marL="91440" marR="91440" marT="45720" marB="45720"/>
+                </a:tc>
+              </a:tr>
             </a:tbl>
           </a:graphicData>
         </a:graphic>
@@ -30990,7 +31356,7 @@
                 <a:ea typeface="Arial"/>
                 <a:cs typeface="Arial"/>
               </a:rPr>
-              <a:t>Comparison input — management, experience and AI</a:t>
+              <a:t>Comparison input — management, AI and security traceability</a:t>
             </a:r>
           </a:p>
         </p:txBody>
@@ -31049,7 +31415,7 @@
                 <a:ea typeface="Arial"/>
                 <a:cs typeface="Arial"/>
               </a:rPr>
-              <a:t>Use these claims as hypotheses; capabilities are edition- and date-dependent.</a:t>
+              <a:t>Traceable is a documented third-party path—not proven Kong 3.14 production fit.</a:t>
             </a:r>
           </a:p>
         </p:txBody>
@@ -31140,7 +31506,7 @@
                 <a:solidFill>
                   <a:srgbClr val="666762"/>
                 </a:solidFill>
-                <a:hlinkClick xmlns:r="http://schemas.openxmlformats.org/officeDocument/2006/relationships" r:id="R165806dea2734863"/>
+                <a:hlinkClick xmlns:r="http://schemas.openxmlformats.org/officeDocument/2006/relationships" r:id="R8bf1a861925543f5"/>
               </a:rPr>
               <a:t>Repo reference</a:t>
             </a:r>
@@ -31157,7 +31523,7 @@
                 <a:solidFill>
                   <a:srgbClr val="666762"/>
                 </a:solidFill>
-                <a:hlinkClick xmlns:r="http://schemas.openxmlformats.org/officeDocument/2006/relationships" r:id="R2bed165f4db24f06"/>
+                <a:hlinkClick xmlns:r="http://schemas.openxmlformats.org/officeDocument/2006/relationships" r:id="R6cfd9859a60b4194"/>
               </a:rPr>
               <a:t>Official docs</a:t>
             </a:r>
@@ -31623,7 +31989,7 @@
                     <a:lstStyle/>
                     <a:p>
                       <a:r>
-                        <a:t>Best fit</a:t>
+                        <a:t>Traceable adjunct</a:t>
                       </a:r>
                     </a:p>
                   </a:txBody>
@@ -31635,7 +32001,7 @@
                     <a:lstStyle/>
                     <a:p>
                       <a:r>
-                        <a:t>Platform engineering</a:t>
+                        <a:t>Plugin → Platform Agent</a:t>
                       </a:r>
                     </a:p>
                   </a:txBody>
@@ -31647,7 +32013,7 @@
                     <a:lstStyle/>
                     <a:p>
                       <a:r>
-                        <a:t>Enterprise API programs</a:t>
+                        <a:t>Not assessed</a:t>
                       </a:r>
                     </a:p>
                   </a:txBody>
@@ -31659,7 +32025,7 @@
                     <a:lstStyle/>
                     <a:p>
                       <a:r>
-                        <a:t>Integration-centric organizations</a:t>
+                        <a:t>Custom-policy baseline</a:t>
                       </a:r>
                     </a:p>
                   </a:txBody>
@@ -31671,7 +32037,7 @@
                     <a:lstStyle/>
                     <a:p>
                       <a:r>
-                        <a:t>Conditional archetype; not a universal rank</a:t>
+                        <a:t>Run GEP-07; do not score</a:t>
                       </a:r>
                     </a:p>
                   </a:txBody>
@@ -31886,7 +32252,7 @@
                 <a:ea typeface="Arial"/>
                 <a:cs typeface="Arial"/>
               </a:rPr>
-              <a:t>Comparison input — economics and evidence ceiling</a:t>
+              <a:t>Comparison input — pricing, lock-in and operating duty</a:t>
             </a:r>
           </a:p>
         </p:txBody>
@@ -31945,7 +32311,7 @@
                 <a:ea typeface="Arial"/>
                 <a:cs typeface="Arial"/>
               </a:rPr>
-              <a:t>Cost and lock-in require commercial, operating and exit evidence—not adjectives.</a:t>
+              <a:t>Normalize exact meters, full operating cost, reversibility and control duty—do not rank from public pages.</a:t>
             </a:r>
           </a:p>
         </p:txBody>
@@ -32036,7 +32402,7 @@
                 <a:solidFill>
                   <a:srgbClr val="666762"/>
                 </a:solidFill>
-                <a:hlinkClick xmlns:r="http://schemas.openxmlformats.org/officeDocument/2006/relationships" r:id="R0b2606423ff642c7"/>
+                <a:hlinkClick xmlns:r="http://schemas.openxmlformats.org/officeDocument/2006/relationships" r:id="R7cfe6bd9200c49bf"/>
               </a:rPr>
               <a:t>Repo reference</a:t>
             </a:r>
@@ -32053,7 +32419,7 @@
                 <a:solidFill>
                   <a:srgbClr val="666762"/>
                 </a:solidFill>
-                <a:hlinkClick xmlns:r="http://schemas.openxmlformats.org/officeDocument/2006/relationships" r:id="R9b961b9138084f2d"/>
+                <a:hlinkClick xmlns:r="http://schemas.openxmlformats.org/officeDocument/2006/relationships" r:id="Re896958e520744f3"/>
               </a:rPr>
               <a:t>Official docs</a:t>
             </a:r>
@@ -32234,7 +32600,7 @@
                     <a:lstStyle/>
                     <a:p>
                       <a:r>
-                        <a:t>Vendor lock-in</a:t>
+                        <a:t>Reversibility / lock-in</a:t>
                       </a:r>
                     </a:p>
                   </a:txBody>
@@ -32282,7 +32648,7 @@
                     <a:lstStyle/>
                     <a:p>
                       <a:r>
-                        <a:t>Unverified; prove rebuild + switching</a:t>
+                        <a:t>Timed rebuild + route-back</a:t>
                       </a:r>
                     </a:p>
                   </a:txBody>
@@ -32296,7 +32662,7 @@
                     <a:lstStyle/>
                     <a:p>
                       <a:r>
-                        <a:t>Cost</a:t>
+                        <a:t>Full TCO / pricing</a:t>
                       </a:r>
                     </a:p>
                   </a:txBody>
@@ -32308,7 +32674,7 @@
                     <a:lstStyle/>
                     <a:p>
                       <a:r>
-                        <a:t>Supplied: Low</a:t>
+                        <a:t>Custom quote</a:t>
                       </a:r>
                     </a:p>
                   </a:txBody>
@@ -32320,7 +32686,7 @@
                     <a:lstStyle/>
                     <a:p>
                       <a:r>
-                        <a:t>Supplied: Medium-high</a:t>
+                        <a:t>Managed PAYG ≠ Hybrid</a:t>
                       </a:r>
                     </a:p>
                   </a:txBody>
@@ -32332,7 +32698,7 @@
                     <a:lstStyle/>
                     <a:p>
                       <a:r>
-                        <a:t>Supplied: High</a:t>
+                        <a:t>Contact sales</a:t>
                       </a:r>
                     </a:p>
                   </a:txBody>
@@ -32344,7 +32710,7 @@
                     <a:lstStyle/>
                     <a:p>
                       <a:r>
-                        <a:t>Unverified; quote + labor + HA/DR + telemetry + migration + support + exit</a:t>
+                        <a:t>Quote + labor + infra + HA/DR + adjunct + exit</a:t>
                       </a:r>
                     </a:p>
                   </a:txBody>
@@ -32358,7 +32724,7 @@
                     <a:lstStyle/>
                     <a:p>
                       <a:r>
-                        <a:t>Overall recommendation</a:t>
+                        <a:t>Control-plane duty</a:t>
                       </a:r>
                     </a:p>
                   </a:txBody>
@@ -32370,7 +32736,7 @@
                     <a:lstStyle/>
                     <a:p>
                       <a:r>
-                        <a:t>Preferred</a:t>
+                        <a:t>Enterprise CP + Postgres</a:t>
                       </a:r>
                     </a:p>
                   </a:txBody>
@@ -32382,7 +32748,7 @@
                     <a:lstStyle/>
                     <a:p>
                       <a:r>
-                        <a:t>Second</a:t>
+                        <a:t>Google mgmt + own runtime</a:t>
                       </a:r>
                     </a:p>
                   </a:txBody>
@@ -32394,7 +32760,7 @@
                     <a:lstStyle/>
                     <a:p>
                       <a:r>
-                        <a:t>Third</a:t>
+                        <a:t>Boundary-dependent</a:t>
                       </a:r>
                     </a:p>
                   </a:txBody>
@@ -32406,7 +32772,7 @@
                     <a:lstStyle/>
                     <a:p>
                       <a:r>
-                        <a:t>Stakeholder direction only; no production or comparative proof</a:t>
+                        <a:t>Funded RACI + support + recovery + on-call</a:t>
                       </a:r>
                     </a:p>
                   </a:txBody>
@@ -32502,7 +32868,7 @@
                 <a:ea typeface="Arial"/>
                 <a:cs typeface="Arial"/>
               </a:rPr>
-              <a:t>No commercial or exit claim is decision-grade until equivalent evidence exists.</a:t>
+              <a:t>No price, lock-in or control-duty claim is decision-grade until equivalent evidence exists.</a:t>
             </a:r>
           </a:p>
         </p:txBody>
@@ -32711,7 +33077,7 @@
                 <a:ea typeface="Arial"/>
                 <a:cs typeface="Arial"/>
               </a:rPr>
-              <a:t>Raw scoring inputs — retain for audit, not as production proof</a:t>
+              <a:t>Historical score audit; governed re-score pending</a:t>
             </a:r>
           </a:p>
         </p:txBody>
@@ -32770,7 +33136,7 @@
                 <a:ea typeface="Arial"/>
                 <a:cs typeface="Arial"/>
               </a:rPr>
-              <a:t>Corrected weighted totals are 93 / 85.5 / 77; ratings remain illustrative author inputs.</a:t>
+              <a:t>The original eight rows remain historical input; six added dimensions still have TBD weights and ratings.</a:t>
             </a:r>
           </a:p>
         </p:txBody>
@@ -32861,7 +33227,7 @@
                 <a:solidFill>
                   <a:srgbClr val="666762"/>
                 </a:solidFill>
-                <a:hlinkClick xmlns:r="http://schemas.openxmlformats.org/officeDocument/2006/relationships" r:id="R5abc87e876e44eab"/>
+                <a:hlinkClick xmlns:r="http://schemas.openxmlformats.org/officeDocument/2006/relationships" r:id="Rdf4bda4da7a046c4"/>
               </a:rPr>
               <a:t>Repo reference</a:t>
             </a:r>
@@ -32878,7 +33244,7 @@
                 <a:solidFill>
                   <a:srgbClr val="666762"/>
                 </a:solidFill>
-                <a:hlinkClick xmlns:r="http://schemas.openxmlformats.org/officeDocument/2006/relationships" r:id="R19dc5454ee814d7e"/>
+                <a:hlinkClick xmlns:r="http://schemas.openxmlformats.org/officeDocument/2006/relationships" r:id="R159d120a3db64d42"/>
               </a:rPr>
               <a:t>Official docs</a:t>
             </a:r>
@@ -33841,7 +34207,7 @@
                 <a:ea typeface="Georgia"/>
                 <a:cs typeface="Georgia"/>
               </a:rPr>
-              <a:t>Ordering is unchanged</a:t>
+              <a:t>Historical ordering unchanged</a:t>
             </a:r>
           </a:p>
         </p:txBody>
@@ -33900,7 +34266,7 @@
                 <a:ea typeface="Arial"/>
                 <a:cs typeface="Arial"/>
               </a:rPr>
-              <a:t>Source result: 93 / 87 / 78</a:t>
+              <a:t>Source: 93 / 87 / 78</a:t>
             </a:r>
           </a:p>
           <a:p xmlns:a="http://schemas.openxmlformats.org/drawingml/2006/main">
@@ -33924,7 +34290,7 @@
                 <a:ea typeface="Arial"/>
                 <a:cs typeface="Arial"/>
               </a:rPr>
-              <a:t>Recalculated: 93 / 85.5 / 77</a:t>
+              <a:t>Corrected: 93 / 85.5 / 77</a:t>
             </a:r>
           </a:p>
         </p:txBody>
@@ -34047,7 +34413,7 @@
                 <a:ea typeface="Consolas"/>
                 <a:cs typeface="Consolas"/>
               </a:rPr>
-              <a:t>BEFORE APPROVAL</a:t>
+              <a:t>GOVERNED RE-SCORE</a:t>
             </a:r>
           </a:p>
         </p:txBody>
@@ -34106,7 +34472,7 @@
                 <a:ea typeface="Georgia"/>
                 <a:cs typeface="Georgia"/>
               </a:rPr>
-              <a:t>Add evidence confidence</a:t>
+              <a:t>Six dimensions remain TBD</a:t>
             </a:r>
           </a:p>
         </p:txBody>
@@ -34165,7 +34531,31 @@
                 <a:ea typeface="Arial"/>
                 <a:cs typeface="Arial"/>
               </a:rPr>
-              <a:t>Rubric · scorers · editions · sources · sensitivity · commercial basis · platform labor · migration cost</a:t>
+              <a:t>Multicloud · scale/recovery · security/trace · reversibility · full TCO · CP duty</a:t>
+            </a:r>
+          </a:p>
+          <a:p xmlns:a="http://schemas.openxmlformats.org/drawingml/2006/main">
+            <a:pPr algn="l">
+              <a:buNone/>
+              <a:defRPr sz="1350" b="0" i="0">
+                <a:solidFill>
+                  <a:srgbClr val="686A66"/>
+                </a:solidFill>
+                <a:latin typeface="Arial"/>
+                <a:ea typeface="Arial"/>
+                <a:cs typeface="Arial"/>
+              </a:defRPr>
+            </a:pPr>
+            <a:r>
+              <a:rPr sz="1350" b="0" i="0">
+                <a:solidFill>
+                  <a:srgbClr val="686A66"/>
+                </a:solidFill>
+                <a:latin typeface="Arial"/>
+                <a:ea typeface="Arial"/>
+                <a:cs typeface="Arial"/>
+              </a:rPr>
+              <a:t>No new total before approval</a:t>
             </a:r>
           </a:p>
         </p:txBody>
@@ -34433,7 +34823,7 @@
                 <a:ea typeface="Arial"/>
                 <a:cs typeface="Arial"/>
               </a:rPr>
-              <a:t>Kubernetes and GitOps carry 35%; weights are stakeholder choices, not market facts.</a:t>
+              <a:t>Kubernetes and GitOps carry 35%; the historical eight weights remain unchanged.</a:t>
             </a:r>
           </a:p>
         </p:txBody>
@@ -34524,7 +34914,7 @@
                 <a:solidFill>
                   <a:srgbClr val="666762"/>
                 </a:solidFill>
-                <a:hlinkClick xmlns:r="http://schemas.openxmlformats.org/officeDocument/2006/relationships" r:id="Rb06e53d022ed41e2"/>
+                <a:hlinkClick xmlns:r="http://schemas.openxmlformats.org/officeDocument/2006/relationships" r:id="R9a7e86023198430c"/>
               </a:rPr>
               <a:t>Repo reference</a:t>
             </a:r>
@@ -34541,7 +34931,7 @@
                 <a:solidFill>
                   <a:srgbClr val="666762"/>
                 </a:solidFill>
-                <a:hlinkClick xmlns:r="http://schemas.openxmlformats.org/officeDocument/2006/relationships" r:id="R7245e5aab3a5435a"/>
+                <a:hlinkClick xmlns:r="http://schemas.openxmlformats.org/officeDocument/2006/relationships" r:id="R0fd72cf9e355403c"/>
               </a:rPr>
               <a:t>Official docs</a:t>
             </a:r>
@@ -36165,7 +36555,7 @@
                 <a:ea typeface="Consolas"/>
                 <a:cs typeface="Consolas"/>
               </a:rPr>
-              <a:t>NOT SEPARATELY WEIGHTED</a:t>
+              <a:t>GOVERNED RE-SCORE</a:t>
             </a:r>
           </a:p>
         </p:txBody>
@@ -36224,7 +36614,7 @@
                 <a:ea typeface="Georgia"/>
                 <a:cs typeface="Georgia"/>
               </a:rPr>
-              <a:t>Four decisions remain hidden</a:t>
+              <a:t>Six dimensions stay pending</a:t>
             </a:r>
           </a:p>
         </p:txBody>
@@ -36283,7 +36673,7 @@
                 <a:ea typeface="Arial"/>
                 <a:cs typeface="Arial"/>
               </a:rPr>
-              <a:t>• Developer experience / self-service</a:t>
+              <a:t>• Multicloud / sovereignty</a:t>
             </a:r>
           </a:p>
           <a:p xmlns:a="http://schemas.openxmlformats.org/drawingml/2006/main">
@@ -36307,7 +36697,7 @@
                 <a:ea typeface="Arial"/>
                 <a:cs typeface="Arial"/>
               </a:rPr>
-              <a:t>• Multicloud placement and sovereignty</a:t>
+              <a:t>• Scalability / robustness</a:t>
             </a:r>
           </a:p>
           <a:p xmlns:a="http://schemas.openxmlformats.org/drawingml/2006/main">
@@ -36331,7 +36721,7 @@
                 <a:ea typeface="Arial"/>
                 <a:cs typeface="Arial"/>
               </a:rPr>
-              <a:t>• Migration effort and coexistence</a:t>
+              <a:t>• Security, IAM / traceability</a:t>
             </a:r>
           </a:p>
           <a:p xmlns:a="http://schemas.openxmlformats.org/drawingml/2006/main">
@@ -36355,7 +36745,55 @@
                 <a:ea typeface="Arial"/>
                 <a:cs typeface="Arial"/>
               </a:rPr>
-              <a:t>• Platform labor, HA/DR and commercial TCO</a:t>
+              <a:t>• Reversibility / vendor dependency</a:t>
+            </a:r>
+          </a:p>
+          <a:p xmlns:a="http://schemas.openxmlformats.org/drawingml/2006/main">
+            <a:pPr algn="l">
+              <a:buNone/>
+              <a:defRPr sz="1425" b="0" i="0">
+                <a:solidFill>
+                  <a:srgbClr val="686A66"/>
+                </a:solidFill>
+                <a:latin typeface="Arial"/>
+                <a:ea typeface="Arial"/>
+                <a:cs typeface="Arial"/>
+              </a:defRPr>
+            </a:pPr>
+            <a:r>
+              <a:rPr sz="1425" b="0" i="0">
+                <a:solidFill>
+                  <a:srgbClr val="686A66"/>
+                </a:solidFill>
+                <a:latin typeface="Arial"/>
+                <a:ea typeface="Arial"/>
+                <a:cs typeface="Arial"/>
+              </a:rPr>
+              <a:t>• Fully allocated TCO</a:t>
+            </a:r>
+          </a:p>
+          <a:p xmlns:a="http://schemas.openxmlformats.org/drawingml/2006/main">
+            <a:pPr algn="l">
+              <a:buNone/>
+              <a:defRPr sz="1425" b="0" i="0">
+                <a:solidFill>
+                  <a:srgbClr val="686A66"/>
+                </a:solidFill>
+                <a:latin typeface="Arial"/>
+                <a:ea typeface="Arial"/>
+                <a:cs typeface="Arial"/>
+              </a:defRPr>
+            </a:pPr>
+            <a:r>
+              <a:rPr sz="1425" b="0" i="0">
+                <a:solidFill>
+                  <a:srgbClr val="686A66"/>
+                </a:solidFill>
+                <a:latin typeface="Arial"/>
+                <a:ea typeface="Arial"/>
+                <a:cs typeface="Arial"/>
+              </a:rPr>
+              <a:t>• Control-plane operating duty</a:t>
             </a:r>
           </a:p>
         </p:txBody>
@@ -36414,7 +36852,7 @@
                 <a:ea typeface="Consolas"/>
                 <a:cs typeface="Consolas"/>
               </a:rPr>
-              <a:t>Implication</a:t>
+              <a:t>Rule</a:t>
             </a:r>
           </a:p>
         </p:txBody>
@@ -36449,7 +36887,7 @@
         </p:spPr>
         <p:txBody>
           <a:bodyPr xmlns:a="http://schemas.openxmlformats.org/drawingml/2006/main" wrap="square" lIns="0" tIns="0" rIns="0" bIns="0" anchor="t">
-            <a:normAutofit fontScale="92702"/>
+            <a:normAutofit fontScale="85379"/>
           </a:bodyPr>
           <a:lstStyle xmlns:a="http://schemas.openxmlformats.org/drawingml/2006/main"/>
           <a:p xmlns:a="http://schemas.openxmlformats.org/drawingml/2006/main">
@@ -36473,7 +36911,7 @@
                 <a:ea typeface="Georgia"/>
                 <a:cs typeface="Georgia"/>
               </a:rPr>
-              <a:t>Re-score after the proof programme supplies evidence and sensitivity ranges.</a:t>
+              <a:t>Approve weights, rubric, evidence floor, scorers and sensitivity before any new total.</a:t>
             </a:r>
           </a:p>
         </p:txBody>
@@ -36832,7 +37270,7 @@
                 <a:solidFill>
                   <a:srgbClr val="666762"/>
                 </a:solidFill>
-                <a:hlinkClick xmlns:r="http://schemas.openxmlformats.org/officeDocument/2006/relationships" r:id="Rf75a9349b5be48b1"/>
+                <a:hlinkClick xmlns:r="http://schemas.openxmlformats.org/officeDocument/2006/relationships" r:id="R43e07d92e3c149ef"/>
               </a:rPr>
               <a:t>Repo reference</a:t>
             </a:r>
@@ -36849,7 +37287,7 @@
                 <a:solidFill>
                   <a:srgbClr val="666762"/>
                 </a:solidFill>
-                <a:hlinkClick xmlns:r="http://schemas.openxmlformats.org/officeDocument/2006/relationships" r:id="R18155f8c7edc4c37"/>
+                <a:hlinkClick xmlns:r="http://schemas.openxmlformats.org/officeDocument/2006/relationships" r:id="Ra095d4038fdf44ea"/>
               </a:rPr>
               <a:t>Official docs</a:t>
             </a:r>
@@ -38555,7 +38993,7 @@
                 <a:ea typeface="Arial"/>
                 <a:cs typeface="Arial"/>
               </a:rPr>
-              <a:t>The supplied model puts Kong first—before evidence confidence is applied</a:t>
+              <a:t>Preserve the historical score; govern the re-score</a:t>
             </a:r>
           </a:p>
         </p:txBody>
@@ -38614,7 +39052,7 @@
                 <a:ea typeface="Arial"/>
                 <a:cs typeface="Arial"/>
               </a:rPr>
-              <a:t>Recalculated from the stated weights and ratings; illustrative author scoring only.</a:t>
+              <a:t>Corrected totals remain 93 / 85.5 / 77; added dimensions are pending approval.</a:t>
             </a:r>
           </a:p>
         </p:txBody>
@@ -38705,7 +39143,7 @@
                 <a:solidFill>
                   <a:srgbClr val="666762"/>
                 </a:solidFill>
-                <a:hlinkClick xmlns:r="http://schemas.openxmlformats.org/officeDocument/2006/relationships" r:id="R88879672033d4e82"/>
+                <a:hlinkClick xmlns:r="http://schemas.openxmlformats.org/officeDocument/2006/relationships" r:id="R1499fc48bf18445c"/>
               </a:rPr>
               <a:t>Repo reference</a:t>
             </a:r>
@@ -38722,7 +39160,7 @@
                 <a:solidFill>
                   <a:srgbClr val="666762"/>
                 </a:solidFill>
-                <a:hlinkClick xmlns:r="http://schemas.openxmlformats.org/officeDocument/2006/relationships" r:id="R8122a350462a4292"/>
+                <a:hlinkClick xmlns:r="http://schemas.openxmlformats.org/officeDocument/2006/relationships" r:id="R8dbd86b6b0274c09"/>
               </a:rPr>
               <a:t>Official docs</a:t>
             </a:r>
@@ -39721,7 +40159,7 @@
         </p:spPr>
         <p:txBody>
           <a:bodyPr xmlns:a="http://schemas.openxmlformats.org/drawingml/2006/main" wrap="square" lIns="0" tIns="0" rIns="0" bIns="0" anchor="t">
-            <a:normAutofit fontScale="87150"/>
+            <a:normAutofit fontScale="100000"/>
           </a:bodyPr>
           <a:lstStyle xmlns:a="http://schemas.openxmlformats.org/drawingml/2006/main"/>
           <a:p xmlns:a="http://schemas.openxmlformats.org/drawingml/2006/main">
@@ -39745,7 +40183,7 @@
                 <a:ea typeface="Georgia"/>
                 <a:cs typeface="Georgia"/>
               </a:rPr>
-              <a:t>Do not approve production from this score</a:t>
+              <a:t>Governed re-score pending</a:t>
             </a:r>
           </a:p>
         </p:txBody>
@@ -39804,7 +40242,7 @@
                 <a:ea typeface="Arial"/>
                 <a:cs typeface="Arial"/>
               </a:rPr>
-              <a:t>Missing: scoring rubric · named scorers · evidence map · confidence · sensitivity · editions · commercial basis</a:t>
+              <a:t>No new total until exact options · six dimensions · weights/ranges · rubric · evidence floor · scorers · sensitivity · dissent · approval</a:t>
             </a:r>
           </a:p>
         </p:txBody>
@@ -40163,7 +40601,7 @@
                 <a:solidFill>
                   <a:srgbClr val="666762"/>
                 </a:solidFill>
-                <a:hlinkClick xmlns:r="http://schemas.openxmlformats.org/officeDocument/2006/relationships" r:id="R7846045e644648b2"/>
+                <a:hlinkClick xmlns:r="http://schemas.openxmlformats.org/officeDocument/2006/relationships" r:id="Rf60ec131aa3e47e2"/>
               </a:rPr>
               <a:t>Repo reference</a:t>
             </a:r>
@@ -40180,7 +40618,7 @@
                 <a:solidFill>
                   <a:srgbClr val="666762"/>
                 </a:solidFill>
-                <a:hlinkClick xmlns:r="http://schemas.openxmlformats.org/officeDocument/2006/relationships" r:id="R855dabcda0f84546"/>
+                <a:hlinkClick xmlns:r="http://schemas.openxmlformats.org/officeDocument/2006/relationships" r:id="R1147370ba3824598"/>
               </a:rPr>
               <a:t>Official docs</a:t>
             </a:r>
@@ -41285,7 +41723,7 @@
                 <a:solidFill>
                   <a:srgbClr val="666762"/>
                 </a:solidFill>
-                <a:hlinkClick xmlns:r="http://schemas.openxmlformats.org/officeDocument/2006/relationships" r:id="R40b18f316e974fdb"/>
+                <a:hlinkClick xmlns:r="http://schemas.openxmlformats.org/officeDocument/2006/relationships" r:id="Rf25d17a953474647"/>
               </a:rPr>
               <a:t>Repo reference</a:t>
             </a:r>
@@ -41302,7 +41740,7 @@
                 <a:solidFill>
                   <a:srgbClr val="666762"/>
                 </a:solidFill>
-                <a:hlinkClick xmlns:r="http://schemas.openxmlformats.org/officeDocument/2006/relationships" r:id="R8c4120106ef94e9f"/>
+                <a:hlinkClick xmlns:r="http://schemas.openxmlformats.org/officeDocument/2006/relationships" r:id="Rbdc628a493f24ada"/>
               </a:rPr>
               <a:t>Official docs</a:t>
             </a:r>
@@ -42387,7 +42825,7 @@
                 <a:ea typeface="Arial"/>
                 <a:cs typeface="Arial"/>
               </a:rPr>
-              <a:t>Self-managed control works only if the enterprise funds the duty</a:t>
+              <a:t>Control-plane custody transfers operating accountability</a:t>
             </a:r>
           </a:p>
         </p:txBody>
@@ -42446,7 +42884,7 @@
                 <a:ea typeface="Arial"/>
                 <a:cs typeface="Arial"/>
               </a:rPr>
-              <a:t>Control-plane custody is an operating model—not a free architecture property.</a:t>
+              <a:t>Control advantage must be weighed against permanent CP, database, trust, plugin, support and on-call duty.</a:t>
             </a:r>
           </a:p>
         </p:txBody>
@@ -42537,7 +42975,7 @@
                 <a:solidFill>
                   <a:srgbClr val="666762"/>
                 </a:solidFill>
-                <a:hlinkClick xmlns:r="http://schemas.openxmlformats.org/officeDocument/2006/relationships" r:id="R7788c1b87a914549"/>
+                <a:hlinkClick xmlns:r="http://schemas.openxmlformats.org/officeDocument/2006/relationships" r:id="Rb6ee57469edd4a85"/>
               </a:rPr>
               <a:t>Repo reference</a:t>
             </a:r>
@@ -42554,7 +42992,7 @@
                 <a:solidFill>
                   <a:srgbClr val="666762"/>
                 </a:solidFill>
-                <a:hlinkClick xmlns:r="http://schemas.openxmlformats.org/officeDocument/2006/relationships" r:id="R6bb072e5547e46c8"/>
+                <a:hlinkClick xmlns:r="http://schemas.openxmlformats.org/officeDocument/2006/relationships" r:id="R4164bce6d9c8461f"/>
               </a:rPr>
               <a:t>Official docs</a:t>
             </a:r>
@@ -43124,7 +43562,7 @@
                 <a:ea typeface="Consolas"/>
                 <a:cs typeface="Consolas"/>
               </a:rPr>
-              <a:t>PERMANENT DUTY</a:t>
+              <a:t>OPERATING ACCOUNTABILITY</a:t>
             </a:r>
           </a:p>
         </p:txBody>
@@ -43214,7 +43652,7 @@
                 <a:ea typeface="Arial"/>
                 <a:cs typeface="Arial"/>
               </a:rPr>
-              <a:t>Control-plane service and PostgreSQL HA</a:t>
+              <a:t>Scalability, regional robustness and recovery</a:t>
             </a:r>
           </a:p>
         </p:txBody>
@@ -43304,7 +43742,7 @@
                 <a:ea typeface="Arial"/>
                 <a:cs typeface="Arial"/>
               </a:rPr>
-              <a:t>PKI, certificates and trust admission</a:t>
+              <a:t>Security, IAM, PKI and access lifecycle</a:t>
             </a:r>
           </a:p>
         </p:txBody>
@@ -43394,7 +43832,7 @@
                 <a:ea typeface="Arial"/>
                 <a:cs typeface="Arial"/>
               </a:rPr>
-              <a:t>Backup, restore, upgrade and rollback boundaries</a:t>
+              <a:t>Traceability, evidence custody and privacy</a:t>
             </a:r>
           </a:p>
         </p:txBody>
@@ -43484,7 +43922,7 @@
                 <a:ea typeface="Arial"/>
                 <a:cs typeface="Arial"/>
               </a:rPr>
-              <a:t>24×7 ownership, observability and capacity</a:t>
+              <a:t>Licensing, support and fully allocated TCO</a:t>
             </a:r>
           </a:p>
         </p:txBody>
@@ -43519,7 +43957,7 @@
         </p:spPr>
         <p:txBody>
           <a:bodyPr xmlns:a="http://schemas.openxmlformats.org/drawingml/2006/main" wrap="square" lIns="0" tIns="0" rIns="0" bIns="0" anchor="t">
-            <a:normAutofit fontScale="98159"/>
+            <a:normAutofit fontScale="100000"/>
           </a:bodyPr>
           <a:lstStyle xmlns:a="http://schemas.openxmlformats.org/drawingml/2006/main"/>
           <a:p xmlns:a="http://schemas.openxmlformats.org/drawingml/2006/main">
@@ -43543,7 +43981,7 @@
                 <a:ea typeface="Georgia"/>
                 <a:cs typeface="Georgia"/>
               </a:rPr>
-              <a:t>Answer changes when custody is only a preference—or the enterprise will not fund this duty.</a:t>
+              <a:t>Operating responsibility exposure—not a legal-liability determination.</a:t>
             </a:r>
           </a:p>
         </p:txBody>
@@ -43902,7 +44340,7 @@
                 <a:solidFill>
                   <a:srgbClr val="666762"/>
                 </a:solidFill>
-                <a:hlinkClick xmlns:r="http://schemas.openxmlformats.org/officeDocument/2006/relationships" r:id="R5ae7d99a0a57461a"/>
+                <a:hlinkClick xmlns:r="http://schemas.openxmlformats.org/officeDocument/2006/relationships" r:id="R6018f5851e4b41c1"/>
               </a:rPr>
               <a:t>Repo reference</a:t>
             </a:r>
@@ -43919,7 +44357,7 @@
                 <a:solidFill>
                   <a:srgbClr val="666762"/>
                 </a:solidFill>
-                <a:hlinkClick xmlns:r="http://schemas.openxmlformats.org/officeDocument/2006/relationships" r:id="R20627e867ec94bc7"/>
+                <a:hlinkClick xmlns:r="http://schemas.openxmlformats.org/officeDocument/2006/relationships" r:id="Rb56598cfbfc2479c"/>
               </a:rPr>
               <a:t>Official docs</a:t>
             </a:r>
@@ -44446,7 +44884,7 @@
       </p:sp>
       <p:cxnSp>
         <p:nvCxnSpPr>
-          <p:cNvPr id="345" name=""/>
+          <p:cNvPr id="480" name=""/>
           <p:cNvCxnSpPr>
             <a:stCxn xmlns:a="http://schemas.openxmlformats.org/drawingml/2006/main" id="16" idx="0"/>
             <a:endCxn xmlns:a="http://schemas.openxmlformats.org/drawingml/2006/main" id="10" idx="2"/>
@@ -44472,7 +44910,7 @@
       </p:cxnSp>
       <p:cxnSp>
         <p:nvCxnSpPr>
-          <p:cNvPr id="346" name=""/>
+          <p:cNvPr id="481" name=""/>
           <p:cNvCxnSpPr>
             <a:stCxn xmlns:a="http://schemas.openxmlformats.org/drawingml/2006/main" id="10" idx="2"/>
             <a:endCxn xmlns:a="http://schemas.openxmlformats.org/drawingml/2006/main" id="13" idx="0"/>
@@ -45016,7 +45454,7 @@
       </p:sp>
       <p:cxnSp>
         <p:nvCxnSpPr>
-          <p:cNvPr id="357" name=""/>
+          <p:cNvPr id="492" name=""/>
           <p:cNvCxnSpPr>
             <a:stCxn xmlns:a="http://schemas.openxmlformats.org/drawingml/2006/main" id="10" idx="3"/>
             <a:endCxn xmlns:a="http://schemas.openxmlformats.org/drawingml/2006/main" id="21" idx="1"/>
@@ -45044,7 +45482,7 @@
       </p:cxnSp>
       <p:cxnSp>
         <p:nvCxnSpPr>
-          <p:cNvPr id="358" name=""/>
+          <p:cNvPr id="493" name=""/>
           <p:cNvCxnSpPr>
             <a:stCxn xmlns:a="http://schemas.openxmlformats.org/drawingml/2006/main" id="10" idx="3"/>
             <a:endCxn xmlns:a="http://schemas.openxmlformats.org/drawingml/2006/main" id="24" idx="1"/>
@@ -45072,7 +45510,7 @@
       </p:cxnSp>
       <p:cxnSp>
         <p:nvCxnSpPr>
-          <p:cNvPr id="359" name=""/>
+          <p:cNvPr id="494" name=""/>
           <p:cNvCxnSpPr>
             <a:stCxn xmlns:a="http://schemas.openxmlformats.org/drawingml/2006/main" id="10" idx="3"/>
             <a:endCxn xmlns:a="http://schemas.openxmlformats.org/drawingml/2006/main" id="27" idx="1"/>
@@ -45618,7 +46056,7 @@
       </p:sp>
       <p:cxnSp>
         <p:nvCxnSpPr>
-          <p:cNvPr id="370" name=""/>
+          <p:cNvPr id="505" name=""/>
           <p:cNvCxnSpPr>
             <a:stCxn xmlns:a="http://schemas.openxmlformats.org/drawingml/2006/main" id="21" idx="3"/>
             <a:endCxn xmlns:a="http://schemas.openxmlformats.org/drawingml/2006/main" id="34" idx="1"/>
@@ -45644,7 +46082,7 @@
       </p:cxnSp>
       <p:cxnSp>
         <p:nvCxnSpPr>
-          <p:cNvPr id="371" name=""/>
+          <p:cNvPr id="506" name=""/>
           <p:cNvCxnSpPr>
             <a:stCxn xmlns:a="http://schemas.openxmlformats.org/drawingml/2006/main" id="24" idx="3"/>
             <a:endCxn xmlns:a="http://schemas.openxmlformats.org/drawingml/2006/main" id="37" idx="1"/>
@@ -45670,7 +46108,7 @@
       </p:cxnSp>
       <p:cxnSp>
         <p:nvCxnSpPr>
-          <p:cNvPr id="372" name=""/>
+          <p:cNvPr id="507" name=""/>
           <p:cNvCxnSpPr>
             <a:stCxn xmlns:a="http://schemas.openxmlformats.org/drawingml/2006/main" id="27" idx="3"/>
             <a:endCxn xmlns:a="http://schemas.openxmlformats.org/drawingml/2006/main" id="40" idx="1"/>

</xml_diff>

<commit_message>
Expand Kong evaluation assurance and migration evidence (#15)
</commit_message>
<xml_diff>
--- a/presentations/kong-platform-journey-guided.pptx
+++ b/presentations/kong-platform-journey-guided.pptx
@@ -2,37 +2,37 @@
 <file path=ppt/presentation.xml><?xml version="1.0" encoding="utf-8"?>
 <p:presentation xmlns:p="http://schemas.openxmlformats.org/presentationml/2006/main">
   <p:sldMasterIdLst>
-    <p:sldMasterId xmlns:r="http://schemas.openxmlformats.org/officeDocument/2006/relationships" id="2147483648" r:id="R4b62eac0a0cd43bc"/>
+    <p:sldMasterId xmlns:r="http://schemas.openxmlformats.org/officeDocument/2006/relationships" id="2147483648" r:id="R60c804bd99cd4a7a"/>
   </p:sldMasterIdLst>
   <p:notesMasterIdLst>
-    <p:notesMasterId xmlns:r="http://schemas.openxmlformats.org/officeDocument/2006/relationships" r:id="Refe22afccc0d4e1a"/>
+    <p:notesMasterId xmlns:r="http://schemas.openxmlformats.org/officeDocument/2006/relationships" r:id="R8ea8645e99654ead"/>
   </p:notesMasterIdLst>
   <p:sldIdLst>
-    <p:sldId xmlns:r="http://schemas.openxmlformats.org/officeDocument/2006/relationships" id="256" r:id="Rc6a22fd6916c46a5"/>
-    <p:sldId xmlns:r="http://schemas.openxmlformats.org/officeDocument/2006/relationships" id="257" r:id="Ra7e3628821c34229"/>
-    <p:sldId xmlns:r="http://schemas.openxmlformats.org/officeDocument/2006/relationships" id="258" r:id="Re8002fe98f9a42d1"/>
-    <p:sldId xmlns:r="http://schemas.openxmlformats.org/officeDocument/2006/relationships" id="259" r:id="Rc80315ab95cf42b1"/>
-    <p:sldId xmlns:r="http://schemas.openxmlformats.org/officeDocument/2006/relationships" id="260" r:id="R5c6b2909eb3e4df9"/>
-    <p:sldId xmlns:r="http://schemas.openxmlformats.org/officeDocument/2006/relationships" id="261" r:id="R5c1cd965b7ff4d7b"/>
-    <p:sldId xmlns:r="http://schemas.openxmlformats.org/officeDocument/2006/relationships" id="262" r:id="Rc5f2f188bebf49fd"/>
-    <p:sldId xmlns:r="http://schemas.openxmlformats.org/officeDocument/2006/relationships" id="263" r:id="Re9eed9a85c4a48d3"/>
-    <p:sldId xmlns:r="http://schemas.openxmlformats.org/officeDocument/2006/relationships" id="264" r:id="R750b450220544c72"/>
-    <p:sldId xmlns:r="http://schemas.openxmlformats.org/officeDocument/2006/relationships" id="265" r:id="R57e1cabdedf149e4"/>
-    <p:sldId xmlns:r="http://schemas.openxmlformats.org/officeDocument/2006/relationships" id="266" r:id="R846a6820178b4e14"/>
-    <p:sldId xmlns:r="http://schemas.openxmlformats.org/officeDocument/2006/relationships" id="267" r:id="Rb255afcb79a748fc"/>
-    <p:sldId xmlns:r="http://schemas.openxmlformats.org/officeDocument/2006/relationships" id="268" r:id="R37b6d047d744418a"/>
-    <p:sldId xmlns:r="http://schemas.openxmlformats.org/officeDocument/2006/relationships" id="269" r:id="R9b550ffc8dad46a3"/>
-    <p:sldId xmlns:r="http://schemas.openxmlformats.org/officeDocument/2006/relationships" id="270" r:id="R1160fb4fb332414e"/>
-    <p:sldId xmlns:r="http://schemas.openxmlformats.org/officeDocument/2006/relationships" id="271" r:id="Rc2f0d51e11b5401b"/>
-    <p:sldId xmlns:r="http://schemas.openxmlformats.org/officeDocument/2006/relationships" id="272" r:id="R1b5e7818dade4164"/>
-    <p:sldId xmlns:r="http://schemas.openxmlformats.org/officeDocument/2006/relationships" id="273" r:id="Rb1592122740b4f1e"/>
-    <p:sldId xmlns:r="http://schemas.openxmlformats.org/officeDocument/2006/relationships" id="274" r:id="R1b496fcf14bb44f8"/>
-    <p:sldId xmlns:r="http://schemas.openxmlformats.org/officeDocument/2006/relationships" id="275" r:id="R4c87fe7f9aeb4b65"/>
-    <p:sldId xmlns:r="http://schemas.openxmlformats.org/officeDocument/2006/relationships" id="276" r:id="R99acaf84a52e4c79"/>
-    <p:sldId xmlns:r="http://schemas.openxmlformats.org/officeDocument/2006/relationships" id="277" r:id="R8e1755772fd54b80"/>
-    <p:sldId xmlns:r="http://schemas.openxmlformats.org/officeDocument/2006/relationships" id="278" r:id="R148767c57b5d446b"/>
-    <p:sldId xmlns:r="http://schemas.openxmlformats.org/officeDocument/2006/relationships" id="279" r:id="R3cc1731bb15940fb"/>
-    <p:sldId xmlns:r="http://schemas.openxmlformats.org/officeDocument/2006/relationships" id="280" r:id="R92122c1c0de34d4d"/>
+    <p:sldId xmlns:r="http://schemas.openxmlformats.org/officeDocument/2006/relationships" id="256" r:id="R60417037ab624d4e"/>
+    <p:sldId xmlns:r="http://schemas.openxmlformats.org/officeDocument/2006/relationships" id="257" r:id="R2c199ce8f9684364"/>
+    <p:sldId xmlns:r="http://schemas.openxmlformats.org/officeDocument/2006/relationships" id="258" r:id="R48ce7bd25dec4235"/>
+    <p:sldId xmlns:r="http://schemas.openxmlformats.org/officeDocument/2006/relationships" id="259" r:id="Re4762e8e39b04711"/>
+    <p:sldId xmlns:r="http://schemas.openxmlformats.org/officeDocument/2006/relationships" id="260" r:id="R16fd0fd65f784461"/>
+    <p:sldId xmlns:r="http://schemas.openxmlformats.org/officeDocument/2006/relationships" id="261" r:id="Re445c32833474ff5"/>
+    <p:sldId xmlns:r="http://schemas.openxmlformats.org/officeDocument/2006/relationships" id="262" r:id="R08461cd261c94f1e"/>
+    <p:sldId xmlns:r="http://schemas.openxmlformats.org/officeDocument/2006/relationships" id="263" r:id="Rffb9be0cbc5f4415"/>
+    <p:sldId xmlns:r="http://schemas.openxmlformats.org/officeDocument/2006/relationships" id="264" r:id="Rf781b49f08324795"/>
+    <p:sldId xmlns:r="http://schemas.openxmlformats.org/officeDocument/2006/relationships" id="265" r:id="R5bb1afb818294251"/>
+    <p:sldId xmlns:r="http://schemas.openxmlformats.org/officeDocument/2006/relationships" id="266" r:id="R6790b2e26b3a419a"/>
+    <p:sldId xmlns:r="http://schemas.openxmlformats.org/officeDocument/2006/relationships" id="267" r:id="R9804fcbc98614d06"/>
+    <p:sldId xmlns:r="http://schemas.openxmlformats.org/officeDocument/2006/relationships" id="268" r:id="R10e24505592b4505"/>
+    <p:sldId xmlns:r="http://schemas.openxmlformats.org/officeDocument/2006/relationships" id="269" r:id="Rcd5635638bcd45b5"/>
+    <p:sldId xmlns:r="http://schemas.openxmlformats.org/officeDocument/2006/relationships" id="270" r:id="Rd58c9f084f0b46b5"/>
+    <p:sldId xmlns:r="http://schemas.openxmlformats.org/officeDocument/2006/relationships" id="271" r:id="Rec23cc3e4a1e43dc"/>
+    <p:sldId xmlns:r="http://schemas.openxmlformats.org/officeDocument/2006/relationships" id="272" r:id="Rb5ae40211be346ad"/>
+    <p:sldId xmlns:r="http://schemas.openxmlformats.org/officeDocument/2006/relationships" id="273" r:id="R803f531d739240e5"/>
+    <p:sldId xmlns:r="http://schemas.openxmlformats.org/officeDocument/2006/relationships" id="274" r:id="R9ad9ab9f0b6a4e70"/>
+    <p:sldId xmlns:r="http://schemas.openxmlformats.org/officeDocument/2006/relationships" id="275" r:id="Rf59d9b1dddb24942"/>
+    <p:sldId xmlns:r="http://schemas.openxmlformats.org/officeDocument/2006/relationships" id="276" r:id="Rb14b10d23ac14a3a"/>
+    <p:sldId xmlns:r="http://schemas.openxmlformats.org/officeDocument/2006/relationships" id="277" r:id="R30310c1fae894f85"/>
+    <p:sldId xmlns:r="http://schemas.openxmlformats.org/officeDocument/2006/relationships" id="278" r:id="R4dc361fa1cda4753"/>
+    <p:sldId xmlns:r="http://schemas.openxmlformats.org/officeDocument/2006/relationships" id="279" r:id="R6eefa3814d5a4a13"/>
+    <p:sldId xmlns:r="http://schemas.openxmlformats.org/officeDocument/2006/relationships" id="280" r:id="Re9286a7dffdd4137"/>
   </p:sldIdLst>
   <p:sldSz cx="12192000" cy="6858000"/>
   <p:notesSz cx="6858000" cy="9144000"/>
@@ -1536,7 +1536,7 @@
           </a:p>
           <a:p xmlns:a="http://schemas.openxmlformats.org/drawingml/2006/main">
             <a:r>
-              <a:t>Sequence migration by evidence complexity rather than package count.</a:t>
+              <a:t>Use one stable-edge and evidence-gate doctrine while preserving the different migration units and state boundaries of Mule and Apigee.</a:t>
             </a:r>
           </a:p>
           <a:p xmlns:a="http://schemas.openxmlformats.org/drawingml/2006/main">
@@ -1551,7 +1551,7 @@
           </a:p>
           <a:p xmlns:a="http://schemas.openxmlformats.org/drawingml/2006/main">
             <a:r>
-              <a:t>M0 establishes inventory and safety; M1 handles gateway-dominant work; M2 proves representative hard integrations; M3 establishes the domain factory; M4 resolves the connector and batch tail; M5 retires the shared runtime only after dependency zero.</a:t>
+              <a:t>For Mule, M0 establishes inventory and safety; M1 handles gateway-dominant work; M2 proves representative hard integrations; M3 establishes the domain factory; M4 resolves the connector and batch tail; and M5 retires the shared runtime only after dependency zero. For Apigee, A0 inventories the complete object/state graph; A1 classifies semantic disposition; A2 builds a reversible target; A3 proves a hard representative slice; A4 runs bounded coexistence; A5 collects production-canary evidence; and A6 closes technical, operating, recovery, data, support, and commercial dependency zero.</a:t>
             </a:r>
           </a:p>
           <a:p xmlns:a="http://schemas.openxmlformats.org/drawingml/2006/main">
@@ -1566,7 +1566,7 @@
           </a:p>
           <a:p xmlns:a="http://schemas.openxmlformats.org/drawingml/2006/main">
             <a:r>
-              <a:t>Adopt entry/exit evidence as the wave control, not elapsed time or migrated object count.</a:t>
+              <a:t>Confirm the actual source archetype, choose the relevant rail, and adopt entry/exit evidence rather than elapsed time, package count, or exported proxy count. Assign migration architecture, API product, IAM/security, SRE, domain, FinOps/sourcing, and independent-review roles.</a:t>
             </a:r>
           </a:p>
           <a:p xmlns:a="http://schemas.openxmlformats.org/drawingml/2006/main">
@@ -1596,7 +1596,7 @@
           </a:p>
           <a:p xmlns:a="http://schemas.openxmlformats.org/drawingml/2006/main">
             <a:r>
-              <a:t>These phases are scenario planning. They do not assert current programme progress or duration.</a:t>
+              <a:t>These phases are proposed and not run. They do not assert current programme progress, duration, object count, converter success, or semantic parity. The terminology crosswalk supplies nearest analogues only; each mapping still requires behavior, state, lifecycle, authority, evidence, and ownership proof.</a:t>
             </a:r>
           </a:p>
           <a:p xmlns:a="http://schemas.openxmlformats.org/drawingml/2006/main">
@@ -1611,7 +1611,42 @@
           </a:p>
           <a:p xmlns:a="http://schemas.openxmlformats.org/drawingml/2006/main">
             <a:r>
-              <a:t>- docs/35-mule-migration-strategy.md</a:t>
+              <a:t>- 35-mule-migration-strategy.md</a:t>
+            </a:r>
+          </a:p>
+          <a:p xmlns:a="http://schemas.openxmlformats.org/drawingml/2006/main">
+            <a:r>
+              <a:t>- 50-apigee-migration-strategy.md#proposed-a0a6-migration-roadmap</a:t>
+            </a:r>
+          </a:p>
+          <a:p xmlns:a="http://schemas.openxmlformats.org/drawingml/2006/main">
+            <a:r>
+              <a:t>- 48-kong-guided-evaluation.md</a:t>
+            </a:r>
+          </a:p>
+          <a:p xmlns:a="http://schemas.openxmlformats.org/drawingml/2006/main">
+            <a:r>
+              <a:t>- ../research/glossary.md#kong-terminology-crosswalk</a:t>
+            </a:r>
+          </a:p>
+          <a:p xmlns:a="http://schemas.openxmlformats.org/drawingml/2006/main">
+            <a:r>
+              <a:t>- https://docs.mulesoft.com/gateway/latest/</a:t>
+            </a:r>
+          </a:p>
+          <a:p xmlns:a="http://schemas.openxmlformats.org/drawingml/2006/main">
+            <a:r>
+              <a:t>- https://docs.cloud.google.com/apigee/docs/api-platform/fundamentals/download-api-proxies</a:t>
+            </a:r>
+          </a:p>
+          <a:p xmlns:a="http://schemas.openxmlformats.org/drawingml/2006/main">
+            <a:r>
+              <a:t>- https://docs.cloud.google.com/apigee/docs/api-platform/reference/api-proxy-configuration-reference</a:t>
+            </a:r>
+          </a:p>
+          <a:p xmlns:a="http://schemas.openxmlformats.org/drawingml/2006/main">
+            <a:r>
+              <a:t>- https://developer.konghq.com/gateway/deployment-topologies/</a:t>
             </a:r>
           </a:p>
         </p:txBody>
@@ -1856,7 +1891,7 @@
           </a:p>
           <a:p xmlns:a="http://schemas.openxmlformats.org/drawingml/2006/main">
             <a:r>
-              <a:t>This is not a larger feature demonstration. Each workstream needs a representative environment, named owner, test method, measure, acceptance artifact, threshold and stop condition. The agentic-gateway study remains separate so emerging capabilities do not inflate confidence in the core gateway.</a:t>
+              <a:t>This is not a larger feature demonstration. GEP-01–06 prove the target, APIOps, regional resilience, enterprise IAM, separate agentic study, and evidence-gated recommendation. GEP-07 is a separate security-adjunct feasibility line for Kong plus Traceable against the security team’s Mule baseline. Each workstream needs a representative environment, public role owner, exact BOM, method, measure, acceptance artifact, threshold, independent reviewer, and stop condition.</a:t>
             </a:r>
           </a:p>
           <a:p xmlns:a="http://schemas.openxmlformats.org/drawingml/2006/main">
@@ -1871,7 +1906,7 @@
           </a:p>
           <a:p xmlns:a="http://schemas.openxmlformats.org/drawingml/2006/main">
             <a:r>
-              <a:t>Approve these six workstreams, their owners, capacity and evidence budget—not production scale.</a:t>
+              <a:t>Approve these seven workstreams, their role owners, capacity, evidence budget, reviewers, and stop authority—not production scale and not a Traceable production recommendation.</a:t>
             </a:r>
           </a:p>
           <a:p xmlns:a="http://schemas.openxmlformats.org/drawingml/2006/main">
@@ -1901,7 +1936,7 @@
           </a:p>
           <a:p xmlns:a="http://schemas.openxmlformats.org/drawingml/2006/main">
             <a:r>
-              <a:t>These are required proof activities, not completed results. Verify the Kong Enterprise 3.14 edition, licensing and support status before claiming any capability; retain explicit not-run states.</a:t>
+              <a:t>These are required proof activities, not completed results. For GEP-07, current documentation supports only an `E1` plugin/agent feasibility path. It does not certify the exact Kong Enterprise 3.14 patch, plugin/TPA/EDS BOM, topology, entitlement, support, performance, protocol/payload/streaming coverage, data handling, fail behavior, comparative parity, lifecycle, cost, or production outcome.</a:t>
             </a:r>
           </a:p>
           <a:p xmlns:a="http://schemas.openxmlformats.org/drawingml/2006/main">
@@ -1916,7 +1951,42 @@
           </a:p>
           <a:p xmlns:a="http://schemas.openxmlformats.org/drawingml/2006/main">
             <a:r>
-              <a:t>- docs/48-kong-guided-evaluation.md#six-workstream-target-aligned-proof-programme</a:t>
+              <a:t>- 48-kong-guided-evaluation.md#seven-workstream-target-aligned-proof-programme</a:t>
+            </a:r>
+          </a:p>
+          <a:p xmlns:a="http://schemas.openxmlformats.org/drawingml/2006/main">
+            <a:r>
+              <a:t>- 48-kong-guided-evaluation.md#traceable-by-harness-security-adjunct-feasibility</a:t>
+            </a:r>
+          </a:p>
+          <a:p xmlns:a="http://schemas.openxmlformats.org/drawingml/2006/main">
+            <a:r>
+              <a:t>- https://developer.konghq.com/gateway/version-support-policy/</a:t>
+            </a:r>
+          </a:p>
+          <a:p xmlns:a="http://schemas.openxmlformats.org/drawingml/2006/main">
+            <a:r>
+              <a:t>- https://developer.konghq.com/gateway/hybrid-mode/</a:t>
+            </a:r>
+          </a:p>
+          <a:p xmlns:a="http://schemas.openxmlformats.org/drawingml/2006/main">
+            <a:r>
+              <a:t>- https://developer.konghq.com/gateway/monitoring/</a:t>
+            </a:r>
+          </a:p>
+          <a:p xmlns:a="http://schemas.openxmlformats.org/drawingml/2006/main">
+            <a:r>
+              <a:t>- https://developer.konghq.com/ai-gateway/</a:t>
+            </a:r>
+          </a:p>
+          <a:p xmlns:a="http://schemas.openxmlformats.org/drawingml/2006/main">
+            <a:r>
+              <a:t>- https://docs.traceable.ai/docs/kong</a:t>
+            </a:r>
+          </a:p>
+          <a:p xmlns:a="http://schemas.openxmlformats.org/drawingml/2006/main">
+            <a:r>
+              <a:t>- https://developer.konghq.com/plugins/harness-waap/</a:t>
             </a:r>
           </a:p>
         </p:txBody>
@@ -2306,7 +2376,7 @@
           </a:p>
           <a:p xmlns:a="http://schemas.openxmlformats.org/drawingml/2006/main">
             <a:r>
-              <a:t>Capacity and evidence safety matter, but so do adoption, operating sustainability, exit readiness and accurate estate ownership. Telemetry must stay off the critical path, gaps must be quantified, and prohibited fields must remain absent.</a:t>
+              <a:t>Capacity and evidence safety matter, but so do adoption, operating sustainability, exit readiness and accurate estate ownership. KO-7 is an outcome: administrative/configuration audit, request and security-decision correlation, business evidence, quantified produced/queued/dropped/delivered gaps, and prohibited-field control. Traceable may be one candidate mechanism, but no product name can make KO-7 pass.</a:t>
             </a:r>
           </a:p>
           <a:p xmlns:a="http://schemas.openxmlformats.org/drawingml/2006/main">
@@ -2321,7 +2391,7 @@
           </a:p>
           <a:p xmlns:a="http://schemas.openxmlformats.org/drawingml/2006/main">
             <a:r>
-              <a:t>Confirm which outcome is currently the likely scale blocker and who owns its evidence.</a:t>
+              <a:t>Confirm which outcome is currently the likely scale blocker, which public role owns it, and whether any Traceable dependency is being treated as a mechanism to prove rather than an achieved outcome.</a:t>
             </a:r>
           </a:p>
           <a:p xmlns:a="http://schemas.openxmlformats.org/drawingml/2006/main">
@@ -2351,7 +2421,7 @@
           </a:p>
           <a:p xmlns:a="http://schemas.openxmlformats.org/drawingml/2006/main">
             <a:r>
-              <a:t>These are acceptance categories; no result is asserted on this slide.</a:t>
+              <a:t>These are acceptance categories; no result is asserted on this slide. GEP-07 evidence may inform KO-7 only inside its exact tested boundary and cannot substitute for configuration audit, signal-gap accounting, business correlation, or enterprise evidence controls.</a:t>
             </a:r>
           </a:p>
           <a:p xmlns:a="http://schemas.openxmlformats.org/drawingml/2006/main">
@@ -2366,7 +2436,37 @@
           </a:p>
           <a:p xmlns:a="http://schemas.openxmlformats.org/drawingml/2006/main">
             <a:r>
-              <a:t>- docs/47-kong-enterprise-platform-strategy.md</a:t>
+              <a:t>- 47-kong-enterprise-platform-strategy.md</a:t>
+            </a:r>
+          </a:p>
+          <a:p xmlns:a="http://schemas.openxmlformats.org/drawingml/2006/main">
+            <a:r>
+              <a:t>- 48-kong-guided-evaluation.md</a:t>
+            </a:r>
+          </a:p>
+          <a:p xmlns:a="http://schemas.openxmlformats.org/drawingml/2006/main">
+            <a:r>
+              <a:t>- 48-kong-guided-evaluation.md#traceable-by-harness-security-adjunct-feasibility</a:t>
+            </a:r>
+          </a:p>
+          <a:p xmlns:a="http://schemas.openxmlformats.org/drawingml/2006/main">
+            <a:r>
+              <a:t>- https://developer.konghq.com/gateway/hybrid-mode/</a:t>
+            </a:r>
+          </a:p>
+          <a:p xmlns:a="http://schemas.openxmlformats.org/drawingml/2006/main">
+            <a:r>
+              <a:t>- https://developer.konghq.com/gateway/monitoring/</a:t>
+            </a:r>
+          </a:p>
+          <a:p xmlns:a="http://schemas.openxmlformats.org/drawingml/2006/main">
+            <a:r>
+              <a:t>- https://docs.traceable.ai/docs/kong</a:t>
+            </a:r>
+          </a:p>
+          <a:p xmlns:a="http://schemas.openxmlformats.org/drawingml/2006/main">
+            <a:r>
+              <a:t>- https://developer.konghq.com/plugins/harness-waap/</a:t>
             </a:r>
           </a:p>
         </p:txBody>
@@ -2591,7 +2691,7 @@
           </a:p>
           <a:p xmlns:a="http://schemas.openxmlformats.org/drawingml/2006/main">
             <a:r>
-              <a:t>Preserve the source document's architectural comparison without turning it into a dense main-story slide.</a:t>
+              <a:t>Preserve the sanitized supplied evaluation’s architectural comparison while making the new multicloud, scalability, and robustness obligations explicit.</a:t>
             </a:r>
           </a:p>
           <a:p xmlns:a="http://schemas.openxmlformats.org/drawingml/2006/main">
@@ -2606,7 +2706,7 @@
           </a:p>
           <a:p xmlns:a="http://schemas.openxmlformats.org/drawingml/2006/main">
             <a:r>
-              <a:t>The supplied labels are shown explicitly as supplied assessments. Official documentation supports the high-level deployment models, but the relative ratings require an evidence rubric and versioned testing.</a:t>
+              <a:t>The supplied labels remain stakeholder assessments preserved in docs/48. Official documentation supports high-level deployment mechanisms, not relative outcomes. GEC-19 keeps scalability and robustness explicitly unscored until equivalent target-shaped load, saturation, clean-node scale, failure, recovery, and reconciliation evidence exists. Multicloud must separate runtime placement from management dependency, sovereignty, failure independence, support, and operating cost.</a:t>
             </a:r>
           </a:p>
           <a:p xmlns:a="http://schemas.openxmlformats.org/drawingml/2006/main">
@@ -2621,7 +2721,7 @@
           </a:p>
           <a:p xmlns:a="http://schemas.openxmlformats.org/drawingml/2006/main">
             <a:r>
-              <a:t>Use this table to identify proof questions, not to re-litigate the feature list in the room.</a:t>
+              <a:t>Use this table to assign symmetric architecture/SRE proof questions, not to add favorable labels or ratings in the room.</a:t>
             </a:r>
           </a:p>
           <a:p xmlns:a="http://schemas.openxmlformats.org/drawingml/2006/main">
@@ -2651,7 +2751,7 @@
           </a:p>
           <a:p xmlns:a="http://schemas.openxmlformats.org/drawingml/2006/main">
             <a:r>
-              <a:t>Qualitative ratings are not independently validated and may change by edition and release.</a:t>
+              <a:t>Qualitative ratings are not independently validated and may change by exact edition, release, topology, entitlement, workload, region, dependency, and operating model. “Multicloud” and “scalable” are not scoreable yes/no features.</a:t>
             </a:r>
           </a:p>
           <a:p xmlns:a="http://schemas.openxmlformats.org/drawingml/2006/main">
@@ -2666,7 +2766,22 @@
           </a:p>
           <a:p xmlns:a="http://schemas.openxmlformats.org/drawingml/2006/main">
             <a:r>
-              <a:t>- docs/48-kong-guided-evaluation.md#supplied-comparison-input-architecture-and-delivery</a:t>
+              <a:t>- 48-kong-guided-evaluation.md#supplied-comparison-input-architecture-and-delivery</a:t>
+            </a:r>
+          </a:p>
+          <a:p xmlns:a="http://schemas.openxmlformats.org/drawingml/2006/main">
+            <a:r>
+              <a:t>- 48-kong-guided-evaluation.md#meeting-feedback-assurance-crosswalk</a:t>
+            </a:r>
+          </a:p>
+          <a:p xmlns:a="http://schemas.openxmlformats.org/drawingml/2006/main">
+            <a:r>
+              <a:t>- 48-kong-guided-evaluation.md#proposed-governed-re-score</a:t>
+            </a:r>
+          </a:p>
+          <a:p xmlns:a="http://schemas.openxmlformats.org/drawingml/2006/main">
+            <a:r>
+              <a:t>- https://developer.konghq.com/gateway/deployment-topologies/</a:t>
             </a:r>
           </a:p>
           <a:p xmlns:a="http://schemas.openxmlformats.org/drawingml/2006/main">
@@ -2676,12 +2791,22 @@
           </a:p>
           <a:p xmlns:a="http://schemas.openxmlformats.org/drawingml/2006/main">
             <a:r>
+              <a:t>- https://developer.konghq.com/ai-gateway/</a:t>
+            </a:r>
+          </a:p>
+          <a:p xmlns:a="http://schemas.openxmlformats.org/drawingml/2006/main">
+            <a:r>
               <a:t>- https://docs.cloud.google.com/apigee/docs/hybrid/v1.16/what-is-hybrid</a:t>
             </a:r>
           </a:p>
           <a:p xmlns:a="http://schemas.openxmlformats.org/drawingml/2006/main">
             <a:r>
               <a:t>- https://docs.mulesoft.com/gateway/latest/</a:t>
+            </a:r>
+          </a:p>
+          <a:p xmlns:a="http://schemas.openxmlformats.org/drawingml/2006/main">
+            <a:r>
+              <a:t>- https://learn.microsoft.com/en-us/azure/api-management/self-hosted-gateway-overview</a:t>
             </a:r>
           </a:p>
         </p:txBody>
@@ -2756,7 +2881,7 @@
           </a:p>
           <a:p xmlns:a="http://schemas.openxmlformats.org/drawingml/2006/main">
             <a:r>
-              <a:t>Preserve the management and experience claims while making their evidence status explicit.</a:t>
+              <a:t>Preserve the management and experience claims while making emerging AI and third-party security-adjunct evidence boundaries explicit.</a:t>
             </a:r>
           </a:p>
           <a:p xmlns:a="http://schemas.openxmlformats.org/drawingml/2006/main">
@@ -2771,7 +2896,7 @@
           </a:p>
           <a:p xmlns:a="http://schemas.openxmlformats.org/drawingml/2006/main">
             <a:r>
-              <a:t>Lifecycle, governance, portal, developer experience, AI, customization, and best-fit claims must be tested against the required use cases. AI capabilities are changing rapidly and should always be dated and versioned.</a:t>
+              <a:t>Lifecycle, governance, portal, developer experience, AI, customization, and best-fit claims must be tested against required use cases. GEC-20 records Kong-plus-Traceable as documented feasibility only: a plugin/agent path does not prove exact 3.14 support, security effectiveness, traceability, data safety, performance, scaling, comparative parity, cost, or safe lifecycle behavior.</a:t>
             </a:r>
           </a:p>
           <a:p xmlns:a="http://schemas.openxmlformats.org/drawingml/2006/main">
@@ -2786,7 +2911,7 @@
           </a:p>
           <a:p xmlns:a="http://schemas.openxmlformats.org/drawingml/2006/main">
             <a:r>
-              <a:t>Move every unverified adjective into the proof backlog with an owner and artifact.</a:t>
+              <a:t>Move every unverified adjective into the proof backlog with a public role owner, exact option/BOM, artifact, reviewer, and stop rule. Confirm that Traceable remains GEP-07 rather than a gateway option or score.</a:t>
             </a:r>
           </a:p>
           <a:p xmlns:a="http://schemas.openxmlformats.org/drawingml/2006/main">
@@ -2816,7 +2941,7 @@
           </a:p>
           <a:p xmlns:a="http://schemas.openxmlformats.org/drawingml/2006/main">
             <a:r>
-              <a:t>Product capability and commercial terms are edition- and date-dependent.</a:t>
+              <a:t>Product, plugin, agent, entitlement, support, and commercial terms are edition-, version-, topology-, and date-dependent. Current Traceable/Kong documentation is `E1` mechanism evidence only.</a:t>
             </a:r>
           </a:p>
           <a:p xmlns:a="http://schemas.openxmlformats.org/drawingml/2006/main">
@@ -2831,7 +2956,17 @@
           </a:p>
           <a:p xmlns:a="http://schemas.openxmlformats.org/drawingml/2006/main">
             <a:r>
-              <a:t>- docs/48-kong-guided-evaluation.md#supplied-comparison-input-management-experience-and-ai</a:t>
+              <a:t>- 48-kong-guided-evaluation.md#supplied-comparison-input-management-experience-and-ai</a:t>
+            </a:r>
+          </a:p>
+          <a:p xmlns:a="http://schemas.openxmlformats.org/drawingml/2006/main">
+            <a:r>
+              <a:t>- 48-kong-guided-evaluation.md#traceable-by-harness-security-adjunct-feasibility</a:t>
+            </a:r>
+          </a:p>
+          <a:p xmlns:a="http://schemas.openxmlformats.org/drawingml/2006/main">
+            <a:r>
+              <a:t>- https://developer.konghq.com/gateway/deployment-topologies/</a:t>
             </a:r>
           </a:p>
           <a:p xmlns:a="http://schemas.openxmlformats.org/drawingml/2006/main">
@@ -2841,12 +2976,32 @@
           </a:p>
           <a:p xmlns:a="http://schemas.openxmlformats.org/drawingml/2006/main">
             <a:r>
+              <a:t>- https://docs.traceable.ai/docs/kong</a:t>
+            </a:r>
+          </a:p>
+          <a:p xmlns:a="http://schemas.openxmlformats.org/drawingml/2006/main">
+            <a:r>
+              <a:t>- https://developer.konghq.com/plugins/harness-waap/</a:t>
+            </a:r>
+          </a:p>
+          <a:p xmlns:a="http://schemas.openxmlformats.org/drawingml/2006/main">
+            <a:r>
+              <a:t>- https://docs.traceable.ai/docs/tracing-agents-rule-evaluation-for-protection</a:t>
+            </a:r>
+          </a:p>
+          <a:p xmlns:a="http://schemas.openxmlformats.org/drawingml/2006/main">
+            <a:r>
+              <a:t>- https://docs.cloud.google.com/apigee/docs/hybrid/v1.16/what-is-hybrid</a:t>
+            </a:r>
+          </a:p>
+          <a:p xmlns:a="http://schemas.openxmlformats.org/drawingml/2006/main">
+            <a:r>
               <a:t>- https://docs.mulesoft.com/gateway/latest/</a:t>
             </a:r>
           </a:p>
           <a:p xmlns:a="http://schemas.openxmlformats.org/drawingml/2006/main">
             <a:r>
-              <a:t>- https://docs.cloud.google.com/apigee/docs/hybrid/v1.16/what-is-hybrid</a:t>
+              <a:t>- https://learn.microsoft.com/en-us/azure/api-management/self-hosted-gateway-overview</a:t>
             </a:r>
           </a:p>
         </p:txBody>
@@ -2921,7 +3076,7 @@
           </a:p>
           <a:p xmlns:a="http://schemas.openxmlformats.org/drawingml/2006/main">
             <a:r>
-              <a:t>Expose the economic and exit claims as proof obligations rather than conclusions.</a:t>
+              <a:t>Expose pricing, operating-duty, adjunct-cost, lock-in, and exit claims as separate proof obligations rather than conclusions.</a:t>
             </a:r>
           </a:p>
           <a:p xmlns:a="http://schemas.openxmlformats.org/drawingml/2006/main">
@@ -2936,7 +3091,7 @@
           </a:p>
           <a:p xmlns:a="http://schemas.openxmlformats.org/drawingml/2006/main">
             <a:r>
-              <a:t>Cost and lock-in cannot be inferred from topology. They require quotes, platform labor, HA/DR, support, observability, portal/product tooling, network and egress, migration effort, and an exit rehearsal.</a:t>
+              <a:t>Public price pages define meters or quote boundaries, not a comparable price rank. Fully allocated TCO requires exact options and quotes plus infrastructure, PostgreSQL, PKI, platform/SRE/on-call labor, HA/DR, telemetry, portal/product tooling, network/egress, plugins and security adjuncts, support, migration, dual run, incident exposure, custody switch, and clean exit. Lock-in requires an observed representative non-source rebuild and a ledger of configuration/policy, identity/product state, data/analytics, plugin, procedure, support, and commercial dependencies.</a:t>
             </a:r>
           </a:p>
           <a:p xmlns:a="http://schemas.openxmlformats.org/drawingml/2006/main">
@@ -2951,7 +3106,7 @@
           </a:p>
           <a:p xmlns:a="http://schemas.openxmlformats.org/drawingml/2006/main">
             <a:r>
-              <a:t>Assign owners and artifacts for TCO, custody and exit evidence.</a:t>
+              <a:t>Assign public FinOps, sourcing, platform/SRE, security-adjunct, migration, and independent-review roles for the normalized low/base/high model, rebuild, custody switch, and clean-exit evidence.</a:t>
             </a:r>
           </a:p>
           <a:p xmlns:a="http://schemas.openxmlformats.org/drawingml/2006/main">
@@ -2981,7 +3136,7 @@
           </a:p>
           <a:p xmlns:a="http://schemas.openxmlformats.org/drawingml/2006/main">
             <a:r>
-              <a:t>Commercial terms and estate leverage are organization- and date-specific.</a:t>
+              <a:t>Commercial terms and estate leverage are organization- and date-specific. Do not publish restricted quotes. The public record should expose meter/quote boundaries, assumptions, role ownership, evidence state, and disposition only. Operating accountability is not a legal-liability verdict.</a:t>
             </a:r>
           </a:p>
           <a:p xmlns:a="http://schemas.openxmlformats.org/drawingml/2006/main">
@@ -2996,7 +3151,42 @@
           </a:p>
           <a:p xmlns:a="http://schemas.openxmlformats.org/drawingml/2006/main">
             <a:r>
-              <a:t>- docs/48-kong-guided-evaluation.md#supplied-comparison-input-economics-and-evidence-ceiling</a:t>
+              <a:t>- 48-kong-guided-evaluation.md#supplied-comparison-input-economics-and-evidence-ceiling</a:t>
+            </a:r>
+          </a:p>
+          <a:p xmlns:a="http://schemas.openxmlformats.org/drawingml/2006/main">
+            <a:r>
+              <a:t>- 48-kong-guided-evaluation.md#proposed-governed-re-score</a:t>
+            </a:r>
+          </a:p>
+          <a:p xmlns:a="http://schemas.openxmlformats.org/drawingml/2006/main">
+            <a:r>
+              <a:t>- https://konghq.com/pricing</a:t>
+            </a:r>
+          </a:p>
+          <a:p xmlns:a="http://schemas.openxmlformats.org/drawingml/2006/main">
+            <a:r>
+              <a:t>- https://cloud.google.com/apigee/pricing</a:t>
+            </a:r>
+          </a:p>
+          <a:p xmlns:a="http://schemas.openxmlformats.org/drawingml/2006/main">
+            <a:r>
+              <a:t>- https://www.mulesoft.com/anypoint-pricing</a:t>
+            </a:r>
+          </a:p>
+          <a:p xmlns:a="http://schemas.openxmlformats.org/drawingml/2006/main">
+            <a:r>
+              <a:t>- https://developer.konghq.com/gateway/deployment-topologies/</a:t>
+            </a:r>
+          </a:p>
+          <a:p xmlns:a="http://schemas.openxmlformats.org/drawingml/2006/main">
+            <a:r>
+              <a:t>- https://docs.cloud.google.com/apigee/docs/hybrid/v1.16/what-is-hybrid</a:t>
+            </a:r>
+          </a:p>
+          <a:p xmlns:a="http://schemas.openxmlformats.org/drawingml/2006/main">
+            <a:r>
+              <a:t>- https://docs.traceable.ai/docs/kong</a:t>
             </a:r>
           </a:p>
         </p:txBody>
@@ -3071,7 +3261,7 @@
           </a:p>
           <a:p xmlns:a="http://schemas.openxmlformats.org/drawingml/2006/main">
             <a:r>
-              <a:t>Provide an auditable record of the source scorecard without elevating it above its evidence level.</a:t>
+              <a:t>Provide an auditable record of the source scorecard while making the unfinished governed recalculation visible.</a:t>
             </a:r>
           </a:p>
           <a:p xmlns:a="http://schemas.openxmlformats.org/drawingml/2006/main">
@@ -3086,7 +3276,7 @@
           </a:p>
           <a:p xmlns:a="http://schemas.openxmlformats.org/drawingml/2006/main">
             <a:r>
-              <a:t>The inputs are copied from the supplied document. Recalculating weight times rating yields 93 for Kong, 85.5 for Apigee and 77 for MuleSoft. This appendix preserves transparency and makes the evidence backlog explicit.</a:t>
+              <a:t>The inputs are preserved from the sanitized supplied evaluation. Recalculating weight times rating yields 93 for Kong, 85.5 for Apigee, and 77 for MuleSoft. Those values remain historical stakeholder input. `GRS-01`–`GRS-06` adds multicloud, scalability/robustness, security/IAM/traceability, reversibility/vendor dependency, fully allocated TCO, and control-plane operating responsibility to a future governed specification; every added weight and rating remains `TBD`.</a:t>
             </a:r>
           </a:p>
           <a:p xmlns:a="http://schemas.openxmlformats.org/drawingml/2006/main">
@@ -3101,7 +3291,7 @@
           </a:p>
           <a:p xmlns:a="http://schemas.openxmlformats.org/drawingml/2006/main">
             <a:r>
-              <a:t>If the scorecard remains a governance artifact, add confidence, sensitivity and accountable sign-off.</a:t>
+              <a:t>If the scorecard remains a governance artifact, approve exact options, mandatory gates, the scoring rubric, score-capable common evidence, dimensions and weights/ranges, confidence/unknown treatment, role-based scorers and approvers, sensitivity, lower/upper bounds, maximum regret, dissent, and independent sign-off. Do not calculate a new total in the room.</a:t>
             </a:r>
           </a:p>
           <a:p xmlns:a="http://schemas.openxmlformats.org/drawingml/2006/main">
@@ -3131,7 +3321,7 @@
           </a:p>
           <a:p xmlns:a="http://schemas.openxmlformats.org/drawingml/2006/main">
             <a:r>
-              <a:t>Scores are illustrative author inputs, not an independent benchmark or production outcome.</a:t>
+              <a:t>Scores are illustrative stakeholder inputs, not an independent benchmark or production outcome. The pending re-score cannot be tuned to preserve a preferred order, and unknown evidence cannot silently become zero or earn points.</a:t>
             </a:r>
           </a:p>
           <a:p xmlns:a="http://schemas.openxmlformats.org/drawingml/2006/main">
@@ -3146,7 +3336,42 @@
           </a:p>
           <a:p xmlns:a="http://schemas.openxmlformats.org/drawingml/2006/main">
             <a:r>
-              <a:t>- docs/48-kong-guided-evaluation.md#supplied-scoring-audit</a:t>
+              <a:t>- 48-kong-guided-evaluation.md#supplied-scoring-audit</a:t>
+            </a:r>
+          </a:p>
+          <a:p xmlns:a="http://schemas.openxmlformats.org/drawingml/2006/main">
+            <a:r>
+              <a:t>- 48-kong-guided-evaluation.md#proposed-governed-re-score</a:t>
+            </a:r>
+          </a:p>
+          <a:p xmlns:a="http://schemas.openxmlformats.org/drawingml/2006/main">
+            <a:r>
+              <a:t>- ../decision-matrix/scoring-guide.md</a:t>
+            </a:r>
+          </a:p>
+          <a:p xmlns:a="http://schemas.openxmlformats.org/drawingml/2006/main">
+            <a:r>
+              <a:t>- https://developer.konghq.com/gateway/deployment-topologies/</a:t>
+            </a:r>
+          </a:p>
+          <a:p xmlns:a="http://schemas.openxmlformats.org/drawingml/2006/main">
+            <a:r>
+              <a:t>- https://developer.konghq.com/ai-gateway/</a:t>
+            </a:r>
+          </a:p>
+          <a:p xmlns:a="http://schemas.openxmlformats.org/drawingml/2006/main">
+            <a:r>
+              <a:t>- https://docs.cloud.google.com/apigee/docs/hybrid/v1.16/what-is-hybrid</a:t>
+            </a:r>
+          </a:p>
+          <a:p xmlns:a="http://schemas.openxmlformats.org/drawingml/2006/main">
+            <a:r>
+              <a:t>- https://docs.mulesoft.com/gateway/latest/</a:t>
+            </a:r>
+          </a:p>
+          <a:p xmlns:a="http://schemas.openxmlformats.org/drawingml/2006/main">
+            <a:r>
+              <a:t>- https://learn.microsoft.com/en-us/azure/api-management/self-hosted-gateway-overview</a:t>
             </a:r>
           </a:p>
         </p:txBody>
@@ -3221,7 +3446,7 @@
           </a:p>
           <a:p xmlns:a="http://schemas.openxmlformats.org/drawingml/2006/main">
             <a:r>
-              <a:t>Make the decision model transparent before showing a result.</a:t>
+              <a:t>Make the historical weighting model transparent and expose the dimensions required for a governed re-score.</a:t>
             </a:r>
           </a:p>
           <a:p xmlns:a="http://schemas.openxmlformats.org/drawingml/2006/main">
@@ -3236,7 +3461,7 @@
           </a:p>
           <a:p xmlns:a="http://schemas.openxmlformats.org/drawingml/2006/main">
             <a:r>
-              <a:t>Eight weighted categories sum to 100%. Developer experience and multicloud appear in the narrative but not as distinct weights. Migration effort and operating labor are also absent, so the score is a directional preference model, not a full business case.</a:t>
+              <a:t>Eight supplied categories sum to 100%, and Kubernetes plus GitOps carry 35%. Multicloud, robustness, reversibility/vendor dependency, fully allocated TCO, and control-plane operating responsibility are absent or compressed in that simplified model, but they are already present in the canonical 120-criterion matrix. The proposed `GRS-01`–`GRS-06` specification exposes them without duplicating the taxonomy. Its weights and ratings remain `TBD`.</a:t>
             </a:r>
           </a:p>
           <a:p xmlns:a="http://schemas.openxmlformats.org/drawingml/2006/main">
@@ -3251,7 +3476,7 @@
           </a:p>
           <a:p xmlns:a="http://schemas.openxmlformats.org/drawingml/2006/main">
             <a:r>
-              <a:t>Confirm the weights and add sensitivity ranges before using them as an approval mechanism.</a:t>
+              <a:t>Approve the re-score dimensions, exact-option boundary, mandatory gates, evidence floor, role-based scorer and approver panel, weight ranges, confidence treatment, sensitivity method, dissent rule, and permitted decision use. Do not assign ratings in this meeting.</a:t>
             </a:r>
           </a:p>
           <a:p xmlns:a="http://schemas.openxmlformats.org/drawingml/2006/main">
@@ -3281,7 +3506,7 @@
           </a:p>
           <a:p xmlns:a="http://schemas.openxmlformats.org/drawingml/2006/main">
             <a:r>
-              <a:t>Ratings lack a documented rubric, named scorers, evidence confidence, product edition and sensitivity analysis.</a:t>
+              <a:t>The proposed re-score is pending, not a revised ranking. Ratings still lack an approved rubric, score-capable evidence, exact options, scorer panel, confidence, common-evidence treatment, bounds, maximum-regret analysis, and sensitivity approval.</a:t>
             </a:r>
           </a:p>
           <a:p xmlns:a="http://schemas.openxmlformats.org/drawingml/2006/main">
@@ -3296,7 +3521,32 @@
           </a:p>
           <a:p xmlns:a="http://schemas.openxmlformats.org/drawingml/2006/main">
             <a:r>
-              <a:t>- docs/48-kong-guided-evaluation.md#supplied-weighting-model</a:t>
+              <a:t>- 48-kong-guided-evaluation.md#supplied-weighting-model</a:t>
+            </a:r>
+          </a:p>
+          <a:p xmlns:a="http://schemas.openxmlformats.org/drawingml/2006/main">
+            <a:r>
+              <a:t>- 48-kong-guided-evaluation.md#meeting-feedback-assurance-crosswalk</a:t>
+            </a:r>
+          </a:p>
+          <a:p xmlns:a="http://schemas.openxmlformats.org/drawingml/2006/main">
+            <a:r>
+              <a:t>- 48-kong-guided-evaluation.md#proposed-governed-re-score</a:t>
+            </a:r>
+          </a:p>
+          <a:p xmlns:a="http://schemas.openxmlformats.org/drawingml/2006/main">
+            <a:r>
+              <a:t>- ../decision-matrix/scoring-guide.md</a:t>
+            </a:r>
+          </a:p>
+          <a:p xmlns:a="http://schemas.openxmlformats.org/drawingml/2006/main">
+            <a:r>
+              <a:t>- https://developer.konghq.com/gateway/deployment-topologies/</a:t>
+            </a:r>
+          </a:p>
+          <a:p xmlns:a="http://schemas.openxmlformats.org/drawingml/2006/main">
+            <a:r>
+              <a:t>- https://developer.konghq.com/gateway/hybrid-mode/</a:t>
             </a:r>
           </a:p>
         </p:txBody>
@@ -3556,7 +3806,7 @@
           </a:p>
           <a:p xmlns:a="http://schemas.openxmlformats.org/drawingml/2006/main">
             <a:r>
-              <a:t>The Kong total is 93. The same formula yields 85.5 for Apigee and 77 for MuleSoft, rather than 87 and 78 in the source results table. The ordering is unchanged, but the arithmetic and evidence limits matter.</a:t>
+              <a:t>The historical inputs recalculate to 93 for Kong, 85.5 for Apigee, and 77 for MuleSoft rather than 87 and 78 in the source results table. Preserve those inputs and the correction for audit. Do not publish an expanded total until `GRS-01`–`GRS-06`, exact options, mandatory gates, rubric, score-capable evidence, weights, confidence, scorer panel, sensitivity, bounds, regret treatment, and dissent are approved.</a:t>
             </a:r>
           </a:p>
           <a:p xmlns:a="http://schemas.openxmlformats.org/drawingml/2006/main">
@@ -3571,7 +3821,7 @@
           </a:p>
           <a:p xmlns:a="http://schemas.openxmlformats.org/drawingml/2006/main">
             <a:r>
-              <a:t>Treat the result as a directional preference to test, not a selection proof.</a:t>
+              <a:t>Confirm that the historical score remains directional preference input only, then assign role ownership for a governed recalculation that is allowed to change—not preserve—the order.</a:t>
             </a:r>
           </a:p>
           <a:p xmlns:a="http://schemas.openxmlformats.org/drawingml/2006/main">
@@ -3601,7 +3851,7 @@
           </a:p>
           <a:p xmlns:a="http://schemas.openxmlformats.org/drawingml/2006/main">
             <a:r>
-              <a:t>No sensitivity analysis or confidence adjustment has been applied. Exact scores should stay out of external claims.</a:t>
+              <a:t>No governed recalculation has been run. The added dimensions still have `TBD` weights and ratings, and the historical scores should not be presented as an independent benchmark, confidence percentage, or production-fit result.</a:t>
             </a:r>
           </a:p>
           <a:p xmlns:a="http://schemas.openxmlformats.org/drawingml/2006/main">
@@ -3616,7 +3866,37 @@
           </a:p>
           <a:p xmlns:a="http://schemas.openxmlformats.org/drawingml/2006/main">
             <a:r>
-              <a:t>- docs/48-kong-guided-evaluation.md#supplied-scoring-audit</a:t>
+              <a:t>- 48-kong-guided-evaluation.md#supplied-scoring-audit</a:t>
+            </a:r>
+          </a:p>
+          <a:p xmlns:a="http://schemas.openxmlformats.org/drawingml/2006/main">
+            <a:r>
+              <a:t>- 48-kong-guided-evaluation.md#proposed-governed-re-score</a:t>
+            </a:r>
+          </a:p>
+          <a:p xmlns:a="http://schemas.openxmlformats.org/drawingml/2006/main">
+            <a:r>
+              <a:t>- ../decision-matrix/scoring-guide.md</a:t>
+            </a:r>
+          </a:p>
+          <a:p xmlns:a="http://schemas.openxmlformats.org/drawingml/2006/main">
+            <a:r>
+              <a:t>- https://developer.konghq.com/gateway/deployment-topologies/</a:t>
+            </a:r>
+          </a:p>
+          <a:p xmlns:a="http://schemas.openxmlformats.org/drawingml/2006/main">
+            <a:r>
+              <a:t>- https://docs.cloud.google.com/apigee/docs/hybrid/v1.16/what-is-hybrid</a:t>
+            </a:r>
+          </a:p>
+          <a:p xmlns:a="http://schemas.openxmlformats.org/drawingml/2006/main">
+            <a:r>
+              <a:t>- https://docs.mulesoft.com/gateway/latest/</a:t>
+            </a:r>
+          </a:p>
+          <a:p xmlns:a="http://schemas.openxmlformats.org/drawingml/2006/main">
+            <a:r>
+              <a:t>- https://learn.microsoft.com/en-us/azure/api-management/self-hosted-gateway-overview</a:t>
             </a:r>
           </a:p>
         </p:txBody>
@@ -3996,7 +4276,7 @@
           </a:p>
           <a:p xmlns:a="http://schemas.openxmlformats.org/drawingml/2006/main">
             <a:r>
-              <a:t>Make the cost side of the target operating boundary visible.</a:t>
+              <a:t>Make the accountability, risk, and fully allocated cost side of the target operating boundary visible without making an unsupported legal conclusion.</a:t>
             </a:r>
           </a:p>
           <a:p xmlns:a="http://schemas.openxmlformats.org/drawingml/2006/main">
@@ -4011,7 +4291,7 @@
           </a:p>
           <a:p xmlns:a="http://schemas.openxmlformats.org/drawingml/2006/main">
             <a:r>
-              <a:t>The same custody that makes self-managed Kong attractive also creates permanent CP, database, PKI, upgrade, restore and 24×7 obligations. Those duties must have named owners and funded capacity.</a:t>
+              <a:t>The same custody that makes self-managed Kong attractive transfers permanent CP, PostgreSQL, PKI, Admin API, plugin/license, audit, upgrade, restore, support, and 24×7 service duties to enterprise roles. Cached data-plane service narrows one failure consequence; it does not remove control-plane recovery, urgent mutation/revocation, clean-node scale, reconciliation, or service accountability.</a:t>
             </a:r>
           </a:p>
           <a:p xmlns:a="http://schemas.openxmlformats.org/drawingml/2006/main">
@@ -4026,7 +4306,7 @@
           </a:p>
           <a:p xmlns:a="http://schemas.openxmlformats.org/drawingml/2006/main">
             <a:r>
-              <a:t>Confirm whether these duties belong inside the enterprise platform operating model.</a:t>
+              <a:t>Confirm whether platform product, database/SRE, PKI/security, release engineering, service management, sourcing/FinOps, and support roles accept the duty, capacity, objectives, evidence, and escalation path.</a:t>
             </a:r>
           </a:p>
           <a:p xmlns:a="http://schemas.openxmlformats.org/drawingml/2006/main">
@@ -4056,7 +4336,7 @@
           </a:p>
           <a:p xmlns:a="http://schemas.openxmlformats.org/drawingml/2006/main">
             <a:r>
-              <a:t>Control-plane outage continuity does not imply mutation, revocation or recovery guarantees; those are separate tests.</a:t>
+              <a:t>This is an operating-accountability and risk-exposure statement. Contractual allocation depends on exact support and commercial evidence; legal liability requires counsel in the approved restricted process. Control-plane continuity does not imply mutation, revocation, clean-node admission, or recovery guarantees.</a:t>
             </a:r>
           </a:p>
           <a:p xmlns:a="http://schemas.openxmlformats.org/drawingml/2006/main">
@@ -4071,12 +4351,27 @@
           </a:p>
           <a:p xmlns:a="http://schemas.openxmlformats.org/drawingml/2006/main">
             <a:r>
+              <a:t>- 47-kong-enterprise-platform-strategy.md</a:t>
+            </a:r>
+          </a:p>
+          <a:p xmlns:a="http://schemas.openxmlformats.org/drawingml/2006/main">
+            <a:r>
+              <a:t>- 48-kong-guided-evaluation.md</a:t>
+            </a:r>
+          </a:p>
+          <a:p xmlns:a="http://schemas.openxmlformats.org/drawingml/2006/main">
+            <a:r>
+              <a:t>- ../research/glossary.md#kong-terminology-crosswalk</a:t>
+            </a:r>
+          </a:p>
+          <a:p xmlns:a="http://schemas.openxmlformats.org/drawingml/2006/main">
+            <a:r>
               <a:t>- https://developer.konghq.com/gateway/hybrid-mode/</a:t>
             </a:r>
           </a:p>
           <a:p xmlns:a="http://schemas.openxmlformats.org/drawingml/2006/main">
             <a:r>
-              <a:t>- docs/47-kong-enterprise-platform-strategy.md</a:t>
+              <a:t>- https://developer.konghq.com/gateway/version-support-policy/</a:t>
             </a:r>
           </a:p>
         </p:txBody>
@@ -4299,7 +4594,7 @@
   </p:cSld>
   <p:clrMap bg1="lt1" tx1="dk1" bg2="lt2" tx2="dk2" accent1="accent1" accent2="accent2" accent3="accent3" accent4="accent4" accent5="accent5" accent6="accent6" hlink="hlink" folHlink="folHlink"/>
   <p:sldLayoutIdLst>
-    <p:sldLayoutId xmlns:r="http://schemas.openxmlformats.org/officeDocument/2006/relationships" id="2147483649" r:id="R67ba9097afc64f3f"/>
+    <p:sldLayoutId xmlns:r="http://schemas.openxmlformats.org/officeDocument/2006/relationships" id="2147483649" r:id="R919bba39c6d941da"/>
   </p:sldLayoutIdLst>
   <p:txStyles>
     <p:titleStyle>
@@ -5601,7 +5896,7 @@
                 <a:solidFill>
                   <a:srgbClr val="666762"/>
                 </a:solidFill>
-                <a:hlinkClick xmlns:r="http://schemas.openxmlformats.org/officeDocument/2006/relationships" r:id="Rbbf0e434237d45b8"/>
+                <a:hlinkClick xmlns:r="http://schemas.openxmlformats.org/officeDocument/2006/relationships" r:id="R063df1eeff244169"/>
               </a:rPr>
               <a:t>Repo reference</a:t>
             </a:r>
@@ -5618,7 +5913,7 @@
                 <a:solidFill>
                   <a:srgbClr val="666762"/>
                 </a:solidFill>
-                <a:hlinkClick xmlns:r="http://schemas.openxmlformats.org/officeDocument/2006/relationships" r:id="Rfe537a1e1a0844bf"/>
+                <a:hlinkClick xmlns:r="http://schemas.openxmlformats.org/officeDocument/2006/relationships" r:id="Rabfc1b3f59d745bf"/>
               </a:rPr>
               <a:t>Official docs</a:t>
             </a:r>
@@ -5979,7 +6274,7 @@
                 <a:solidFill>
                   <a:srgbClr val="666762"/>
                 </a:solidFill>
-                <a:hlinkClick xmlns:r="http://schemas.openxmlformats.org/officeDocument/2006/relationships" r:id="R0a801d7f63804d41"/>
+                <a:hlinkClick xmlns:r="http://schemas.openxmlformats.org/officeDocument/2006/relationships" r:id="Rf1f8380c03b349e3"/>
               </a:rPr>
               <a:t>Repo reference</a:t>
             </a:r>
@@ -5996,7 +6291,7 @@
                 <a:solidFill>
                   <a:srgbClr val="666762"/>
                 </a:solidFill>
-                <a:hlinkClick xmlns:r="http://schemas.openxmlformats.org/officeDocument/2006/relationships" r:id="R1d3dcd7ae7b94e35"/>
+                <a:hlinkClick xmlns:r="http://schemas.openxmlformats.org/officeDocument/2006/relationships" r:id="R6ce6f9e3429549b3"/>
               </a:rPr>
               <a:t>Official docs</a:t>
             </a:r>
@@ -7285,7 +7580,7 @@
                 <a:solidFill>
                   <a:srgbClr val="666762"/>
                 </a:solidFill>
-                <a:hlinkClick xmlns:r="http://schemas.openxmlformats.org/officeDocument/2006/relationships" r:id="Rced0b2ba97b540b7"/>
+                <a:hlinkClick xmlns:r="http://schemas.openxmlformats.org/officeDocument/2006/relationships" r:id="Rafbb0ef3c20f4602"/>
               </a:rPr>
               <a:t>Repo reference</a:t>
             </a:r>
@@ -7302,7 +7597,7 @@
                 <a:solidFill>
                   <a:srgbClr val="666762"/>
                 </a:solidFill>
-                <a:hlinkClick xmlns:r="http://schemas.openxmlformats.org/officeDocument/2006/relationships" r:id="R52c80b63c6294c51"/>
+                <a:hlinkClick xmlns:r="http://schemas.openxmlformats.org/officeDocument/2006/relationships" r:id="R43d221ddfb2240a0"/>
               </a:rPr>
               <a:t>Official docs</a:t>
             </a:r>
@@ -8078,7 +8373,7 @@
       </p:sp>
       <p:cxnSp>
         <p:nvCxnSpPr>
-          <p:cNvPr id="194" name=""/>
+          <p:cNvPr id="263" name=""/>
           <p:cNvCxnSpPr>
             <a:stCxn xmlns:a="http://schemas.openxmlformats.org/drawingml/2006/main" id="9" idx="3"/>
             <a:endCxn xmlns:a="http://schemas.openxmlformats.org/drawingml/2006/main" id="12" idx="1"/>
@@ -8104,7 +8399,7 @@
       </p:cxnSp>
       <p:cxnSp>
         <p:nvCxnSpPr>
-          <p:cNvPr id="195" name=""/>
+          <p:cNvPr id="264" name=""/>
           <p:cNvCxnSpPr>
             <a:stCxn xmlns:a="http://schemas.openxmlformats.org/drawingml/2006/main" id="12" idx="3"/>
             <a:endCxn xmlns:a="http://schemas.openxmlformats.org/drawingml/2006/main" id="15" idx="1"/>
@@ -8130,7 +8425,7 @@
       </p:cxnSp>
       <p:cxnSp>
         <p:nvCxnSpPr>
-          <p:cNvPr id="196" name=""/>
+          <p:cNvPr id="265" name=""/>
           <p:cNvCxnSpPr>
             <a:stCxn xmlns:a="http://schemas.openxmlformats.org/drawingml/2006/main" id="15" idx="3"/>
             <a:endCxn xmlns:a="http://schemas.openxmlformats.org/drawingml/2006/main" id="18" idx="1"/>
@@ -9112,7 +9407,7 @@
                 <a:solidFill>
                   <a:srgbClr val="666762"/>
                 </a:solidFill>
-                <a:hlinkClick xmlns:r="http://schemas.openxmlformats.org/officeDocument/2006/relationships" r:id="R523210e31ed74dd5"/>
+                <a:hlinkClick xmlns:r="http://schemas.openxmlformats.org/officeDocument/2006/relationships" r:id="Rd2d3cea478524721"/>
               </a:rPr>
               <a:t>Repo reference</a:t>
             </a:r>
@@ -9129,7 +9424,7 @@
                 <a:solidFill>
                   <a:srgbClr val="666762"/>
                 </a:solidFill>
-                <a:hlinkClick xmlns:r="http://schemas.openxmlformats.org/officeDocument/2006/relationships" r:id="R51ee73d822b94c21"/>
+                <a:hlinkClick xmlns:r="http://schemas.openxmlformats.org/officeDocument/2006/relationships" r:id="R539c58432d4744c9"/>
               </a:rPr>
               <a:t>Official docs</a:t>
             </a:r>
@@ -10764,7 +11059,7 @@
                 <a:solidFill>
                   <a:srgbClr val="666762"/>
                 </a:solidFill>
-                <a:hlinkClick xmlns:r="http://schemas.openxmlformats.org/officeDocument/2006/relationships" r:id="Re66eedb839c54273"/>
+                <a:hlinkClick xmlns:r="http://schemas.openxmlformats.org/officeDocument/2006/relationships" r:id="Ra2b5e1c4e28a46a7"/>
               </a:rPr>
               <a:t>Repo reference</a:t>
             </a:r>
@@ -10781,7 +11076,7 @@
                 <a:solidFill>
                   <a:srgbClr val="666762"/>
                 </a:solidFill>
-                <a:hlinkClick xmlns:r="http://schemas.openxmlformats.org/officeDocument/2006/relationships" r:id="R00a9e463814e48f4"/>
+                <a:hlinkClick xmlns:r="http://schemas.openxmlformats.org/officeDocument/2006/relationships" r:id="Rf70857b4e97e4c7d"/>
               </a:rPr>
               <a:t>Official docs</a:t>
             </a:r>
@@ -13008,7 +13303,7 @@
                 <a:solidFill>
                   <a:srgbClr val="666762"/>
                 </a:solidFill>
-                <a:hlinkClick xmlns:r="http://schemas.openxmlformats.org/officeDocument/2006/relationships" r:id="R7aa7d65826ad432c"/>
+                <a:hlinkClick xmlns:r="http://schemas.openxmlformats.org/officeDocument/2006/relationships" r:id="Rf626b329861a487b"/>
               </a:rPr>
               <a:t>Repo reference</a:t>
             </a:r>
@@ -13025,7 +13320,7 @@
                 <a:solidFill>
                   <a:srgbClr val="666762"/>
                 </a:solidFill>
-                <a:hlinkClick xmlns:r="http://schemas.openxmlformats.org/officeDocument/2006/relationships" r:id="R1e11eac9486c4b0b"/>
+                <a:hlinkClick xmlns:r="http://schemas.openxmlformats.org/officeDocument/2006/relationships" r:id="R712569a5a4d54fb7"/>
               </a:rPr>
               <a:t>Official docs</a:t>
             </a:r>
@@ -14971,7 +15266,7 @@
                 <a:solidFill>
                   <a:srgbClr val="666762"/>
                 </a:solidFill>
-                <a:hlinkClick xmlns:r="http://schemas.openxmlformats.org/officeDocument/2006/relationships" r:id="R2da00fdd75884681"/>
+                <a:hlinkClick xmlns:r="http://schemas.openxmlformats.org/officeDocument/2006/relationships" r:id="R1263daf97d134853"/>
               </a:rPr>
               <a:t>Repo reference</a:t>
             </a:r>
@@ -14988,7 +15283,7 @@
                 <a:solidFill>
                   <a:srgbClr val="666762"/>
                 </a:solidFill>
-                <a:hlinkClick xmlns:r="http://schemas.openxmlformats.org/officeDocument/2006/relationships" r:id="Rc4928489af994148"/>
+                <a:hlinkClick xmlns:r="http://schemas.openxmlformats.org/officeDocument/2006/relationships" r:id="R4bbe7096d3104c54"/>
               </a:rPr>
               <a:t>Official docs</a:t>
             </a:r>
@@ -15845,7 +16140,7 @@
       </p:sp>
       <p:cxnSp>
         <p:nvCxnSpPr>
-          <p:cNvPr id="223" name=""/>
+          <p:cNvPr id="307" name=""/>
           <p:cNvCxnSpPr>
             <a:stCxn xmlns:a="http://schemas.openxmlformats.org/drawingml/2006/main" id="9" idx="3"/>
             <a:endCxn xmlns:a="http://schemas.openxmlformats.org/drawingml/2006/main" id="12" idx="1"/>
@@ -15871,7 +16166,7 @@
       </p:cxnSp>
       <p:cxnSp>
         <p:nvCxnSpPr>
-          <p:cNvPr id="224" name=""/>
+          <p:cNvPr id="308" name=""/>
           <p:cNvCxnSpPr>
             <a:stCxn xmlns:a="http://schemas.openxmlformats.org/drawingml/2006/main" id="12" idx="3"/>
             <a:endCxn xmlns:a="http://schemas.openxmlformats.org/drawingml/2006/main" id="15" idx="1"/>
@@ -15899,7 +16194,7 @@
       </p:cxnSp>
       <p:cxnSp>
         <p:nvCxnSpPr>
-          <p:cNvPr id="225" name=""/>
+          <p:cNvPr id="309" name=""/>
           <p:cNvCxnSpPr>
             <a:stCxn xmlns:a="http://schemas.openxmlformats.org/drawingml/2006/main" id="12" idx="3"/>
             <a:endCxn xmlns:a="http://schemas.openxmlformats.org/drawingml/2006/main" id="18" idx="1"/>
@@ -15927,7 +16222,7 @@
       </p:cxnSp>
       <p:cxnSp>
         <p:nvCxnSpPr>
-          <p:cNvPr id="226" name=""/>
+          <p:cNvPr id="310" name=""/>
           <p:cNvCxnSpPr>
             <a:stCxn xmlns:a="http://schemas.openxmlformats.org/drawingml/2006/main" id="15" idx="3"/>
             <a:endCxn xmlns:a="http://schemas.openxmlformats.org/drawingml/2006/main" id="21" idx="1"/>
@@ -15955,7 +16250,7 @@
       </p:cxnSp>
       <p:cxnSp>
         <p:nvCxnSpPr>
-          <p:cNvPr id="227" name=""/>
+          <p:cNvPr id="311" name=""/>
           <p:cNvCxnSpPr>
             <a:stCxn xmlns:a="http://schemas.openxmlformats.org/drawingml/2006/main" id="18" idx="3"/>
             <a:endCxn xmlns:a="http://schemas.openxmlformats.org/drawingml/2006/main" id="21" idx="1"/>
@@ -16336,7 +16631,7 @@
                 <a:ea typeface="Arial"/>
                 <a:cs typeface="Arial"/>
               </a:rPr>
-              <a:t>Migration advances on evidence—not time</a:t>
+              <a:t>Mule and Apigee migration advance on evidence—not time</a:t>
             </a:r>
           </a:p>
         </p:txBody>
@@ -16395,7 +16690,30 @@
                 <a:ea typeface="Arial"/>
                 <a:cs typeface="Arial"/>
               </a:rPr>
-              <a:t>A scenario planning sequence—not current programme status.</a:t>
+              <a:t>Mule M0–M5 and </a:t>
+            </a:r>
+            <a:r>
+              <a:rPr sz="1575" b="0" i="0">
+                <a:solidFill>
+                  <a:srgbClr val="686A66"/>
+                </a:solidFill>
+                <a:latin typeface="Arial"/>
+                <a:ea typeface="Arial"/>
+                <a:cs typeface="Arial"/>
+                <a:hlinkClick xmlns:r="http://schemas.openxmlformats.org/officeDocument/2006/relationships" r:id="R62e375ce0497439d"/>
+              </a:rPr>
+              <a:t>Apigee A0–A6</a:t>
+            </a:r>
+            <a:r>
+              <a:rPr sz="1575" b="0" i="0">
+                <a:solidFill>
+                  <a:srgbClr val="686A66"/>
+                </a:solidFill>
+                <a:latin typeface="Arial"/>
+                <a:ea typeface="Arial"/>
+                <a:cs typeface="Arial"/>
+              </a:rPr>
+              <a:t> share stable-edge, coexistence, route-back and dependency-zero gates.</a:t>
             </a:r>
           </a:p>
         </p:txBody>
@@ -16486,7 +16804,7 @@
                 <a:solidFill>
                   <a:srgbClr val="666762"/>
                 </a:solidFill>
-                <a:hlinkClick xmlns:r="http://schemas.openxmlformats.org/officeDocument/2006/relationships" r:id="R1022742dc6a645c1"/>
+                <a:hlinkClick xmlns:r="http://schemas.openxmlformats.org/officeDocument/2006/relationships" r:id="R1c28582fbaff48e4"/>
               </a:rPr>
               <a:t>Repo reference</a:t>
             </a:r>
@@ -16503,7 +16821,7 @@
                 <a:solidFill>
                   <a:srgbClr val="666762"/>
                 </a:solidFill>
-                <a:hlinkClick xmlns:r="http://schemas.openxmlformats.org/officeDocument/2006/relationships" r:id="R97cd161f45374955"/>
+                <a:hlinkClick xmlns:r="http://schemas.openxmlformats.org/officeDocument/2006/relationships" r:id="R7f21fb6e85534687"/>
               </a:rPr>
               <a:t>Official docs</a:t>
             </a:r>
@@ -16623,7 +16941,7 @@
                 <a:ea typeface="Consolas"/>
                 <a:cs typeface="Consolas"/>
               </a:rPr>
-              <a:t>M0</a:t>
+              <a:t>M0/A0</a:t>
             </a:r>
           </a:p>
         </p:txBody>
@@ -16682,7 +17000,7 @@
                 <a:ea typeface="Georgia"/>
                 <a:cs typeface="Georgia"/>
               </a:rPr>
-              <a:t>Inventory + safety</a:t>
+              <a:t>Inventory + freeze</a:t>
             </a:r>
           </a:p>
         </p:txBody>
@@ -16831,7 +17149,31 @@
                 <a:ea typeface="Arial"/>
                 <a:cs typeface="Arial"/>
               </a:rPr>
-              <a:t>owners + runtime access</a:t>
+              <a:t>Mule duty + state</a:t>
+            </a:r>
+          </a:p>
+          <a:p xmlns:a="http://schemas.openxmlformats.org/drawingml/2006/main">
+            <a:pPr algn="l">
+              <a:buNone/>
+              <a:defRPr sz="1200" b="0" i="0">
+                <a:solidFill>
+                  <a:srgbClr val="111111"/>
+                </a:solidFill>
+                <a:latin typeface="Arial"/>
+                <a:ea typeface="Arial"/>
+                <a:cs typeface="Arial"/>
+              </a:defRPr>
+            </a:pPr>
+            <a:r>
+              <a:rPr sz="1200" b="0" i="0">
+                <a:solidFill>
+                  <a:srgbClr val="111111"/>
+                </a:solidFill>
+                <a:latin typeface="Arial"/>
+                <a:ea typeface="Arial"/>
+                <a:cs typeface="Arial"/>
+              </a:rPr>
+              <a:t>Apigee object graph</a:t>
             </a:r>
           </a:p>
         </p:txBody>
@@ -16949,7 +17291,7 @@
                 <a:ea typeface="Arial"/>
                 <a:cs typeface="Arial"/>
               </a:rPr>
-              <a:t>traffic / state / schedule reconciled</a:t>
+              <a:t>reconciled denominator</a:t>
             </a:r>
           </a:p>
         </p:txBody>
@@ -17039,7 +17381,7 @@
                 <a:ea typeface="Consolas"/>
                 <a:cs typeface="Consolas"/>
               </a:rPr>
-              <a:t>M1</a:t>
+              <a:t>M1/A1</a:t>
             </a:r>
           </a:p>
         </p:txBody>
@@ -17098,7 +17440,7 @@
                 <a:ea typeface="Georgia"/>
                 <a:cs typeface="Georgia"/>
               </a:rPr>
-              <a:t>Gateway-</a:t>
+              <a:t>Classify</a:t>
             </a:r>
           </a:p>
           <a:p xmlns:a="http://schemas.openxmlformats.org/drawingml/2006/main">
@@ -17122,7 +17464,7 @@
                 <a:ea typeface="Georgia"/>
                 <a:cs typeface="Georgia"/>
               </a:rPr>
-              <a:t>dominant</a:t>
+              <a:t>semantics</a:t>
             </a:r>
           </a:p>
         </p:txBody>
@@ -17271,7 +17613,7 @@
                 <a:ea typeface="Arial"/>
                 <a:cs typeface="Arial"/>
               </a:rPr>
-              <a:t>pattern + active digest</a:t>
+              <a:t>policy + behavior map</a:t>
             </a:r>
           </a:p>
         </p:txBody>
@@ -17389,7 +17731,7 @@
                 <a:ea typeface="Arial"/>
                 <a:cs typeface="Arial"/>
               </a:rPr>
-              <a:t>parity + restart + rollback</a:t>
+              <a:t>owner + destination</a:t>
             </a:r>
           </a:p>
         </p:txBody>
@@ -17479,7 +17821,7 @@
                 <a:ea typeface="Consolas"/>
                 <a:cs typeface="Consolas"/>
               </a:rPr>
-              <a:t>M2</a:t>
+              <a:t>M2/A2</a:t>
             </a:r>
           </a:p>
         </p:txBody>
@@ -17538,7 +17880,7 @@
                 <a:ea typeface="Georgia"/>
                 <a:cs typeface="Georgia"/>
               </a:rPr>
-              <a:t>Representative</a:t>
+              <a:t>Reversible</a:t>
             </a:r>
           </a:p>
           <a:p xmlns:a="http://schemas.openxmlformats.org/drawingml/2006/main">
@@ -17562,7 +17904,7 @@
                 <a:ea typeface="Georgia"/>
                 <a:cs typeface="Georgia"/>
               </a:rPr>
-              <a:t>integrations</a:t>
+              <a:t>foundation</a:t>
             </a:r>
           </a:p>
         </p:txBody>
@@ -17711,7 +18053,7 @@
                 <a:ea typeface="Arial"/>
                 <a:cs typeface="Arial"/>
               </a:rPr>
-              <a:t>idempotency + target runtime</a:t>
+              <a:t>BOM + APIOps + IAM</a:t>
             </a:r>
           </a:p>
         </p:txBody>
@@ -17829,7 +18171,7 @@
                 <a:ea typeface="Arial"/>
                 <a:cs typeface="Arial"/>
               </a:rPr>
-              <a:t>semantics + recovery accepted</a:t>
+              <a:t>restore + route-back</a:t>
             </a:r>
           </a:p>
         </p:txBody>
@@ -17919,7 +18261,7 @@
                 <a:ea typeface="Consolas"/>
                 <a:cs typeface="Consolas"/>
               </a:rPr>
-              <a:t>M3</a:t>
+              <a:t>M3/A3</a:t>
             </a:r>
           </a:p>
         </p:txBody>
@@ -17978,7 +18320,31 @@
                 <a:ea typeface="Georgia"/>
                 <a:cs typeface="Georgia"/>
               </a:rPr>
-              <a:t>Domain factory</a:t>
+              <a:t>Representative</a:t>
+            </a:r>
+          </a:p>
+          <a:p xmlns:a="http://schemas.openxmlformats.org/drawingml/2006/main">
+            <a:pPr algn="l">
+              <a:buNone/>
+              <a:defRPr sz="1725" b="0" i="0">
+                <a:solidFill>
+                  <a:srgbClr val="111111"/>
+                </a:solidFill>
+                <a:latin typeface="Georgia"/>
+                <a:ea typeface="Georgia"/>
+                <a:cs typeface="Georgia"/>
+              </a:defRPr>
+            </a:pPr>
+            <a:r>
+              <a:rPr sz="1725" b="0" i="0">
+                <a:solidFill>
+                  <a:srgbClr val="111111"/>
+                </a:solidFill>
+                <a:latin typeface="Georgia"/>
+                <a:ea typeface="Georgia"/>
+                <a:cs typeface="Georgia"/>
+              </a:rPr>
+              <a:t>parity</a:t>
             </a:r>
           </a:p>
         </p:txBody>
@@ -18127,7 +18493,7 @@
                 <a:ea typeface="Arial"/>
                 <a:cs typeface="Arial"/>
               </a:rPr>
-              <a:t>funded owners + automation</a:t>
+              <a:t>hard slice + corpus</a:t>
             </a:r>
           </a:p>
         </p:txBody>
@@ -18245,7 +18611,7 @@
                 <a:ea typeface="Arial"/>
                 <a:cs typeface="Arial"/>
               </a:rPr>
-              <a:t>ownership transferred</a:t>
+              <a:t>security + state + SLO</a:t>
             </a:r>
           </a:p>
         </p:txBody>
@@ -18335,7 +18701,7 @@
                 <a:ea typeface="Consolas"/>
                 <a:cs typeface="Consolas"/>
               </a:rPr>
-              <a:t>M4</a:t>
+              <a:t>M4/A4</a:t>
             </a:r>
           </a:p>
         </p:txBody>
@@ -18394,7 +18760,7 @@
                 <a:ea typeface="Georgia"/>
                 <a:cs typeface="Georgia"/>
               </a:rPr>
-              <a:t>Connector +</a:t>
+              <a:t>Bounded</a:t>
             </a:r>
           </a:p>
           <a:p xmlns:a="http://schemas.openxmlformats.org/drawingml/2006/main">
@@ -18418,7 +18784,7 @@
                 <a:ea typeface="Georgia"/>
                 <a:cs typeface="Georgia"/>
               </a:rPr>
-              <a:t>batch tail</a:t>
+              <a:t>coexistence</a:t>
             </a:r>
           </a:p>
         </p:txBody>
@@ -18567,7 +18933,7 @@
                 <a:ea typeface="Arial"/>
                 <a:cs typeface="Arial"/>
               </a:rPr>
-              <a:t>replace / retain decision</a:t>
+              <a:t>cohort + identity/state</a:t>
             </a:r>
           </a:p>
         </p:txBody>
@@ -18685,7 +19051,7 @@
                 <a:ea typeface="Arial"/>
                 <a:cs typeface="Arial"/>
               </a:rPr>
-              <a:t>exception bounded or removed</a:t>
+              <a:t>reconcile + timed rollback</a:t>
             </a:r>
           </a:p>
         </p:txBody>
@@ -18751,7 +19117,7 @@
         </p:spPr>
         <p:txBody>
           <a:bodyPr xmlns:a="http://schemas.openxmlformats.org/drawingml/2006/main" wrap="square" lIns="0" tIns="0" rIns="0" bIns="0" anchor="t">
-            <a:normAutofit fontScale="100000"/>
+            <a:normAutofit fontScale="96144"/>
           </a:bodyPr>
           <a:lstStyle xmlns:a="http://schemas.openxmlformats.org/drawingml/2006/main"/>
           <a:p xmlns:a="http://schemas.openxmlformats.org/drawingml/2006/main">
@@ -18775,7 +19141,7 @@
                 <a:ea typeface="Consolas"/>
                 <a:cs typeface="Consolas"/>
               </a:rPr>
-              <a:t>M5</a:t>
+              <a:t>M5/A5+</a:t>
             </a:r>
           </a:p>
         </p:txBody>
@@ -18810,7 +19176,7 @@
         </p:spPr>
         <p:txBody>
           <a:bodyPr xmlns:a="http://schemas.openxmlformats.org/drawingml/2006/main" wrap="square" lIns="0" tIns="0" rIns="0" bIns="0" anchor="t">
-            <a:normAutofit fontScale="100000"/>
+            <a:normAutofit fontScale="97472"/>
           </a:bodyPr>
           <a:lstStyle xmlns:a="http://schemas.openxmlformats.org/drawingml/2006/main"/>
           <a:p xmlns:a="http://schemas.openxmlformats.org/drawingml/2006/main">
@@ -18834,7 +19200,7 @@
                 <a:ea typeface="Georgia"/>
                 <a:cs typeface="Georgia"/>
               </a:rPr>
-              <a:t>Retire shared</a:t>
+              <a:t>Canary → A6</a:t>
             </a:r>
           </a:p>
           <a:p xmlns:a="http://schemas.openxmlformats.org/drawingml/2006/main">
@@ -18858,7 +19224,7 @@
                 <a:ea typeface="Georgia"/>
                 <a:cs typeface="Georgia"/>
               </a:rPr>
-              <a:t>runtime</a:t>
+              <a:t>dependency zero</a:t>
             </a:r>
           </a:p>
         </p:txBody>
@@ -19007,7 +19373,7 @@
                 <a:ea typeface="Arial"/>
                 <a:cs typeface="Arial"/>
               </a:rPr>
-              <a:t>traffic zero + archives</a:t>
+              <a:t>representative operating evidence</a:t>
             </a:r>
           </a:p>
         </p:txBody>
@@ -19125,7 +19491,7 @@
                 <a:ea typeface="Arial"/>
                 <a:cs typeface="Arial"/>
               </a:rPr>
-              <a:t>dependency zero</a:t>
+              <a:t>all source duties closed</a:t>
             </a:r>
           </a:p>
         </p:txBody>
@@ -19160,7 +19526,7 @@
         </p:spPr>
         <p:txBody>
           <a:bodyPr xmlns:a="http://schemas.openxmlformats.org/drawingml/2006/main" wrap="square" lIns="0" tIns="0" rIns="0" bIns="0" anchor="t">
-            <a:normAutofit fontScale="100000"/>
+            <a:normAutofit fontScale="90246"/>
           </a:bodyPr>
           <a:lstStyle xmlns:a="http://schemas.openxmlformats.org/drawingml/2006/main"/>
           <a:p xmlns:a="http://schemas.openxmlformats.org/drawingml/2006/main">
@@ -19184,7 +19550,7 @@
                 <a:ea typeface="Georgia"/>
                 <a:cs typeface="Georgia"/>
               </a:rPr>
-              <a:t>No wave advances because the calendar moved.</a:t>
+              <a:t>No path advances because the calendar moved—or a proxy bundle exported.</a:t>
             </a:r>
           </a:p>
         </p:txBody>
@@ -19543,7 +19909,7 @@
                 <a:solidFill>
                   <a:srgbClr val="666762"/>
                 </a:solidFill>
-                <a:hlinkClick xmlns:r="http://schemas.openxmlformats.org/officeDocument/2006/relationships" r:id="Re9a24bf5ed534727"/>
+                <a:hlinkClick xmlns:r="http://schemas.openxmlformats.org/officeDocument/2006/relationships" r:id="Rd0140178fd474b49"/>
               </a:rPr>
               <a:t>Repo reference</a:t>
             </a:r>
@@ -19560,7 +19926,7 @@
                 <a:solidFill>
                   <a:srgbClr val="666762"/>
                 </a:solidFill>
-                <a:hlinkClick xmlns:r="http://schemas.openxmlformats.org/officeDocument/2006/relationships" r:id="Rce6543ac207849c1"/>
+                <a:hlinkClick xmlns:r="http://schemas.openxmlformats.org/officeDocument/2006/relationships" r:id="Re4a0a24c3f964747"/>
               </a:rPr>
               <a:t>Official docs</a:t>
             </a:r>
@@ -20751,7 +21117,7 @@
                 <a:ea typeface="Arial"/>
                 <a:cs typeface="Arial"/>
               </a:rPr>
-              <a:t>Six workstreams convert a functional baseline into decision-grade evidence.</a:t>
+              <a:t>Seven workstreams convert the local baseline into decision-grade target evidence.</a:t>
             </a:r>
           </a:p>
         </p:txBody>
@@ -20842,7 +21208,7 @@
                 <a:solidFill>
                   <a:srgbClr val="666762"/>
                 </a:solidFill>
-                <a:hlinkClick xmlns:r="http://schemas.openxmlformats.org/officeDocument/2006/relationships" r:id="R4209fdf0f1a6407e"/>
+                <a:hlinkClick xmlns:r="http://schemas.openxmlformats.org/officeDocument/2006/relationships" r:id="R18ea84ca327940c5"/>
               </a:rPr>
               <a:t>Repo reference</a:t>
             </a:r>
@@ -20859,7 +21225,7 @@
                 <a:solidFill>
                   <a:srgbClr val="666762"/>
                 </a:solidFill>
-                <a:hlinkClick xmlns:r="http://schemas.openxmlformats.org/officeDocument/2006/relationships" r:id="R6ff692ef042d4ad1"/>
+                <a:hlinkClick xmlns:r="http://schemas.openxmlformats.org/officeDocument/2006/relationships" r:id="R221a2808b8c54ac9"/>
               </a:rPr>
               <a:t>Official docs</a:t>
             </a:r>
@@ -21929,7 +22295,7 @@
                 <a:ea typeface="Consolas"/>
                 <a:cs typeface="Consolas"/>
               </a:rPr>
-              <a:t>AGENTIC + DECISION</a:t>
+              <a:t>AGENTIC + SECURITY + DECISION</a:t>
             </a:r>
           </a:p>
         </p:txBody>
@@ -22203,7 +22569,7 @@
         </p:spPr>
         <p:txBody>
           <a:bodyPr xmlns:a="http://schemas.openxmlformats.org/drawingml/2006/main" wrap="square" lIns="0" tIns="0" rIns="0" bIns="0" anchor="t">
-            <a:normAutofit fontScale="100000"/>
+            <a:normAutofit fontScale="95441"/>
           </a:bodyPr>
           <a:lstStyle xmlns:a="http://schemas.openxmlformats.org/drawingml/2006/main"/>
           <a:p xmlns:a="http://schemas.openxmlformats.org/drawingml/2006/main">
@@ -22227,7 +22593,7 @@
                 <a:ea typeface="Consolas"/>
                 <a:cs typeface="Consolas"/>
               </a:rPr>
-              <a:t>06</a:t>
+              <a:t>06 / 07</a:t>
             </a:r>
           </a:p>
         </p:txBody>
@@ -22286,7 +22652,7 @@
                 <a:ea typeface="Georgia"/>
                 <a:cs typeface="Georgia"/>
               </a:rPr>
-              <a:t>Evidence-gated recommendation</a:t>
+              <a:t>Decision gate + security adjunct</a:t>
             </a:r>
           </a:p>
         </p:txBody>
@@ -22345,7 +22711,7 @@
                 <a:ea typeface="Arial"/>
                 <a:cs typeface="Arial"/>
               </a:rPr>
-              <a:t>Base production scope on executed results and reviewable artifacts—not documented capability.</a:t>
+              <a:t>GEP-06 binds scope to executed evidence. GEP-07 proves Kong + Traceable behavior, overhead, privacy, support and safe uninstall.</a:t>
             </a:r>
           </a:p>
         </p:txBody>
@@ -22435,7 +22801,7 @@
                 <a:ea typeface="Arial"/>
                 <a:cs typeface="Arial"/>
               </a:rPr>
-              <a:t>Documented capability creates a hypothesis; executed evidence changes the decision.</a:t>
+              <a:t>Traceable documents a plugin/agent path; only execution can establish production fit.</a:t>
             </a:r>
           </a:p>
         </p:txBody>
@@ -22794,7 +23160,7 @@
                 <a:solidFill>
                   <a:srgbClr val="666762"/>
                 </a:solidFill>
-                <a:hlinkClick xmlns:r="http://schemas.openxmlformats.org/officeDocument/2006/relationships" r:id="R21bf07e7b8524a3a"/>
+                <a:hlinkClick xmlns:r="http://schemas.openxmlformats.org/officeDocument/2006/relationships" r:id="Rd5102ee8f65a423c"/>
               </a:rPr>
               <a:t>Repo reference</a:t>
             </a:r>
@@ -22811,7 +23177,7 @@
                 <a:solidFill>
                   <a:srgbClr val="666762"/>
                 </a:solidFill>
-                <a:hlinkClick xmlns:r="http://schemas.openxmlformats.org/officeDocument/2006/relationships" r:id="Re3b90cdc619542e5"/>
+                <a:hlinkClick xmlns:r="http://schemas.openxmlformats.org/officeDocument/2006/relationships" r:id="Rb4a02421c0ce42e8"/>
               </a:rPr>
               <a:t>Official docs</a:t>
             </a:r>
@@ -25166,7 +25532,7 @@
                 <a:solidFill>
                   <a:srgbClr val="666762"/>
                 </a:solidFill>
-                <a:hlinkClick xmlns:r="http://schemas.openxmlformats.org/officeDocument/2006/relationships" r:id="R9a847bc6e3494304"/>
+                <a:hlinkClick xmlns:r="http://schemas.openxmlformats.org/officeDocument/2006/relationships" r:id="R1adb478676e24d4f"/>
               </a:rPr>
               <a:t>Repo reference</a:t>
             </a:r>
@@ -25183,7 +25549,7 @@
                 <a:solidFill>
                   <a:srgbClr val="666762"/>
                 </a:solidFill>
-                <a:hlinkClick xmlns:r="http://schemas.openxmlformats.org/officeDocument/2006/relationships" r:id="R9cbef054e21c4756"/>
+                <a:hlinkClick xmlns:r="http://schemas.openxmlformats.org/officeDocument/2006/relationships" r:id="Ra49e7b2f39b04741"/>
               </a:rPr>
               <a:t>Official docs</a:t>
             </a:r>
@@ -26718,7 +27084,7 @@
                 <a:ea typeface="Arial"/>
                 <a:cs typeface="Arial"/>
               </a:rPr>
-              <a:t>A technically healthy gateway can still fail the enterprise outcome gate.</a:t>
+              <a:t>Capacity, security traceability, adoption, toil, exit and estate truth all gate scale.</a:t>
             </a:r>
           </a:p>
         </p:txBody>
@@ -26809,7 +27175,7 @@
                 <a:solidFill>
                   <a:srgbClr val="666762"/>
                 </a:solidFill>
-                <a:hlinkClick xmlns:r="http://schemas.openxmlformats.org/officeDocument/2006/relationships" r:id="R067ace37372f4444"/>
+                <a:hlinkClick xmlns:r="http://schemas.openxmlformats.org/officeDocument/2006/relationships" r:id="R3bf9810ed14d46cb"/>
               </a:rPr>
               <a:t>Repo reference</a:t>
             </a:r>
@@ -26826,7 +27192,7 @@
                 <a:solidFill>
                   <a:srgbClr val="666762"/>
                 </a:solidFill>
-                <a:hlinkClick xmlns:r="http://schemas.openxmlformats.org/officeDocument/2006/relationships" r:id="Rab5bb13600e0468a"/>
+                <a:hlinkClick xmlns:r="http://schemas.openxmlformats.org/officeDocument/2006/relationships" r:id="R7bc13b7db82d40b0"/>
               </a:rPr>
               <a:t>Official docs</a:t>
             </a:r>
@@ -27279,7 +27645,7 @@
                 <a:ea typeface="Georgia"/>
                 <a:cs typeface="Georgia"/>
               </a:rPr>
-              <a:t>Evidence safety</a:t>
+              <a:t>Security traceability</a:t>
             </a:r>
           </a:p>
         </p:txBody>
@@ -27369,7 +27735,7 @@
                 <a:ea typeface="Arial"/>
                 <a:cs typeface="Arial"/>
               </a:rPr>
-              <a:t>off-path telemetry · quantified gaps · no prohibited fields</a:t>
+              <a:t>config + request + security correlation · quantified gaps · no prohibited fields</a:t>
             </a:r>
           </a:p>
         </p:txBody>
@@ -28751,7 +29117,7 @@
                 <a:solidFill>
                   <a:srgbClr val="666762"/>
                 </a:solidFill>
-                <a:hlinkClick xmlns:r="http://schemas.openxmlformats.org/officeDocument/2006/relationships" r:id="R68631eaad1bf4d4a"/>
+                <a:hlinkClick xmlns:r="http://schemas.openxmlformats.org/officeDocument/2006/relationships" r:id="R9d6a043af80d4a02"/>
               </a:rPr>
               <a:t>Repo reference</a:t>
             </a:r>
@@ -28768,7 +29134,7 @@
                 <a:solidFill>
                   <a:srgbClr val="666762"/>
                 </a:solidFill>
-                <a:hlinkClick xmlns:r="http://schemas.openxmlformats.org/officeDocument/2006/relationships" r:id="Rb799a19b5ac44ed8"/>
+                <a:hlinkClick xmlns:r="http://schemas.openxmlformats.org/officeDocument/2006/relationships" r:id="R3840573ea64c4e76"/>
               </a:rPr>
               <a:t>Official docs</a:t>
             </a:r>
@@ -29190,7 +29556,7 @@
       </p:sp>
       <p:cxnSp>
         <p:nvCxnSpPr>
-          <p:cNvPr id="205" name=""/>
+          <p:cNvPr id="286" name=""/>
           <p:cNvCxnSpPr>
             <a:stCxn xmlns:a="http://schemas.openxmlformats.org/drawingml/2006/main" id="9" idx="1"/>
             <a:endCxn xmlns:a="http://schemas.openxmlformats.org/drawingml/2006/main" id="12" idx="3"/>
@@ -29395,7 +29761,7 @@
       </p:sp>
       <p:cxnSp>
         <p:nvCxnSpPr>
-          <p:cNvPr id="209" name=""/>
+          <p:cNvPr id="290" name=""/>
           <p:cNvCxnSpPr>
             <a:stCxn xmlns:a="http://schemas.openxmlformats.org/drawingml/2006/main" id="9" idx="1"/>
             <a:endCxn xmlns:a="http://schemas.openxmlformats.org/drawingml/2006/main" id="16" idx="3"/>
@@ -29600,7 +29966,7 @@
       </p:sp>
       <p:cxnSp>
         <p:nvCxnSpPr>
-          <p:cNvPr id="213" name=""/>
+          <p:cNvPr id="294" name=""/>
           <p:cNvCxnSpPr>
             <a:stCxn xmlns:a="http://schemas.openxmlformats.org/drawingml/2006/main" id="9" idx="3"/>
             <a:endCxn xmlns:a="http://schemas.openxmlformats.org/drawingml/2006/main" id="20" idx="1"/>
@@ -29805,7 +30171,7 @@
       </p:sp>
       <p:cxnSp>
         <p:nvCxnSpPr>
-          <p:cNvPr id="217" name=""/>
+          <p:cNvPr id="298" name=""/>
           <p:cNvCxnSpPr>
             <a:stCxn xmlns:a="http://schemas.openxmlformats.org/drawingml/2006/main" id="9" idx="3"/>
             <a:endCxn xmlns:a="http://schemas.openxmlformats.org/drawingml/2006/main" id="24" idx="1"/>
@@ -30094,7 +30460,7 @@
                 <a:ea typeface="Arial"/>
                 <a:cs typeface="Arial"/>
               </a:rPr>
-              <a:t>Comparison input — architecture and delivery</a:t>
+              <a:t>Comparison input — architecture, multicloud and robustness</a:t>
             </a:r>
           </a:p>
         </p:txBody>
@@ -30153,7 +30519,7 @@
                 <a:ea typeface="Arial"/>
                 <a:cs typeface="Arial"/>
               </a:rPr>
-              <a:t>Condensed from the supplied document; validate qualitative labels against versions and evidence.</a:t>
+              <a:t>Supplied labels stay visible; scalability and recovery remain unscored until equivalent execution.</a:t>
             </a:r>
           </a:p>
         </p:txBody>
@@ -30244,7 +30610,7 @@
                 <a:solidFill>
                   <a:srgbClr val="666762"/>
                 </a:solidFill>
-                <a:hlinkClick xmlns:r="http://schemas.openxmlformats.org/officeDocument/2006/relationships" r:id="Rd3188f8e04384b28"/>
+                <a:hlinkClick xmlns:r="http://schemas.openxmlformats.org/officeDocument/2006/relationships" r:id="Rb24633c9f3f440e9"/>
               </a:rPr>
               <a:t>Repo reference</a:t>
             </a:r>
@@ -30261,7 +30627,7 @@
                 <a:solidFill>
                   <a:srgbClr val="666762"/>
                 </a:solidFill>
-                <a:hlinkClick xmlns:r="http://schemas.openxmlformats.org/officeDocument/2006/relationships" r:id="Rd3bcecb3cb084b48"/>
+                <a:hlinkClick xmlns:r="http://schemas.openxmlformats.org/officeDocument/2006/relationships" r:id="R0cd94291b15244a6"/>
               </a:rPr>
               <a:t>Official docs</a:t>
             </a:r>
@@ -30541,7 +30907,7 @@
                     <a:lstStyle/>
                     <a:p>
                       <a:r>
-                        <a:t>Kubernetes</a:t>
+                        <a:t>Kubernetes / GitOps</a:t>
                       </a:r>
                     </a:p>
                   </a:txBody>
@@ -30565,7 +30931,7 @@
                     <a:lstStyle/>
                     <a:p>
                       <a:r>
-                        <a:t>Supplied: Very Good</a:t>
+                        <a:t>Hybrid runtime / tools</a:t>
                       </a:r>
                     </a:p>
                   </a:txBody>
@@ -30577,7 +30943,7 @@
                     <a:lstStyle/>
                     <a:p>
                       <a:r>
-                        <a:t>Supplied: Good</a:t>
+                        <a:t>Supplied: Good / Moderate</a:t>
                       </a:r>
                     </a:p>
                   </a:txBody>
@@ -30589,69 +30955,7 @@
                     <a:lstStyle/>
                     <a:p>
                       <a:r>
-                        <a:t>Run representative proof</a:t>
-                      </a:r>
-                    </a:p>
-                  </a:txBody>
-                  <a:tcPr marL="91440" marR="91440" marT="45720" marB="45720"/>
-                </a:tc>
-              </a:tr>
-              <a:tr h="538843">
-                <a:tc>
-                  <a:txBody>
-                    <a:bodyPr/>
-                    <a:lstStyle/>
-                    <a:p>
-                      <a:r>
-                        <a:t>GitOps</a:t>
-                      </a:r>
-                    </a:p>
-                  </a:txBody>
-                  <a:tcPr marL="91440" marR="91440" marT="45720" marB="45720"/>
-                </a:tc>
-                <a:tc>
-                  <a:txBody>
-                    <a:bodyPr/>
-                    <a:lstStyle/>
-                    <a:p>
-                      <a:r>
-                        <a:t>Supplied: Excellent</a:t>
-                      </a:r>
-                    </a:p>
-                  </a:txBody>
-                  <a:tcPr marL="91440" marR="91440" marT="45720" marB="45720"/>
-                </a:tc>
-                <a:tc>
-                  <a:txBody>
-                    <a:bodyPr/>
-                    <a:lstStyle/>
-                    <a:p>
-                      <a:r>
-                        <a:t>Supplied: Moderate</a:t>
-                      </a:r>
-                    </a:p>
-                  </a:txBody>
-                  <a:tcPr marL="91440" marR="91440" marT="45720" marB="45720"/>
-                </a:tc>
-                <a:tc>
-                  <a:txBody>
-                    <a:bodyPr/>
-                    <a:lstStyle/>
-                    <a:p>
-                      <a:r>
-                        <a:t>Supplied: Moderate</a:t>
-                      </a:r>
-                    </a:p>
-                  </a:txBody>
-                  <a:tcPr marL="91440" marR="91440" marT="45720" marB="45720"/>
-                </a:tc>
-                <a:tc>
-                  <a:txBody>
-                    <a:bodyPr/>
-                    <a:lstStyle/>
-                    <a:p>
-                      <a:r>
-                        <a:t>Measure repeatability</a:t>
+                        <a:t>Versioned delivery proof</a:t>
                       </a:r>
                     </a:p>
                   </a:txBody>
@@ -30677,7 +30981,7 @@
                     <a:lstStyle/>
                     <a:p>
                       <a:r>
-                        <a:t>OTel / Prometheus ecosystem</a:t>
+                        <a:t>OTel / Prometheus</a:t>
                       </a:r>
                     </a:p>
                   </a:txBody>
@@ -30782,6 +31086,68 @@
                   <a:tcPr marL="91440" marR="91440" marT="45720" marB="45720"/>
                 </a:tc>
               </a:tr>
+              <a:tr h="538843">
+                <a:tc>
+                  <a:txBody>
+                    <a:bodyPr/>
+                    <a:lstStyle/>
+                    <a:p>
+                      <a:r>
+                        <a:t>Scalability / robustness</a:t>
+                      </a:r>
+                    </a:p>
+                  </a:txBody>
+                  <a:tcPr marL="91440" marR="91440" marT="45720" marB="45720"/>
+                </a:tc>
+                <a:tc>
+                  <a:txBody>
+                    <a:bodyPr/>
+                    <a:lstStyle/>
+                    <a:p>
+                      <a:r>
+                        <a:t>Not supplied</a:t>
+                      </a:r>
+                    </a:p>
+                  </a:txBody>
+                  <a:tcPr marL="91440" marR="91440" marT="45720" marB="45720"/>
+                </a:tc>
+                <a:tc>
+                  <a:txBody>
+                    <a:bodyPr/>
+                    <a:lstStyle/>
+                    <a:p>
+                      <a:r>
+                        <a:t>Not supplied</a:t>
+                      </a:r>
+                    </a:p>
+                  </a:txBody>
+                  <a:tcPr marL="91440" marR="91440" marT="45720" marB="45720"/>
+                </a:tc>
+                <a:tc>
+                  <a:txBody>
+                    <a:bodyPr/>
+                    <a:lstStyle/>
+                    <a:p>
+                      <a:r>
+                        <a:t>Not supplied</a:t>
+                      </a:r>
+                    </a:p>
+                  </a:txBody>
+                  <a:tcPr marL="91440" marR="91440" marT="45720" marB="45720"/>
+                </a:tc>
+                <a:tc>
+                  <a:txBody>
+                    <a:bodyPr/>
+                    <a:lstStyle/>
+                    <a:p>
+                      <a:r>
+                        <a:t>Load + failure + recovery</a:t>
+                      </a:r>
+                    </a:p>
+                  </a:txBody>
+                  <a:tcPr marL="91440" marR="91440" marT="45720" marB="45720"/>
+                </a:tc>
+              </a:tr>
             </a:tbl>
           </a:graphicData>
         </a:graphic>
@@ -30990,7 +31356,7 @@
                 <a:ea typeface="Arial"/>
                 <a:cs typeface="Arial"/>
               </a:rPr>
-              <a:t>Comparison input — management, experience and AI</a:t>
+              <a:t>Comparison input — management, AI and security traceability</a:t>
             </a:r>
           </a:p>
         </p:txBody>
@@ -31049,7 +31415,7 @@
                 <a:ea typeface="Arial"/>
                 <a:cs typeface="Arial"/>
               </a:rPr>
-              <a:t>Use these claims as hypotheses; capabilities are edition- and date-dependent.</a:t>
+              <a:t>Traceable is a documented third-party path—not proven Kong 3.14 production fit.</a:t>
             </a:r>
           </a:p>
         </p:txBody>
@@ -31140,7 +31506,7 @@
                 <a:solidFill>
                   <a:srgbClr val="666762"/>
                 </a:solidFill>
-                <a:hlinkClick xmlns:r="http://schemas.openxmlformats.org/officeDocument/2006/relationships" r:id="R165806dea2734863"/>
+                <a:hlinkClick xmlns:r="http://schemas.openxmlformats.org/officeDocument/2006/relationships" r:id="R8bf1a861925543f5"/>
               </a:rPr>
               <a:t>Repo reference</a:t>
             </a:r>
@@ -31157,7 +31523,7 @@
                 <a:solidFill>
                   <a:srgbClr val="666762"/>
                 </a:solidFill>
-                <a:hlinkClick xmlns:r="http://schemas.openxmlformats.org/officeDocument/2006/relationships" r:id="R2bed165f4db24f06"/>
+                <a:hlinkClick xmlns:r="http://schemas.openxmlformats.org/officeDocument/2006/relationships" r:id="R6cfd9859a60b4194"/>
               </a:rPr>
               <a:t>Official docs</a:t>
             </a:r>
@@ -31623,7 +31989,7 @@
                     <a:lstStyle/>
                     <a:p>
                       <a:r>
-                        <a:t>Best fit</a:t>
+                        <a:t>Traceable adjunct</a:t>
                       </a:r>
                     </a:p>
                   </a:txBody>
@@ -31635,7 +32001,7 @@
                     <a:lstStyle/>
                     <a:p>
                       <a:r>
-                        <a:t>Platform engineering</a:t>
+                        <a:t>Plugin → Platform Agent</a:t>
                       </a:r>
                     </a:p>
                   </a:txBody>
@@ -31647,7 +32013,7 @@
                     <a:lstStyle/>
                     <a:p>
                       <a:r>
-                        <a:t>Enterprise API programs</a:t>
+                        <a:t>Not assessed</a:t>
                       </a:r>
                     </a:p>
                   </a:txBody>
@@ -31659,7 +32025,7 @@
                     <a:lstStyle/>
                     <a:p>
                       <a:r>
-                        <a:t>Integration-centric organizations</a:t>
+                        <a:t>Custom-policy baseline</a:t>
                       </a:r>
                     </a:p>
                   </a:txBody>
@@ -31671,7 +32037,7 @@
                     <a:lstStyle/>
                     <a:p>
                       <a:r>
-                        <a:t>Conditional archetype; not a universal rank</a:t>
+                        <a:t>Run GEP-07; do not score</a:t>
                       </a:r>
                     </a:p>
                   </a:txBody>
@@ -31886,7 +32252,7 @@
                 <a:ea typeface="Arial"/>
                 <a:cs typeface="Arial"/>
               </a:rPr>
-              <a:t>Comparison input — economics and evidence ceiling</a:t>
+              <a:t>Comparison input — pricing, lock-in and operating duty</a:t>
             </a:r>
           </a:p>
         </p:txBody>
@@ -31945,7 +32311,7 @@
                 <a:ea typeface="Arial"/>
                 <a:cs typeface="Arial"/>
               </a:rPr>
-              <a:t>Cost and lock-in require commercial, operating and exit evidence—not adjectives.</a:t>
+              <a:t>Normalize exact meters, full operating cost, reversibility and control duty—do not rank from public pages.</a:t>
             </a:r>
           </a:p>
         </p:txBody>
@@ -32036,7 +32402,7 @@
                 <a:solidFill>
                   <a:srgbClr val="666762"/>
                 </a:solidFill>
-                <a:hlinkClick xmlns:r="http://schemas.openxmlformats.org/officeDocument/2006/relationships" r:id="R0b2606423ff642c7"/>
+                <a:hlinkClick xmlns:r="http://schemas.openxmlformats.org/officeDocument/2006/relationships" r:id="R7cfe6bd9200c49bf"/>
               </a:rPr>
               <a:t>Repo reference</a:t>
             </a:r>
@@ -32053,7 +32419,7 @@
                 <a:solidFill>
                   <a:srgbClr val="666762"/>
                 </a:solidFill>
-                <a:hlinkClick xmlns:r="http://schemas.openxmlformats.org/officeDocument/2006/relationships" r:id="R9b961b9138084f2d"/>
+                <a:hlinkClick xmlns:r="http://schemas.openxmlformats.org/officeDocument/2006/relationships" r:id="Re896958e520744f3"/>
               </a:rPr>
               <a:t>Official docs</a:t>
             </a:r>
@@ -32234,7 +32600,7 @@
                     <a:lstStyle/>
                     <a:p>
                       <a:r>
-                        <a:t>Vendor lock-in</a:t>
+                        <a:t>Reversibility / lock-in</a:t>
                       </a:r>
                     </a:p>
                   </a:txBody>
@@ -32282,7 +32648,7 @@
                     <a:lstStyle/>
                     <a:p>
                       <a:r>
-                        <a:t>Unverified; prove rebuild + switching</a:t>
+                        <a:t>Timed rebuild + route-back</a:t>
                       </a:r>
                     </a:p>
                   </a:txBody>
@@ -32296,7 +32662,7 @@
                     <a:lstStyle/>
                     <a:p>
                       <a:r>
-                        <a:t>Cost</a:t>
+                        <a:t>Full TCO / pricing</a:t>
                       </a:r>
                     </a:p>
                   </a:txBody>
@@ -32308,7 +32674,7 @@
                     <a:lstStyle/>
                     <a:p>
                       <a:r>
-                        <a:t>Supplied: Low</a:t>
+                        <a:t>Custom quote</a:t>
                       </a:r>
                     </a:p>
                   </a:txBody>
@@ -32320,7 +32686,7 @@
                     <a:lstStyle/>
                     <a:p>
                       <a:r>
-                        <a:t>Supplied: Medium-high</a:t>
+                        <a:t>Managed PAYG ≠ Hybrid</a:t>
                       </a:r>
                     </a:p>
                   </a:txBody>
@@ -32332,7 +32698,7 @@
                     <a:lstStyle/>
                     <a:p>
                       <a:r>
-                        <a:t>Supplied: High</a:t>
+                        <a:t>Contact sales</a:t>
                       </a:r>
                     </a:p>
                   </a:txBody>
@@ -32344,7 +32710,7 @@
                     <a:lstStyle/>
                     <a:p>
                       <a:r>
-                        <a:t>Unverified; quote + labor + HA/DR + telemetry + migration + support + exit</a:t>
+                        <a:t>Quote + labor + infra + HA/DR + adjunct + exit</a:t>
                       </a:r>
                     </a:p>
                   </a:txBody>
@@ -32358,7 +32724,7 @@
                     <a:lstStyle/>
                     <a:p>
                       <a:r>
-                        <a:t>Overall recommendation</a:t>
+                        <a:t>Control-plane duty</a:t>
                       </a:r>
                     </a:p>
                   </a:txBody>
@@ -32370,7 +32736,7 @@
                     <a:lstStyle/>
                     <a:p>
                       <a:r>
-                        <a:t>Preferred</a:t>
+                        <a:t>Enterprise CP + Postgres</a:t>
                       </a:r>
                     </a:p>
                   </a:txBody>
@@ -32382,7 +32748,7 @@
                     <a:lstStyle/>
                     <a:p>
                       <a:r>
-                        <a:t>Second</a:t>
+                        <a:t>Google mgmt + own runtime</a:t>
                       </a:r>
                     </a:p>
                   </a:txBody>
@@ -32394,7 +32760,7 @@
                     <a:lstStyle/>
                     <a:p>
                       <a:r>
-                        <a:t>Third</a:t>
+                        <a:t>Boundary-dependent</a:t>
                       </a:r>
                     </a:p>
                   </a:txBody>
@@ -32406,7 +32772,7 @@
                     <a:lstStyle/>
                     <a:p>
                       <a:r>
-                        <a:t>Stakeholder direction only; no production or comparative proof</a:t>
+                        <a:t>Funded RACI + support + recovery + on-call</a:t>
                       </a:r>
                     </a:p>
                   </a:txBody>
@@ -32502,7 +32868,7 @@
                 <a:ea typeface="Arial"/>
                 <a:cs typeface="Arial"/>
               </a:rPr>
-              <a:t>No commercial or exit claim is decision-grade until equivalent evidence exists.</a:t>
+              <a:t>No price, lock-in or control-duty claim is decision-grade until equivalent evidence exists.</a:t>
             </a:r>
           </a:p>
         </p:txBody>
@@ -32711,7 +33077,7 @@
                 <a:ea typeface="Arial"/>
                 <a:cs typeface="Arial"/>
               </a:rPr>
-              <a:t>Raw scoring inputs — retain for audit, not as production proof</a:t>
+              <a:t>Historical score audit; governed re-score pending</a:t>
             </a:r>
           </a:p>
         </p:txBody>
@@ -32770,7 +33136,7 @@
                 <a:ea typeface="Arial"/>
                 <a:cs typeface="Arial"/>
               </a:rPr>
-              <a:t>Corrected weighted totals are 93 / 85.5 / 77; ratings remain illustrative author inputs.</a:t>
+              <a:t>The original eight rows remain historical input; six added dimensions still have TBD weights and ratings.</a:t>
             </a:r>
           </a:p>
         </p:txBody>
@@ -32861,7 +33227,7 @@
                 <a:solidFill>
                   <a:srgbClr val="666762"/>
                 </a:solidFill>
-                <a:hlinkClick xmlns:r="http://schemas.openxmlformats.org/officeDocument/2006/relationships" r:id="R5abc87e876e44eab"/>
+                <a:hlinkClick xmlns:r="http://schemas.openxmlformats.org/officeDocument/2006/relationships" r:id="Rdf4bda4da7a046c4"/>
               </a:rPr>
               <a:t>Repo reference</a:t>
             </a:r>
@@ -32878,7 +33244,7 @@
                 <a:solidFill>
                   <a:srgbClr val="666762"/>
                 </a:solidFill>
-                <a:hlinkClick xmlns:r="http://schemas.openxmlformats.org/officeDocument/2006/relationships" r:id="R19dc5454ee814d7e"/>
+                <a:hlinkClick xmlns:r="http://schemas.openxmlformats.org/officeDocument/2006/relationships" r:id="R159d120a3db64d42"/>
               </a:rPr>
               <a:t>Official docs</a:t>
             </a:r>
@@ -33841,7 +34207,7 @@
                 <a:ea typeface="Georgia"/>
                 <a:cs typeface="Georgia"/>
               </a:rPr>
-              <a:t>Ordering is unchanged</a:t>
+              <a:t>Historical ordering unchanged</a:t>
             </a:r>
           </a:p>
         </p:txBody>
@@ -33900,7 +34266,7 @@
                 <a:ea typeface="Arial"/>
                 <a:cs typeface="Arial"/>
               </a:rPr>
-              <a:t>Source result: 93 / 87 / 78</a:t>
+              <a:t>Source: 93 / 87 / 78</a:t>
             </a:r>
           </a:p>
           <a:p xmlns:a="http://schemas.openxmlformats.org/drawingml/2006/main">
@@ -33924,7 +34290,7 @@
                 <a:ea typeface="Arial"/>
                 <a:cs typeface="Arial"/>
               </a:rPr>
-              <a:t>Recalculated: 93 / 85.5 / 77</a:t>
+              <a:t>Corrected: 93 / 85.5 / 77</a:t>
             </a:r>
           </a:p>
         </p:txBody>
@@ -34047,7 +34413,7 @@
                 <a:ea typeface="Consolas"/>
                 <a:cs typeface="Consolas"/>
               </a:rPr>
-              <a:t>BEFORE APPROVAL</a:t>
+              <a:t>GOVERNED RE-SCORE</a:t>
             </a:r>
           </a:p>
         </p:txBody>
@@ -34106,7 +34472,7 @@
                 <a:ea typeface="Georgia"/>
                 <a:cs typeface="Georgia"/>
               </a:rPr>
-              <a:t>Add evidence confidence</a:t>
+              <a:t>Six dimensions remain TBD</a:t>
             </a:r>
           </a:p>
         </p:txBody>
@@ -34165,7 +34531,31 @@
                 <a:ea typeface="Arial"/>
                 <a:cs typeface="Arial"/>
               </a:rPr>
-              <a:t>Rubric · scorers · editions · sources · sensitivity · commercial basis · platform labor · migration cost</a:t>
+              <a:t>Multicloud · scale/recovery · security/trace · reversibility · full TCO · CP duty</a:t>
+            </a:r>
+          </a:p>
+          <a:p xmlns:a="http://schemas.openxmlformats.org/drawingml/2006/main">
+            <a:pPr algn="l">
+              <a:buNone/>
+              <a:defRPr sz="1350" b="0" i="0">
+                <a:solidFill>
+                  <a:srgbClr val="686A66"/>
+                </a:solidFill>
+                <a:latin typeface="Arial"/>
+                <a:ea typeface="Arial"/>
+                <a:cs typeface="Arial"/>
+              </a:defRPr>
+            </a:pPr>
+            <a:r>
+              <a:rPr sz="1350" b="0" i="0">
+                <a:solidFill>
+                  <a:srgbClr val="686A66"/>
+                </a:solidFill>
+                <a:latin typeface="Arial"/>
+                <a:ea typeface="Arial"/>
+                <a:cs typeface="Arial"/>
+              </a:rPr>
+              <a:t>No new total before approval</a:t>
             </a:r>
           </a:p>
         </p:txBody>
@@ -34433,7 +34823,7 @@
                 <a:ea typeface="Arial"/>
                 <a:cs typeface="Arial"/>
               </a:rPr>
-              <a:t>Kubernetes and GitOps carry 35%; weights are stakeholder choices, not market facts.</a:t>
+              <a:t>Kubernetes and GitOps carry 35%; the historical eight weights remain unchanged.</a:t>
             </a:r>
           </a:p>
         </p:txBody>
@@ -34524,7 +34914,7 @@
                 <a:solidFill>
                   <a:srgbClr val="666762"/>
                 </a:solidFill>
-                <a:hlinkClick xmlns:r="http://schemas.openxmlformats.org/officeDocument/2006/relationships" r:id="Rb06e53d022ed41e2"/>
+                <a:hlinkClick xmlns:r="http://schemas.openxmlformats.org/officeDocument/2006/relationships" r:id="R9a7e86023198430c"/>
               </a:rPr>
               <a:t>Repo reference</a:t>
             </a:r>
@@ -34541,7 +34931,7 @@
                 <a:solidFill>
                   <a:srgbClr val="666762"/>
                 </a:solidFill>
-                <a:hlinkClick xmlns:r="http://schemas.openxmlformats.org/officeDocument/2006/relationships" r:id="R7245e5aab3a5435a"/>
+                <a:hlinkClick xmlns:r="http://schemas.openxmlformats.org/officeDocument/2006/relationships" r:id="R0fd72cf9e355403c"/>
               </a:rPr>
               <a:t>Official docs</a:t>
             </a:r>
@@ -36165,7 +36555,7 @@
                 <a:ea typeface="Consolas"/>
                 <a:cs typeface="Consolas"/>
               </a:rPr>
-              <a:t>NOT SEPARATELY WEIGHTED</a:t>
+              <a:t>GOVERNED RE-SCORE</a:t>
             </a:r>
           </a:p>
         </p:txBody>
@@ -36224,7 +36614,7 @@
                 <a:ea typeface="Georgia"/>
                 <a:cs typeface="Georgia"/>
               </a:rPr>
-              <a:t>Four decisions remain hidden</a:t>
+              <a:t>Six dimensions stay pending</a:t>
             </a:r>
           </a:p>
         </p:txBody>
@@ -36283,7 +36673,7 @@
                 <a:ea typeface="Arial"/>
                 <a:cs typeface="Arial"/>
               </a:rPr>
-              <a:t>• Developer experience / self-service</a:t>
+              <a:t>• Multicloud / sovereignty</a:t>
             </a:r>
           </a:p>
           <a:p xmlns:a="http://schemas.openxmlformats.org/drawingml/2006/main">
@@ -36307,7 +36697,7 @@
                 <a:ea typeface="Arial"/>
                 <a:cs typeface="Arial"/>
               </a:rPr>
-              <a:t>• Multicloud placement and sovereignty</a:t>
+              <a:t>• Scalability / robustness</a:t>
             </a:r>
           </a:p>
           <a:p xmlns:a="http://schemas.openxmlformats.org/drawingml/2006/main">
@@ -36331,7 +36721,7 @@
                 <a:ea typeface="Arial"/>
                 <a:cs typeface="Arial"/>
               </a:rPr>
-              <a:t>• Migration effort and coexistence</a:t>
+              <a:t>• Security, IAM / traceability</a:t>
             </a:r>
           </a:p>
           <a:p xmlns:a="http://schemas.openxmlformats.org/drawingml/2006/main">
@@ -36355,7 +36745,55 @@
                 <a:ea typeface="Arial"/>
                 <a:cs typeface="Arial"/>
               </a:rPr>
-              <a:t>• Platform labor, HA/DR and commercial TCO</a:t>
+              <a:t>• Reversibility / vendor dependency</a:t>
+            </a:r>
+          </a:p>
+          <a:p xmlns:a="http://schemas.openxmlformats.org/drawingml/2006/main">
+            <a:pPr algn="l">
+              <a:buNone/>
+              <a:defRPr sz="1425" b="0" i="0">
+                <a:solidFill>
+                  <a:srgbClr val="686A66"/>
+                </a:solidFill>
+                <a:latin typeface="Arial"/>
+                <a:ea typeface="Arial"/>
+                <a:cs typeface="Arial"/>
+              </a:defRPr>
+            </a:pPr>
+            <a:r>
+              <a:rPr sz="1425" b="0" i="0">
+                <a:solidFill>
+                  <a:srgbClr val="686A66"/>
+                </a:solidFill>
+                <a:latin typeface="Arial"/>
+                <a:ea typeface="Arial"/>
+                <a:cs typeface="Arial"/>
+              </a:rPr>
+              <a:t>• Fully allocated TCO</a:t>
+            </a:r>
+          </a:p>
+          <a:p xmlns:a="http://schemas.openxmlformats.org/drawingml/2006/main">
+            <a:pPr algn="l">
+              <a:buNone/>
+              <a:defRPr sz="1425" b="0" i="0">
+                <a:solidFill>
+                  <a:srgbClr val="686A66"/>
+                </a:solidFill>
+                <a:latin typeface="Arial"/>
+                <a:ea typeface="Arial"/>
+                <a:cs typeface="Arial"/>
+              </a:defRPr>
+            </a:pPr>
+            <a:r>
+              <a:rPr sz="1425" b="0" i="0">
+                <a:solidFill>
+                  <a:srgbClr val="686A66"/>
+                </a:solidFill>
+                <a:latin typeface="Arial"/>
+                <a:ea typeface="Arial"/>
+                <a:cs typeface="Arial"/>
+              </a:rPr>
+              <a:t>• Control-plane operating duty</a:t>
             </a:r>
           </a:p>
         </p:txBody>
@@ -36414,7 +36852,7 @@
                 <a:ea typeface="Consolas"/>
                 <a:cs typeface="Consolas"/>
               </a:rPr>
-              <a:t>Implication</a:t>
+              <a:t>Rule</a:t>
             </a:r>
           </a:p>
         </p:txBody>
@@ -36449,7 +36887,7 @@
         </p:spPr>
         <p:txBody>
           <a:bodyPr xmlns:a="http://schemas.openxmlformats.org/drawingml/2006/main" wrap="square" lIns="0" tIns="0" rIns="0" bIns="0" anchor="t">
-            <a:normAutofit fontScale="92702"/>
+            <a:normAutofit fontScale="85379"/>
           </a:bodyPr>
           <a:lstStyle xmlns:a="http://schemas.openxmlformats.org/drawingml/2006/main"/>
           <a:p xmlns:a="http://schemas.openxmlformats.org/drawingml/2006/main">
@@ -36473,7 +36911,7 @@
                 <a:ea typeface="Georgia"/>
                 <a:cs typeface="Georgia"/>
               </a:rPr>
-              <a:t>Re-score after the proof programme supplies evidence and sensitivity ranges.</a:t>
+              <a:t>Approve weights, rubric, evidence floor, scorers and sensitivity before any new total.</a:t>
             </a:r>
           </a:p>
         </p:txBody>
@@ -36832,7 +37270,7 @@
                 <a:solidFill>
                   <a:srgbClr val="666762"/>
                 </a:solidFill>
-                <a:hlinkClick xmlns:r="http://schemas.openxmlformats.org/officeDocument/2006/relationships" r:id="Rf75a9349b5be48b1"/>
+                <a:hlinkClick xmlns:r="http://schemas.openxmlformats.org/officeDocument/2006/relationships" r:id="R43e07d92e3c149ef"/>
               </a:rPr>
               <a:t>Repo reference</a:t>
             </a:r>
@@ -36849,7 +37287,7 @@
                 <a:solidFill>
                   <a:srgbClr val="666762"/>
                 </a:solidFill>
-                <a:hlinkClick xmlns:r="http://schemas.openxmlformats.org/officeDocument/2006/relationships" r:id="R18155f8c7edc4c37"/>
+                <a:hlinkClick xmlns:r="http://schemas.openxmlformats.org/officeDocument/2006/relationships" r:id="Ra095d4038fdf44ea"/>
               </a:rPr>
               <a:t>Official docs</a:t>
             </a:r>
@@ -38555,7 +38993,7 @@
                 <a:ea typeface="Arial"/>
                 <a:cs typeface="Arial"/>
               </a:rPr>
-              <a:t>The supplied model puts Kong first—before evidence confidence is applied</a:t>
+              <a:t>Preserve the historical score; govern the re-score</a:t>
             </a:r>
           </a:p>
         </p:txBody>
@@ -38614,7 +39052,7 @@
                 <a:ea typeface="Arial"/>
                 <a:cs typeface="Arial"/>
               </a:rPr>
-              <a:t>Recalculated from the stated weights and ratings; illustrative author scoring only.</a:t>
+              <a:t>Corrected totals remain 93 / 85.5 / 77; added dimensions are pending approval.</a:t>
             </a:r>
           </a:p>
         </p:txBody>
@@ -38705,7 +39143,7 @@
                 <a:solidFill>
                   <a:srgbClr val="666762"/>
                 </a:solidFill>
-                <a:hlinkClick xmlns:r="http://schemas.openxmlformats.org/officeDocument/2006/relationships" r:id="R88879672033d4e82"/>
+                <a:hlinkClick xmlns:r="http://schemas.openxmlformats.org/officeDocument/2006/relationships" r:id="R1499fc48bf18445c"/>
               </a:rPr>
               <a:t>Repo reference</a:t>
             </a:r>
@@ -38722,7 +39160,7 @@
                 <a:solidFill>
                   <a:srgbClr val="666762"/>
                 </a:solidFill>
-                <a:hlinkClick xmlns:r="http://schemas.openxmlformats.org/officeDocument/2006/relationships" r:id="R8122a350462a4292"/>
+                <a:hlinkClick xmlns:r="http://schemas.openxmlformats.org/officeDocument/2006/relationships" r:id="R8dbd86b6b0274c09"/>
               </a:rPr>
               <a:t>Official docs</a:t>
             </a:r>
@@ -39721,7 +40159,7 @@
         </p:spPr>
         <p:txBody>
           <a:bodyPr xmlns:a="http://schemas.openxmlformats.org/drawingml/2006/main" wrap="square" lIns="0" tIns="0" rIns="0" bIns="0" anchor="t">
-            <a:normAutofit fontScale="87150"/>
+            <a:normAutofit fontScale="100000"/>
           </a:bodyPr>
           <a:lstStyle xmlns:a="http://schemas.openxmlformats.org/drawingml/2006/main"/>
           <a:p xmlns:a="http://schemas.openxmlformats.org/drawingml/2006/main">
@@ -39745,7 +40183,7 @@
                 <a:ea typeface="Georgia"/>
                 <a:cs typeface="Georgia"/>
               </a:rPr>
-              <a:t>Do not approve production from this score</a:t>
+              <a:t>Governed re-score pending</a:t>
             </a:r>
           </a:p>
         </p:txBody>
@@ -39804,7 +40242,7 @@
                 <a:ea typeface="Arial"/>
                 <a:cs typeface="Arial"/>
               </a:rPr>
-              <a:t>Missing: scoring rubric · named scorers · evidence map · confidence · sensitivity · editions · commercial basis</a:t>
+              <a:t>No new total until exact options · six dimensions · weights/ranges · rubric · evidence floor · scorers · sensitivity · dissent · approval</a:t>
             </a:r>
           </a:p>
         </p:txBody>
@@ -40163,7 +40601,7 @@
                 <a:solidFill>
                   <a:srgbClr val="666762"/>
                 </a:solidFill>
-                <a:hlinkClick xmlns:r="http://schemas.openxmlformats.org/officeDocument/2006/relationships" r:id="R7846045e644648b2"/>
+                <a:hlinkClick xmlns:r="http://schemas.openxmlformats.org/officeDocument/2006/relationships" r:id="Rf60ec131aa3e47e2"/>
               </a:rPr>
               <a:t>Repo reference</a:t>
             </a:r>
@@ -40180,7 +40618,7 @@
                 <a:solidFill>
                   <a:srgbClr val="666762"/>
                 </a:solidFill>
-                <a:hlinkClick xmlns:r="http://schemas.openxmlformats.org/officeDocument/2006/relationships" r:id="R855dabcda0f84546"/>
+                <a:hlinkClick xmlns:r="http://schemas.openxmlformats.org/officeDocument/2006/relationships" r:id="R1147370ba3824598"/>
               </a:rPr>
               <a:t>Official docs</a:t>
             </a:r>
@@ -41285,7 +41723,7 @@
                 <a:solidFill>
                   <a:srgbClr val="666762"/>
                 </a:solidFill>
-                <a:hlinkClick xmlns:r="http://schemas.openxmlformats.org/officeDocument/2006/relationships" r:id="R40b18f316e974fdb"/>
+                <a:hlinkClick xmlns:r="http://schemas.openxmlformats.org/officeDocument/2006/relationships" r:id="Rf25d17a953474647"/>
               </a:rPr>
               <a:t>Repo reference</a:t>
             </a:r>
@@ -41302,7 +41740,7 @@
                 <a:solidFill>
                   <a:srgbClr val="666762"/>
                 </a:solidFill>
-                <a:hlinkClick xmlns:r="http://schemas.openxmlformats.org/officeDocument/2006/relationships" r:id="R8c4120106ef94e9f"/>
+                <a:hlinkClick xmlns:r="http://schemas.openxmlformats.org/officeDocument/2006/relationships" r:id="Rbdc628a493f24ada"/>
               </a:rPr>
               <a:t>Official docs</a:t>
             </a:r>
@@ -42387,7 +42825,7 @@
                 <a:ea typeface="Arial"/>
                 <a:cs typeface="Arial"/>
               </a:rPr>
-              <a:t>Self-managed control works only if the enterprise funds the duty</a:t>
+              <a:t>Control-plane custody transfers operating accountability</a:t>
             </a:r>
           </a:p>
         </p:txBody>
@@ -42446,7 +42884,7 @@
                 <a:ea typeface="Arial"/>
                 <a:cs typeface="Arial"/>
               </a:rPr>
-              <a:t>Control-plane custody is an operating model—not a free architecture property.</a:t>
+              <a:t>Control advantage must be weighed against permanent CP, database, trust, plugin, support and on-call duty.</a:t>
             </a:r>
           </a:p>
         </p:txBody>
@@ -42537,7 +42975,7 @@
                 <a:solidFill>
                   <a:srgbClr val="666762"/>
                 </a:solidFill>
-                <a:hlinkClick xmlns:r="http://schemas.openxmlformats.org/officeDocument/2006/relationships" r:id="R7788c1b87a914549"/>
+                <a:hlinkClick xmlns:r="http://schemas.openxmlformats.org/officeDocument/2006/relationships" r:id="Rb6ee57469edd4a85"/>
               </a:rPr>
               <a:t>Repo reference</a:t>
             </a:r>
@@ -42554,7 +42992,7 @@
                 <a:solidFill>
                   <a:srgbClr val="666762"/>
                 </a:solidFill>
-                <a:hlinkClick xmlns:r="http://schemas.openxmlformats.org/officeDocument/2006/relationships" r:id="R6bb072e5547e46c8"/>
+                <a:hlinkClick xmlns:r="http://schemas.openxmlformats.org/officeDocument/2006/relationships" r:id="R4164bce6d9c8461f"/>
               </a:rPr>
               <a:t>Official docs</a:t>
             </a:r>
@@ -43124,7 +43562,7 @@
                 <a:ea typeface="Consolas"/>
                 <a:cs typeface="Consolas"/>
               </a:rPr>
-              <a:t>PERMANENT DUTY</a:t>
+              <a:t>OPERATING ACCOUNTABILITY</a:t>
             </a:r>
           </a:p>
         </p:txBody>
@@ -43214,7 +43652,7 @@
                 <a:ea typeface="Arial"/>
                 <a:cs typeface="Arial"/>
               </a:rPr>
-              <a:t>Control-plane service and PostgreSQL HA</a:t>
+              <a:t>Scalability, regional robustness and recovery</a:t>
             </a:r>
           </a:p>
         </p:txBody>
@@ -43304,7 +43742,7 @@
                 <a:ea typeface="Arial"/>
                 <a:cs typeface="Arial"/>
               </a:rPr>
-              <a:t>PKI, certificates and trust admission</a:t>
+              <a:t>Security, IAM, PKI and access lifecycle</a:t>
             </a:r>
           </a:p>
         </p:txBody>
@@ -43394,7 +43832,7 @@
                 <a:ea typeface="Arial"/>
                 <a:cs typeface="Arial"/>
               </a:rPr>
-              <a:t>Backup, restore, upgrade and rollback boundaries</a:t>
+              <a:t>Traceability, evidence custody and privacy</a:t>
             </a:r>
           </a:p>
         </p:txBody>
@@ -43484,7 +43922,7 @@
                 <a:ea typeface="Arial"/>
                 <a:cs typeface="Arial"/>
               </a:rPr>
-              <a:t>24×7 ownership, observability and capacity</a:t>
+              <a:t>Licensing, support and fully allocated TCO</a:t>
             </a:r>
           </a:p>
         </p:txBody>
@@ -43519,7 +43957,7 @@
         </p:spPr>
         <p:txBody>
           <a:bodyPr xmlns:a="http://schemas.openxmlformats.org/drawingml/2006/main" wrap="square" lIns="0" tIns="0" rIns="0" bIns="0" anchor="t">
-            <a:normAutofit fontScale="98159"/>
+            <a:normAutofit fontScale="100000"/>
           </a:bodyPr>
           <a:lstStyle xmlns:a="http://schemas.openxmlformats.org/drawingml/2006/main"/>
           <a:p xmlns:a="http://schemas.openxmlformats.org/drawingml/2006/main">
@@ -43543,7 +43981,7 @@
                 <a:ea typeface="Georgia"/>
                 <a:cs typeface="Georgia"/>
               </a:rPr>
-              <a:t>Answer changes when custody is only a preference—or the enterprise will not fund this duty.</a:t>
+              <a:t>Operating responsibility exposure—not a legal-liability determination.</a:t>
             </a:r>
           </a:p>
         </p:txBody>
@@ -43902,7 +44340,7 @@
                 <a:solidFill>
                   <a:srgbClr val="666762"/>
                 </a:solidFill>
-                <a:hlinkClick xmlns:r="http://schemas.openxmlformats.org/officeDocument/2006/relationships" r:id="R5ae7d99a0a57461a"/>
+                <a:hlinkClick xmlns:r="http://schemas.openxmlformats.org/officeDocument/2006/relationships" r:id="R6018f5851e4b41c1"/>
               </a:rPr>
               <a:t>Repo reference</a:t>
             </a:r>
@@ -43919,7 +44357,7 @@
                 <a:solidFill>
                   <a:srgbClr val="666762"/>
                 </a:solidFill>
-                <a:hlinkClick xmlns:r="http://schemas.openxmlformats.org/officeDocument/2006/relationships" r:id="R20627e867ec94bc7"/>
+                <a:hlinkClick xmlns:r="http://schemas.openxmlformats.org/officeDocument/2006/relationships" r:id="Rb56598cfbfc2479c"/>
               </a:rPr>
               <a:t>Official docs</a:t>
             </a:r>
@@ -44446,7 +44884,7 @@
       </p:sp>
       <p:cxnSp>
         <p:nvCxnSpPr>
-          <p:cNvPr id="345" name=""/>
+          <p:cNvPr id="480" name=""/>
           <p:cNvCxnSpPr>
             <a:stCxn xmlns:a="http://schemas.openxmlformats.org/drawingml/2006/main" id="16" idx="0"/>
             <a:endCxn xmlns:a="http://schemas.openxmlformats.org/drawingml/2006/main" id="10" idx="2"/>
@@ -44472,7 +44910,7 @@
       </p:cxnSp>
       <p:cxnSp>
         <p:nvCxnSpPr>
-          <p:cNvPr id="346" name=""/>
+          <p:cNvPr id="481" name=""/>
           <p:cNvCxnSpPr>
             <a:stCxn xmlns:a="http://schemas.openxmlformats.org/drawingml/2006/main" id="10" idx="2"/>
             <a:endCxn xmlns:a="http://schemas.openxmlformats.org/drawingml/2006/main" id="13" idx="0"/>
@@ -45016,7 +45454,7 @@
       </p:sp>
       <p:cxnSp>
         <p:nvCxnSpPr>
-          <p:cNvPr id="357" name=""/>
+          <p:cNvPr id="492" name=""/>
           <p:cNvCxnSpPr>
             <a:stCxn xmlns:a="http://schemas.openxmlformats.org/drawingml/2006/main" id="10" idx="3"/>
             <a:endCxn xmlns:a="http://schemas.openxmlformats.org/drawingml/2006/main" id="21" idx="1"/>
@@ -45044,7 +45482,7 @@
       </p:cxnSp>
       <p:cxnSp>
         <p:nvCxnSpPr>
-          <p:cNvPr id="358" name=""/>
+          <p:cNvPr id="493" name=""/>
           <p:cNvCxnSpPr>
             <a:stCxn xmlns:a="http://schemas.openxmlformats.org/drawingml/2006/main" id="10" idx="3"/>
             <a:endCxn xmlns:a="http://schemas.openxmlformats.org/drawingml/2006/main" id="24" idx="1"/>
@@ -45072,7 +45510,7 @@
       </p:cxnSp>
       <p:cxnSp>
         <p:nvCxnSpPr>
-          <p:cNvPr id="359" name=""/>
+          <p:cNvPr id="494" name=""/>
           <p:cNvCxnSpPr>
             <a:stCxn xmlns:a="http://schemas.openxmlformats.org/drawingml/2006/main" id="10" idx="3"/>
             <a:endCxn xmlns:a="http://schemas.openxmlformats.org/drawingml/2006/main" id="27" idx="1"/>
@@ -45618,7 +46056,7 @@
       </p:sp>
       <p:cxnSp>
         <p:nvCxnSpPr>
-          <p:cNvPr id="370" name=""/>
+          <p:cNvPr id="505" name=""/>
           <p:cNvCxnSpPr>
             <a:stCxn xmlns:a="http://schemas.openxmlformats.org/drawingml/2006/main" id="21" idx="3"/>
             <a:endCxn xmlns:a="http://schemas.openxmlformats.org/drawingml/2006/main" id="34" idx="1"/>
@@ -45644,7 +46082,7 @@
       </p:cxnSp>
       <p:cxnSp>
         <p:nvCxnSpPr>
-          <p:cNvPr id="371" name=""/>
+          <p:cNvPr id="506" name=""/>
           <p:cNvCxnSpPr>
             <a:stCxn xmlns:a="http://schemas.openxmlformats.org/drawingml/2006/main" id="24" idx="3"/>
             <a:endCxn xmlns:a="http://schemas.openxmlformats.org/drawingml/2006/main" id="37" idx="1"/>
@@ -45670,7 +46108,7 @@
       </p:cxnSp>
       <p:cxnSp>
         <p:nvCxnSpPr>
-          <p:cNvPr id="372" name=""/>
+          <p:cNvPr id="507" name=""/>
           <p:cNvCxnSpPr>
             <a:stCxn xmlns:a="http://schemas.openxmlformats.org/drawingml/2006/main" id="27" idx="3"/>
             <a:endCxn xmlns:a="http://schemas.openxmlformats.org/drawingml/2006/main" id="40" idx="1"/>

</xml_diff>

<commit_message>
fix: clarify Kong architecture control flows
</commit_message>
<xml_diff>
--- a/presentations/kong-platform-journey-guided.pptx
+++ b/presentations/kong-platform-journey-guided.pptx
@@ -2,37 +2,37 @@
 <file path=ppt/presentation.xml><?xml version="1.0" encoding="utf-8"?>
 <p:presentation xmlns:p="http://schemas.openxmlformats.org/presentationml/2006/main">
   <p:sldMasterIdLst>
-    <p:sldMasterId xmlns:r="http://schemas.openxmlformats.org/officeDocument/2006/relationships" id="2147483648" r:id="R60c804bd99cd4a7a"/>
+    <p:sldMasterId xmlns:r="http://schemas.openxmlformats.org/officeDocument/2006/relationships" id="2147483648" r:id="R975861b5c8804d56"/>
   </p:sldMasterIdLst>
   <p:notesMasterIdLst>
-    <p:notesMasterId xmlns:r="http://schemas.openxmlformats.org/officeDocument/2006/relationships" r:id="R8ea8645e99654ead"/>
+    <p:notesMasterId xmlns:r="http://schemas.openxmlformats.org/officeDocument/2006/relationships" r:id="R922eed57b6a641ad"/>
   </p:notesMasterIdLst>
   <p:sldIdLst>
-    <p:sldId xmlns:r="http://schemas.openxmlformats.org/officeDocument/2006/relationships" id="256" r:id="R60417037ab624d4e"/>
-    <p:sldId xmlns:r="http://schemas.openxmlformats.org/officeDocument/2006/relationships" id="257" r:id="R2c199ce8f9684364"/>
-    <p:sldId xmlns:r="http://schemas.openxmlformats.org/officeDocument/2006/relationships" id="258" r:id="R48ce7bd25dec4235"/>
-    <p:sldId xmlns:r="http://schemas.openxmlformats.org/officeDocument/2006/relationships" id="259" r:id="Re4762e8e39b04711"/>
-    <p:sldId xmlns:r="http://schemas.openxmlformats.org/officeDocument/2006/relationships" id="260" r:id="R16fd0fd65f784461"/>
-    <p:sldId xmlns:r="http://schemas.openxmlformats.org/officeDocument/2006/relationships" id="261" r:id="Re445c32833474ff5"/>
-    <p:sldId xmlns:r="http://schemas.openxmlformats.org/officeDocument/2006/relationships" id="262" r:id="R08461cd261c94f1e"/>
-    <p:sldId xmlns:r="http://schemas.openxmlformats.org/officeDocument/2006/relationships" id="263" r:id="Rffb9be0cbc5f4415"/>
-    <p:sldId xmlns:r="http://schemas.openxmlformats.org/officeDocument/2006/relationships" id="264" r:id="Rf781b49f08324795"/>
-    <p:sldId xmlns:r="http://schemas.openxmlformats.org/officeDocument/2006/relationships" id="265" r:id="R5bb1afb818294251"/>
-    <p:sldId xmlns:r="http://schemas.openxmlformats.org/officeDocument/2006/relationships" id="266" r:id="R6790b2e26b3a419a"/>
-    <p:sldId xmlns:r="http://schemas.openxmlformats.org/officeDocument/2006/relationships" id="267" r:id="R9804fcbc98614d06"/>
-    <p:sldId xmlns:r="http://schemas.openxmlformats.org/officeDocument/2006/relationships" id="268" r:id="R10e24505592b4505"/>
-    <p:sldId xmlns:r="http://schemas.openxmlformats.org/officeDocument/2006/relationships" id="269" r:id="Rcd5635638bcd45b5"/>
-    <p:sldId xmlns:r="http://schemas.openxmlformats.org/officeDocument/2006/relationships" id="270" r:id="Rd58c9f084f0b46b5"/>
-    <p:sldId xmlns:r="http://schemas.openxmlformats.org/officeDocument/2006/relationships" id="271" r:id="Rec23cc3e4a1e43dc"/>
-    <p:sldId xmlns:r="http://schemas.openxmlformats.org/officeDocument/2006/relationships" id="272" r:id="Rb5ae40211be346ad"/>
-    <p:sldId xmlns:r="http://schemas.openxmlformats.org/officeDocument/2006/relationships" id="273" r:id="R803f531d739240e5"/>
-    <p:sldId xmlns:r="http://schemas.openxmlformats.org/officeDocument/2006/relationships" id="274" r:id="R9ad9ab9f0b6a4e70"/>
-    <p:sldId xmlns:r="http://schemas.openxmlformats.org/officeDocument/2006/relationships" id="275" r:id="Rf59d9b1dddb24942"/>
-    <p:sldId xmlns:r="http://schemas.openxmlformats.org/officeDocument/2006/relationships" id="276" r:id="Rb14b10d23ac14a3a"/>
-    <p:sldId xmlns:r="http://schemas.openxmlformats.org/officeDocument/2006/relationships" id="277" r:id="R30310c1fae894f85"/>
-    <p:sldId xmlns:r="http://schemas.openxmlformats.org/officeDocument/2006/relationships" id="278" r:id="R4dc361fa1cda4753"/>
-    <p:sldId xmlns:r="http://schemas.openxmlformats.org/officeDocument/2006/relationships" id="279" r:id="R6eefa3814d5a4a13"/>
-    <p:sldId xmlns:r="http://schemas.openxmlformats.org/officeDocument/2006/relationships" id="280" r:id="Re9286a7dffdd4137"/>
+    <p:sldId xmlns:r="http://schemas.openxmlformats.org/officeDocument/2006/relationships" id="256" r:id="R9e70a360828e44f9"/>
+    <p:sldId xmlns:r="http://schemas.openxmlformats.org/officeDocument/2006/relationships" id="257" r:id="R083f11c5772744ec"/>
+    <p:sldId xmlns:r="http://schemas.openxmlformats.org/officeDocument/2006/relationships" id="258" r:id="Rbe22d6f50c4d4d42"/>
+    <p:sldId xmlns:r="http://schemas.openxmlformats.org/officeDocument/2006/relationships" id="259" r:id="R3519d4f3ff3544b8"/>
+    <p:sldId xmlns:r="http://schemas.openxmlformats.org/officeDocument/2006/relationships" id="260" r:id="R9eb020fddcc444f0"/>
+    <p:sldId xmlns:r="http://schemas.openxmlformats.org/officeDocument/2006/relationships" id="261" r:id="R94485daa3e0e4c8f"/>
+    <p:sldId xmlns:r="http://schemas.openxmlformats.org/officeDocument/2006/relationships" id="262" r:id="Rb6751758b970431b"/>
+    <p:sldId xmlns:r="http://schemas.openxmlformats.org/officeDocument/2006/relationships" id="263" r:id="R92935a1cd7a14976"/>
+    <p:sldId xmlns:r="http://schemas.openxmlformats.org/officeDocument/2006/relationships" id="264" r:id="R3dadd38e036245ec"/>
+    <p:sldId xmlns:r="http://schemas.openxmlformats.org/officeDocument/2006/relationships" id="265" r:id="R3205d701fde4405f"/>
+    <p:sldId xmlns:r="http://schemas.openxmlformats.org/officeDocument/2006/relationships" id="266" r:id="R39985952344b4606"/>
+    <p:sldId xmlns:r="http://schemas.openxmlformats.org/officeDocument/2006/relationships" id="267" r:id="Rf448f58b70694253"/>
+    <p:sldId xmlns:r="http://schemas.openxmlformats.org/officeDocument/2006/relationships" id="268" r:id="R090135c77e294254"/>
+    <p:sldId xmlns:r="http://schemas.openxmlformats.org/officeDocument/2006/relationships" id="269" r:id="R6622dfbad56c4f0c"/>
+    <p:sldId xmlns:r="http://schemas.openxmlformats.org/officeDocument/2006/relationships" id="270" r:id="R0b2befc46e6d4c88"/>
+    <p:sldId xmlns:r="http://schemas.openxmlformats.org/officeDocument/2006/relationships" id="271" r:id="Rb206314e6fd541a8"/>
+    <p:sldId xmlns:r="http://schemas.openxmlformats.org/officeDocument/2006/relationships" id="272" r:id="Rda0673765add44a5"/>
+    <p:sldId xmlns:r="http://schemas.openxmlformats.org/officeDocument/2006/relationships" id="273" r:id="R85b5241bdda74030"/>
+    <p:sldId xmlns:r="http://schemas.openxmlformats.org/officeDocument/2006/relationships" id="274" r:id="Rbfbb077bfdbf44ea"/>
+    <p:sldId xmlns:r="http://schemas.openxmlformats.org/officeDocument/2006/relationships" id="275" r:id="Rfe6e5236d69b4b5a"/>
+    <p:sldId xmlns:r="http://schemas.openxmlformats.org/officeDocument/2006/relationships" id="276" r:id="R2926369e4c2343b8"/>
+    <p:sldId xmlns:r="http://schemas.openxmlformats.org/officeDocument/2006/relationships" id="277" r:id="R625759e43a16404a"/>
+    <p:sldId xmlns:r="http://schemas.openxmlformats.org/officeDocument/2006/relationships" id="278" r:id="R1b919f9b039d4020"/>
+    <p:sldId xmlns:r="http://schemas.openxmlformats.org/officeDocument/2006/relationships" id="279" r:id="R87edbf3ab0884e57"/>
+    <p:sldId xmlns:r="http://schemas.openxmlformats.org/officeDocument/2006/relationships" id="280" r:id="R3ce78a58660746ea"/>
   </p:sldIdLst>
   <p:sldSz cx="12192000" cy="6858000"/>
   <p:notesSz cx="6858000" cy="9144000"/>
@@ -4594,7 +4594,7 @@
   </p:cSld>
   <p:clrMap bg1="lt1" tx1="dk1" bg2="lt2" tx2="dk2" accent1="accent1" accent2="accent2" accent3="accent3" accent4="accent4" accent5="accent5" accent6="accent6" hlink="hlink" folHlink="folHlink"/>
   <p:sldLayoutIdLst>
-    <p:sldLayoutId xmlns:r="http://schemas.openxmlformats.org/officeDocument/2006/relationships" id="2147483649" r:id="R919bba39c6d941da"/>
+    <p:sldLayoutId xmlns:r="http://schemas.openxmlformats.org/officeDocument/2006/relationships" id="2147483649" r:id="Rdc7a175706444340"/>
   </p:sldLayoutIdLst>
   <p:txStyles>
     <p:titleStyle>
@@ -5896,7 +5896,7 @@
                 <a:solidFill>
                   <a:srgbClr val="666762"/>
                 </a:solidFill>
-                <a:hlinkClick xmlns:r="http://schemas.openxmlformats.org/officeDocument/2006/relationships" r:id="R063df1eeff244169"/>
+                <a:hlinkClick xmlns:r="http://schemas.openxmlformats.org/officeDocument/2006/relationships" r:id="R18b3931df0674cbd"/>
               </a:rPr>
               <a:t>Repo reference</a:t>
             </a:r>
@@ -5913,7 +5913,7 @@
                 <a:solidFill>
                   <a:srgbClr val="666762"/>
                 </a:solidFill>
-                <a:hlinkClick xmlns:r="http://schemas.openxmlformats.org/officeDocument/2006/relationships" r:id="Rabfc1b3f59d745bf"/>
+                <a:hlinkClick xmlns:r="http://schemas.openxmlformats.org/officeDocument/2006/relationships" r:id="R6f2cc002186e4538"/>
               </a:rPr>
               <a:t>Official docs</a:t>
             </a:r>
@@ -6274,7 +6274,7 @@
                 <a:solidFill>
                   <a:srgbClr val="666762"/>
                 </a:solidFill>
-                <a:hlinkClick xmlns:r="http://schemas.openxmlformats.org/officeDocument/2006/relationships" r:id="Rf1f8380c03b349e3"/>
+                <a:hlinkClick xmlns:r="http://schemas.openxmlformats.org/officeDocument/2006/relationships" r:id="R486679cd395d4f4b"/>
               </a:rPr>
               <a:t>Repo reference</a:t>
             </a:r>
@@ -6291,7 +6291,7 @@
                 <a:solidFill>
                   <a:srgbClr val="666762"/>
                 </a:solidFill>
-                <a:hlinkClick xmlns:r="http://schemas.openxmlformats.org/officeDocument/2006/relationships" r:id="R6ce6f9e3429549b3"/>
+                <a:hlinkClick xmlns:r="http://schemas.openxmlformats.org/officeDocument/2006/relationships" r:id="R882b0e3b9ba8486c"/>
               </a:rPr>
               <a:t>Official docs</a:t>
             </a:r>
@@ -7580,7 +7580,7 @@
                 <a:solidFill>
                   <a:srgbClr val="666762"/>
                 </a:solidFill>
-                <a:hlinkClick xmlns:r="http://schemas.openxmlformats.org/officeDocument/2006/relationships" r:id="Rafbb0ef3c20f4602"/>
+                <a:hlinkClick xmlns:r="http://schemas.openxmlformats.org/officeDocument/2006/relationships" r:id="Rbc372a36e6814a61"/>
               </a:rPr>
               <a:t>Repo reference</a:t>
             </a:r>
@@ -7597,7 +7597,7 @@
                 <a:solidFill>
                   <a:srgbClr val="666762"/>
                 </a:solidFill>
-                <a:hlinkClick xmlns:r="http://schemas.openxmlformats.org/officeDocument/2006/relationships" r:id="R43d221ddfb2240a0"/>
+                <a:hlinkClick xmlns:r="http://schemas.openxmlformats.org/officeDocument/2006/relationships" r:id="R1f842da340dc4db5"/>
               </a:rPr>
               <a:t>Official docs</a:t>
             </a:r>
@@ -8373,7 +8373,7 @@
       </p:sp>
       <p:cxnSp>
         <p:nvCxnSpPr>
-          <p:cNvPr id="263" name=""/>
+          <p:cNvPr id="309" name=""/>
           <p:cNvCxnSpPr>
             <a:stCxn xmlns:a="http://schemas.openxmlformats.org/drawingml/2006/main" id="9" idx="3"/>
             <a:endCxn xmlns:a="http://schemas.openxmlformats.org/drawingml/2006/main" id="12" idx="1"/>
@@ -8399,7 +8399,7 @@
       </p:cxnSp>
       <p:cxnSp>
         <p:nvCxnSpPr>
-          <p:cNvPr id="264" name=""/>
+          <p:cNvPr id="310" name=""/>
           <p:cNvCxnSpPr>
             <a:stCxn xmlns:a="http://schemas.openxmlformats.org/drawingml/2006/main" id="12" idx="3"/>
             <a:endCxn xmlns:a="http://schemas.openxmlformats.org/drawingml/2006/main" id="15" idx="1"/>
@@ -8425,7 +8425,7 @@
       </p:cxnSp>
       <p:cxnSp>
         <p:nvCxnSpPr>
-          <p:cNvPr id="265" name=""/>
+          <p:cNvPr id="311" name=""/>
           <p:cNvCxnSpPr>
             <a:stCxn xmlns:a="http://schemas.openxmlformats.org/drawingml/2006/main" id="15" idx="3"/>
             <a:endCxn xmlns:a="http://schemas.openxmlformats.org/drawingml/2006/main" id="18" idx="1"/>
@@ -9407,7 +9407,7 @@
                 <a:solidFill>
                   <a:srgbClr val="666762"/>
                 </a:solidFill>
-                <a:hlinkClick xmlns:r="http://schemas.openxmlformats.org/officeDocument/2006/relationships" r:id="Rd2d3cea478524721"/>
+                <a:hlinkClick xmlns:r="http://schemas.openxmlformats.org/officeDocument/2006/relationships" r:id="R986a96f400774a58"/>
               </a:rPr>
               <a:t>Repo reference</a:t>
             </a:r>
@@ -9424,7 +9424,7 @@
                 <a:solidFill>
                   <a:srgbClr val="666762"/>
                 </a:solidFill>
-                <a:hlinkClick xmlns:r="http://schemas.openxmlformats.org/officeDocument/2006/relationships" r:id="R539c58432d4744c9"/>
+                <a:hlinkClick xmlns:r="http://schemas.openxmlformats.org/officeDocument/2006/relationships" r:id="R26160a55e6e247e6"/>
               </a:rPr>
               <a:t>Official docs</a:t>
             </a:r>
@@ -11059,7 +11059,7 @@
                 <a:solidFill>
                   <a:srgbClr val="666762"/>
                 </a:solidFill>
-                <a:hlinkClick xmlns:r="http://schemas.openxmlformats.org/officeDocument/2006/relationships" r:id="Ra2b5e1c4e28a46a7"/>
+                <a:hlinkClick xmlns:r="http://schemas.openxmlformats.org/officeDocument/2006/relationships" r:id="R064ac837132c4098"/>
               </a:rPr>
               <a:t>Repo reference</a:t>
             </a:r>
@@ -11076,7 +11076,7 @@
                 <a:solidFill>
                   <a:srgbClr val="666762"/>
                 </a:solidFill>
-                <a:hlinkClick xmlns:r="http://schemas.openxmlformats.org/officeDocument/2006/relationships" r:id="Rf70857b4e97e4c7d"/>
+                <a:hlinkClick xmlns:r="http://schemas.openxmlformats.org/officeDocument/2006/relationships" r:id="R15942daaa3cf4b43"/>
               </a:rPr>
               <a:t>Official docs</a:t>
             </a:r>
@@ -13303,7 +13303,7 @@
                 <a:solidFill>
                   <a:srgbClr val="666762"/>
                 </a:solidFill>
-                <a:hlinkClick xmlns:r="http://schemas.openxmlformats.org/officeDocument/2006/relationships" r:id="Rf626b329861a487b"/>
+                <a:hlinkClick xmlns:r="http://schemas.openxmlformats.org/officeDocument/2006/relationships" r:id="Rdc1d9af182974e34"/>
               </a:rPr>
               <a:t>Repo reference</a:t>
             </a:r>
@@ -13320,7 +13320,7 @@
                 <a:solidFill>
                   <a:srgbClr val="666762"/>
                 </a:solidFill>
-                <a:hlinkClick xmlns:r="http://schemas.openxmlformats.org/officeDocument/2006/relationships" r:id="R712569a5a4d54fb7"/>
+                <a:hlinkClick xmlns:r="http://schemas.openxmlformats.org/officeDocument/2006/relationships" r:id="R15f6e7610c514a41"/>
               </a:rPr>
               <a:t>Official docs</a:t>
             </a:r>
@@ -15266,7 +15266,7 @@
                 <a:solidFill>
                   <a:srgbClr val="666762"/>
                 </a:solidFill>
-                <a:hlinkClick xmlns:r="http://schemas.openxmlformats.org/officeDocument/2006/relationships" r:id="R1263daf97d134853"/>
+                <a:hlinkClick xmlns:r="http://schemas.openxmlformats.org/officeDocument/2006/relationships" r:id="R09d9dda4f9024890"/>
               </a:rPr>
               <a:t>Repo reference</a:t>
             </a:r>
@@ -15283,7 +15283,7 @@
                 <a:solidFill>
                   <a:srgbClr val="666762"/>
                 </a:solidFill>
-                <a:hlinkClick xmlns:r="http://schemas.openxmlformats.org/officeDocument/2006/relationships" r:id="R4bbe7096d3104c54"/>
+                <a:hlinkClick xmlns:r="http://schemas.openxmlformats.org/officeDocument/2006/relationships" r:id="R4f6e0cf26e9042b3"/>
               </a:rPr>
               <a:t>Official docs</a:t>
             </a:r>
@@ -16140,7 +16140,7 @@
       </p:sp>
       <p:cxnSp>
         <p:nvCxnSpPr>
-          <p:cNvPr id="307" name=""/>
+          <p:cNvPr id="363" name=""/>
           <p:cNvCxnSpPr>
             <a:stCxn xmlns:a="http://schemas.openxmlformats.org/drawingml/2006/main" id="9" idx="3"/>
             <a:endCxn xmlns:a="http://schemas.openxmlformats.org/drawingml/2006/main" id="12" idx="1"/>
@@ -16166,7 +16166,7 @@
       </p:cxnSp>
       <p:cxnSp>
         <p:nvCxnSpPr>
-          <p:cNvPr id="308" name=""/>
+          <p:cNvPr id="364" name=""/>
           <p:cNvCxnSpPr>
             <a:stCxn xmlns:a="http://schemas.openxmlformats.org/drawingml/2006/main" id="12" idx="3"/>
             <a:endCxn xmlns:a="http://schemas.openxmlformats.org/drawingml/2006/main" id="15" idx="1"/>
@@ -16194,7 +16194,7 @@
       </p:cxnSp>
       <p:cxnSp>
         <p:nvCxnSpPr>
-          <p:cNvPr id="309" name=""/>
+          <p:cNvPr id="365" name=""/>
           <p:cNvCxnSpPr>
             <a:stCxn xmlns:a="http://schemas.openxmlformats.org/drawingml/2006/main" id="12" idx="3"/>
             <a:endCxn xmlns:a="http://schemas.openxmlformats.org/drawingml/2006/main" id="18" idx="1"/>
@@ -16222,7 +16222,7 @@
       </p:cxnSp>
       <p:cxnSp>
         <p:nvCxnSpPr>
-          <p:cNvPr id="310" name=""/>
+          <p:cNvPr id="366" name=""/>
           <p:cNvCxnSpPr>
             <a:stCxn xmlns:a="http://schemas.openxmlformats.org/drawingml/2006/main" id="15" idx="3"/>
             <a:endCxn xmlns:a="http://schemas.openxmlformats.org/drawingml/2006/main" id="21" idx="1"/>
@@ -16250,7 +16250,7 @@
       </p:cxnSp>
       <p:cxnSp>
         <p:nvCxnSpPr>
-          <p:cNvPr id="311" name=""/>
+          <p:cNvPr id="367" name=""/>
           <p:cNvCxnSpPr>
             <a:stCxn xmlns:a="http://schemas.openxmlformats.org/drawingml/2006/main" id="18" idx="3"/>
             <a:endCxn xmlns:a="http://schemas.openxmlformats.org/drawingml/2006/main" id="21" idx="1"/>
@@ -16700,7 +16700,7 @@
                 <a:latin typeface="Arial"/>
                 <a:ea typeface="Arial"/>
                 <a:cs typeface="Arial"/>
-                <a:hlinkClick xmlns:r="http://schemas.openxmlformats.org/officeDocument/2006/relationships" r:id="R62e375ce0497439d"/>
+                <a:hlinkClick xmlns:r="http://schemas.openxmlformats.org/officeDocument/2006/relationships" r:id="R911fb143ee444a90"/>
               </a:rPr>
               <a:t>Apigee A0–A6</a:t>
             </a:r>
@@ -16804,7 +16804,7 @@
                 <a:solidFill>
                   <a:srgbClr val="666762"/>
                 </a:solidFill>
-                <a:hlinkClick xmlns:r="http://schemas.openxmlformats.org/officeDocument/2006/relationships" r:id="R1c28582fbaff48e4"/>
+                <a:hlinkClick xmlns:r="http://schemas.openxmlformats.org/officeDocument/2006/relationships" r:id="Rac7c1ddceb70471f"/>
               </a:rPr>
               <a:t>Repo reference</a:t>
             </a:r>
@@ -16821,7 +16821,7 @@
                 <a:solidFill>
                   <a:srgbClr val="666762"/>
                 </a:solidFill>
-                <a:hlinkClick xmlns:r="http://schemas.openxmlformats.org/officeDocument/2006/relationships" r:id="R7f21fb6e85534687"/>
+                <a:hlinkClick xmlns:r="http://schemas.openxmlformats.org/officeDocument/2006/relationships" r:id="R9e76e9e80ab14a5c"/>
               </a:rPr>
               <a:t>Official docs</a:t>
             </a:r>
@@ -19909,7 +19909,7 @@
                 <a:solidFill>
                   <a:srgbClr val="666762"/>
                 </a:solidFill>
-                <a:hlinkClick xmlns:r="http://schemas.openxmlformats.org/officeDocument/2006/relationships" r:id="Rd0140178fd474b49"/>
+                <a:hlinkClick xmlns:r="http://schemas.openxmlformats.org/officeDocument/2006/relationships" r:id="R7b24b5b1d5ec44bd"/>
               </a:rPr>
               <a:t>Repo reference</a:t>
             </a:r>
@@ -19926,7 +19926,7 @@
                 <a:solidFill>
                   <a:srgbClr val="666762"/>
                 </a:solidFill>
-                <a:hlinkClick xmlns:r="http://schemas.openxmlformats.org/officeDocument/2006/relationships" r:id="Re4a0a24c3f964747"/>
+                <a:hlinkClick xmlns:r="http://schemas.openxmlformats.org/officeDocument/2006/relationships" r:id="R6058eb4ba4084118"/>
               </a:rPr>
               <a:t>Official docs</a:t>
             </a:r>
@@ -21208,7 +21208,7 @@
                 <a:solidFill>
                   <a:srgbClr val="666762"/>
                 </a:solidFill>
-                <a:hlinkClick xmlns:r="http://schemas.openxmlformats.org/officeDocument/2006/relationships" r:id="R18ea84ca327940c5"/>
+                <a:hlinkClick xmlns:r="http://schemas.openxmlformats.org/officeDocument/2006/relationships" r:id="R1cca879826c049e8"/>
               </a:rPr>
               <a:t>Repo reference</a:t>
             </a:r>
@@ -21225,7 +21225,7 @@
                 <a:solidFill>
                   <a:srgbClr val="666762"/>
                 </a:solidFill>
-                <a:hlinkClick xmlns:r="http://schemas.openxmlformats.org/officeDocument/2006/relationships" r:id="R221a2808b8c54ac9"/>
+                <a:hlinkClick xmlns:r="http://schemas.openxmlformats.org/officeDocument/2006/relationships" r:id="R8eb50f367df945fb"/>
               </a:rPr>
               <a:t>Official docs</a:t>
             </a:r>
@@ -23160,7 +23160,7 @@
                 <a:solidFill>
                   <a:srgbClr val="666762"/>
                 </a:solidFill>
-                <a:hlinkClick xmlns:r="http://schemas.openxmlformats.org/officeDocument/2006/relationships" r:id="Rd5102ee8f65a423c"/>
+                <a:hlinkClick xmlns:r="http://schemas.openxmlformats.org/officeDocument/2006/relationships" r:id="R274505ff38eb4d77"/>
               </a:rPr>
               <a:t>Repo reference</a:t>
             </a:r>
@@ -23177,7 +23177,7 @@
                 <a:solidFill>
                   <a:srgbClr val="666762"/>
                 </a:solidFill>
-                <a:hlinkClick xmlns:r="http://schemas.openxmlformats.org/officeDocument/2006/relationships" r:id="Rb4a02421c0ce42e8"/>
+                <a:hlinkClick xmlns:r="http://schemas.openxmlformats.org/officeDocument/2006/relationships" r:id="Rfdb9c78545bf484f"/>
               </a:rPr>
               <a:t>Official docs</a:t>
             </a:r>
@@ -25532,7 +25532,7 @@
                 <a:solidFill>
                   <a:srgbClr val="666762"/>
                 </a:solidFill>
-                <a:hlinkClick xmlns:r="http://schemas.openxmlformats.org/officeDocument/2006/relationships" r:id="R1adb478676e24d4f"/>
+                <a:hlinkClick xmlns:r="http://schemas.openxmlformats.org/officeDocument/2006/relationships" r:id="R192e07b295744540"/>
               </a:rPr>
               <a:t>Repo reference</a:t>
             </a:r>
@@ -25549,7 +25549,7 @@
                 <a:solidFill>
                   <a:srgbClr val="666762"/>
                 </a:solidFill>
-                <a:hlinkClick xmlns:r="http://schemas.openxmlformats.org/officeDocument/2006/relationships" r:id="Ra49e7b2f39b04741"/>
+                <a:hlinkClick xmlns:r="http://schemas.openxmlformats.org/officeDocument/2006/relationships" r:id="R499af43ac8924fbe"/>
               </a:rPr>
               <a:t>Official docs</a:t>
             </a:r>
@@ -27175,7 +27175,7 @@
                 <a:solidFill>
                   <a:srgbClr val="666762"/>
                 </a:solidFill>
-                <a:hlinkClick xmlns:r="http://schemas.openxmlformats.org/officeDocument/2006/relationships" r:id="R3bf9810ed14d46cb"/>
+                <a:hlinkClick xmlns:r="http://schemas.openxmlformats.org/officeDocument/2006/relationships" r:id="R6228357ccc72424a"/>
               </a:rPr>
               <a:t>Repo reference</a:t>
             </a:r>
@@ -27192,7 +27192,7 @@
                 <a:solidFill>
                   <a:srgbClr val="666762"/>
                 </a:solidFill>
-                <a:hlinkClick xmlns:r="http://schemas.openxmlformats.org/officeDocument/2006/relationships" r:id="R7bc13b7db82d40b0"/>
+                <a:hlinkClick xmlns:r="http://schemas.openxmlformats.org/officeDocument/2006/relationships" r:id="Rddff6a529e0044d1"/>
               </a:rPr>
               <a:t>Official docs</a:t>
             </a:r>
@@ -29117,7 +29117,7 @@
                 <a:solidFill>
                   <a:srgbClr val="666762"/>
                 </a:solidFill>
-                <a:hlinkClick xmlns:r="http://schemas.openxmlformats.org/officeDocument/2006/relationships" r:id="R9d6a043af80d4a02"/>
+                <a:hlinkClick xmlns:r="http://schemas.openxmlformats.org/officeDocument/2006/relationships" r:id="Ra0871fde61a842ae"/>
               </a:rPr>
               <a:t>Repo reference</a:t>
             </a:r>
@@ -29134,7 +29134,7 @@
                 <a:solidFill>
                   <a:srgbClr val="666762"/>
                 </a:solidFill>
-                <a:hlinkClick xmlns:r="http://schemas.openxmlformats.org/officeDocument/2006/relationships" r:id="R3840573ea64c4e76"/>
+                <a:hlinkClick xmlns:r="http://schemas.openxmlformats.org/officeDocument/2006/relationships" r:id="R1d5e1775c2ef4f4d"/>
               </a:rPr>
               <a:t>Official docs</a:t>
             </a:r>
@@ -29556,7 +29556,7 @@
       </p:sp>
       <p:cxnSp>
         <p:nvCxnSpPr>
-          <p:cNvPr id="286" name=""/>
+          <p:cNvPr id="340" name=""/>
           <p:cNvCxnSpPr>
             <a:stCxn xmlns:a="http://schemas.openxmlformats.org/drawingml/2006/main" id="9" idx="1"/>
             <a:endCxn xmlns:a="http://schemas.openxmlformats.org/drawingml/2006/main" id="12" idx="3"/>
@@ -29761,7 +29761,7 @@
       </p:sp>
       <p:cxnSp>
         <p:nvCxnSpPr>
-          <p:cNvPr id="290" name=""/>
+          <p:cNvPr id="344" name=""/>
           <p:cNvCxnSpPr>
             <a:stCxn xmlns:a="http://schemas.openxmlformats.org/drawingml/2006/main" id="9" idx="1"/>
             <a:endCxn xmlns:a="http://schemas.openxmlformats.org/drawingml/2006/main" id="16" idx="3"/>
@@ -29966,7 +29966,7 @@
       </p:sp>
       <p:cxnSp>
         <p:nvCxnSpPr>
-          <p:cNvPr id="294" name=""/>
+          <p:cNvPr id="348" name=""/>
           <p:cNvCxnSpPr>
             <a:stCxn xmlns:a="http://schemas.openxmlformats.org/drawingml/2006/main" id="9" idx="3"/>
             <a:endCxn xmlns:a="http://schemas.openxmlformats.org/drawingml/2006/main" id="20" idx="1"/>
@@ -30171,7 +30171,7 @@
       </p:sp>
       <p:cxnSp>
         <p:nvCxnSpPr>
-          <p:cNvPr id="298" name=""/>
+          <p:cNvPr id="352" name=""/>
           <p:cNvCxnSpPr>
             <a:stCxn xmlns:a="http://schemas.openxmlformats.org/drawingml/2006/main" id="9" idx="3"/>
             <a:endCxn xmlns:a="http://schemas.openxmlformats.org/drawingml/2006/main" id="24" idx="1"/>
@@ -30610,7 +30610,7 @@
                 <a:solidFill>
                   <a:srgbClr val="666762"/>
                 </a:solidFill>
-                <a:hlinkClick xmlns:r="http://schemas.openxmlformats.org/officeDocument/2006/relationships" r:id="Rb24633c9f3f440e9"/>
+                <a:hlinkClick xmlns:r="http://schemas.openxmlformats.org/officeDocument/2006/relationships" r:id="Rbfdb6c0cc3c34b29"/>
               </a:rPr>
               <a:t>Repo reference</a:t>
             </a:r>
@@ -30627,7 +30627,7 @@
                 <a:solidFill>
                   <a:srgbClr val="666762"/>
                 </a:solidFill>
-                <a:hlinkClick xmlns:r="http://schemas.openxmlformats.org/officeDocument/2006/relationships" r:id="R0cd94291b15244a6"/>
+                <a:hlinkClick xmlns:r="http://schemas.openxmlformats.org/officeDocument/2006/relationships" r:id="Racb5107a8469471b"/>
               </a:rPr>
               <a:t>Official docs</a:t>
             </a:r>
@@ -31506,7 +31506,7 @@
                 <a:solidFill>
                   <a:srgbClr val="666762"/>
                 </a:solidFill>
-                <a:hlinkClick xmlns:r="http://schemas.openxmlformats.org/officeDocument/2006/relationships" r:id="R8bf1a861925543f5"/>
+                <a:hlinkClick xmlns:r="http://schemas.openxmlformats.org/officeDocument/2006/relationships" r:id="Rb42ccb04d4174c75"/>
               </a:rPr>
               <a:t>Repo reference</a:t>
             </a:r>
@@ -31523,7 +31523,7 @@
                 <a:solidFill>
                   <a:srgbClr val="666762"/>
                 </a:solidFill>
-                <a:hlinkClick xmlns:r="http://schemas.openxmlformats.org/officeDocument/2006/relationships" r:id="R6cfd9859a60b4194"/>
+                <a:hlinkClick xmlns:r="http://schemas.openxmlformats.org/officeDocument/2006/relationships" r:id="R5bf9243421164134"/>
               </a:rPr>
               <a:t>Official docs</a:t>
             </a:r>
@@ -32402,7 +32402,7 @@
                 <a:solidFill>
                   <a:srgbClr val="666762"/>
                 </a:solidFill>
-                <a:hlinkClick xmlns:r="http://schemas.openxmlformats.org/officeDocument/2006/relationships" r:id="R7cfe6bd9200c49bf"/>
+                <a:hlinkClick xmlns:r="http://schemas.openxmlformats.org/officeDocument/2006/relationships" r:id="R698e43ea352f4cec"/>
               </a:rPr>
               <a:t>Repo reference</a:t>
             </a:r>
@@ -32419,7 +32419,7 @@
                 <a:solidFill>
                   <a:srgbClr val="666762"/>
                 </a:solidFill>
-                <a:hlinkClick xmlns:r="http://schemas.openxmlformats.org/officeDocument/2006/relationships" r:id="Re896958e520744f3"/>
+                <a:hlinkClick xmlns:r="http://schemas.openxmlformats.org/officeDocument/2006/relationships" r:id="Rd64158f14a5a48af"/>
               </a:rPr>
               <a:t>Official docs</a:t>
             </a:r>
@@ -33227,7 +33227,7 @@
                 <a:solidFill>
                   <a:srgbClr val="666762"/>
                 </a:solidFill>
-                <a:hlinkClick xmlns:r="http://schemas.openxmlformats.org/officeDocument/2006/relationships" r:id="Rdf4bda4da7a046c4"/>
+                <a:hlinkClick xmlns:r="http://schemas.openxmlformats.org/officeDocument/2006/relationships" r:id="Rf7d71e730c90463c"/>
               </a:rPr>
               <a:t>Repo reference</a:t>
             </a:r>
@@ -33244,7 +33244,7 @@
                 <a:solidFill>
                   <a:srgbClr val="666762"/>
                 </a:solidFill>
-                <a:hlinkClick xmlns:r="http://schemas.openxmlformats.org/officeDocument/2006/relationships" r:id="R159d120a3db64d42"/>
+                <a:hlinkClick xmlns:r="http://schemas.openxmlformats.org/officeDocument/2006/relationships" r:id="R97ddcb1bf39042cd"/>
               </a:rPr>
               <a:t>Official docs</a:t>
             </a:r>
@@ -34914,7 +34914,7 @@
                 <a:solidFill>
                   <a:srgbClr val="666762"/>
                 </a:solidFill>
-                <a:hlinkClick xmlns:r="http://schemas.openxmlformats.org/officeDocument/2006/relationships" r:id="R9a7e86023198430c"/>
+                <a:hlinkClick xmlns:r="http://schemas.openxmlformats.org/officeDocument/2006/relationships" r:id="Rb3fc4f30f3cb47d9"/>
               </a:rPr>
               <a:t>Repo reference</a:t>
             </a:r>
@@ -34931,7 +34931,7 @@
                 <a:solidFill>
                   <a:srgbClr val="666762"/>
                 </a:solidFill>
-                <a:hlinkClick xmlns:r="http://schemas.openxmlformats.org/officeDocument/2006/relationships" r:id="R0fd72cf9e355403c"/>
+                <a:hlinkClick xmlns:r="http://schemas.openxmlformats.org/officeDocument/2006/relationships" r:id="Rcf6e412bb60f4d85"/>
               </a:rPr>
               <a:t>Official docs</a:t>
             </a:r>
@@ -37270,7 +37270,7 @@
                 <a:solidFill>
                   <a:srgbClr val="666762"/>
                 </a:solidFill>
-                <a:hlinkClick xmlns:r="http://schemas.openxmlformats.org/officeDocument/2006/relationships" r:id="R43e07d92e3c149ef"/>
+                <a:hlinkClick xmlns:r="http://schemas.openxmlformats.org/officeDocument/2006/relationships" r:id="R1bbf74f275ce4491"/>
               </a:rPr>
               <a:t>Repo reference</a:t>
             </a:r>
@@ -37287,7 +37287,7 @@
                 <a:solidFill>
                   <a:srgbClr val="666762"/>
                 </a:solidFill>
-                <a:hlinkClick xmlns:r="http://schemas.openxmlformats.org/officeDocument/2006/relationships" r:id="Ra095d4038fdf44ea"/>
+                <a:hlinkClick xmlns:r="http://schemas.openxmlformats.org/officeDocument/2006/relationships" r:id="R79b752accd5a476d"/>
               </a:rPr>
               <a:t>Official docs</a:t>
             </a:r>
@@ -39143,7 +39143,7 @@
                 <a:solidFill>
                   <a:srgbClr val="666762"/>
                 </a:solidFill>
-                <a:hlinkClick xmlns:r="http://schemas.openxmlformats.org/officeDocument/2006/relationships" r:id="R1499fc48bf18445c"/>
+                <a:hlinkClick xmlns:r="http://schemas.openxmlformats.org/officeDocument/2006/relationships" r:id="R169ecf520e9a4de8"/>
               </a:rPr>
               <a:t>Repo reference</a:t>
             </a:r>
@@ -39160,7 +39160,7 @@
                 <a:solidFill>
                   <a:srgbClr val="666762"/>
                 </a:solidFill>
-                <a:hlinkClick xmlns:r="http://schemas.openxmlformats.org/officeDocument/2006/relationships" r:id="R8dbd86b6b0274c09"/>
+                <a:hlinkClick xmlns:r="http://schemas.openxmlformats.org/officeDocument/2006/relationships" r:id="Rec3f0979ab254c34"/>
               </a:rPr>
               <a:t>Official docs</a:t>
             </a:r>
@@ -40601,7 +40601,7 @@
                 <a:solidFill>
                   <a:srgbClr val="666762"/>
                 </a:solidFill>
-                <a:hlinkClick xmlns:r="http://schemas.openxmlformats.org/officeDocument/2006/relationships" r:id="Rf60ec131aa3e47e2"/>
+                <a:hlinkClick xmlns:r="http://schemas.openxmlformats.org/officeDocument/2006/relationships" r:id="R48c49c48f20c4a3a"/>
               </a:rPr>
               <a:t>Repo reference</a:t>
             </a:r>
@@ -40618,7 +40618,7 @@
                 <a:solidFill>
                   <a:srgbClr val="666762"/>
                 </a:solidFill>
-                <a:hlinkClick xmlns:r="http://schemas.openxmlformats.org/officeDocument/2006/relationships" r:id="R1147370ba3824598"/>
+                <a:hlinkClick xmlns:r="http://schemas.openxmlformats.org/officeDocument/2006/relationships" r:id="R478c41f9df1e4257"/>
               </a:rPr>
               <a:t>Official docs</a:t>
             </a:r>
@@ -41723,7 +41723,7 @@
                 <a:solidFill>
                   <a:srgbClr val="666762"/>
                 </a:solidFill>
-                <a:hlinkClick xmlns:r="http://schemas.openxmlformats.org/officeDocument/2006/relationships" r:id="Rf25d17a953474647"/>
+                <a:hlinkClick xmlns:r="http://schemas.openxmlformats.org/officeDocument/2006/relationships" r:id="Rfa7856dc91e14807"/>
               </a:rPr>
               <a:t>Repo reference</a:t>
             </a:r>
@@ -41740,7 +41740,7 @@
                 <a:solidFill>
                   <a:srgbClr val="666762"/>
                 </a:solidFill>
-                <a:hlinkClick xmlns:r="http://schemas.openxmlformats.org/officeDocument/2006/relationships" r:id="Rbdc628a493f24ada"/>
+                <a:hlinkClick xmlns:r="http://schemas.openxmlformats.org/officeDocument/2006/relationships" r:id="Ra2f840fc46fd473b"/>
               </a:rPr>
               <a:t>Official docs</a:t>
             </a:r>
@@ -42975,7 +42975,7 @@
                 <a:solidFill>
                   <a:srgbClr val="666762"/>
                 </a:solidFill>
-                <a:hlinkClick xmlns:r="http://schemas.openxmlformats.org/officeDocument/2006/relationships" r:id="Rb6ee57469edd4a85"/>
+                <a:hlinkClick xmlns:r="http://schemas.openxmlformats.org/officeDocument/2006/relationships" r:id="R4e67341ed29f4aae"/>
               </a:rPr>
               <a:t>Repo reference</a:t>
             </a:r>
@@ -42992,7 +42992,7 @@
                 <a:solidFill>
                   <a:srgbClr val="666762"/>
                 </a:solidFill>
-                <a:hlinkClick xmlns:r="http://schemas.openxmlformats.org/officeDocument/2006/relationships" r:id="R4164bce6d9c8461f"/>
+                <a:hlinkClick xmlns:r="http://schemas.openxmlformats.org/officeDocument/2006/relationships" r:id="R3c0d23fb5fb546f2"/>
               </a:rPr>
               <a:t>Official docs</a:t>
             </a:r>
@@ -44340,7 +44340,7 @@
                 <a:solidFill>
                   <a:srgbClr val="666762"/>
                 </a:solidFill>
-                <a:hlinkClick xmlns:r="http://schemas.openxmlformats.org/officeDocument/2006/relationships" r:id="R6018f5851e4b41c1"/>
+                <a:hlinkClick xmlns:r="http://schemas.openxmlformats.org/officeDocument/2006/relationships" r:id="R265fee4e8fb44b2e"/>
               </a:rPr>
               <a:t>Repo reference</a:t>
             </a:r>
@@ -44357,7 +44357,7 @@
                 <a:solidFill>
                   <a:srgbClr val="666762"/>
                 </a:solidFill>
-                <a:hlinkClick xmlns:r="http://schemas.openxmlformats.org/officeDocument/2006/relationships" r:id="Rb56598cfbfc2479c"/>
+                <a:hlinkClick xmlns:r="http://schemas.openxmlformats.org/officeDocument/2006/relationships" r:id="R7a167986bee34b7d"/>
               </a:rPr>
               <a:t>Official docs</a:t>
             </a:r>
@@ -44884,17 +44884,17 @@
       </p:sp>
       <p:cxnSp>
         <p:nvCxnSpPr>
-          <p:cNvPr id="480" name=""/>
+          <p:cNvPr id="570" name=""/>
           <p:cNvCxnSpPr>
-            <a:stCxn xmlns:a="http://schemas.openxmlformats.org/drawingml/2006/main" id="16" idx="0"/>
-            <a:endCxn xmlns:a="http://schemas.openxmlformats.org/drawingml/2006/main" id="10" idx="2"/>
+            <a:stCxn xmlns:a="http://schemas.openxmlformats.org/drawingml/2006/main" id="16" idx="1"/>
+            <a:endCxn xmlns:a="http://schemas.openxmlformats.org/drawingml/2006/main" id="10" idx="1"/>
           </p:cNvCxnSpPr>
           <p:nvPr/>
         </p:nvCxnSpPr>
         <p:spPr>
           <a:xfrm xmlns:a="http://schemas.openxmlformats.org/drawingml/2006/main" flipV="1">
-            <a:off x="1876425" y="3476625"/>
-            <a:ext cx="1304925" cy="1590675"/>
+            <a:off x="457200" y="2990850"/>
+            <a:ext cx="228600" cy="2419350"/>
           </a:xfrm>
           <a:prstGeom xmlns:a="http://schemas.openxmlformats.org/drawingml/2006/main" prst="bentConnector4">
             <a:avLst/>
@@ -44910,7 +44910,7 @@
       </p:cxnSp>
       <p:cxnSp>
         <p:nvCxnSpPr>
-          <p:cNvPr id="481" name=""/>
+          <p:cNvPr id="571" name=""/>
           <p:cNvCxnSpPr>
             <a:stCxn xmlns:a="http://schemas.openxmlformats.org/drawingml/2006/main" id="10" idx="2"/>
             <a:endCxn xmlns:a="http://schemas.openxmlformats.org/drawingml/2006/main" id="13" idx="0"/>
@@ -45454,7 +45454,7 @@
       </p:sp>
       <p:cxnSp>
         <p:nvCxnSpPr>
-          <p:cNvPr id="492" name=""/>
+          <p:cNvPr id="582" name=""/>
           <p:cNvCxnSpPr>
             <a:stCxn xmlns:a="http://schemas.openxmlformats.org/drawingml/2006/main" id="10" idx="3"/>
             <a:endCxn xmlns:a="http://schemas.openxmlformats.org/drawingml/2006/main" id="21" idx="1"/>
@@ -45482,7 +45482,7 @@
       </p:cxnSp>
       <p:cxnSp>
         <p:nvCxnSpPr>
-          <p:cNvPr id="493" name=""/>
+          <p:cNvPr id="583" name=""/>
           <p:cNvCxnSpPr>
             <a:stCxn xmlns:a="http://schemas.openxmlformats.org/drawingml/2006/main" id="10" idx="3"/>
             <a:endCxn xmlns:a="http://schemas.openxmlformats.org/drawingml/2006/main" id="24" idx="1"/>
@@ -45510,7 +45510,7 @@
       </p:cxnSp>
       <p:cxnSp>
         <p:nvCxnSpPr>
-          <p:cNvPr id="494" name=""/>
+          <p:cNvPr id="584" name=""/>
           <p:cNvCxnSpPr>
             <a:stCxn xmlns:a="http://schemas.openxmlformats.org/drawingml/2006/main" id="10" idx="3"/>
             <a:endCxn xmlns:a="http://schemas.openxmlformats.org/drawingml/2006/main" id="27" idx="1"/>
@@ -46056,7 +46056,7 @@
       </p:sp>
       <p:cxnSp>
         <p:nvCxnSpPr>
-          <p:cNvPr id="505" name=""/>
+          <p:cNvPr id="595" name=""/>
           <p:cNvCxnSpPr>
             <a:stCxn xmlns:a="http://schemas.openxmlformats.org/drawingml/2006/main" id="21" idx="3"/>
             <a:endCxn xmlns:a="http://schemas.openxmlformats.org/drawingml/2006/main" id="34" idx="1"/>
@@ -46082,7 +46082,7 @@
       </p:cxnSp>
       <p:cxnSp>
         <p:nvCxnSpPr>
-          <p:cNvPr id="506" name=""/>
+          <p:cNvPr id="596" name=""/>
           <p:cNvCxnSpPr>
             <a:stCxn xmlns:a="http://schemas.openxmlformats.org/drawingml/2006/main" id="24" idx="3"/>
             <a:endCxn xmlns:a="http://schemas.openxmlformats.org/drawingml/2006/main" id="37" idx="1"/>
@@ -46108,7 +46108,7 @@
       </p:cxnSp>
       <p:cxnSp>
         <p:nvCxnSpPr>
-          <p:cNvPr id="507" name=""/>
+          <p:cNvPr id="597" name=""/>
           <p:cNvCxnSpPr>
             <a:stCxn xmlns:a="http://schemas.openxmlformats.org/drawingml/2006/main" id="27" idx="3"/>
             <a:endCxn xmlns:a="http://schemas.openxmlformats.org/drawingml/2006/main" id="40" idx="1"/>

</xml_diff>

<commit_message>
fix: clarify Kong architecture control flows (#16)
</commit_message>
<xml_diff>
--- a/presentations/kong-platform-journey-guided.pptx
+++ b/presentations/kong-platform-journey-guided.pptx
@@ -2,37 +2,37 @@
 <file path=ppt/presentation.xml><?xml version="1.0" encoding="utf-8"?>
 <p:presentation xmlns:p="http://schemas.openxmlformats.org/presentationml/2006/main">
   <p:sldMasterIdLst>
-    <p:sldMasterId xmlns:r="http://schemas.openxmlformats.org/officeDocument/2006/relationships" id="2147483648" r:id="R60c804bd99cd4a7a"/>
+    <p:sldMasterId xmlns:r="http://schemas.openxmlformats.org/officeDocument/2006/relationships" id="2147483648" r:id="R975861b5c8804d56"/>
   </p:sldMasterIdLst>
   <p:notesMasterIdLst>
-    <p:notesMasterId xmlns:r="http://schemas.openxmlformats.org/officeDocument/2006/relationships" r:id="R8ea8645e99654ead"/>
+    <p:notesMasterId xmlns:r="http://schemas.openxmlformats.org/officeDocument/2006/relationships" r:id="R922eed57b6a641ad"/>
   </p:notesMasterIdLst>
   <p:sldIdLst>
-    <p:sldId xmlns:r="http://schemas.openxmlformats.org/officeDocument/2006/relationships" id="256" r:id="R60417037ab624d4e"/>
-    <p:sldId xmlns:r="http://schemas.openxmlformats.org/officeDocument/2006/relationships" id="257" r:id="R2c199ce8f9684364"/>
-    <p:sldId xmlns:r="http://schemas.openxmlformats.org/officeDocument/2006/relationships" id="258" r:id="R48ce7bd25dec4235"/>
-    <p:sldId xmlns:r="http://schemas.openxmlformats.org/officeDocument/2006/relationships" id="259" r:id="Re4762e8e39b04711"/>
-    <p:sldId xmlns:r="http://schemas.openxmlformats.org/officeDocument/2006/relationships" id="260" r:id="R16fd0fd65f784461"/>
-    <p:sldId xmlns:r="http://schemas.openxmlformats.org/officeDocument/2006/relationships" id="261" r:id="Re445c32833474ff5"/>
-    <p:sldId xmlns:r="http://schemas.openxmlformats.org/officeDocument/2006/relationships" id="262" r:id="R08461cd261c94f1e"/>
-    <p:sldId xmlns:r="http://schemas.openxmlformats.org/officeDocument/2006/relationships" id="263" r:id="Rffb9be0cbc5f4415"/>
-    <p:sldId xmlns:r="http://schemas.openxmlformats.org/officeDocument/2006/relationships" id="264" r:id="Rf781b49f08324795"/>
-    <p:sldId xmlns:r="http://schemas.openxmlformats.org/officeDocument/2006/relationships" id="265" r:id="R5bb1afb818294251"/>
-    <p:sldId xmlns:r="http://schemas.openxmlformats.org/officeDocument/2006/relationships" id="266" r:id="R6790b2e26b3a419a"/>
-    <p:sldId xmlns:r="http://schemas.openxmlformats.org/officeDocument/2006/relationships" id="267" r:id="R9804fcbc98614d06"/>
-    <p:sldId xmlns:r="http://schemas.openxmlformats.org/officeDocument/2006/relationships" id="268" r:id="R10e24505592b4505"/>
-    <p:sldId xmlns:r="http://schemas.openxmlformats.org/officeDocument/2006/relationships" id="269" r:id="Rcd5635638bcd45b5"/>
-    <p:sldId xmlns:r="http://schemas.openxmlformats.org/officeDocument/2006/relationships" id="270" r:id="Rd58c9f084f0b46b5"/>
-    <p:sldId xmlns:r="http://schemas.openxmlformats.org/officeDocument/2006/relationships" id="271" r:id="Rec23cc3e4a1e43dc"/>
-    <p:sldId xmlns:r="http://schemas.openxmlformats.org/officeDocument/2006/relationships" id="272" r:id="Rb5ae40211be346ad"/>
-    <p:sldId xmlns:r="http://schemas.openxmlformats.org/officeDocument/2006/relationships" id="273" r:id="R803f531d739240e5"/>
-    <p:sldId xmlns:r="http://schemas.openxmlformats.org/officeDocument/2006/relationships" id="274" r:id="R9ad9ab9f0b6a4e70"/>
-    <p:sldId xmlns:r="http://schemas.openxmlformats.org/officeDocument/2006/relationships" id="275" r:id="Rf59d9b1dddb24942"/>
-    <p:sldId xmlns:r="http://schemas.openxmlformats.org/officeDocument/2006/relationships" id="276" r:id="Rb14b10d23ac14a3a"/>
-    <p:sldId xmlns:r="http://schemas.openxmlformats.org/officeDocument/2006/relationships" id="277" r:id="R30310c1fae894f85"/>
-    <p:sldId xmlns:r="http://schemas.openxmlformats.org/officeDocument/2006/relationships" id="278" r:id="R4dc361fa1cda4753"/>
-    <p:sldId xmlns:r="http://schemas.openxmlformats.org/officeDocument/2006/relationships" id="279" r:id="R6eefa3814d5a4a13"/>
-    <p:sldId xmlns:r="http://schemas.openxmlformats.org/officeDocument/2006/relationships" id="280" r:id="Re9286a7dffdd4137"/>
+    <p:sldId xmlns:r="http://schemas.openxmlformats.org/officeDocument/2006/relationships" id="256" r:id="R9e70a360828e44f9"/>
+    <p:sldId xmlns:r="http://schemas.openxmlformats.org/officeDocument/2006/relationships" id="257" r:id="R083f11c5772744ec"/>
+    <p:sldId xmlns:r="http://schemas.openxmlformats.org/officeDocument/2006/relationships" id="258" r:id="Rbe22d6f50c4d4d42"/>
+    <p:sldId xmlns:r="http://schemas.openxmlformats.org/officeDocument/2006/relationships" id="259" r:id="R3519d4f3ff3544b8"/>
+    <p:sldId xmlns:r="http://schemas.openxmlformats.org/officeDocument/2006/relationships" id="260" r:id="R9eb020fddcc444f0"/>
+    <p:sldId xmlns:r="http://schemas.openxmlformats.org/officeDocument/2006/relationships" id="261" r:id="R94485daa3e0e4c8f"/>
+    <p:sldId xmlns:r="http://schemas.openxmlformats.org/officeDocument/2006/relationships" id="262" r:id="Rb6751758b970431b"/>
+    <p:sldId xmlns:r="http://schemas.openxmlformats.org/officeDocument/2006/relationships" id="263" r:id="R92935a1cd7a14976"/>
+    <p:sldId xmlns:r="http://schemas.openxmlformats.org/officeDocument/2006/relationships" id="264" r:id="R3dadd38e036245ec"/>
+    <p:sldId xmlns:r="http://schemas.openxmlformats.org/officeDocument/2006/relationships" id="265" r:id="R3205d701fde4405f"/>
+    <p:sldId xmlns:r="http://schemas.openxmlformats.org/officeDocument/2006/relationships" id="266" r:id="R39985952344b4606"/>
+    <p:sldId xmlns:r="http://schemas.openxmlformats.org/officeDocument/2006/relationships" id="267" r:id="Rf448f58b70694253"/>
+    <p:sldId xmlns:r="http://schemas.openxmlformats.org/officeDocument/2006/relationships" id="268" r:id="R090135c77e294254"/>
+    <p:sldId xmlns:r="http://schemas.openxmlformats.org/officeDocument/2006/relationships" id="269" r:id="R6622dfbad56c4f0c"/>
+    <p:sldId xmlns:r="http://schemas.openxmlformats.org/officeDocument/2006/relationships" id="270" r:id="R0b2befc46e6d4c88"/>
+    <p:sldId xmlns:r="http://schemas.openxmlformats.org/officeDocument/2006/relationships" id="271" r:id="Rb206314e6fd541a8"/>
+    <p:sldId xmlns:r="http://schemas.openxmlformats.org/officeDocument/2006/relationships" id="272" r:id="Rda0673765add44a5"/>
+    <p:sldId xmlns:r="http://schemas.openxmlformats.org/officeDocument/2006/relationships" id="273" r:id="R85b5241bdda74030"/>
+    <p:sldId xmlns:r="http://schemas.openxmlformats.org/officeDocument/2006/relationships" id="274" r:id="Rbfbb077bfdbf44ea"/>
+    <p:sldId xmlns:r="http://schemas.openxmlformats.org/officeDocument/2006/relationships" id="275" r:id="Rfe6e5236d69b4b5a"/>
+    <p:sldId xmlns:r="http://schemas.openxmlformats.org/officeDocument/2006/relationships" id="276" r:id="R2926369e4c2343b8"/>
+    <p:sldId xmlns:r="http://schemas.openxmlformats.org/officeDocument/2006/relationships" id="277" r:id="R625759e43a16404a"/>
+    <p:sldId xmlns:r="http://schemas.openxmlformats.org/officeDocument/2006/relationships" id="278" r:id="R1b919f9b039d4020"/>
+    <p:sldId xmlns:r="http://schemas.openxmlformats.org/officeDocument/2006/relationships" id="279" r:id="R87edbf3ab0884e57"/>
+    <p:sldId xmlns:r="http://schemas.openxmlformats.org/officeDocument/2006/relationships" id="280" r:id="R3ce78a58660746ea"/>
   </p:sldIdLst>
   <p:sldSz cx="12192000" cy="6858000"/>
   <p:notesSz cx="6858000" cy="9144000"/>
@@ -4594,7 +4594,7 @@
   </p:cSld>
   <p:clrMap bg1="lt1" tx1="dk1" bg2="lt2" tx2="dk2" accent1="accent1" accent2="accent2" accent3="accent3" accent4="accent4" accent5="accent5" accent6="accent6" hlink="hlink" folHlink="folHlink"/>
   <p:sldLayoutIdLst>
-    <p:sldLayoutId xmlns:r="http://schemas.openxmlformats.org/officeDocument/2006/relationships" id="2147483649" r:id="R919bba39c6d941da"/>
+    <p:sldLayoutId xmlns:r="http://schemas.openxmlformats.org/officeDocument/2006/relationships" id="2147483649" r:id="Rdc7a175706444340"/>
   </p:sldLayoutIdLst>
   <p:txStyles>
     <p:titleStyle>
@@ -5896,7 +5896,7 @@
                 <a:solidFill>
                   <a:srgbClr val="666762"/>
                 </a:solidFill>
-                <a:hlinkClick xmlns:r="http://schemas.openxmlformats.org/officeDocument/2006/relationships" r:id="R063df1eeff244169"/>
+                <a:hlinkClick xmlns:r="http://schemas.openxmlformats.org/officeDocument/2006/relationships" r:id="R18b3931df0674cbd"/>
               </a:rPr>
               <a:t>Repo reference</a:t>
             </a:r>
@@ -5913,7 +5913,7 @@
                 <a:solidFill>
                   <a:srgbClr val="666762"/>
                 </a:solidFill>
-                <a:hlinkClick xmlns:r="http://schemas.openxmlformats.org/officeDocument/2006/relationships" r:id="Rabfc1b3f59d745bf"/>
+                <a:hlinkClick xmlns:r="http://schemas.openxmlformats.org/officeDocument/2006/relationships" r:id="R6f2cc002186e4538"/>
               </a:rPr>
               <a:t>Official docs</a:t>
             </a:r>
@@ -6274,7 +6274,7 @@
                 <a:solidFill>
                   <a:srgbClr val="666762"/>
                 </a:solidFill>
-                <a:hlinkClick xmlns:r="http://schemas.openxmlformats.org/officeDocument/2006/relationships" r:id="Rf1f8380c03b349e3"/>
+                <a:hlinkClick xmlns:r="http://schemas.openxmlformats.org/officeDocument/2006/relationships" r:id="R486679cd395d4f4b"/>
               </a:rPr>
               <a:t>Repo reference</a:t>
             </a:r>
@@ -6291,7 +6291,7 @@
                 <a:solidFill>
                   <a:srgbClr val="666762"/>
                 </a:solidFill>
-                <a:hlinkClick xmlns:r="http://schemas.openxmlformats.org/officeDocument/2006/relationships" r:id="R6ce6f9e3429549b3"/>
+                <a:hlinkClick xmlns:r="http://schemas.openxmlformats.org/officeDocument/2006/relationships" r:id="R882b0e3b9ba8486c"/>
               </a:rPr>
               <a:t>Official docs</a:t>
             </a:r>
@@ -7580,7 +7580,7 @@
                 <a:solidFill>
                   <a:srgbClr val="666762"/>
                 </a:solidFill>
-                <a:hlinkClick xmlns:r="http://schemas.openxmlformats.org/officeDocument/2006/relationships" r:id="Rafbb0ef3c20f4602"/>
+                <a:hlinkClick xmlns:r="http://schemas.openxmlformats.org/officeDocument/2006/relationships" r:id="Rbc372a36e6814a61"/>
               </a:rPr>
               <a:t>Repo reference</a:t>
             </a:r>
@@ -7597,7 +7597,7 @@
                 <a:solidFill>
                   <a:srgbClr val="666762"/>
                 </a:solidFill>
-                <a:hlinkClick xmlns:r="http://schemas.openxmlformats.org/officeDocument/2006/relationships" r:id="R43d221ddfb2240a0"/>
+                <a:hlinkClick xmlns:r="http://schemas.openxmlformats.org/officeDocument/2006/relationships" r:id="R1f842da340dc4db5"/>
               </a:rPr>
               <a:t>Official docs</a:t>
             </a:r>
@@ -8373,7 +8373,7 @@
       </p:sp>
       <p:cxnSp>
         <p:nvCxnSpPr>
-          <p:cNvPr id="263" name=""/>
+          <p:cNvPr id="309" name=""/>
           <p:cNvCxnSpPr>
             <a:stCxn xmlns:a="http://schemas.openxmlformats.org/drawingml/2006/main" id="9" idx="3"/>
             <a:endCxn xmlns:a="http://schemas.openxmlformats.org/drawingml/2006/main" id="12" idx="1"/>
@@ -8399,7 +8399,7 @@
       </p:cxnSp>
       <p:cxnSp>
         <p:nvCxnSpPr>
-          <p:cNvPr id="264" name=""/>
+          <p:cNvPr id="310" name=""/>
           <p:cNvCxnSpPr>
             <a:stCxn xmlns:a="http://schemas.openxmlformats.org/drawingml/2006/main" id="12" idx="3"/>
             <a:endCxn xmlns:a="http://schemas.openxmlformats.org/drawingml/2006/main" id="15" idx="1"/>
@@ -8425,7 +8425,7 @@
       </p:cxnSp>
       <p:cxnSp>
         <p:nvCxnSpPr>
-          <p:cNvPr id="265" name=""/>
+          <p:cNvPr id="311" name=""/>
           <p:cNvCxnSpPr>
             <a:stCxn xmlns:a="http://schemas.openxmlformats.org/drawingml/2006/main" id="15" idx="3"/>
             <a:endCxn xmlns:a="http://schemas.openxmlformats.org/drawingml/2006/main" id="18" idx="1"/>
@@ -9407,7 +9407,7 @@
                 <a:solidFill>
                   <a:srgbClr val="666762"/>
                 </a:solidFill>
-                <a:hlinkClick xmlns:r="http://schemas.openxmlformats.org/officeDocument/2006/relationships" r:id="Rd2d3cea478524721"/>
+                <a:hlinkClick xmlns:r="http://schemas.openxmlformats.org/officeDocument/2006/relationships" r:id="R986a96f400774a58"/>
               </a:rPr>
               <a:t>Repo reference</a:t>
             </a:r>
@@ -9424,7 +9424,7 @@
                 <a:solidFill>
                   <a:srgbClr val="666762"/>
                 </a:solidFill>
-                <a:hlinkClick xmlns:r="http://schemas.openxmlformats.org/officeDocument/2006/relationships" r:id="R539c58432d4744c9"/>
+                <a:hlinkClick xmlns:r="http://schemas.openxmlformats.org/officeDocument/2006/relationships" r:id="R26160a55e6e247e6"/>
               </a:rPr>
               <a:t>Official docs</a:t>
             </a:r>
@@ -11059,7 +11059,7 @@
                 <a:solidFill>
                   <a:srgbClr val="666762"/>
                 </a:solidFill>
-                <a:hlinkClick xmlns:r="http://schemas.openxmlformats.org/officeDocument/2006/relationships" r:id="Ra2b5e1c4e28a46a7"/>
+                <a:hlinkClick xmlns:r="http://schemas.openxmlformats.org/officeDocument/2006/relationships" r:id="R064ac837132c4098"/>
               </a:rPr>
               <a:t>Repo reference</a:t>
             </a:r>
@@ -11076,7 +11076,7 @@
                 <a:solidFill>
                   <a:srgbClr val="666762"/>
                 </a:solidFill>
-                <a:hlinkClick xmlns:r="http://schemas.openxmlformats.org/officeDocument/2006/relationships" r:id="Rf70857b4e97e4c7d"/>
+                <a:hlinkClick xmlns:r="http://schemas.openxmlformats.org/officeDocument/2006/relationships" r:id="R15942daaa3cf4b43"/>
               </a:rPr>
               <a:t>Official docs</a:t>
             </a:r>
@@ -13303,7 +13303,7 @@
                 <a:solidFill>
                   <a:srgbClr val="666762"/>
                 </a:solidFill>
-                <a:hlinkClick xmlns:r="http://schemas.openxmlformats.org/officeDocument/2006/relationships" r:id="Rf626b329861a487b"/>
+                <a:hlinkClick xmlns:r="http://schemas.openxmlformats.org/officeDocument/2006/relationships" r:id="Rdc1d9af182974e34"/>
               </a:rPr>
               <a:t>Repo reference</a:t>
             </a:r>
@@ -13320,7 +13320,7 @@
                 <a:solidFill>
                   <a:srgbClr val="666762"/>
                 </a:solidFill>
-                <a:hlinkClick xmlns:r="http://schemas.openxmlformats.org/officeDocument/2006/relationships" r:id="R712569a5a4d54fb7"/>
+                <a:hlinkClick xmlns:r="http://schemas.openxmlformats.org/officeDocument/2006/relationships" r:id="R15f6e7610c514a41"/>
               </a:rPr>
               <a:t>Official docs</a:t>
             </a:r>
@@ -15266,7 +15266,7 @@
                 <a:solidFill>
                   <a:srgbClr val="666762"/>
                 </a:solidFill>
-                <a:hlinkClick xmlns:r="http://schemas.openxmlformats.org/officeDocument/2006/relationships" r:id="R1263daf97d134853"/>
+                <a:hlinkClick xmlns:r="http://schemas.openxmlformats.org/officeDocument/2006/relationships" r:id="R09d9dda4f9024890"/>
               </a:rPr>
               <a:t>Repo reference</a:t>
             </a:r>
@@ -15283,7 +15283,7 @@
                 <a:solidFill>
                   <a:srgbClr val="666762"/>
                 </a:solidFill>
-                <a:hlinkClick xmlns:r="http://schemas.openxmlformats.org/officeDocument/2006/relationships" r:id="R4bbe7096d3104c54"/>
+                <a:hlinkClick xmlns:r="http://schemas.openxmlformats.org/officeDocument/2006/relationships" r:id="R4f6e0cf26e9042b3"/>
               </a:rPr>
               <a:t>Official docs</a:t>
             </a:r>
@@ -16140,7 +16140,7 @@
       </p:sp>
       <p:cxnSp>
         <p:nvCxnSpPr>
-          <p:cNvPr id="307" name=""/>
+          <p:cNvPr id="363" name=""/>
           <p:cNvCxnSpPr>
             <a:stCxn xmlns:a="http://schemas.openxmlformats.org/drawingml/2006/main" id="9" idx="3"/>
             <a:endCxn xmlns:a="http://schemas.openxmlformats.org/drawingml/2006/main" id="12" idx="1"/>
@@ -16166,7 +16166,7 @@
       </p:cxnSp>
       <p:cxnSp>
         <p:nvCxnSpPr>
-          <p:cNvPr id="308" name=""/>
+          <p:cNvPr id="364" name=""/>
           <p:cNvCxnSpPr>
             <a:stCxn xmlns:a="http://schemas.openxmlformats.org/drawingml/2006/main" id="12" idx="3"/>
             <a:endCxn xmlns:a="http://schemas.openxmlformats.org/drawingml/2006/main" id="15" idx="1"/>
@@ -16194,7 +16194,7 @@
       </p:cxnSp>
       <p:cxnSp>
         <p:nvCxnSpPr>
-          <p:cNvPr id="309" name=""/>
+          <p:cNvPr id="365" name=""/>
           <p:cNvCxnSpPr>
             <a:stCxn xmlns:a="http://schemas.openxmlformats.org/drawingml/2006/main" id="12" idx="3"/>
             <a:endCxn xmlns:a="http://schemas.openxmlformats.org/drawingml/2006/main" id="18" idx="1"/>
@@ -16222,7 +16222,7 @@
       </p:cxnSp>
       <p:cxnSp>
         <p:nvCxnSpPr>
-          <p:cNvPr id="310" name=""/>
+          <p:cNvPr id="366" name=""/>
           <p:cNvCxnSpPr>
             <a:stCxn xmlns:a="http://schemas.openxmlformats.org/drawingml/2006/main" id="15" idx="3"/>
             <a:endCxn xmlns:a="http://schemas.openxmlformats.org/drawingml/2006/main" id="21" idx="1"/>
@@ -16250,7 +16250,7 @@
       </p:cxnSp>
       <p:cxnSp>
         <p:nvCxnSpPr>
-          <p:cNvPr id="311" name=""/>
+          <p:cNvPr id="367" name=""/>
           <p:cNvCxnSpPr>
             <a:stCxn xmlns:a="http://schemas.openxmlformats.org/drawingml/2006/main" id="18" idx="3"/>
             <a:endCxn xmlns:a="http://schemas.openxmlformats.org/drawingml/2006/main" id="21" idx="1"/>
@@ -16700,7 +16700,7 @@
                 <a:latin typeface="Arial"/>
                 <a:ea typeface="Arial"/>
                 <a:cs typeface="Arial"/>
-                <a:hlinkClick xmlns:r="http://schemas.openxmlformats.org/officeDocument/2006/relationships" r:id="R62e375ce0497439d"/>
+                <a:hlinkClick xmlns:r="http://schemas.openxmlformats.org/officeDocument/2006/relationships" r:id="R911fb143ee444a90"/>
               </a:rPr>
               <a:t>Apigee A0–A6</a:t>
             </a:r>
@@ -16804,7 +16804,7 @@
                 <a:solidFill>
                   <a:srgbClr val="666762"/>
                 </a:solidFill>
-                <a:hlinkClick xmlns:r="http://schemas.openxmlformats.org/officeDocument/2006/relationships" r:id="R1c28582fbaff48e4"/>
+                <a:hlinkClick xmlns:r="http://schemas.openxmlformats.org/officeDocument/2006/relationships" r:id="Rac7c1ddceb70471f"/>
               </a:rPr>
               <a:t>Repo reference</a:t>
             </a:r>
@@ -16821,7 +16821,7 @@
                 <a:solidFill>
                   <a:srgbClr val="666762"/>
                 </a:solidFill>
-                <a:hlinkClick xmlns:r="http://schemas.openxmlformats.org/officeDocument/2006/relationships" r:id="R7f21fb6e85534687"/>
+                <a:hlinkClick xmlns:r="http://schemas.openxmlformats.org/officeDocument/2006/relationships" r:id="R9e76e9e80ab14a5c"/>
               </a:rPr>
               <a:t>Official docs</a:t>
             </a:r>
@@ -19909,7 +19909,7 @@
                 <a:solidFill>
                   <a:srgbClr val="666762"/>
                 </a:solidFill>
-                <a:hlinkClick xmlns:r="http://schemas.openxmlformats.org/officeDocument/2006/relationships" r:id="Rd0140178fd474b49"/>
+                <a:hlinkClick xmlns:r="http://schemas.openxmlformats.org/officeDocument/2006/relationships" r:id="R7b24b5b1d5ec44bd"/>
               </a:rPr>
               <a:t>Repo reference</a:t>
             </a:r>
@@ -19926,7 +19926,7 @@
                 <a:solidFill>
                   <a:srgbClr val="666762"/>
                 </a:solidFill>
-                <a:hlinkClick xmlns:r="http://schemas.openxmlformats.org/officeDocument/2006/relationships" r:id="Re4a0a24c3f964747"/>
+                <a:hlinkClick xmlns:r="http://schemas.openxmlformats.org/officeDocument/2006/relationships" r:id="R6058eb4ba4084118"/>
               </a:rPr>
               <a:t>Official docs</a:t>
             </a:r>
@@ -21208,7 +21208,7 @@
                 <a:solidFill>
                   <a:srgbClr val="666762"/>
                 </a:solidFill>
-                <a:hlinkClick xmlns:r="http://schemas.openxmlformats.org/officeDocument/2006/relationships" r:id="R18ea84ca327940c5"/>
+                <a:hlinkClick xmlns:r="http://schemas.openxmlformats.org/officeDocument/2006/relationships" r:id="R1cca879826c049e8"/>
               </a:rPr>
               <a:t>Repo reference</a:t>
             </a:r>
@@ -21225,7 +21225,7 @@
                 <a:solidFill>
                   <a:srgbClr val="666762"/>
                 </a:solidFill>
-                <a:hlinkClick xmlns:r="http://schemas.openxmlformats.org/officeDocument/2006/relationships" r:id="R221a2808b8c54ac9"/>
+                <a:hlinkClick xmlns:r="http://schemas.openxmlformats.org/officeDocument/2006/relationships" r:id="R8eb50f367df945fb"/>
               </a:rPr>
               <a:t>Official docs</a:t>
             </a:r>
@@ -23160,7 +23160,7 @@
                 <a:solidFill>
                   <a:srgbClr val="666762"/>
                 </a:solidFill>
-                <a:hlinkClick xmlns:r="http://schemas.openxmlformats.org/officeDocument/2006/relationships" r:id="Rd5102ee8f65a423c"/>
+                <a:hlinkClick xmlns:r="http://schemas.openxmlformats.org/officeDocument/2006/relationships" r:id="R274505ff38eb4d77"/>
               </a:rPr>
               <a:t>Repo reference</a:t>
             </a:r>
@@ -23177,7 +23177,7 @@
                 <a:solidFill>
                   <a:srgbClr val="666762"/>
                 </a:solidFill>
-                <a:hlinkClick xmlns:r="http://schemas.openxmlformats.org/officeDocument/2006/relationships" r:id="Rb4a02421c0ce42e8"/>
+                <a:hlinkClick xmlns:r="http://schemas.openxmlformats.org/officeDocument/2006/relationships" r:id="Rfdb9c78545bf484f"/>
               </a:rPr>
               <a:t>Official docs</a:t>
             </a:r>
@@ -25532,7 +25532,7 @@
                 <a:solidFill>
                   <a:srgbClr val="666762"/>
                 </a:solidFill>
-                <a:hlinkClick xmlns:r="http://schemas.openxmlformats.org/officeDocument/2006/relationships" r:id="R1adb478676e24d4f"/>
+                <a:hlinkClick xmlns:r="http://schemas.openxmlformats.org/officeDocument/2006/relationships" r:id="R192e07b295744540"/>
               </a:rPr>
               <a:t>Repo reference</a:t>
             </a:r>
@@ -25549,7 +25549,7 @@
                 <a:solidFill>
                   <a:srgbClr val="666762"/>
                 </a:solidFill>
-                <a:hlinkClick xmlns:r="http://schemas.openxmlformats.org/officeDocument/2006/relationships" r:id="Ra49e7b2f39b04741"/>
+                <a:hlinkClick xmlns:r="http://schemas.openxmlformats.org/officeDocument/2006/relationships" r:id="R499af43ac8924fbe"/>
               </a:rPr>
               <a:t>Official docs</a:t>
             </a:r>
@@ -27175,7 +27175,7 @@
                 <a:solidFill>
                   <a:srgbClr val="666762"/>
                 </a:solidFill>
-                <a:hlinkClick xmlns:r="http://schemas.openxmlformats.org/officeDocument/2006/relationships" r:id="R3bf9810ed14d46cb"/>
+                <a:hlinkClick xmlns:r="http://schemas.openxmlformats.org/officeDocument/2006/relationships" r:id="R6228357ccc72424a"/>
               </a:rPr>
               <a:t>Repo reference</a:t>
             </a:r>
@@ -27192,7 +27192,7 @@
                 <a:solidFill>
                   <a:srgbClr val="666762"/>
                 </a:solidFill>
-                <a:hlinkClick xmlns:r="http://schemas.openxmlformats.org/officeDocument/2006/relationships" r:id="R7bc13b7db82d40b0"/>
+                <a:hlinkClick xmlns:r="http://schemas.openxmlformats.org/officeDocument/2006/relationships" r:id="Rddff6a529e0044d1"/>
               </a:rPr>
               <a:t>Official docs</a:t>
             </a:r>
@@ -29117,7 +29117,7 @@
                 <a:solidFill>
                   <a:srgbClr val="666762"/>
                 </a:solidFill>
-                <a:hlinkClick xmlns:r="http://schemas.openxmlformats.org/officeDocument/2006/relationships" r:id="R9d6a043af80d4a02"/>
+                <a:hlinkClick xmlns:r="http://schemas.openxmlformats.org/officeDocument/2006/relationships" r:id="Ra0871fde61a842ae"/>
               </a:rPr>
               <a:t>Repo reference</a:t>
             </a:r>
@@ -29134,7 +29134,7 @@
                 <a:solidFill>
                   <a:srgbClr val="666762"/>
                 </a:solidFill>
-                <a:hlinkClick xmlns:r="http://schemas.openxmlformats.org/officeDocument/2006/relationships" r:id="R3840573ea64c4e76"/>
+                <a:hlinkClick xmlns:r="http://schemas.openxmlformats.org/officeDocument/2006/relationships" r:id="R1d5e1775c2ef4f4d"/>
               </a:rPr>
               <a:t>Official docs</a:t>
             </a:r>
@@ -29556,7 +29556,7 @@
       </p:sp>
       <p:cxnSp>
         <p:nvCxnSpPr>
-          <p:cNvPr id="286" name=""/>
+          <p:cNvPr id="340" name=""/>
           <p:cNvCxnSpPr>
             <a:stCxn xmlns:a="http://schemas.openxmlformats.org/drawingml/2006/main" id="9" idx="1"/>
             <a:endCxn xmlns:a="http://schemas.openxmlformats.org/drawingml/2006/main" id="12" idx="3"/>
@@ -29761,7 +29761,7 @@
       </p:sp>
       <p:cxnSp>
         <p:nvCxnSpPr>
-          <p:cNvPr id="290" name=""/>
+          <p:cNvPr id="344" name=""/>
           <p:cNvCxnSpPr>
             <a:stCxn xmlns:a="http://schemas.openxmlformats.org/drawingml/2006/main" id="9" idx="1"/>
             <a:endCxn xmlns:a="http://schemas.openxmlformats.org/drawingml/2006/main" id="16" idx="3"/>
@@ -29966,7 +29966,7 @@
       </p:sp>
       <p:cxnSp>
         <p:nvCxnSpPr>
-          <p:cNvPr id="294" name=""/>
+          <p:cNvPr id="348" name=""/>
           <p:cNvCxnSpPr>
             <a:stCxn xmlns:a="http://schemas.openxmlformats.org/drawingml/2006/main" id="9" idx="3"/>
             <a:endCxn xmlns:a="http://schemas.openxmlformats.org/drawingml/2006/main" id="20" idx="1"/>
@@ -30171,7 +30171,7 @@
       </p:sp>
       <p:cxnSp>
         <p:nvCxnSpPr>
-          <p:cNvPr id="298" name=""/>
+          <p:cNvPr id="352" name=""/>
           <p:cNvCxnSpPr>
             <a:stCxn xmlns:a="http://schemas.openxmlformats.org/drawingml/2006/main" id="9" idx="3"/>
             <a:endCxn xmlns:a="http://schemas.openxmlformats.org/drawingml/2006/main" id="24" idx="1"/>
@@ -30610,7 +30610,7 @@
                 <a:solidFill>
                   <a:srgbClr val="666762"/>
                 </a:solidFill>
-                <a:hlinkClick xmlns:r="http://schemas.openxmlformats.org/officeDocument/2006/relationships" r:id="Rb24633c9f3f440e9"/>
+                <a:hlinkClick xmlns:r="http://schemas.openxmlformats.org/officeDocument/2006/relationships" r:id="Rbfdb6c0cc3c34b29"/>
               </a:rPr>
               <a:t>Repo reference</a:t>
             </a:r>
@@ -30627,7 +30627,7 @@
                 <a:solidFill>
                   <a:srgbClr val="666762"/>
                 </a:solidFill>
-                <a:hlinkClick xmlns:r="http://schemas.openxmlformats.org/officeDocument/2006/relationships" r:id="R0cd94291b15244a6"/>
+                <a:hlinkClick xmlns:r="http://schemas.openxmlformats.org/officeDocument/2006/relationships" r:id="Racb5107a8469471b"/>
               </a:rPr>
               <a:t>Official docs</a:t>
             </a:r>
@@ -31506,7 +31506,7 @@
                 <a:solidFill>
                   <a:srgbClr val="666762"/>
                 </a:solidFill>
-                <a:hlinkClick xmlns:r="http://schemas.openxmlformats.org/officeDocument/2006/relationships" r:id="R8bf1a861925543f5"/>
+                <a:hlinkClick xmlns:r="http://schemas.openxmlformats.org/officeDocument/2006/relationships" r:id="Rb42ccb04d4174c75"/>
               </a:rPr>
               <a:t>Repo reference</a:t>
             </a:r>
@@ -31523,7 +31523,7 @@
                 <a:solidFill>
                   <a:srgbClr val="666762"/>
                 </a:solidFill>
-                <a:hlinkClick xmlns:r="http://schemas.openxmlformats.org/officeDocument/2006/relationships" r:id="R6cfd9859a60b4194"/>
+                <a:hlinkClick xmlns:r="http://schemas.openxmlformats.org/officeDocument/2006/relationships" r:id="R5bf9243421164134"/>
               </a:rPr>
               <a:t>Official docs</a:t>
             </a:r>
@@ -32402,7 +32402,7 @@
                 <a:solidFill>
                   <a:srgbClr val="666762"/>
                 </a:solidFill>
-                <a:hlinkClick xmlns:r="http://schemas.openxmlformats.org/officeDocument/2006/relationships" r:id="R7cfe6bd9200c49bf"/>
+                <a:hlinkClick xmlns:r="http://schemas.openxmlformats.org/officeDocument/2006/relationships" r:id="R698e43ea352f4cec"/>
               </a:rPr>
               <a:t>Repo reference</a:t>
             </a:r>
@@ -32419,7 +32419,7 @@
                 <a:solidFill>
                   <a:srgbClr val="666762"/>
                 </a:solidFill>
-                <a:hlinkClick xmlns:r="http://schemas.openxmlformats.org/officeDocument/2006/relationships" r:id="Re896958e520744f3"/>
+                <a:hlinkClick xmlns:r="http://schemas.openxmlformats.org/officeDocument/2006/relationships" r:id="Rd64158f14a5a48af"/>
               </a:rPr>
               <a:t>Official docs</a:t>
             </a:r>
@@ -33227,7 +33227,7 @@
                 <a:solidFill>
                   <a:srgbClr val="666762"/>
                 </a:solidFill>
-                <a:hlinkClick xmlns:r="http://schemas.openxmlformats.org/officeDocument/2006/relationships" r:id="Rdf4bda4da7a046c4"/>
+                <a:hlinkClick xmlns:r="http://schemas.openxmlformats.org/officeDocument/2006/relationships" r:id="Rf7d71e730c90463c"/>
               </a:rPr>
               <a:t>Repo reference</a:t>
             </a:r>
@@ -33244,7 +33244,7 @@
                 <a:solidFill>
                   <a:srgbClr val="666762"/>
                 </a:solidFill>
-                <a:hlinkClick xmlns:r="http://schemas.openxmlformats.org/officeDocument/2006/relationships" r:id="R159d120a3db64d42"/>
+                <a:hlinkClick xmlns:r="http://schemas.openxmlformats.org/officeDocument/2006/relationships" r:id="R97ddcb1bf39042cd"/>
               </a:rPr>
               <a:t>Official docs</a:t>
             </a:r>
@@ -34914,7 +34914,7 @@
                 <a:solidFill>
                   <a:srgbClr val="666762"/>
                 </a:solidFill>
-                <a:hlinkClick xmlns:r="http://schemas.openxmlformats.org/officeDocument/2006/relationships" r:id="R9a7e86023198430c"/>
+                <a:hlinkClick xmlns:r="http://schemas.openxmlformats.org/officeDocument/2006/relationships" r:id="Rb3fc4f30f3cb47d9"/>
               </a:rPr>
               <a:t>Repo reference</a:t>
             </a:r>
@@ -34931,7 +34931,7 @@
                 <a:solidFill>
                   <a:srgbClr val="666762"/>
                 </a:solidFill>
-                <a:hlinkClick xmlns:r="http://schemas.openxmlformats.org/officeDocument/2006/relationships" r:id="R0fd72cf9e355403c"/>
+                <a:hlinkClick xmlns:r="http://schemas.openxmlformats.org/officeDocument/2006/relationships" r:id="Rcf6e412bb60f4d85"/>
               </a:rPr>
               <a:t>Official docs</a:t>
             </a:r>
@@ -37270,7 +37270,7 @@
                 <a:solidFill>
                   <a:srgbClr val="666762"/>
                 </a:solidFill>
-                <a:hlinkClick xmlns:r="http://schemas.openxmlformats.org/officeDocument/2006/relationships" r:id="R43e07d92e3c149ef"/>
+                <a:hlinkClick xmlns:r="http://schemas.openxmlformats.org/officeDocument/2006/relationships" r:id="R1bbf74f275ce4491"/>
               </a:rPr>
               <a:t>Repo reference</a:t>
             </a:r>
@@ -37287,7 +37287,7 @@
                 <a:solidFill>
                   <a:srgbClr val="666762"/>
                 </a:solidFill>
-                <a:hlinkClick xmlns:r="http://schemas.openxmlformats.org/officeDocument/2006/relationships" r:id="Ra095d4038fdf44ea"/>
+                <a:hlinkClick xmlns:r="http://schemas.openxmlformats.org/officeDocument/2006/relationships" r:id="R79b752accd5a476d"/>
               </a:rPr>
               <a:t>Official docs</a:t>
             </a:r>
@@ -39143,7 +39143,7 @@
                 <a:solidFill>
                   <a:srgbClr val="666762"/>
                 </a:solidFill>
-                <a:hlinkClick xmlns:r="http://schemas.openxmlformats.org/officeDocument/2006/relationships" r:id="R1499fc48bf18445c"/>
+                <a:hlinkClick xmlns:r="http://schemas.openxmlformats.org/officeDocument/2006/relationships" r:id="R169ecf520e9a4de8"/>
               </a:rPr>
               <a:t>Repo reference</a:t>
             </a:r>
@@ -39160,7 +39160,7 @@
                 <a:solidFill>
                   <a:srgbClr val="666762"/>
                 </a:solidFill>
-                <a:hlinkClick xmlns:r="http://schemas.openxmlformats.org/officeDocument/2006/relationships" r:id="R8dbd86b6b0274c09"/>
+                <a:hlinkClick xmlns:r="http://schemas.openxmlformats.org/officeDocument/2006/relationships" r:id="Rec3f0979ab254c34"/>
               </a:rPr>
               <a:t>Official docs</a:t>
             </a:r>
@@ -40601,7 +40601,7 @@
                 <a:solidFill>
                   <a:srgbClr val="666762"/>
                 </a:solidFill>
-                <a:hlinkClick xmlns:r="http://schemas.openxmlformats.org/officeDocument/2006/relationships" r:id="Rf60ec131aa3e47e2"/>
+                <a:hlinkClick xmlns:r="http://schemas.openxmlformats.org/officeDocument/2006/relationships" r:id="R48c49c48f20c4a3a"/>
               </a:rPr>
               <a:t>Repo reference</a:t>
             </a:r>
@@ -40618,7 +40618,7 @@
                 <a:solidFill>
                   <a:srgbClr val="666762"/>
                 </a:solidFill>
-                <a:hlinkClick xmlns:r="http://schemas.openxmlformats.org/officeDocument/2006/relationships" r:id="R1147370ba3824598"/>
+                <a:hlinkClick xmlns:r="http://schemas.openxmlformats.org/officeDocument/2006/relationships" r:id="R478c41f9df1e4257"/>
               </a:rPr>
               <a:t>Official docs</a:t>
             </a:r>
@@ -41723,7 +41723,7 @@
                 <a:solidFill>
                   <a:srgbClr val="666762"/>
                 </a:solidFill>
-                <a:hlinkClick xmlns:r="http://schemas.openxmlformats.org/officeDocument/2006/relationships" r:id="Rf25d17a953474647"/>
+                <a:hlinkClick xmlns:r="http://schemas.openxmlformats.org/officeDocument/2006/relationships" r:id="Rfa7856dc91e14807"/>
               </a:rPr>
               <a:t>Repo reference</a:t>
             </a:r>
@@ -41740,7 +41740,7 @@
                 <a:solidFill>
                   <a:srgbClr val="666762"/>
                 </a:solidFill>
-                <a:hlinkClick xmlns:r="http://schemas.openxmlformats.org/officeDocument/2006/relationships" r:id="Rbdc628a493f24ada"/>
+                <a:hlinkClick xmlns:r="http://schemas.openxmlformats.org/officeDocument/2006/relationships" r:id="Ra2f840fc46fd473b"/>
               </a:rPr>
               <a:t>Official docs</a:t>
             </a:r>
@@ -42975,7 +42975,7 @@
                 <a:solidFill>
                   <a:srgbClr val="666762"/>
                 </a:solidFill>
-                <a:hlinkClick xmlns:r="http://schemas.openxmlformats.org/officeDocument/2006/relationships" r:id="Rb6ee57469edd4a85"/>
+                <a:hlinkClick xmlns:r="http://schemas.openxmlformats.org/officeDocument/2006/relationships" r:id="R4e67341ed29f4aae"/>
               </a:rPr>
               <a:t>Repo reference</a:t>
             </a:r>
@@ -42992,7 +42992,7 @@
                 <a:solidFill>
                   <a:srgbClr val="666762"/>
                 </a:solidFill>
-                <a:hlinkClick xmlns:r="http://schemas.openxmlformats.org/officeDocument/2006/relationships" r:id="R4164bce6d9c8461f"/>
+                <a:hlinkClick xmlns:r="http://schemas.openxmlformats.org/officeDocument/2006/relationships" r:id="R3c0d23fb5fb546f2"/>
               </a:rPr>
               <a:t>Official docs</a:t>
             </a:r>
@@ -44340,7 +44340,7 @@
                 <a:solidFill>
                   <a:srgbClr val="666762"/>
                 </a:solidFill>
-                <a:hlinkClick xmlns:r="http://schemas.openxmlformats.org/officeDocument/2006/relationships" r:id="R6018f5851e4b41c1"/>
+                <a:hlinkClick xmlns:r="http://schemas.openxmlformats.org/officeDocument/2006/relationships" r:id="R265fee4e8fb44b2e"/>
               </a:rPr>
               <a:t>Repo reference</a:t>
             </a:r>
@@ -44357,7 +44357,7 @@
                 <a:solidFill>
                   <a:srgbClr val="666762"/>
                 </a:solidFill>
-                <a:hlinkClick xmlns:r="http://schemas.openxmlformats.org/officeDocument/2006/relationships" r:id="Rb56598cfbfc2479c"/>
+                <a:hlinkClick xmlns:r="http://schemas.openxmlformats.org/officeDocument/2006/relationships" r:id="R7a167986bee34b7d"/>
               </a:rPr>
               <a:t>Official docs</a:t>
             </a:r>
@@ -44884,17 +44884,17 @@
       </p:sp>
       <p:cxnSp>
         <p:nvCxnSpPr>
-          <p:cNvPr id="480" name=""/>
+          <p:cNvPr id="570" name=""/>
           <p:cNvCxnSpPr>
-            <a:stCxn xmlns:a="http://schemas.openxmlformats.org/drawingml/2006/main" id="16" idx="0"/>
-            <a:endCxn xmlns:a="http://schemas.openxmlformats.org/drawingml/2006/main" id="10" idx="2"/>
+            <a:stCxn xmlns:a="http://schemas.openxmlformats.org/drawingml/2006/main" id="16" idx="1"/>
+            <a:endCxn xmlns:a="http://schemas.openxmlformats.org/drawingml/2006/main" id="10" idx="1"/>
           </p:cNvCxnSpPr>
           <p:nvPr/>
         </p:nvCxnSpPr>
         <p:spPr>
           <a:xfrm xmlns:a="http://schemas.openxmlformats.org/drawingml/2006/main" flipV="1">
-            <a:off x="1876425" y="3476625"/>
-            <a:ext cx="1304925" cy="1590675"/>
+            <a:off x="457200" y="2990850"/>
+            <a:ext cx="228600" cy="2419350"/>
           </a:xfrm>
           <a:prstGeom xmlns:a="http://schemas.openxmlformats.org/drawingml/2006/main" prst="bentConnector4">
             <a:avLst/>
@@ -44910,7 +44910,7 @@
       </p:cxnSp>
       <p:cxnSp>
         <p:nvCxnSpPr>
-          <p:cNvPr id="481" name=""/>
+          <p:cNvPr id="571" name=""/>
           <p:cNvCxnSpPr>
             <a:stCxn xmlns:a="http://schemas.openxmlformats.org/drawingml/2006/main" id="10" idx="2"/>
             <a:endCxn xmlns:a="http://schemas.openxmlformats.org/drawingml/2006/main" id="13" idx="0"/>
@@ -45454,7 +45454,7 @@
       </p:sp>
       <p:cxnSp>
         <p:nvCxnSpPr>
-          <p:cNvPr id="492" name=""/>
+          <p:cNvPr id="582" name=""/>
           <p:cNvCxnSpPr>
             <a:stCxn xmlns:a="http://schemas.openxmlformats.org/drawingml/2006/main" id="10" idx="3"/>
             <a:endCxn xmlns:a="http://schemas.openxmlformats.org/drawingml/2006/main" id="21" idx="1"/>
@@ -45482,7 +45482,7 @@
       </p:cxnSp>
       <p:cxnSp>
         <p:nvCxnSpPr>
-          <p:cNvPr id="493" name=""/>
+          <p:cNvPr id="583" name=""/>
           <p:cNvCxnSpPr>
             <a:stCxn xmlns:a="http://schemas.openxmlformats.org/drawingml/2006/main" id="10" idx="3"/>
             <a:endCxn xmlns:a="http://schemas.openxmlformats.org/drawingml/2006/main" id="24" idx="1"/>
@@ -45510,7 +45510,7 @@
       </p:cxnSp>
       <p:cxnSp>
         <p:nvCxnSpPr>
-          <p:cNvPr id="494" name=""/>
+          <p:cNvPr id="584" name=""/>
           <p:cNvCxnSpPr>
             <a:stCxn xmlns:a="http://schemas.openxmlformats.org/drawingml/2006/main" id="10" idx="3"/>
             <a:endCxn xmlns:a="http://schemas.openxmlformats.org/drawingml/2006/main" id="27" idx="1"/>
@@ -46056,7 +46056,7 @@
       </p:sp>
       <p:cxnSp>
         <p:nvCxnSpPr>
-          <p:cNvPr id="505" name=""/>
+          <p:cNvPr id="595" name=""/>
           <p:cNvCxnSpPr>
             <a:stCxn xmlns:a="http://schemas.openxmlformats.org/drawingml/2006/main" id="21" idx="3"/>
             <a:endCxn xmlns:a="http://schemas.openxmlformats.org/drawingml/2006/main" id="34" idx="1"/>
@@ -46082,7 +46082,7 @@
       </p:cxnSp>
       <p:cxnSp>
         <p:nvCxnSpPr>
-          <p:cNvPr id="506" name=""/>
+          <p:cNvPr id="596" name=""/>
           <p:cNvCxnSpPr>
             <a:stCxn xmlns:a="http://schemas.openxmlformats.org/drawingml/2006/main" id="24" idx="3"/>
             <a:endCxn xmlns:a="http://schemas.openxmlformats.org/drawingml/2006/main" id="37" idx="1"/>
@@ -46108,7 +46108,7 @@
       </p:cxnSp>
       <p:cxnSp>
         <p:nvCxnSpPr>
-          <p:cNvPr id="507" name=""/>
+          <p:cNvPr id="597" name=""/>
           <p:cNvCxnSpPr>
             <a:stCxn xmlns:a="http://schemas.openxmlformats.org/drawingml/2006/main" id="27" idx="3"/>
             <a:endCxn xmlns:a="http://schemas.openxmlformats.org/drawingml/2006/main" id="40" idx="1"/>

</xml_diff>

<commit_message>
Expand early Kong assessment gates
</commit_message>
<xml_diff>
--- a/presentations/kong-platform-journey-guided.pptx
+++ b/presentations/kong-platform-journey-guided.pptx
@@ -2,37 +2,37 @@
 <file path=ppt/presentation.xml><?xml version="1.0" encoding="utf-8"?>
 <p:presentation xmlns:p="http://schemas.openxmlformats.org/presentationml/2006/main">
   <p:sldMasterIdLst>
-    <p:sldMasterId xmlns:r="http://schemas.openxmlformats.org/officeDocument/2006/relationships" id="2147483648" r:id="R84bd8bfb80ce41c6"/>
+    <p:sldMasterId xmlns:r="http://schemas.openxmlformats.org/officeDocument/2006/relationships" id="2147483648" r:id="R858e6dfbed724f2d"/>
   </p:sldMasterIdLst>
   <p:notesMasterIdLst>
-    <p:notesMasterId xmlns:r="http://schemas.openxmlformats.org/officeDocument/2006/relationships" r:id="R60283102e2d047ee"/>
+    <p:notesMasterId xmlns:r="http://schemas.openxmlformats.org/officeDocument/2006/relationships" r:id="R6ebd533a1bc84b62"/>
   </p:notesMasterIdLst>
   <p:sldIdLst>
-    <p:sldId xmlns:r="http://schemas.openxmlformats.org/officeDocument/2006/relationships" id="256" r:id="Rd42a571b14424c72"/>
-    <p:sldId xmlns:r="http://schemas.openxmlformats.org/officeDocument/2006/relationships" id="257" r:id="R19a300a9fbe24b86"/>
-    <p:sldId xmlns:r="http://schemas.openxmlformats.org/officeDocument/2006/relationships" id="258" r:id="Rabde214444b54797"/>
-    <p:sldId xmlns:r="http://schemas.openxmlformats.org/officeDocument/2006/relationships" id="259" r:id="R57a26c9028fa448a"/>
-    <p:sldId xmlns:r="http://schemas.openxmlformats.org/officeDocument/2006/relationships" id="260" r:id="R1317879f208a4b3b"/>
-    <p:sldId xmlns:r="http://schemas.openxmlformats.org/officeDocument/2006/relationships" id="261" r:id="R79138c3e38bc422a"/>
-    <p:sldId xmlns:r="http://schemas.openxmlformats.org/officeDocument/2006/relationships" id="262" r:id="R41593cd6e3d04e84"/>
-    <p:sldId xmlns:r="http://schemas.openxmlformats.org/officeDocument/2006/relationships" id="263" r:id="R81a6333097514565"/>
-    <p:sldId xmlns:r="http://schemas.openxmlformats.org/officeDocument/2006/relationships" id="264" r:id="R6f8dcffa866d4f22"/>
-    <p:sldId xmlns:r="http://schemas.openxmlformats.org/officeDocument/2006/relationships" id="265" r:id="R8eec536ec0904513"/>
-    <p:sldId xmlns:r="http://schemas.openxmlformats.org/officeDocument/2006/relationships" id="266" r:id="R6f48f3af41e34de5"/>
-    <p:sldId xmlns:r="http://schemas.openxmlformats.org/officeDocument/2006/relationships" id="267" r:id="R40dff38b55b54ad7"/>
-    <p:sldId xmlns:r="http://schemas.openxmlformats.org/officeDocument/2006/relationships" id="268" r:id="Ra77da39db7c84a62"/>
-    <p:sldId xmlns:r="http://schemas.openxmlformats.org/officeDocument/2006/relationships" id="269" r:id="R501cb0042d51415e"/>
-    <p:sldId xmlns:r="http://schemas.openxmlformats.org/officeDocument/2006/relationships" id="270" r:id="R8fbde56390094b37"/>
-    <p:sldId xmlns:r="http://schemas.openxmlformats.org/officeDocument/2006/relationships" id="271" r:id="R472b424db84a4225"/>
-    <p:sldId xmlns:r="http://schemas.openxmlformats.org/officeDocument/2006/relationships" id="272" r:id="Rfd44aacfc6fb4e0a"/>
-    <p:sldId xmlns:r="http://schemas.openxmlformats.org/officeDocument/2006/relationships" id="273" r:id="Rf6d6cd6f4eef4be7"/>
-    <p:sldId xmlns:r="http://schemas.openxmlformats.org/officeDocument/2006/relationships" id="274" r:id="R28d6cd492bb04341"/>
-    <p:sldId xmlns:r="http://schemas.openxmlformats.org/officeDocument/2006/relationships" id="275" r:id="R24987c21544b4bf3"/>
-    <p:sldId xmlns:r="http://schemas.openxmlformats.org/officeDocument/2006/relationships" id="276" r:id="R2a587f8db21643cc"/>
-    <p:sldId xmlns:r="http://schemas.openxmlformats.org/officeDocument/2006/relationships" id="277" r:id="R59b61c420c2d472f"/>
-    <p:sldId xmlns:r="http://schemas.openxmlformats.org/officeDocument/2006/relationships" id="278" r:id="R3883b960fe1b4c3a"/>
-    <p:sldId xmlns:r="http://schemas.openxmlformats.org/officeDocument/2006/relationships" id="279" r:id="R2c2455e77e5040c9"/>
-    <p:sldId xmlns:r="http://schemas.openxmlformats.org/officeDocument/2006/relationships" id="280" r:id="R55a8954c0d234313"/>
+    <p:sldId xmlns:r="http://schemas.openxmlformats.org/officeDocument/2006/relationships" id="256" r:id="Rb0eb92a06863413a"/>
+    <p:sldId xmlns:r="http://schemas.openxmlformats.org/officeDocument/2006/relationships" id="257" r:id="Rb77e59cf60fb4e8e"/>
+    <p:sldId xmlns:r="http://schemas.openxmlformats.org/officeDocument/2006/relationships" id="258" r:id="R1a8896d48690466d"/>
+    <p:sldId xmlns:r="http://schemas.openxmlformats.org/officeDocument/2006/relationships" id="259" r:id="Rf7b18928cdd34a4e"/>
+    <p:sldId xmlns:r="http://schemas.openxmlformats.org/officeDocument/2006/relationships" id="260" r:id="Rc3b1aed683b44c5f"/>
+    <p:sldId xmlns:r="http://schemas.openxmlformats.org/officeDocument/2006/relationships" id="261" r:id="Rade92c5fd39f49a6"/>
+    <p:sldId xmlns:r="http://schemas.openxmlformats.org/officeDocument/2006/relationships" id="262" r:id="R50e39946c8984dd8"/>
+    <p:sldId xmlns:r="http://schemas.openxmlformats.org/officeDocument/2006/relationships" id="263" r:id="Rfee8a6e1826a4f43"/>
+    <p:sldId xmlns:r="http://schemas.openxmlformats.org/officeDocument/2006/relationships" id="264" r:id="R95b9c7660ea34222"/>
+    <p:sldId xmlns:r="http://schemas.openxmlformats.org/officeDocument/2006/relationships" id="265" r:id="R57d9d1252a2d4202"/>
+    <p:sldId xmlns:r="http://schemas.openxmlformats.org/officeDocument/2006/relationships" id="266" r:id="R1c80494bf943417a"/>
+    <p:sldId xmlns:r="http://schemas.openxmlformats.org/officeDocument/2006/relationships" id="267" r:id="Rb5e52b2f91114aa7"/>
+    <p:sldId xmlns:r="http://schemas.openxmlformats.org/officeDocument/2006/relationships" id="268" r:id="R83f4d493a2ad4cc5"/>
+    <p:sldId xmlns:r="http://schemas.openxmlformats.org/officeDocument/2006/relationships" id="269" r:id="R9723c12797124bde"/>
+    <p:sldId xmlns:r="http://schemas.openxmlformats.org/officeDocument/2006/relationships" id="270" r:id="Rf07de05b1f544b20"/>
+    <p:sldId xmlns:r="http://schemas.openxmlformats.org/officeDocument/2006/relationships" id="271" r:id="R9b18ed3f1ebd4603"/>
+    <p:sldId xmlns:r="http://schemas.openxmlformats.org/officeDocument/2006/relationships" id="272" r:id="R9b33be129d6d4553"/>
+    <p:sldId xmlns:r="http://schemas.openxmlformats.org/officeDocument/2006/relationships" id="273" r:id="Rd6962affd3984adb"/>
+    <p:sldId xmlns:r="http://schemas.openxmlformats.org/officeDocument/2006/relationships" id="274" r:id="R6b82b7cf8bd24b94"/>
+    <p:sldId xmlns:r="http://schemas.openxmlformats.org/officeDocument/2006/relationships" id="275" r:id="Rb8316db721a64c19"/>
+    <p:sldId xmlns:r="http://schemas.openxmlformats.org/officeDocument/2006/relationships" id="276" r:id="R8a77bd9920754903"/>
+    <p:sldId xmlns:r="http://schemas.openxmlformats.org/officeDocument/2006/relationships" id="277" r:id="R5f6ecff89d814063"/>
+    <p:sldId xmlns:r="http://schemas.openxmlformats.org/officeDocument/2006/relationships" id="278" r:id="R8a70c5799b4b440b"/>
+    <p:sldId xmlns:r="http://schemas.openxmlformats.org/officeDocument/2006/relationships" id="279" r:id="R01b597cb402d4a84"/>
+    <p:sldId xmlns:r="http://schemas.openxmlformats.org/officeDocument/2006/relationships" id="280" r:id="R74d4b5b7e68144d2"/>
   </p:sldIdLst>
   <p:sldSz cx="12192000" cy="6858000"/>
   <p:notesSz cx="6858000" cy="9144000"/>
@@ -486,7 +486,7 @@
           </a:p>
           <a:p xmlns:a="http://schemas.openxmlformats.org/drawingml/2006/main">
             <a:r>
-              <a:t>We start from the stated target operating model, explain why Kong leads under that model, and then make the ownership, migration, evidence and exit gates explicit.</a:t>
+              <a:t>We start from the stated target operating model, disposition four early gates for multicloud, clean exit/vendor dependency, fully allocated TCO, and the optional Kong-plus-Traceable solution profile, and then make the ownership, migration, execution evidence and production gates explicit.</a:t>
             </a:r>
           </a:p>
           <a:p xmlns:a="http://schemas.openxmlformats.org/drawingml/2006/main">
@@ -501,7 +501,7 @@
           </a:p>
           <a:p xmlns:a="http://schemas.openxmlformats.org/drawingml/2006/main">
             <a:r>
-              <a:t>Align on the decision question: approve a bounded Kong direction and proof programme—not critical production scale.</a:t>
+              <a:t>Align on the decision question: disposition the early gates, then approve a bounded Kong direction and proof programme—not critical production scale.</a:t>
             </a:r>
           </a:p>
           <a:p xmlns:a="http://schemas.openxmlformats.org/drawingml/2006/main">
@@ -516,7 +516,7 @@
           </a:p>
           <a:p xmlns:a="http://schemas.openxmlformats.org/drawingml/2006/main">
             <a:r>
-              <a:t>First, make the target operating model visible because it drives the scoring and the platform fit.</a:t>
+              <a:t>First, make the target operating model and the four early assessment gates visible because they drive scope, evidence requests, scoring governance, and platform fit.</a:t>
             </a:r>
           </a:p>
           <a:p xmlns:a="http://schemas.openxmlformats.org/drawingml/2006/main">
@@ -531,7 +531,7 @@
           </a:p>
           <a:p xmlns:a="http://schemas.openxmlformats.org/drawingml/2006/main">
             <a:r>
-              <a:t>The supplied Word document is stakeholder input. Its ratings and recommendation are not independent comparative proof.</a:t>
+              <a:t>The sanitized supplied evaluation is stakeholder input. Its ratings and recommendation are not independent comparative proof.</a:t>
             </a:r>
           </a:p>
           <a:p xmlns:a="http://schemas.openxmlformats.org/drawingml/2006/main">
@@ -546,17 +546,47 @@
           </a:p>
           <a:p xmlns:a="http://schemas.openxmlformats.org/drawingml/2006/main">
             <a:r>
-              <a:t>- docs/48-kong-guided-evaluation.md</a:t>
-            </a:r>
-          </a:p>
-          <a:p xmlns:a="http://schemas.openxmlformats.org/drawingml/2006/main">
-            <a:r>
-              <a:t>- docs/47-kong-enterprise-platform-strategy.md</a:t>
-            </a:r>
-          </a:p>
-          <a:p xmlns:a="http://schemas.openxmlformats.org/drawingml/2006/main">
-            <a:r>
-              <a:t>- docs/35-mule-migration-strategy.md</a:t>
+              <a:t>- 48-kong-guided-evaluation.md</a:t>
+            </a:r>
+          </a:p>
+          <a:p xmlns:a="http://schemas.openxmlformats.org/drawingml/2006/main">
+            <a:r>
+              <a:t>- 48-kong-guided-evaluation.md#four-early-assessment-gates</a:t>
+            </a:r>
+          </a:p>
+          <a:p xmlns:a="http://schemas.openxmlformats.org/drawingml/2006/main">
+            <a:r>
+              <a:t>- 47-kong-enterprise-platform-strategy.md</a:t>
+            </a:r>
+          </a:p>
+          <a:p xmlns:a="http://schemas.openxmlformats.org/drawingml/2006/main">
+            <a:r>
+              <a:t>- 35-mule-migration-strategy.md</a:t>
+            </a:r>
+          </a:p>
+          <a:p xmlns:a="http://schemas.openxmlformats.org/drawingml/2006/main">
+            <a:r>
+              <a:t>- https://developer.konghq.com/gateway/deployment-topologies/</a:t>
+            </a:r>
+          </a:p>
+          <a:p xmlns:a="http://schemas.openxmlformats.org/drawingml/2006/main">
+            <a:r>
+              <a:t>- https://developer.konghq.com/gateway/hybrid-mode/</a:t>
+            </a:r>
+          </a:p>
+          <a:p xmlns:a="http://schemas.openxmlformats.org/drawingml/2006/main">
+            <a:r>
+              <a:t>- https://docs.traceable.ai/kong</a:t>
+            </a:r>
+          </a:p>
+          <a:p xmlns:a="http://schemas.openxmlformats.org/drawingml/2006/main">
+            <a:r>
+              <a:t>- https://developer.konghq.com/plugins/harness-waap/</a:t>
+            </a:r>
+          </a:p>
+          <a:p xmlns:a="http://schemas.openxmlformats.org/drawingml/2006/main">
+            <a:r>
+              <a:t>- https://konghq.com/pricing</a:t>
             </a:r>
           </a:p>
         </p:txBody>
@@ -706,12 +736,22 @@
           </a:p>
           <a:p xmlns:a="http://schemas.openxmlformats.org/drawingml/2006/main">
             <a:r>
+              <a:t>- 47-kong-enterprise-platform-strategy.md</a:t>
+            </a:r>
+          </a:p>
+          <a:p xmlns:a="http://schemas.openxmlformats.org/drawingml/2006/main">
+            <a:r>
+              <a:t>- 48-kong-guided-evaluation.md</a:t>
+            </a:r>
+          </a:p>
+          <a:p xmlns:a="http://schemas.openxmlformats.org/drawingml/2006/main">
+            <a:r>
               <a:t>- https://developer.konghq.com/gateway/hybrid-mode/</a:t>
             </a:r>
           </a:p>
           <a:p xmlns:a="http://schemas.openxmlformats.org/drawingml/2006/main">
             <a:r>
-              <a:t>- docs/47-kong-enterprise-platform-strategy.md</a:t>
+              <a:t>- https://developer.konghq.com/gateway/monitoring/</a:t>
             </a:r>
           </a:p>
         </p:txBody>
@@ -861,7 +901,22 @@
           </a:p>
           <a:p xmlns:a="http://schemas.openxmlformats.org/drawingml/2006/main">
             <a:r>
-              <a:t>- docs/47-kong-enterprise-platform-strategy.md</a:t>
+              <a:t>- 47-kong-enterprise-platform-strategy.md</a:t>
+            </a:r>
+          </a:p>
+          <a:p xmlns:a="http://schemas.openxmlformats.org/drawingml/2006/main">
+            <a:r>
+              <a:t>- 48-kong-guided-evaluation.md</a:t>
+            </a:r>
+          </a:p>
+          <a:p xmlns:a="http://schemas.openxmlformats.org/drawingml/2006/main">
+            <a:r>
+              <a:t>- https://developer.konghq.com/gateway/hybrid-mode/</a:t>
+            </a:r>
+          </a:p>
+          <a:p xmlns:a="http://schemas.openxmlformats.org/drawingml/2006/main">
+            <a:r>
+              <a:t>- https://developer.konghq.com/gateway/monitoring/</a:t>
             </a:r>
           </a:p>
         </p:txBody>
@@ -1011,7 +1066,22 @@
           </a:p>
           <a:p xmlns:a="http://schemas.openxmlformats.org/drawingml/2006/main">
             <a:r>
-              <a:t>- docs/47-kong-enterprise-platform-strategy.md</a:t>
+              <a:t>- 47-kong-enterprise-platform-strategy.md</a:t>
+            </a:r>
+          </a:p>
+          <a:p xmlns:a="http://schemas.openxmlformats.org/drawingml/2006/main">
+            <a:r>
+              <a:t>- 48-kong-guided-evaluation.md</a:t>
+            </a:r>
+          </a:p>
+          <a:p xmlns:a="http://schemas.openxmlformats.org/drawingml/2006/main">
+            <a:r>
+              <a:t>- https://developer.konghq.com/gateway/hybrid-mode/</a:t>
+            </a:r>
+          </a:p>
+          <a:p xmlns:a="http://schemas.openxmlformats.org/drawingml/2006/main">
+            <a:r>
+              <a:t>- https://developer.konghq.com/gateway/monitoring/</a:t>
             </a:r>
           </a:p>
         </p:txBody>
@@ -1161,7 +1231,22 @@
           </a:p>
           <a:p xmlns:a="http://schemas.openxmlformats.org/drawingml/2006/main">
             <a:r>
-              <a:t>- docs/47-kong-enterprise-platform-strategy.md</a:t>
+              <a:t>- 47-kong-enterprise-platform-strategy.md</a:t>
+            </a:r>
+          </a:p>
+          <a:p xmlns:a="http://schemas.openxmlformats.org/drawingml/2006/main">
+            <a:r>
+              <a:t>- 48-kong-guided-evaluation.md</a:t>
+            </a:r>
+          </a:p>
+          <a:p xmlns:a="http://schemas.openxmlformats.org/drawingml/2006/main">
+            <a:r>
+              <a:t>- https://developer.konghq.com/gateway/hybrid-mode/</a:t>
+            </a:r>
+          </a:p>
+          <a:p xmlns:a="http://schemas.openxmlformats.org/drawingml/2006/main">
+            <a:r>
+              <a:t>- https://developer.konghq.com/gateway/monitoring/</a:t>
             </a:r>
           </a:p>
         </p:txBody>
@@ -1311,7 +1396,47 @@
           </a:p>
           <a:p xmlns:a="http://schemas.openxmlformats.org/drawingml/2006/main">
             <a:r>
-              <a:t>- docs/35-mule-migration-strategy.md</a:t>
+              <a:t>- 35-mule-migration-strategy.md</a:t>
+            </a:r>
+          </a:p>
+          <a:p xmlns:a="http://schemas.openxmlformats.org/drawingml/2006/main">
+            <a:r>
+              <a:t>- ../research/glossary.md#kong-terminology-crosswalk</a:t>
+            </a:r>
+          </a:p>
+          <a:p xmlns:a="http://schemas.openxmlformats.org/drawingml/2006/main">
+            <a:r>
+              <a:t>- 48-kong-guided-evaluation.md</a:t>
+            </a:r>
+          </a:p>
+          <a:p xmlns:a="http://schemas.openxmlformats.org/drawingml/2006/main">
+            <a:r>
+              <a:t>- https://docs.mulesoft.com/gateway/latest/</a:t>
+            </a:r>
+          </a:p>
+          <a:p xmlns:a="http://schemas.openxmlformats.org/drawingml/2006/main">
+            <a:r>
+              <a:t>- https://developer.konghq.com/gateway/entities/</a:t>
+            </a:r>
+          </a:p>
+          <a:p xmlns:a="http://schemas.openxmlformats.org/drawingml/2006/main">
+            <a:r>
+              <a:t>- https://developer.konghq.com/gateway/entities/plugin/</a:t>
+            </a:r>
+          </a:p>
+          <a:p xmlns:a="http://schemas.openxmlformats.org/drawingml/2006/main">
+            <a:r>
+              <a:t>- https://developer.konghq.com/gateway/deployment-topologies/</a:t>
+            </a:r>
+          </a:p>
+          <a:p xmlns:a="http://schemas.openxmlformats.org/drawingml/2006/main">
+            <a:r>
+              <a:t>- https://docs.cloud.google.com/apigee/docs/api-platform/fundamentals/download-api-proxies</a:t>
+            </a:r>
+          </a:p>
+          <a:p xmlns:a="http://schemas.openxmlformats.org/drawingml/2006/main">
+            <a:r>
+              <a:t>- https://docs.cloud.google.com/apigee/docs/api-platform/reference/api-proxy-configuration-reference</a:t>
             </a:r>
           </a:p>
         </p:txBody>
@@ -1461,7 +1586,42 @@
           </a:p>
           <a:p xmlns:a="http://schemas.openxmlformats.org/drawingml/2006/main">
             <a:r>
-              <a:t>- docs/35-mule-migration-strategy.md</a:t>
+              <a:t>- 35-mule-migration-strategy.md</a:t>
+            </a:r>
+          </a:p>
+          <a:p xmlns:a="http://schemas.openxmlformats.org/drawingml/2006/main">
+            <a:r>
+              <a:t>- 48-kong-guided-evaluation.md</a:t>
+            </a:r>
+          </a:p>
+          <a:p xmlns:a="http://schemas.openxmlformats.org/drawingml/2006/main">
+            <a:r>
+              <a:t>- https://docs.mulesoft.com/gateway/latest/</a:t>
+            </a:r>
+          </a:p>
+          <a:p xmlns:a="http://schemas.openxmlformats.org/drawingml/2006/main">
+            <a:r>
+              <a:t>- https://developer.konghq.com/gateway/entities/</a:t>
+            </a:r>
+          </a:p>
+          <a:p xmlns:a="http://schemas.openxmlformats.org/drawingml/2006/main">
+            <a:r>
+              <a:t>- https://developer.konghq.com/gateway/entities/plugin/</a:t>
+            </a:r>
+          </a:p>
+          <a:p xmlns:a="http://schemas.openxmlformats.org/drawingml/2006/main">
+            <a:r>
+              <a:t>- https://developer.konghq.com/gateway/deployment-topologies/</a:t>
+            </a:r>
+          </a:p>
+          <a:p xmlns:a="http://schemas.openxmlformats.org/drawingml/2006/main">
+            <a:r>
+              <a:t>- https://docs.cloud.google.com/apigee/docs/api-platform/fundamentals/download-api-proxies</a:t>
+            </a:r>
+          </a:p>
+          <a:p xmlns:a="http://schemas.openxmlformats.org/drawingml/2006/main">
+            <a:r>
+              <a:t>- https://docs.cloud.google.com/apigee/docs/api-platform/reference/api-proxy-configuration-reference</a:t>
             </a:r>
           </a:p>
         </p:txBody>
@@ -1806,12 +1966,27 @@
           </a:p>
           <a:p xmlns:a="http://schemas.openxmlformats.org/drawingml/2006/main">
             <a:r>
-              <a:t>- poc/README.md</a:t>
-            </a:r>
-          </a:p>
-          <a:p xmlns:a="http://schemas.openxmlformats.org/drawingml/2006/main">
-            <a:r>
-              <a:t>- docs/47-kong-enterprise-platform-strategy.md</a:t>
+              <a:t>- ../poc/README.md</a:t>
+            </a:r>
+          </a:p>
+          <a:p xmlns:a="http://schemas.openxmlformats.org/drawingml/2006/main">
+            <a:r>
+              <a:t>- 48-kong-guided-evaluation.md</a:t>
+            </a:r>
+          </a:p>
+          <a:p xmlns:a="http://schemas.openxmlformats.org/drawingml/2006/main">
+            <a:r>
+              <a:t>- 47-kong-enterprise-platform-strategy.md</a:t>
+            </a:r>
+          </a:p>
+          <a:p xmlns:a="http://schemas.openxmlformats.org/drawingml/2006/main">
+            <a:r>
+              <a:t>- https://developer.konghq.com/gateway/hybrid-mode/</a:t>
+            </a:r>
+          </a:p>
+          <a:p xmlns:a="http://schemas.openxmlformats.org/drawingml/2006/main">
+            <a:r>
+              <a:t>- https://developer.konghq.com/gateway/monitoring/</a:t>
             </a:r>
           </a:p>
         </p:txBody>
@@ -1991,7 +2166,7 @@
           </a:p>
           <a:p xmlns:a="http://schemas.openxmlformats.org/drawingml/2006/main">
             <a:r>
-              <a:t>- https://docs.traceable.ai/docs/kong</a:t>
+              <a:t>- https://docs.traceable.ai/kong</a:t>
             </a:r>
           </a:p>
           <a:p xmlns:a="http://schemas.openxmlformats.org/drawingml/2006/main">
@@ -2146,7 +2321,27 @@
           </a:p>
           <a:p xmlns:a="http://schemas.openxmlformats.org/drawingml/2006/main">
             <a:r>
-              <a:t>- docs/47-kong-enterprise-platform-strategy.md</a:t>
+              <a:t>- 47-kong-enterprise-platform-strategy.md</a:t>
+            </a:r>
+          </a:p>
+          <a:p xmlns:a="http://schemas.openxmlformats.org/drawingml/2006/main">
+            <a:r>
+              <a:t>- 48-kong-guided-evaluation.md</a:t>
+            </a:r>
+          </a:p>
+          <a:p xmlns:a="http://schemas.openxmlformats.org/drawingml/2006/main">
+            <a:r>
+              <a:t>- https://developer.konghq.com/gateway/hybrid-mode/</a:t>
+            </a:r>
+          </a:p>
+          <a:p xmlns:a="http://schemas.openxmlformats.org/drawingml/2006/main">
+            <a:r>
+              <a:t>- https://developer.konghq.com/gateway/monitoring/</a:t>
+            </a:r>
+          </a:p>
+          <a:p xmlns:a="http://schemas.openxmlformats.org/drawingml/2006/main">
+            <a:r>
+              <a:t>- https://developer.konghq.com/ai-gateway/</a:t>
             </a:r>
           </a:p>
         </p:txBody>
@@ -2221,7 +2416,7 @@
           </a:p>
           <a:p xmlns:a="http://schemas.openxmlformats.org/drawingml/2006/main">
             <a:r>
-              <a:t>Explain why the same product can be a good or poor choice depending on the target operating model.</a:t>
+              <a:t>Explain why the same product can be a good or poor choice depending on the target operating model, and force four material concerns into the assessment before bounded authorization.</a:t>
             </a:r>
           </a:p>
           <a:p xmlns:a="http://schemas.openxmlformats.org/drawingml/2006/main">
@@ -2236,7 +2431,7 @@
           </a:p>
           <a:p xmlns:a="http://schemas.openxmlformats.org/drawingml/2006/main">
             <a:r>
-              <a:t>The supplied assessment favors Kubernetes, GitOps, platform engineering, self-service, observability and emerging AI traffic governance. Those priorities explain why Kong scores well. They should be confirmed with accountable owners.</a:t>
+              <a:t>The supplied assessment favors Kubernetes, GitOps, platform engineering, self-service, observability, multicloud placement and emerging AI traffic governance. Those priorities explain why Kong scores well, but they must be confirmed with accountable owners. Before the room interprets scores or funds a proof programme, it must also disposition four early gates: `EAG-01` multicloud operating fit, `EAG-02` reversibility and vendor dependency, `EAG-03` cost efficiency and fully allocated TCO, and `EAG-04` admission of the optional `KP-SMH1 + GSA-01` Kong-plus-Traceable solution profile.</a:t>
             </a:r>
           </a:p>
           <a:p xmlns:a="http://schemas.openxmlformats.org/drawingml/2006/main">
@@ -2251,7 +2446,7 @@
           </a:p>
           <a:p xmlns:a="http://schemas.openxmlformats.org/drawingml/2006/main">
             <a:r>
-              <a:t>Confirm or amend these target-state assumptions before using them as decision weights.</a:t>
+              <a:t>Confirm or amend the nine target-state inputs. Then confirm, amend, reject, or leave explicitly unknown each early gate, with a public role owner, evidence request, due gate, and hold condition.</a:t>
             </a:r>
           </a:p>
           <a:p xmlns:a="http://schemas.openxmlformats.org/drawingml/2006/main">
@@ -2266,7 +2461,7 @@
           </a:p>
           <a:p xmlns:a="http://schemas.openxmlformats.org/drawingml/2006/main">
             <a:r>
-              <a:t>The next slide shows how those priorities were encoded in the supplied scorecard.</a:t>
+              <a:t>The next slide shows how the priorities were encoded in the supplied scorecard, where the added dimensions remain unknown and Traceable stays outside the platform score.</a:t>
             </a:r>
           </a:p>
           <a:p xmlns:a="http://schemas.openxmlformats.org/drawingml/2006/main">
@@ -2281,7 +2476,7 @@
           </a:p>
           <a:p xmlns:a="http://schemas.openxmlformats.org/drawingml/2006/main">
             <a:r>
-              <a:t>These are stakeholder-stated objectives; the document does not provide a verified workload inventory or current-state baseline.</a:t>
+              <a:t>These are stakeholder-stated objectives and early scope dispositions; the document does not provide a verified workload inventory, multicloud outcome, clean exit, normalized TCO, or executed Kong-plus-Traceable result. Early disposition creates a proof obligation, not evidence that the gate passed.</a:t>
             </a:r>
           </a:p>
           <a:p xmlns:a="http://schemas.openxmlformats.org/drawingml/2006/main">
@@ -2296,7 +2491,37 @@
           </a:p>
           <a:p xmlns:a="http://schemas.openxmlformats.org/drawingml/2006/main">
             <a:r>
-              <a:t>- docs/48-kong-guided-evaluation.md#stated-target-operating-model</a:t>
+              <a:t>- 48-kong-guided-evaluation.md#stated-target-operating-model</a:t>
+            </a:r>
+          </a:p>
+          <a:p xmlns:a="http://schemas.openxmlformats.org/drawingml/2006/main">
+            <a:r>
+              <a:t>- 48-kong-guided-evaluation.md#four-early-assessment-gates</a:t>
+            </a:r>
+          </a:p>
+          <a:p xmlns:a="http://schemas.openxmlformats.org/drawingml/2006/main">
+            <a:r>
+              <a:t>- https://developer.konghq.com/gateway/deployment-topologies/</a:t>
+            </a:r>
+          </a:p>
+          <a:p xmlns:a="http://schemas.openxmlformats.org/drawingml/2006/main">
+            <a:r>
+              <a:t>- https://developer.konghq.com/gateway/hybrid-mode/</a:t>
+            </a:r>
+          </a:p>
+          <a:p xmlns:a="http://schemas.openxmlformats.org/drawingml/2006/main">
+            <a:r>
+              <a:t>- https://docs.traceable.ai/kong</a:t>
+            </a:r>
+          </a:p>
+          <a:p xmlns:a="http://schemas.openxmlformats.org/drawingml/2006/main">
+            <a:r>
+              <a:t>- https://developer.konghq.com/plugins/harness-waap/</a:t>
+            </a:r>
+          </a:p>
+          <a:p xmlns:a="http://schemas.openxmlformats.org/drawingml/2006/main">
+            <a:r>
+              <a:t>- https://konghq.com/pricing</a:t>
             </a:r>
           </a:p>
         </p:txBody>
@@ -2471,7 +2696,12 @@
           </a:p>
           <a:p xmlns:a="http://schemas.openxmlformats.org/drawingml/2006/main">
             <a:r>
-              <a:t>- https://docs.traceable.ai/docs/kong</a:t>
+              <a:t>- https://developer.konghq.com/ai-gateway/</a:t>
+            </a:r>
+          </a:p>
+          <a:p xmlns:a="http://schemas.openxmlformats.org/drawingml/2006/main">
+            <a:r>
+              <a:t>- https://docs.traceable.ai/kong</a:t>
             </a:r>
           </a:p>
           <a:p xmlns:a="http://schemas.openxmlformats.org/drawingml/2006/main">
@@ -2626,7 +2856,27 @@
           </a:p>
           <a:p xmlns:a="http://schemas.openxmlformats.org/drawingml/2006/main">
             <a:r>
-              <a:t>- docs/47-kong-enterprise-platform-strategy.md</a:t>
+              <a:t>- 47-kong-enterprise-platform-strategy.md</a:t>
+            </a:r>
+          </a:p>
+          <a:p xmlns:a="http://schemas.openxmlformats.org/drawingml/2006/main">
+            <a:r>
+              <a:t>- 48-kong-guided-evaluation.md</a:t>
+            </a:r>
+          </a:p>
+          <a:p xmlns:a="http://schemas.openxmlformats.org/drawingml/2006/main">
+            <a:r>
+              <a:t>- https://developer.konghq.com/gateway/hybrid-mode/</a:t>
+            </a:r>
+          </a:p>
+          <a:p xmlns:a="http://schemas.openxmlformats.org/drawingml/2006/main">
+            <a:r>
+              <a:t>- https://developer.konghq.com/gateway/monitoring/</a:t>
+            </a:r>
+          </a:p>
+          <a:p xmlns:a="http://schemas.openxmlformats.org/drawingml/2006/main">
+            <a:r>
+              <a:t>- https://developer.konghq.com/ai-gateway/</a:t>
             </a:r>
           </a:p>
         </p:txBody>
@@ -2986,7 +3236,7 @@
           </a:p>
           <a:p xmlns:a="http://schemas.openxmlformats.org/drawingml/2006/main">
             <a:r>
-              <a:t>- https://docs.traceable.ai/docs/kong</a:t>
+              <a:t>- https://docs.traceable.ai/kong</a:t>
             </a:r>
           </a:p>
           <a:p xmlns:a="http://schemas.openxmlformats.org/drawingml/2006/main">
@@ -3196,7 +3446,7 @@
           </a:p>
           <a:p xmlns:a="http://schemas.openxmlformats.org/drawingml/2006/main">
             <a:r>
-              <a:t>- https://docs.traceable.ai/docs/kong</a:t>
+              <a:t>- https://docs.traceable.ai/kong</a:t>
             </a:r>
           </a:p>
         </p:txBody>
@@ -3476,7 +3726,7 @@
           </a:p>
           <a:p xmlns:a="http://schemas.openxmlformats.org/drawingml/2006/main">
             <a:r>
-              <a:t>Make the historical weighting model transparent and expose the dimensions required for a governed re-score.</a:t>
+              <a:t>Make the historical weighting model transparent, expose the dimensions required for a governed re-score, and keep Traceable as a separate unscored solution-profile gate.</a:t>
             </a:r>
           </a:p>
           <a:p xmlns:a="http://schemas.openxmlformats.org/drawingml/2006/main">
@@ -3491,7 +3741,7 @@
           </a:p>
           <a:p xmlns:a="http://schemas.openxmlformats.org/drawingml/2006/main">
             <a:r>
-              <a:t>Eight supplied categories sum to 100%, and Kubernetes plus GitOps carry 35%. The provisional planning scenario rebases those historical categories to 60% and allocates 40% across multicloud, scalability/robustness, enterprise IAM and traceability, reversibility/vendor dependency, fully allocated TCO, and control-plane operating responsibility. This makes the meeting feedback visible without changing the historical ratings. The 40% split is an assumption to approve or amend; every new product rating remains unknown.</a:t>
+              <a:t>Eight supplied categories sum to 100%, and Kubernetes plus GitOps carry 35%. The provisional planning scenario rebases those historical categories to 60% and allocates 40% across multicloud, scalability/robustness, enterprise IAM and traceability, reversibility/vendor dependency, fully allocated TCO, and control-plane operating responsibility. This makes the meeting feedback visible without changing the historical ratings. The 40% split is an assumption to approve or amend; every new product rating remains unknown. `EAG-04` stays separate: admitting `KP-SMH1 + GSA-01` for GEP-07 study cannot add native Kong points.</a:t>
             </a:r>
           </a:p>
           <a:p xmlns:a="http://schemas.openxmlformats.org/drawingml/2006/main">
@@ -3506,7 +3756,7 @@
           </a:p>
           <a:p xmlns:a="http://schemas.openxmlformats.org/drawingml/2006/main">
             <a:r>
-              <a:t>Approve, amend, or reject the provisional weights and double-counting rules, then assign the exact-option boundary, mandatory gates, evidence floor, scorer and approver panel, rating authority, confidence treatment, sensitivity method, dissent rule, and permitted decision use.</a:t>
+              <a:t>Approve, amend, or reject the provisional weights and double-counting rules; confirm that `EAG-01`–`EAG-03` remain early gates as well as later evidence dimensions and that `EAG-04` remains unscored; then assign the exact-option boundary, mandatory gates, evidence floor, scorer and approver panel, rating authority, confidence treatment, sensitivity method, dissent rule, and permitted decision use.</a:t>
             </a:r>
           </a:p>
           <a:p xmlns:a="http://schemas.openxmlformats.org/drawingml/2006/main">
@@ -3521,7 +3771,7 @@
           </a:p>
           <a:p xmlns:a="http://schemas.openxmlformats.org/drawingml/2006/main">
             <a:r>
-              <a:t>Now compare operating-model fit rather than treating these products as interchangeable feature bundles.</a:t>
+              <a:t>Now compare operating-model fit rather than treating products or optional adjuncts as interchangeable feature bundles.</a:t>
             </a:r>
           </a:p>
           <a:p xmlns:a="http://schemas.openxmlformats.org/drawingml/2006/main">
@@ -3536,7 +3786,7 @@
           </a:p>
           <a:p xmlns:a="http://schemas.openxmlformats.org/drawingml/2006/main">
             <a:r>
-              <a:t>The provisional weights are a scenario, not an approved model or revised ranking. The new ratings remain unknown, 30 mandatory gates remain unknown, and common score-capable evidence coverage is 0%.</a:t>
+              <a:t>The provisional weights are a scenario, not an approved model or revised ranking. The new ratings remain unknown, 30 mandatory gates remain unknown, and common score-capable evidence coverage is 0%. An early-gate disposition is meeting governance input; it cannot narrow a rating range or close an `E2`–`E4` proof obligation.</a:t>
             </a:r>
           </a:p>
           <a:p xmlns:a="http://schemas.openxmlformats.org/drawingml/2006/main">
@@ -3571,6 +3821,16 @@
           </a:p>
           <a:p xmlns:a="http://schemas.openxmlformats.org/drawingml/2006/main">
             <a:r>
+              <a:t>- 48-kong-guided-evaluation.md#four-early-assessment-gates</a:t>
+            </a:r>
+          </a:p>
+          <a:p xmlns:a="http://schemas.openxmlformats.org/drawingml/2006/main">
+            <a:r>
+              <a:t>- 48-kong-guided-evaluation.md#traceable-by-harness-security-adjunct-feasibility</a:t>
+            </a:r>
+          </a:p>
+          <a:p xmlns:a="http://schemas.openxmlformats.org/drawingml/2006/main">
+            <a:r>
               <a:t>- ../decision-matrix/scoring-guide.md</a:t>
             </a:r>
           </a:p>
@@ -3582,6 +3842,21 @@
           <a:p xmlns:a="http://schemas.openxmlformats.org/drawingml/2006/main">
             <a:r>
               <a:t>- https://developer.konghq.com/gateway/hybrid-mode/</a:t>
+            </a:r>
+          </a:p>
+          <a:p xmlns:a="http://schemas.openxmlformats.org/drawingml/2006/main">
+            <a:r>
+              <a:t>- https://docs.traceable.ai/kong</a:t>
+            </a:r>
+          </a:p>
+          <a:p xmlns:a="http://schemas.openxmlformats.org/drawingml/2006/main">
+            <a:r>
+              <a:t>- https://developer.konghq.com/plugins/harness-waap/</a:t>
+            </a:r>
+          </a:p>
+          <a:p xmlns:a="http://schemas.openxmlformats.org/drawingml/2006/main">
+            <a:r>
+              <a:t>- https://konghq.com/pricing</a:t>
             </a:r>
           </a:p>
         </p:txBody>
@@ -3716,7 +3991,7 @@
           </a:p>
           <a:p xmlns:a="http://schemas.openxmlformats.org/drawingml/2006/main">
             <a:r>
-              <a:t>The source document's qualitative ratings and cost/lock-in labels are supplied assessments, not independently verified facts.</a:t>
+              <a:t>The qualitative ratings and cost/lock-in labels preserved in the sanitized supplied evaluation are stakeholder assessments, not independently verified facts.</a:t>
             </a:r>
           </a:p>
           <a:p xmlns:a="http://schemas.openxmlformats.org/drawingml/2006/main">
@@ -3731,7 +4006,7 @@
           </a:p>
           <a:p xmlns:a="http://schemas.openxmlformats.org/drawingml/2006/main">
             <a:r>
-              <a:t>- docs/48-kong-guided-evaluation.md#conditional-option-archetypes</a:t>
+              <a:t>- 48-kong-guided-evaluation.md#conditional-option-archetypes</a:t>
             </a:r>
           </a:p>
           <a:p xmlns:a="http://schemas.openxmlformats.org/drawingml/2006/main">
@@ -4086,7 +4361,17 @@
           </a:p>
           <a:p xmlns:a="http://schemas.openxmlformats.org/drawingml/2006/main">
             <a:r>
-              <a:t>- docs/48-kong-guided-evaluation.md#bounded-authorization</a:t>
+              <a:t>- 48-kong-guided-evaluation.md#bounded-authorization</a:t>
+            </a:r>
+          </a:p>
+          <a:p xmlns:a="http://schemas.openxmlformats.org/drawingml/2006/main">
+            <a:r>
+              <a:t>- https://developer.konghq.com/gateway/hybrid-mode/</a:t>
+            </a:r>
+          </a:p>
+          <a:p xmlns:a="http://schemas.openxmlformats.org/drawingml/2006/main">
+            <a:r>
+              <a:t>- https://developer.konghq.com/gateway/version-support-policy/</a:t>
             </a:r>
           </a:p>
         </p:txBody>
@@ -4236,12 +4521,27 @@
           </a:p>
           <a:p xmlns:a="http://schemas.openxmlformats.org/drawingml/2006/main">
             <a:r>
-              <a:t>- docs/44-kong-multicloud-study-roadmap.md</a:t>
-            </a:r>
-          </a:p>
-          <a:p xmlns:a="http://schemas.openxmlformats.org/drawingml/2006/main">
-            <a:r>
-              <a:t>- docs/47-kong-enterprise-platform-strategy.md</a:t>
+              <a:t>- 44-kong-multicloud-study-roadmap.md</a:t>
+            </a:r>
+          </a:p>
+          <a:p xmlns:a="http://schemas.openxmlformats.org/drawingml/2006/main">
+            <a:r>
+              <a:t>- 47-kong-enterprise-platform-strategy.md</a:t>
+            </a:r>
+          </a:p>
+          <a:p xmlns:a="http://schemas.openxmlformats.org/drawingml/2006/main">
+            <a:r>
+              <a:t>- 48-kong-guided-evaluation.md</a:t>
+            </a:r>
+          </a:p>
+          <a:p xmlns:a="http://schemas.openxmlformats.org/drawingml/2006/main">
+            <a:r>
+              <a:t>- https://developer.konghq.com/gateway/hybrid-mode/</a:t>
+            </a:r>
+          </a:p>
+          <a:p xmlns:a="http://schemas.openxmlformats.org/drawingml/2006/main">
+            <a:r>
+              <a:t>- https://developer.konghq.com/gateway/version-support-policy/</a:t>
             </a:r>
           </a:p>
         </p:txBody>
@@ -4561,12 +4861,22 @@
           </a:p>
           <a:p xmlns:a="http://schemas.openxmlformats.org/drawingml/2006/main">
             <a:r>
+              <a:t>- 47-kong-enterprise-platform-strategy.md</a:t>
+            </a:r>
+          </a:p>
+          <a:p xmlns:a="http://schemas.openxmlformats.org/drawingml/2006/main">
+            <a:r>
+              <a:t>- 48-kong-guided-evaluation.md</a:t>
+            </a:r>
+          </a:p>
+          <a:p xmlns:a="http://schemas.openxmlformats.org/drawingml/2006/main">
+            <a:r>
               <a:t>- https://developer.konghq.com/gateway/hybrid-mode/</a:t>
             </a:r>
           </a:p>
           <a:p xmlns:a="http://schemas.openxmlformats.org/drawingml/2006/main">
             <a:r>
-              <a:t>- docs/47-kong-enterprise-platform-strategy.md</a:t>
+              <a:t>- https://developer.konghq.com/gateway/monitoring/</a:t>
             </a:r>
           </a:p>
         </p:txBody>
@@ -4634,7 +4944,7 @@
   </p:cSld>
   <p:clrMap bg1="lt1" tx1="dk1" bg2="lt2" tx2="dk2" accent1="accent1" accent2="accent2" accent3="accent3" accent4="accent4" accent5="accent5" accent6="accent6" hlink="hlink" folHlink="folHlink"/>
   <p:sldLayoutIdLst>
-    <p:sldLayoutId xmlns:r="http://schemas.openxmlformats.org/officeDocument/2006/relationships" id="2147483649" r:id="Rdce3bcdb06f84998"/>
+    <p:sldLayoutId xmlns:r="http://schemas.openxmlformats.org/officeDocument/2006/relationships" id="2147483649" r:id="Rfaf378160e474549"/>
   </p:sldLayoutIdLst>
   <p:txStyles>
     <p:titleStyle>
@@ -5936,7 +6246,7 @@
                 <a:solidFill>
                   <a:srgbClr val="666762"/>
                 </a:solidFill>
-                <a:hlinkClick xmlns:r="http://schemas.openxmlformats.org/officeDocument/2006/relationships" r:id="R1505224329d44489"/>
+                <a:hlinkClick xmlns:r="http://schemas.openxmlformats.org/officeDocument/2006/relationships" r:id="R0de9632a71a04ee4"/>
               </a:rPr>
               <a:t>Repo reference</a:t>
             </a:r>
@@ -5953,7 +6263,7 @@
                 <a:solidFill>
                   <a:srgbClr val="666762"/>
                 </a:solidFill>
-                <a:hlinkClick xmlns:r="http://schemas.openxmlformats.org/officeDocument/2006/relationships" r:id="R983e45434f464467"/>
+                <a:hlinkClick xmlns:r="http://schemas.openxmlformats.org/officeDocument/2006/relationships" r:id="Rc268edc5ec7c49e3"/>
               </a:rPr>
               <a:t>Official docs</a:t>
             </a:r>
@@ -6314,7 +6624,7 @@
                 <a:solidFill>
                   <a:srgbClr val="666762"/>
                 </a:solidFill>
-                <a:hlinkClick xmlns:r="http://schemas.openxmlformats.org/officeDocument/2006/relationships" r:id="R3bd9c3cbb4c14d7d"/>
+                <a:hlinkClick xmlns:r="http://schemas.openxmlformats.org/officeDocument/2006/relationships" r:id="Rb126e8c959334963"/>
               </a:rPr>
               <a:t>Repo reference</a:t>
             </a:r>
@@ -6331,7 +6641,7 @@
                 <a:solidFill>
                   <a:srgbClr val="666762"/>
                 </a:solidFill>
-                <a:hlinkClick xmlns:r="http://schemas.openxmlformats.org/officeDocument/2006/relationships" r:id="Rd41355a7e97743f6"/>
+                <a:hlinkClick xmlns:r="http://schemas.openxmlformats.org/officeDocument/2006/relationships" r:id="Rf587c8b7276348c7"/>
               </a:rPr>
               <a:t>Official docs</a:t>
             </a:r>
@@ -7620,7 +7930,7 @@
                 <a:solidFill>
                   <a:srgbClr val="666762"/>
                 </a:solidFill>
-                <a:hlinkClick xmlns:r="http://schemas.openxmlformats.org/officeDocument/2006/relationships" r:id="R82b76bf3ce4c4f4d"/>
+                <a:hlinkClick xmlns:r="http://schemas.openxmlformats.org/officeDocument/2006/relationships" r:id="R227e6d7eaca446a1"/>
               </a:rPr>
               <a:t>Repo reference</a:t>
             </a:r>
@@ -7637,7 +7947,7 @@
                 <a:solidFill>
                   <a:srgbClr val="666762"/>
                 </a:solidFill>
-                <a:hlinkClick xmlns:r="http://schemas.openxmlformats.org/officeDocument/2006/relationships" r:id="R478b188305f641f5"/>
+                <a:hlinkClick xmlns:r="http://schemas.openxmlformats.org/officeDocument/2006/relationships" r:id="R62d1984686ef4de6"/>
               </a:rPr>
               <a:t>Official docs</a:t>
             </a:r>
@@ -8413,7 +8723,7 @@
       </p:sp>
       <p:cxnSp>
         <p:nvCxnSpPr>
-          <p:cNvPr id="355" name=""/>
+          <p:cNvPr id="378" name=""/>
           <p:cNvCxnSpPr>
             <a:stCxn xmlns:a="http://schemas.openxmlformats.org/drawingml/2006/main" id="9" idx="3"/>
             <a:endCxn xmlns:a="http://schemas.openxmlformats.org/drawingml/2006/main" id="12" idx="1"/>
@@ -8439,7 +8749,7 @@
       </p:cxnSp>
       <p:cxnSp>
         <p:nvCxnSpPr>
-          <p:cNvPr id="356" name=""/>
+          <p:cNvPr id="379" name=""/>
           <p:cNvCxnSpPr>
             <a:stCxn xmlns:a="http://schemas.openxmlformats.org/drawingml/2006/main" id="12" idx="3"/>
             <a:endCxn xmlns:a="http://schemas.openxmlformats.org/drawingml/2006/main" id="15" idx="1"/>
@@ -8465,7 +8775,7 @@
       </p:cxnSp>
       <p:cxnSp>
         <p:nvCxnSpPr>
-          <p:cNvPr id="357" name=""/>
+          <p:cNvPr id="380" name=""/>
           <p:cNvCxnSpPr>
             <a:stCxn xmlns:a="http://schemas.openxmlformats.org/drawingml/2006/main" id="15" idx="3"/>
             <a:endCxn xmlns:a="http://schemas.openxmlformats.org/drawingml/2006/main" id="18" idx="1"/>
@@ -9447,7 +9757,7 @@
                 <a:solidFill>
                   <a:srgbClr val="666762"/>
                 </a:solidFill>
-                <a:hlinkClick xmlns:r="http://schemas.openxmlformats.org/officeDocument/2006/relationships" r:id="R74a53018a5fb4905"/>
+                <a:hlinkClick xmlns:r="http://schemas.openxmlformats.org/officeDocument/2006/relationships" r:id="R4d9b5dd534b34b8f"/>
               </a:rPr>
               <a:t>Repo reference</a:t>
             </a:r>
@@ -9464,7 +9774,7 @@
                 <a:solidFill>
                   <a:srgbClr val="666762"/>
                 </a:solidFill>
-                <a:hlinkClick xmlns:r="http://schemas.openxmlformats.org/officeDocument/2006/relationships" r:id="R5421aa73b30040a5"/>
+                <a:hlinkClick xmlns:r="http://schemas.openxmlformats.org/officeDocument/2006/relationships" r:id="R9341435459974570"/>
               </a:rPr>
               <a:t>Official docs</a:t>
             </a:r>
@@ -11099,7 +11409,7 @@
                 <a:solidFill>
                   <a:srgbClr val="666762"/>
                 </a:solidFill>
-                <a:hlinkClick xmlns:r="http://schemas.openxmlformats.org/officeDocument/2006/relationships" r:id="Rb94bd70ef6534262"/>
+                <a:hlinkClick xmlns:r="http://schemas.openxmlformats.org/officeDocument/2006/relationships" r:id="R6f299d0d275547ef"/>
               </a:rPr>
               <a:t>Repo reference</a:t>
             </a:r>
@@ -11116,7 +11426,7 @@
                 <a:solidFill>
                   <a:srgbClr val="666762"/>
                 </a:solidFill>
-                <a:hlinkClick xmlns:r="http://schemas.openxmlformats.org/officeDocument/2006/relationships" r:id="Rad2efaac483a46f9"/>
+                <a:hlinkClick xmlns:r="http://schemas.openxmlformats.org/officeDocument/2006/relationships" r:id="R55bb20441405495c"/>
               </a:rPr>
               <a:t>Official docs</a:t>
             </a:r>
@@ -13343,7 +13653,7 @@
                 <a:solidFill>
                   <a:srgbClr val="666762"/>
                 </a:solidFill>
-                <a:hlinkClick xmlns:r="http://schemas.openxmlformats.org/officeDocument/2006/relationships" r:id="Refbd7fb23e4440b2"/>
+                <a:hlinkClick xmlns:r="http://schemas.openxmlformats.org/officeDocument/2006/relationships" r:id="Ref0e3753cfe8442d"/>
               </a:rPr>
               <a:t>Repo reference</a:t>
             </a:r>
@@ -13360,7 +13670,7 @@
                 <a:solidFill>
                   <a:srgbClr val="666762"/>
                 </a:solidFill>
-                <a:hlinkClick xmlns:r="http://schemas.openxmlformats.org/officeDocument/2006/relationships" r:id="R4aa618a6dfd94da0"/>
+                <a:hlinkClick xmlns:r="http://schemas.openxmlformats.org/officeDocument/2006/relationships" r:id="R6a9b5d0ff10740fb"/>
               </a:rPr>
               <a:t>Official docs</a:t>
             </a:r>
@@ -15306,7 +15616,7 @@
                 <a:solidFill>
                   <a:srgbClr val="666762"/>
                 </a:solidFill>
-                <a:hlinkClick xmlns:r="http://schemas.openxmlformats.org/officeDocument/2006/relationships" r:id="Rfe5cc34ae0d8435a"/>
+                <a:hlinkClick xmlns:r="http://schemas.openxmlformats.org/officeDocument/2006/relationships" r:id="R709d3827b98146d6"/>
               </a:rPr>
               <a:t>Repo reference</a:t>
             </a:r>
@@ -15323,7 +15633,7 @@
                 <a:solidFill>
                   <a:srgbClr val="666762"/>
                 </a:solidFill>
-                <a:hlinkClick xmlns:r="http://schemas.openxmlformats.org/officeDocument/2006/relationships" r:id="Rfbde975b56814747"/>
+                <a:hlinkClick xmlns:r="http://schemas.openxmlformats.org/officeDocument/2006/relationships" r:id="R962b119d8fdc4c19"/>
               </a:rPr>
               <a:t>Official docs</a:t>
             </a:r>
@@ -16180,7 +16490,7 @@
       </p:sp>
       <p:cxnSp>
         <p:nvCxnSpPr>
-          <p:cNvPr id="419" name=""/>
+          <p:cNvPr id="447" name=""/>
           <p:cNvCxnSpPr>
             <a:stCxn xmlns:a="http://schemas.openxmlformats.org/drawingml/2006/main" id="9" idx="3"/>
             <a:endCxn xmlns:a="http://schemas.openxmlformats.org/drawingml/2006/main" id="12" idx="1"/>
@@ -16206,7 +16516,7 @@
       </p:cxnSp>
       <p:cxnSp>
         <p:nvCxnSpPr>
-          <p:cNvPr id="420" name=""/>
+          <p:cNvPr id="448" name=""/>
           <p:cNvCxnSpPr>
             <a:stCxn xmlns:a="http://schemas.openxmlformats.org/drawingml/2006/main" id="12" idx="3"/>
             <a:endCxn xmlns:a="http://schemas.openxmlformats.org/drawingml/2006/main" id="15" idx="1"/>
@@ -16234,7 +16544,7 @@
       </p:cxnSp>
       <p:cxnSp>
         <p:nvCxnSpPr>
-          <p:cNvPr id="421" name=""/>
+          <p:cNvPr id="449" name=""/>
           <p:cNvCxnSpPr>
             <a:stCxn xmlns:a="http://schemas.openxmlformats.org/drawingml/2006/main" id="12" idx="3"/>
             <a:endCxn xmlns:a="http://schemas.openxmlformats.org/drawingml/2006/main" id="18" idx="1"/>
@@ -16262,7 +16572,7 @@
       </p:cxnSp>
       <p:cxnSp>
         <p:nvCxnSpPr>
-          <p:cNvPr id="422" name=""/>
+          <p:cNvPr id="450" name=""/>
           <p:cNvCxnSpPr>
             <a:stCxn xmlns:a="http://schemas.openxmlformats.org/drawingml/2006/main" id="15" idx="3"/>
             <a:endCxn xmlns:a="http://schemas.openxmlformats.org/drawingml/2006/main" id="21" idx="1"/>
@@ -16290,7 +16600,7 @@
       </p:cxnSp>
       <p:cxnSp>
         <p:nvCxnSpPr>
-          <p:cNvPr id="423" name=""/>
+          <p:cNvPr id="451" name=""/>
           <p:cNvCxnSpPr>
             <a:stCxn xmlns:a="http://schemas.openxmlformats.org/drawingml/2006/main" id="18" idx="3"/>
             <a:endCxn xmlns:a="http://schemas.openxmlformats.org/drawingml/2006/main" id="21" idx="1"/>
@@ -16824,7 +17134,7 @@
                 <a:solidFill>
                   <a:srgbClr val="666762"/>
                 </a:solidFill>
-                <a:hlinkClick xmlns:r="http://schemas.openxmlformats.org/officeDocument/2006/relationships" r:id="R89172a4789e242c0"/>
+                <a:hlinkClick xmlns:r="http://schemas.openxmlformats.org/officeDocument/2006/relationships" r:id="Ra95138df65a34bd0"/>
               </a:rPr>
               <a:t>Repo reference</a:t>
             </a:r>
@@ -16841,7 +17151,7 @@
                 <a:solidFill>
                   <a:srgbClr val="666762"/>
                 </a:solidFill>
-                <a:hlinkClick xmlns:r="http://schemas.openxmlformats.org/officeDocument/2006/relationships" r:id="R4720e7f299c54dea"/>
+                <a:hlinkClick xmlns:r="http://schemas.openxmlformats.org/officeDocument/2006/relationships" r:id="R3a7c2bd4c3294efb"/>
               </a:rPr>
               <a:t>Official docs</a:t>
             </a:r>
@@ -16998,7 +17308,7 @@
                 <a:latin typeface="Consolas"/>
                 <a:ea typeface="Consolas"/>
                 <a:cs typeface="Consolas"/>
-                <a:hlinkClick xmlns:r="http://schemas.openxmlformats.org/officeDocument/2006/relationships" r:id="R524e515f6ea34930"/>
+                <a:hlinkClick xmlns:r="http://schemas.openxmlformats.org/officeDocument/2006/relationships" r:id="Rcbe625bddb4b43ab"/>
               </a:rPr>
               <a:t>Apigee A0–A6</a:t>
             </a:r>
@@ -19559,7 +19869,7 @@
                 <a:latin typeface="Arial"/>
                 <a:ea typeface="Arial"/>
                 <a:cs typeface="Arial"/>
-                <a:hlinkClick xmlns:r="http://schemas.openxmlformats.org/officeDocument/2006/relationships" r:id="R2eb00c20980b4eb8"/>
+                <a:hlinkClick xmlns:r="http://schemas.openxmlformats.org/officeDocument/2006/relationships" r:id="R62a4047e0cac4615"/>
               </a:rPr>
               <a:t>MULE COUNTERPART · M0–M5</a:t>
             </a:r>
@@ -19738,7 +20048,7 @@
                 <a:latin typeface="Arial"/>
                 <a:ea typeface="Arial"/>
                 <a:cs typeface="Arial"/>
-                <a:hlinkClick xmlns:r="http://schemas.openxmlformats.org/officeDocument/2006/relationships" r:id="R5971096796954770"/>
+                <a:hlinkClick xmlns:r="http://schemas.openxmlformats.org/officeDocument/2006/relationships" r:id="R6360f749119845ed"/>
               </a:rPr>
               <a:t>Terminology crosswalk</a:t>
             </a:r>
@@ -20099,7 +20409,7 @@
                 <a:solidFill>
                   <a:srgbClr val="666762"/>
                 </a:solidFill>
-                <a:hlinkClick xmlns:r="http://schemas.openxmlformats.org/officeDocument/2006/relationships" r:id="Re7d5c667f4ea4583"/>
+                <a:hlinkClick xmlns:r="http://schemas.openxmlformats.org/officeDocument/2006/relationships" r:id="R186fc017997e493f"/>
               </a:rPr>
               <a:t>Repo reference</a:t>
             </a:r>
@@ -20116,7 +20426,7 @@
                 <a:solidFill>
                   <a:srgbClr val="666762"/>
                 </a:solidFill>
-                <a:hlinkClick xmlns:r="http://schemas.openxmlformats.org/officeDocument/2006/relationships" r:id="Rf0bf18d712894daf"/>
+                <a:hlinkClick xmlns:r="http://schemas.openxmlformats.org/officeDocument/2006/relationships" r:id="R9bc5b62e68ea48a3"/>
               </a:rPr>
               <a:t>Official docs</a:t>
             </a:r>
@@ -21398,7 +21708,7 @@
                 <a:solidFill>
                   <a:srgbClr val="666762"/>
                 </a:solidFill>
-                <a:hlinkClick xmlns:r="http://schemas.openxmlformats.org/officeDocument/2006/relationships" r:id="R93290581b3384990"/>
+                <a:hlinkClick xmlns:r="http://schemas.openxmlformats.org/officeDocument/2006/relationships" r:id="Rfab9575e17fb4f91"/>
               </a:rPr>
               <a:t>Repo reference</a:t>
             </a:r>
@@ -21415,7 +21725,7 @@
                 <a:solidFill>
                   <a:srgbClr val="666762"/>
                 </a:solidFill>
-                <a:hlinkClick xmlns:r="http://schemas.openxmlformats.org/officeDocument/2006/relationships" r:id="R00b06a147ce444ce"/>
+                <a:hlinkClick xmlns:r="http://schemas.openxmlformats.org/officeDocument/2006/relationships" r:id="R2198dc9f60154ae5"/>
               </a:rPr>
               <a:t>Official docs</a:t>
             </a:r>
@@ -23350,7 +23660,7 @@
                 <a:solidFill>
                   <a:srgbClr val="666762"/>
                 </a:solidFill>
-                <a:hlinkClick xmlns:r="http://schemas.openxmlformats.org/officeDocument/2006/relationships" r:id="R40fb33b9ac954795"/>
+                <a:hlinkClick xmlns:r="http://schemas.openxmlformats.org/officeDocument/2006/relationships" r:id="Re241d8192b8044fe"/>
               </a:rPr>
               <a:t>Repo reference</a:t>
             </a:r>
@@ -23367,7 +23677,7 @@
                 <a:solidFill>
                   <a:srgbClr val="666762"/>
                 </a:solidFill>
-                <a:hlinkClick xmlns:r="http://schemas.openxmlformats.org/officeDocument/2006/relationships" r:id="R4476ac92f55542dd"/>
+                <a:hlinkClick xmlns:r="http://schemas.openxmlformats.org/officeDocument/2006/relationships" r:id="Rfc214d2ff4914fd8"/>
               </a:rPr>
               <a:t>Official docs</a:t>
             </a:r>
@@ -25572,7 +25882,7 @@
                 <a:ea typeface="Arial"/>
                 <a:cs typeface="Arial"/>
               </a:rPr>
-              <a:t>The operating model—not the feature list—drives the decision</a:t>
+              <a:t>The operating model and four early gates drive the decision</a:t>
             </a:r>
           </a:p>
         </p:txBody>
@@ -25631,7 +25941,7 @@
                 <a:ea typeface="Arial"/>
                 <a:cs typeface="Arial"/>
               </a:rPr>
-              <a:t>Treat these as stated target inputs to confirm, not yet as observed current-state facts.</a:t>
+              <a:t>Confirm target inputs, then disposition multicloud, exit, TCO and the Traceable adjunct.</a:t>
             </a:r>
           </a:p>
         </p:txBody>
@@ -25722,7 +26032,7 @@
                 <a:solidFill>
                   <a:srgbClr val="666762"/>
                 </a:solidFill>
-                <a:hlinkClick xmlns:r="http://schemas.openxmlformats.org/officeDocument/2006/relationships" r:id="R50c2722509184a1c"/>
+                <a:hlinkClick xmlns:r="http://schemas.openxmlformats.org/officeDocument/2006/relationships" r:id="R8593854d8757457c"/>
               </a:rPr>
               <a:t>Repo reference</a:t>
             </a:r>
@@ -25739,7 +26049,7 @@
                 <a:solidFill>
                   <a:srgbClr val="666762"/>
                 </a:solidFill>
-                <a:hlinkClick xmlns:r="http://schemas.openxmlformats.org/officeDocument/2006/relationships" r:id="R6a105b206a1b4d4d"/>
+                <a:hlinkClick xmlns:r="http://schemas.openxmlformats.org/officeDocument/2006/relationships" r:id="Rf0ca63fd1ca34c9d"/>
               </a:rPr>
               <a:t>Official docs</a:t>
             </a:r>
@@ -26728,7 +27038,7 @@
                 <a:ea typeface="Georgia"/>
                 <a:cs typeface="Georgia"/>
               </a:rPr>
-              <a:t>Security + observability</a:t>
+              <a:t>Security + Traceable adjunct</a:t>
             </a:r>
           </a:p>
         </p:txBody>
@@ -27006,7 +27316,7 @@
                 <a:ea typeface="Arial"/>
                 <a:cs typeface="Arial"/>
               </a:rPr>
-              <a:t>Decision lens: which operating boundary best enables this model with acceptable permanent duty?</a:t>
+              <a:t>EARLY GATES: MULTICLOUD · CLEAN EXIT · FULL TCO · TRACEABLE / HARNESS</a:t>
             </a:r>
           </a:p>
         </p:txBody>
@@ -27365,7 +27675,7 @@
                 <a:solidFill>
                   <a:srgbClr val="666762"/>
                 </a:solidFill>
-                <a:hlinkClick xmlns:r="http://schemas.openxmlformats.org/officeDocument/2006/relationships" r:id="R5f3c5b0cabde4412"/>
+                <a:hlinkClick xmlns:r="http://schemas.openxmlformats.org/officeDocument/2006/relationships" r:id="Rcbdd7db680d94238"/>
               </a:rPr>
               <a:t>Repo reference</a:t>
             </a:r>
@@ -27382,7 +27692,7 @@
                 <a:solidFill>
                   <a:srgbClr val="666762"/>
                 </a:solidFill>
-                <a:hlinkClick xmlns:r="http://schemas.openxmlformats.org/officeDocument/2006/relationships" r:id="R7557731dbf7946a6"/>
+                <a:hlinkClick xmlns:r="http://schemas.openxmlformats.org/officeDocument/2006/relationships" r:id="R0bb57ba060a44f4d"/>
               </a:rPr>
               <a:t>Official docs</a:t>
             </a:r>
@@ -29307,7 +29617,7 @@
                 <a:solidFill>
                   <a:srgbClr val="666762"/>
                 </a:solidFill>
-                <a:hlinkClick xmlns:r="http://schemas.openxmlformats.org/officeDocument/2006/relationships" r:id="R6ccea5cb38f549fe"/>
+                <a:hlinkClick xmlns:r="http://schemas.openxmlformats.org/officeDocument/2006/relationships" r:id="R5bc171cb920e458c"/>
               </a:rPr>
               <a:t>Repo reference</a:t>
             </a:r>
@@ -29324,7 +29634,7 @@
                 <a:solidFill>
                   <a:srgbClr val="666762"/>
                 </a:solidFill>
-                <a:hlinkClick xmlns:r="http://schemas.openxmlformats.org/officeDocument/2006/relationships" r:id="R73e19e9f344f492d"/>
+                <a:hlinkClick xmlns:r="http://schemas.openxmlformats.org/officeDocument/2006/relationships" r:id="R2c67acfe63584f32"/>
               </a:rPr>
               <a:t>Official docs</a:t>
             </a:r>
@@ -29746,7 +30056,7 @@
       </p:sp>
       <p:cxnSp>
         <p:nvCxnSpPr>
-          <p:cNvPr id="394" name=""/>
+          <p:cNvPr id="421" name=""/>
           <p:cNvCxnSpPr>
             <a:stCxn xmlns:a="http://schemas.openxmlformats.org/drawingml/2006/main" id="9" idx="1"/>
             <a:endCxn xmlns:a="http://schemas.openxmlformats.org/drawingml/2006/main" id="12" idx="3"/>
@@ -29951,7 +30261,7 @@
       </p:sp>
       <p:cxnSp>
         <p:nvCxnSpPr>
-          <p:cNvPr id="398" name=""/>
+          <p:cNvPr id="425" name=""/>
           <p:cNvCxnSpPr>
             <a:stCxn xmlns:a="http://schemas.openxmlformats.org/drawingml/2006/main" id="9" idx="1"/>
             <a:endCxn xmlns:a="http://schemas.openxmlformats.org/drawingml/2006/main" id="16" idx="3"/>
@@ -30156,7 +30466,7 @@
       </p:sp>
       <p:cxnSp>
         <p:nvCxnSpPr>
-          <p:cNvPr id="402" name=""/>
+          <p:cNvPr id="429" name=""/>
           <p:cNvCxnSpPr>
             <a:stCxn xmlns:a="http://schemas.openxmlformats.org/drawingml/2006/main" id="9" idx="3"/>
             <a:endCxn xmlns:a="http://schemas.openxmlformats.org/drawingml/2006/main" id="20" idx="1"/>
@@ -30361,7 +30671,7 @@
       </p:sp>
       <p:cxnSp>
         <p:nvCxnSpPr>
-          <p:cNvPr id="406" name=""/>
+          <p:cNvPr id="433" name=""/>
           <p:cNvCxnSpPr>
             <a:stCxn xmlns:a="http://schemas.openxmlformats.org/drawingml/2006/main" id="9" idx="3"/>
             <a:endCxn xmlns:a="http://schemas.openxmlformats.org/drawingml/2006/main" id="24" idx="1"/>
@@ -30800,7 +31110,7 @@
                 <a:solidFill>
                   <a:srgbClr val="666762"/>
                 </a:solidFill>
-                <a:hlinkClick xmlns:r="http://schemas.openxmlformats.org/officeDocument/2006/relationships" r:id="R5e845ab4861c4574"/>
+                <a:hlinkClick xmlns:r="http://schemas.openxmlformats.org/officeDocument/2006/relationships" r:id="Rf8d994bc1b4c4233"/>
               </a:rPr>
               <a:t>Repo reference</a:t>
             </a:r>
@@ -30817,7 +31127,7 @@
                 <a:solidFill>
                   <a:srgbClr val="666762"/>
                 </a:solidFill>
-                <a:hlinkClick xmlns:r="http://schemas.openxmlformats.org/officeDocument/2006/relationships" r:id="R4df67573af3c4f6d"/>
+                <a:hlinkClick xmlns:r="http://schemas.openxmlformats.org/officeDocument/2006/relationships" r:id="R7f5f21f474d144b2"/>
               </a:rPr>
               <a:t>Official docs</a:t>
             </a:r>
@@ -31696,7 +32006,7 @@
                 <a:solidFill>
                   <a:srgbClr val="666762"/>
                 </a:solidFill>
-                <a:hlinkClick xmlns:r="http://schemas.openxmlformats.org/officeDocument/2006/relationships" r:id="R8dec884f30624955"/>
+                <a:hlinkClick xmlns:r="http://schemas.openxmlformats.org/officeDocument/2006/relationships" r:id="R71afb8b781cd41ac"/>
               </a:rPr>
               <a:t>Repo reference</a:t>
             </a:r>
@@ -31713,7 +32023,7 @@
                 <a:solidFill>
                   <a:srgbClr val="666762"/>
                 </a:solidFill>
-                <a:hlinkClick xmlns:r="http://schemas.openxmlformats.org/officeDocument/2006/relationships" r:id="R336cdc99b169402b"/>
+                <a:hlinkClick xmlns:r="http://schemas.openxmlformats.org/officeDocument/2006/relationships" r:id="R4cc48dfdfff6424b"/>
               </a:rPr>
               <a:t>Official docs</a:t>
             </a:r>
@@ -32592,7 +32902,7 @@
                 <a:solidFill>
                   <a:srgbClr val="666762"/>
                 </a:solidFill>
-                <a:hlinkClick xmlns:r="http://schemas.openxmlformats.org/officeDocument/2006/relationships" r:id="R21ebff295ce7429d"/>
+                <a:hlinkClick xmlns:r="http://schemas.openxmlformats.org/officeDocument/2006/relationships" r:id="R96fbd7b916884c3f"/>
               </a:rPr>
               <a:t>Repo reference</a:t>
             </a:r>
@@ -32609,7 +32919,7 @@
                 <a:solidFill>
                   <a:srgbClr val="666762"/>
                 </a:solidFill>
-                <a:hlinkClick xmlns:r="http://schemas.openxmlformats.org/officeDocument/2006/relationships" r:id="Reb083c12c36545ec"/>
+                <a:hlinkClick xmlns:r="http://schemas.openxmlformats.org/officeDocument/2006/relationships" r:id="R37b3062bb24e4515"/>
               </a:rPr>
               <a:t>Official docs</a:t>
             </a:r>
@@ -33417,7 +33727,7 @@
                 <a:solidFill>
                   <a:srgbClr val="666762"/>
                 </a:solidFill>
-                <a:hlinkClick xmlns:r="http://schemas.openxmlformats.org/officeDocument/2006/relationships" r:id="Rdd27e409df1b4c7d"/>
+                <a:hlinkClick xmlns:r="http://schemas.openxmlformats.org/officeDocument/2006/relationships" r:id="R9401e9b2253d4100"/>
               </a:rPr>
               <a:t>Repo reference</a:t>
             </a:r>
@@ -33434,7 +33744,7 @@
                 <a:solidFill>
                   <a:srgbClr val="666762"/>
                 </a:solidFill>
-                <a:hlinkClick xmlns:r="http://schemas.openxmlformats.org/officeDocument/2006/relationships" r:id="R6b76b5d950df4de2"/>
+                <a:hlinkClick xmlns:r="http://schemas.openxmlformats.org/officeDocument/2006/relationships" r:id="Rac401c109bb64823"/>
               </a:rPr>
               <a:t>Official docs</a:t>
             </a:r>
@@ -36618,7 +36928,7 @@
                 <a:ea typeface="Arial"/>
                 <a:cs typeface="Arial"/>
               </a:rPr>
-              <a:t>Historical weights stay visible; the provisional model rebases them to 60% and adds a 40% unknown block.</a:t>
+              <a:t>Historical weights stay visible; six added dimensions remain unknown, and Traceable stays an unscored gate.</a:t>
             </a:r>
           </a:p>
         </p:txBody>
@@ -36709,7 +37019,7 @@
                 <a:solidFill>
                   <a:srgbClr val="666762"/>
                 </a:solidFill>
-                <a:hlinkClick xmlns:r="http://schemas.openxmlformats.org/officeDocument/2006/relationships" r:id="R9dd0ae648db447dc"/>
+                <a:hlinkClick xmlns:r="http://schemas.openxmlformats.org/officeDocument/2006/relationships" r:id="R65266310be0e4a1b"/>
               </a:rPr>
               <a:t>Repo reference</a:t>
             </a:r>
@@ -36726,7 +37036,7 @@
                 <a:solidFill>
                   <a:srgbClr val="666762"/>
                 </a:solidFill>
-                <a:hlinkClick xmlns:r="http://schemas.openxmlformats.org/officeDocument/2006/relationships" r:id="R71b476e2b678452b"/>
+                <a:hlinkClick xmlns:r="http://schemas.openxmlformats.org/officeDocument/2006/relationships" r:id="Rd3f039e529c74117"/>
               </a:rPr>
               <a:t>Official docs</a:t>
             </a:r>
@@ -38700,7 +39010,7 @@
         </p:spPr>
         <p:txBody>
           <a:bodyPr xmlns:a="http://schemas.openxmlformats.org/drawingml/2006/main" wrap="square" lIns="0" tIns="0" rIns="0" bIns="0" anchor="t">
-            <a:normAutofit fontScale="91945"/>
+            <a:normAutofit fontScale="86193"/>
           </a:bodyPr>
           <a:lstStyle xmlns:a="http://schemas.openxmlformats.org/drawingml/2006/main"/>
           <a:p xmlns:a="http://schemas.openxmlformats.org/drawingml/2006/main">
@@ -38724,7 +39034,7 @@
                 <a:ea typeface="Georgia"/>
                 <a:cs typeface="Georgia"/>
               </a:rPr>
-              <a:t>Weights are assumptions; every GRS product rating remains Unknown [0,10].</a:t>
+              <a:t>Traceable / Harness is an unscored gate; every GRS rating remains Unknown [0,10].</a:t>
             </a:r>
           </a:p>
         </p:txBody>
@@ -39083,7 +39393,7 @@
                 <a:solidFill>
                   <a:srgbClr val="666762"/>
                 </a:solidFill>
-                <a:hlinkClick xmlns:r="http://schemas.openxmlformats.org/officeDocument/2006/relationships" r:id="Ra6a74b7c294940ca"/>
+                <a:hlinkClick xmlns:r="http://schemas.openxmlformats.org/officeDocument/2006/relationships" r:id="R6f29cd6d8e304a68"/>
               </a:rPr>
               <a:t>Repo reference</a:t>
             </a:r>
@@ -39100,7 +39410,7 @@
                 <a:solidFill>
                   <a:srgbClr val="666762"/>
                 </a:solidFill>
-                <a:hlinkClick xmlns:r="http://schemas.openxmlformats.org/officeDocument/2006/relationships" r:id="R1fea18c30d134d6c"/>
+                <a:hlinkClick xmlns:r="http://schemas.openxmlformats.org/officeDocument/2006/relationships" r:id="R6e9b573d621c4970"/>
               </a:rPr>
               <a:t>Official docs</a:t>
             </a:r>
@@ -40956,7 +41266,7 @@
                 <a:solidFill>
                   <a:srgbClr val="666762"/>
                 </a:solidFill>
-                <a:hlinkClick xmlns:r="http://schemas.openxmlformats.org/officeDocument/2006/relationships" r:id="R8c36ad9c07e14534"/>
+                <a:hlinkClick xmlns:r="http://schemas.openxmlformats.org/officeDocument/2006/relationships" r:id="R84f767f677b740a6"/>
               </a:rPr>
               <a:t>Repo reference</a:t>
             </a:r>
@@ -40973,7 +41283,7 @@
                 <a:solidFill>
                   <a:srgbClr val="666762"/>
                 </a:solidFill>
-                <a:hlinkClick xmlns:r="http://schemas.openxmlformats.org/officeDocument/2006/relationships" r:id="Rf7a64300c105432a"/>
+                <a:hlinkClick xmlns:r="http://schemas.openxmlformats.org/officeDocument/2006/relationships" r:id="Rd48c27f0363d4960"/>
               </a:rPr>
               <a:t>Official docs</a:t>
             </a:r>
@@ -42007,6 +42317,7 @@
           <a:lstStyle xmlns:a="http://schemas.openxmlformats.org/drawingml/2006/main"/>
           <a:p xmlns:a="http://schemas.openxmlformats.org/drawingml/2006/main">
             <a:pPr algn="ctr">
+              <a:buNone/>
               <a:defRPr sz="1350">
                 <a:solidFill>
                   <a:srgbClr val="93948F"/>
@@ -42067,6 +42378,7 @@
           <a:lstStyle xmlns:a="http://schemas.openxmlformats.org/drawingml/2006/main"/>
           <a:p xmlns:a="http://schemas.openxmlformats.org/drawingml/2006/main">
             <a:pPr algn="r">
+              <a:buNone/>
               <a:defRPr sz="1800">
                 <a:solidFill>
                   <a:srgbClr val="5537D6"/>
@@ -42127,6 +42439,7 @@
           <a:lstStyle xmlns:a="http://schemas.openxmlformats.org/drawingml/2006/main"/>
           <a:p xmlns:a="http://schemas.openxmlformats.org/drawingml/2006/main">
             <a:pPr algn="ctr">
+              <a:buNone/>
               <a:defRPr sz="1350">
                 <a:solidFill>
                   <a:srgbClr val="93948F"/>
@@ -42187,6 +42500,7 @@
           <a:lstStyle xmlns:a="http://schemas.openxmlformats.org/drawingml/2006/main"/>
           <a:p xmlns:a="http://schemas.openxmlformats.org/drawingml/2006/main">
             <a:pPr algn="r">
+              <a:buNone/>
               <a:defRPr sz="1800">
                 <a:solidFill>
                   <a:srgbClr val="5537D6"/>
@@ -42247,6 +42561,7 @@
           <a:lstStyle xmlns:a="http://schemas.openxmlformats.org/drawingml/2006/main"/>
           <a:p xmlns:a="http://schemas.openxmlformats.org/drawingml/2006/main">
             <a:pPr algn="ctr">
+              <a:buNone/>
               <a:defRPr sz="1350">
                 <a:solidFill>
                   <a:srgbClr val="93948F"/>
@@ -42307,6 +42622,7 @@
           <a:lstStyle xmlns:a="http://schemas.openxmlformats.org/drawingml/2006/main"/>
           <a:p xmlns:a="http://schemas.openxmlformats.org/drawingml/2006/main">
             <a:pPr algn="r">
+              <a:buNone/>
               <a:defRPr sz="1800">
                 <a:solidFill>
                   <a:srgbClr val="5537D6"/>
@@ -42684,7 +43000,7 @@
                 <a:solidFill>
                   <a:srgbClr val="666762"/>
                 </a:solidFill>
-                <a:hlinkClick xmlns:r="http://schemas.openxmlformats.org/officeDocument/2006/relationships" r:id="R08aba886a99c4ae0"/>
+                <a:hlinkClick xmlns:r="http://schemas.openxmlformats.org/officeDocument/2006/relationships" r:id="R9b7fe541cc314c74"/>
               </a:rPr>
               <a:t>Repo reference</a:t>
             </a:r>
@@ -42701,7 +43017,7 @@
                 <a:solidFill>
                   <a:srgbClr val="666762"/>
                 </a:solidFill>
-                <a:hlinkClick xmlns:r="http://schemas.openxmlformats.org/officeDocument/2006/relationships" r:id="R9675c118e1234325"/>
+                <a:hlinkClick xmlns:r="http://schemas.openxmlformats.org/officeDocument/2006/relationships" r:id="R0e682bc240d04521"/>
               </a:rPr>
               <a:t>Official docs</a:t>
             </a:r>
@@ -43806,7 +44122,7 @@
                 <a:solidFill>
                   <a:srgbClr val="666762"/>
                 </a:solidFill>
-                <a:hlinkClick xmlns:r="http://schemas.openxmlformats.org/officeDocument/2006/relationships" r:id="Rff77b14c39de4286"/>
+                <a:hlinkClick xmlns:r="http://schemas.openxmlformats.org/officeDocument/2006/relationships" r:id="R61cb1937c51a4f0b"/>
               </a:rPr>
               <a:t>Repo reference</a:t>
             </a:r>
@@ -43823,7 +44139,7 @@
                 <a:solidFill>
                   <a:srgbClr val="666762"/>
                 </a:solidFill>
-                <a:hlinkClick xmlns:r="http://schemas.openxmlformats.org/officeDocument/2006/relationships" r:id="R6999cac732e947dd"/>
+                <a:hlinkClick xmlns:r="http://schemas.openxmlformats.org/officeDocument/2006/relationships" r:id="R160ab15bd438459b"/>
               </a:rPr>
               <a:t>Official docs</a:t>
             </a:r>
@@ -45058,7 +45374,7 @@
                 <a:solidFill>
                   <a:srgbClr val="666762"/>
                 </a:solidFill>
-                <a:hlinkClick xmlns:r="http://schemas.openxmlformats.org/officeDocument/2006/relationships" r:id="Ra6bb97bd5b5a4e05"/>
+                <a:hlinkClick xmlns:r="http://schemas.openxmlformats.org/officeDocument/2006/relationships" r:id="R9884dffe971c4f65"/>
               </a:rPr>
               <a:t>Repo reference</a:t>
             </a:r>
@@ -45075,7 +45391,7 @@
                 <a:solidFill>
                   <a:srgbClr val="666762"/>
                 </a:solidFill>
-                <a:hlinkClick xmlns:r="http://schemas.openxmlformats.org/officeDocument/2006/relationships" r:id="R76cda340086e43c2"/>
+                <a:hlinkClick xmlns:r="http://schemas.openxmlformats.org/officeDocument/2006/relationships" r:id="R1ebbc4ef7079476a"/>
               </a:rPr>
               <a:t>Official docs</a:t>
             </a:r>
@@ -46423,7 +46739,7 @@
                 <a:solidFill>
                   <a:srgbClr val="666762"/>
                 </a:solidFill>
-                <a:hlinkClick xmlns:r="http://schemas.openxmlformats.org/officeDocument/2006/relationships" r:id="Rcf1ac1910d4d4bda"/>
+                <a:hlinkClick xmlns:r="http://schemas.openxmlformats.org/officeDocument/2006/relationships" r:id="R0dce02e35aa84728"/>
               </a:rPr>
               <a:t>Repo reference</a:t>
             </a:r>
@@ -46440,7 +46756,7 @@
                 <a:solidFill>
                   <a:srgbClr val="666762"/>
                 </a:solidFill>
-                <a:hlinkClick xmlns:r="http://schemas.openxmlformats.org/officeDocument/2006/relationships" r:id="Rf10bd3b7a4de426f"/>
+                <a:hlinkClick xmlns:r="http://schemas.openxmlformats.org/officeDocument/2006/relationships" r:id="R51357be61ea84d99"/>
               </a:rPr>
               <a:t>Official docs</a:t>
             </a:r>
@@ -46967,7 +47283,7 @@
       </p:sp>
       <p:cxnSp>
         <p:nvCxnSpPr>
-          <p:cNvPr id="660" name=""/>
+          <p:cNvPr id="705" name=""/>
           <p:cNvCxnSpPr>
             <a:stCxn xmlns:a="http://schemas.openxmlformats.org/drawingml/2006/main" id="16" idx="1"/>
             <a:endCxn xmlns:a="http://schemas.openxmlformats.org/drawingml/2006/main" id="10" idx="1"/>
@@ -46993,7 +47309,7 @@
       </p:cxnSp>
       <p:cxnSp>
         <p:nvCxnSpPr>
-          <p:cNvPr id="661" name=""/>
+          <p:cNvPr id="706" name=""/>
           <p:cNvCxnSpPr>
             <a:stCxn xmlns:a="http://schemas.openxmlformats.org/drawingml/2006/main" id="10" idx="2"/>
             <a:endCxn xmlns:a="http://schemas.openxmlformats.org/drawingml/2006/main" id="13" idx="0"/>
@@ -47537,7 +47853,7 @@
       </p:sp>
       <p:cxnSp>
         <p:nvCxnSpPr>
-          <p:cNvPr id="672" name=""/>
+          <p:cNvPr id="717" name=""/>
           <p:cNvCxnSpPr>
             <a:stCxn xmlns:a="http://schemas.openxmlformats.org/drawingml/2006/main" id="10" idx="3"/>
             <a:endCxn xmlns:a="http://schemas.openxmlformats.org/drawingml/2006/main" id="21" idx="1"/>
@@ -47565,7 +47881,7 @@
       </p:cxnSp>
       <p:cxnSp>
         <p:nvCxnSpPr>
-          <p:cNvPr id="673" name=""/>
+          <p:cNvPr id="718" name=""/>
           <p:cNvCxnSpPr>
             <a:stCxn xmlns:a="http://schemas.openxmlformats.org/drawingml/2006/main" id="10" idx="3"/>
             <a:endCxn xmlns:a="http://schemas.openxmlformats.org/drawingml/2006/main" id="24" idx="1"/>
@@ -47593,7 +47909,7 @@
       </p:cxnSp>
       <p:cxnSp>
         <p:nvCxnSpPr>
-          <p:cNvPr id="674" name=""/>
+          <p:cNvPr id="719" name=""/>
           <p:cNvCxnSpPr>
             <a:stCxn xmlns:a="http://schemas.openxmlformats.org/drawingml/2006/main" id="10" idx="3"/>
             <a:endCxn xmlns:a="http://schemas.openxmlformats.org/drawingml/2006/main" id="27" idx="1"/>
@@ -48139,7 +48455,7 @@
       </p:sp>
       <p:cxnSp>
         <p:nvCxnSpPr>
-          <p:cNvPr id="685" name=""/>
+          <p:cNvPr id="730" name=""/>
           <p:cNvCxnSpPr>
             <a:stCxn xmlns:a="http://schemas.openxmlformats.org/drawingml/2006/main" id="21" idx="3"/>
             <a:endCxn xmlns:a="http://schemas.openxmlformats.org/drawingml/2006/main" id="34" idx="1"/>
@@ -48165,7 +48481,7 @@
       </p:cxnSp>
       <p:cxnSp>
         <p:nvCxnSpPr>
-          <p:cNvPr id="686" name=""/>
+          <p:cNvPr id="731" name=""/>
           <p:cNvCxnSpPr>
             <a:stCxn xmlns:a="http://schemas.openxmlformats.org/drawingml/2006/main" id="24" idx="3"/>
             <a:endCxn xmlns:a="http://schemas.openxmlformats.org/drawingml/2006/main" id="37" idx="1"/>
@@ -48191,7 +48507,7 @@
       </p:cxnSp>
       <p:cxnSp>
         <p:nvCxnSpPr>
-          <p:cNvPr id="687" name=""/>
+          <p:cNvPr id="732" name=""/>
           <p:cNvCxnSpPr>
             <a:stCxn xmlns:a="http://schemas.openxmlformats.org/drawingml/2006/main" id="27" idx="3"/>
             <a:endCxn xmlns:a="http://schemas.openxmlformats.org/drawingml/2006/main" id="40" idx="1"/>

</xml_diff>

<commit_message>
Correct guided Kong deck boundaries, duties, outcomes and companion
Project the canonical operating boundaries (KP-SMH1/KMC-3, Konnect
custody benchmark KMC-1, non-Kong exit KPS-P9) and the custody-fit
permanent duties from docs/48 instead of the KMC-2 pair and a
mislabelled counterfactual; render outcome cards with canonical docs/47
names; carry figure-contract text into diagram takeaways; add a scroll
cue for overflowing frames; localize portal links in rendered guides;
align the PowerPoint companion (date, GTM-07 label, KO names and notes,
typefaces) and pin its new hash. Review findings F1-F11 of 2026-08-22.

Co-Authored-By: Claude Fable 5 <noreply@anthropic.com>
</commit_message>
<xml_diff>
--- a/presentations/kong-platform-journey-guided.pptx
+++ b/presentations/kong-platform-journey-guided.pptx
@@ -2291,7 +2291,7 @@
           </a:p>
           <a:p>
             <a:r>
-              <a:t>Each mechanism is paired with a measurable outcome and a reviewable artifact. State fidelity, request reliability, trust admission, recovery and safe change are all separate admission dimensions.</a:t>
+              <a:t>Each mechanism is paired with a measurable outcome and a reviewable artifact. Trustworthy active state, business reliability, trust integrity, management recoverability and safe change are all separate admission dimensions.</a:t>
             </a:r>
           </a:p>
           <a:p>
@@ -2635,7 +2635,7 @@
           </a:p>
           <a:p>
             <a:r>
-              <a:t>Capacity and evidence safety matter, but so do adoption, operating sustainability, exit readiness and accurate estate ownership. KO-7 is an outcome: administrative/configuration audit, request and security-decision correlation, business evidence, quantified produced/queued/dropped/delivered gaps, and prohibited-field control. Traceable may be one candidate mechanism, but no product name can make KO-7 pass.</a:t>
+              <a:t>Capacity isolation and evidence safety matter, but so do platform adoption, operating sustainability, reversibility and estate truth. KO-7 is an outcome: administrative/configuration audit, request and security-decision correlation, business evidence, quantified produced/queued/dropped/delivered gaps, and prohibited-field control. Traceable may be one candidate mechanism, but no product name can make KO-7 pass.</a:t>
             </a:r>
           </a:p>
           <a:p>
@@ -8851,7 +8851,7 @@
                 <a:ea typeface="Consolas"/>
                 <a:cs typeface="Consolas"/>
               </a:rPr>
-              <a:t>20 AUG 2026  •  WORKING DECISION BRIEF</a:t>
+              <a:t>22 AUG 2026  •  WORKING DECISION BRIEF</a:t>
             </a:r>
           </a:p>
         </p:txBody>
@@ -23870,9 +23870,9 @@
                 <a:solidFill>
                   <a:srgbClr val="5537D6"/>
                 </a:solidFill>
-                <a:latin typeface="Georgia"/>
-                <a:ea typeface="Georgia"/>
-                <a:cs typeface="Georgia"/>
+                <a:latin typeface="Consolas"/>
+                <a:ea typeface="Consolas"/>
+                <a:cs typeface="Consolas"/>
               </a:defRPr>
             </a:pPr>
             <a:r>
@@ -23880,9 +23880,9 @@
                 <a:solidFill>
                   <a:srgbClr val="5537D6"/>
                 </a:solidFill>
-                <a:latin typeface="Georgia"/>
-                <a:ea typeface="Georgia"/>
-                <a:cs typeface="Georgia"/>
+                <a:latin typeface="Consolas"/>
+                <a:ea typeface="Consolas"/>
+                <a:cs typeface="Consolas"/>
               </a:rPr>
               <a:t>0</a:t>
             </a:r>
@@ -27355,7 +27355,7 @@
                 <a:ea typeface="Georgia"/>
                 <a:cs typeface="Georgia"/>
               </a:rPr>
-              <a:t>State fidelity</a:t>
+              <a:t>Trustworthy active state</a:t>
             </a:r>
           </a:p>
         </p:txBody>
@@ -27749,7 +27749,7 @@
                 <a:ea typeface="Georgia"/>
                 <a:cs typeface="Georgia"/>
               </a:rPr>
-              <a:t>Request reliability</a:t>
+              <a:t>Business reliability</a:t>
             </a:r>
           </a:p>
         </p:txBody>
@@ -28143,7 +28143,7 @@
                 <a:ea typeface="Georgia"/>
                 <a:cs typeface="Georgia"/>
               </a:rPr>
-              <a:t>Trust admission</a:t>
+              <a:t>Trust integrity</a:t>
             </a:r>
           </a:p>
         </p:txBody>
@@ -28537,7 +28537,7 @@
                 <a:ea typeface="Georgia"/>
                 <a:cs typeface="Georgia"/>
               </a:rPr>
-              <a:t>Recovery</a:t>
+              <a:t>Management recoverability</a:t>
             </a:r>
           </a:p>
         </p:txBody>
@@ -30624,7 +30624,7 @@
                 <a:ea typeface="Georgia"/>
                 <a:cs typeface="Georgia"/>
               </a:rPr>
-              <a:t>Security + Traceable adjunct</a:t>
+              <a:t>Security + observability</a:t>
             </a:r>
           </a:p>
         </p:txBody>
@@ -31540,7 +31540,7 @@
                 <a:ea typeface="Georgia"/>
                 <a:cs typeface="Georgia"/>
               </a:rPr>
-              <a:t>Capacity</a:t>
+              <a:t>Capacity isolation</a:t>
             </a:r>
           </a:p>
         </p:txBody>
@@ -31787,7 +31787,7 @@
               </a:defRPr>
             </a:pPr>
             <a:r>
-              <a:rPr sz="2025" b="0" i="0">
+              <a:rPr sz="1400" b="0" i="0">
                 <a:solidFill>
                   <a:srgbClr val="111111"/>
                 </a:solidFill>
@@ -31795,7 +31795,7 @@
                 <a:ea typeface="Georgia"/>
                 <a:cs typeface="Georgia"/>
               </a:rPr>
-              <a:t>Security traceability</a:t>
+              <a:t>Security traceability and evidence safety</a:t>
             </a:r>
           </a:p>
         </p:txBody>
@@ -32050,7 +32050,7 @@
                 <a:ea typeface="Georgia"/>
                 <a:cs typeface="Georgia"/>
               </a:rPr>
-              <a:t>Adoption</a:t>
+              <a:t>Platform adoption</a:t>
             </a:r>
           </a:p>
         </p:txBody>
@@ -32297,7 +32297,7 @@
               </a:defRPr>
             </a:pPr>
             <a:r>
-              <a:rPr sz="2025" b="0" i="0">
+              <a:rPr sz="1650" b="0" i="0">
                 <a:solidFill>
                   <a:srgbClr val="111111"/>
                 </a:solidFill>
@@ -32305,7 +32305,7 @@
                 <a:ea typeface="Georgia"/>
                 <a:cs typeface="Georgia"/>
               </a:rPr>
-              <a:t>Sustainability</a:t>
+              <a:t>Operating sustainability</a:t>
             </a:r>
           </a:p>
         </p:txBody>
@@ -32560,7 +32560,7 @@
                 <a:ea typeface="Georgia"/>
                 <a:cs typeface="Georgia"/>
               </a:rPr>
-              <a:t>Exit readiness</a:t>
+              <a:t>Reversibility</a:t>
             </a:r>
           </a:p>
         </p:txBody>
@@ -35043,6 +35043,11 @@
                     <a:lstStyle/>
                     <a:p>
                       <a:r>
+                        <a:rPr>
+                          <a:latin typeface="Arial"/>
+                          <a:ea typeface="Arial"/>
+                          <a:cs typeface="Arial"/>
+                        </a:rPr>
                         <a:t>Dimension</a:t>
                       </a:r>
                     </a:p>
@@ -35055,6 +35060,11 @@
                     <a:lstStyle/>
                     <a:p>
                       <a:r>
+                        <a:rPr>
+                          <a:latin typeface="Arial"/>
+                          <a:ea typeface="Arial"/>
+                          <a:cs typeface="Arial"/>
+                        </a:rPr>
                         <a:t>Kong</a:t>
                       </a:r>
                     </a:p>
@@ -35067,6 +35077,11 @@
                     <a:lstStyle/>
                     <a:p>
                       <a:r>
+                        <a:rPr>
+                          <a:latin typeface="Arial"/>
+                          <a:ea typeface="Arial"/>
+                          <a:cs typeface="Arial"/>
+                        </a:rPr>
                         <a:t>Apigee</a:t>
                       </a:r>
                     </a:p>
@@ -35079,6 +35094,11 @@
                     <a:lstStyle/>
                     <a:p>
                       <a:r>
+                        <a:rPr>
+                          <a:latin typeface="Arial"/>
+                          <a:ea typeface="Arial"/>
+                          <a:cs typeface="Arial"/>
+                        </a:rPr>
                         <a:t>MuleSoft</a:t>
                       </a:r>
                     </a:p>
@@ -35091,6 +35111,11 @@
                     <a:lstStyle/>
                     <a:p>
                       <a:r>
+                        <a:rPr>
+                          <a:latin typeface="Arial"/>
+                          <a:ea typeface="Arial"/>
+                          <a:cs typeface="Arial"/>
+                        </a:rPr>
                         <a:t>Decision use</a:t>
                       </a:r>
                     </a:p>
@@ -35110,6 +35135,11 @@
                     <a:lstStyle/>
                     <a:p>
                       <a:r>
+                        <a:rPr>
+                          <a:latin typeface="Arial"/>
+                          <a:ea typeface="Arial"/>
+                          <a:cs typeface="Arial"/>
+                        </a:rPr>
                         <a:t>Primary focus</a:t>
                       </a:r>
                     </a:p>
@@ -35122,6 +35152,11 @@
                     <a:lstStyle/>
                     <a:p>
                       <a:r>
+                        <a:rPr>
+                          <a:latin typeface="Arial"/>
+                          <a:ea typeface="Arial"/>
+                          <a:cs typeface="Arial"/>
+                        </a:rPr>
                         <a:t>Connectivity platform</a:t>
                       </a:r>
                     </a:p>
@@ -35134,6 +35169,11 @@
                     <a:lstStyle/>
                     <a:p>
                       <a:r>
+                        <a:rPr>
+                          <a:latin typeface="Arial"/>
+                          <a:ea typeface="Arial"/>
+                          <a:cs typeface="Arial"/>
+                        </a:rPr>
                         <a:t>Enterprise API management</a:t>
                       </a:r>
                     </a:p>
@@ -35146,6 +35186,11 @@
                     <a:lstStyle/>
                     <a:p>
                       <a:r>
+                        <a:rPr>
+                          <a:latin typeface="Arial"/>
+                          <a:ea typeface="Arial"/>
+                          <a:cs typeface="Arial"/>
+                        </a:rPr>
                         <a:t>API mgmt in Anypoint</a:t>
                       </a:r>
                     </a:p>
@@ -35158,6 +35203,11 @@
                     <a:lstStyle/>
                     <a:p>
                       <a:r>
+                        <a:rPr>
+                          <a:latin typeface="Arial"/>
+                          <a:ea typeface="Arial"/>
+                          <a:cs typeface="Arial"/>
+                        </a:rPr>
                         <a:t>Operating model</a:t>
                       </a:r>
                     </a:p>
@@ -35177,6 +35227,11 @@
                     <a:lstStyle/>
                     <a:p>
                       <a:r>
+                        <a:rPr>
+                          <a:latin typeface="Arial"/>
+                          <a:ea typeface="Arial"/>
+                          <a:cs typeface="Arial"/>
+                        </a:rPr>
                         <a:t>Control / runtime</a:t>
                       </a:r>
                     </a:p>
@@ -35189,6 +35244,11 @@
                     <a:lstStyle/>
                     <a:p>
                       <a:r>
+                        <a:rPr>
+                          <a:latin typeface="Arial"/>
+                          <a:ea typeface="Arial"/>
+                          <a:cs typeface="Arial"/>
+                        </a:rPr>
                         <a:t>Hybrid CP / DP</a:t>
                       </a:r>
                     </a:p>
@@ -35201,6 +35261,11 @@
                     <a:lstStyle/>
                     <a:p>
                       <a:r>
+                        <a:rPr>
+                          <a:latin typeface="Arial"/>
+                          <a:ea typeface="Arial"/>
+                          <a:cs typeface="Arial"/>
+                        </a:rPr>
                         <a:t>Google mgmt + K8s runtime</a:t>
                       </a:r>
                     </a:p>
@@ -35213,6 +35278,11 @@
                     <a:lstStyle/>
                     <a:p>
                       <a:r>
+                        <a:rPr>
+                          <a:latin typeface="Arial"/>
+                          <a:ea typeface="Arial"/>
+                          <a:cs typeface="Arial"/>
+                        </a:rPr>
                         <a:t>Managed or self-managed gateway</a:t>
                       </a:r>
                     </a:p>
@@ -35225,6 +35295,11 @@
                     <a:lstStyle/>
                     <a:p>
                       <a:r>
+                        <a:rPr>
+                          <a:latin typeface="Arial"/>
+                          <a:ea typeface="Arial"/>
+                          <a:cs typeface="Arial"/>
+                        </a:rPr>
                         <a:t>Custody + duty</a:t>
                       </a:r>
                     </a:p>
@@ -35244,6 +35319,11 @@
                     <a:lstStyle/>
                     <a:p>
                       <a:r>
+                        <a:rPr>
+                          <a:latin typeface="Arial"/>
+                          <a:ea typeface="Arial"/>
+                          <a:cs typeface="Arial"/>
+                        </a:rPr>
                         <a:t>Kubernetes / GitOps</a:t>
                       </a:r>
                     </a:p>
@@ -35256,6 +35336,11 @@
                     <a:lstStyle/>
                     <a:p>
                       <a:r>
+                        <a:rPr>
+                          <a:latin typeface="Arial"/>
+                          <a:ea typeface="Arial"/>
+                          <a:cs typeface="Arial"/>
+                        </a:rPr>
                         <a:t>Supplied: Excellent</a:t>
                       </a:r>
                     </a:p>
@@ -35268,6 +35353,11 @@
                     <a:lstStyle/>
                     <a:p>
                       <a:r>
+                        <a:rPr>
+                          <a:latin typeface="Arial"/>
+                          <a:ea typeface="Arial"/>
+                          <a:cs typeface="Arial"/>
+                        </a:rPr>
                         <a:t>Hybrid runtime / tools</a:t>
                       </a:r>
                     </a:p>
@@ -35280,6 +35370,11 @@
                     <a:lstStyle/>
                     <a:p>
                       <a:r>
+                        <a:rPr>
+                          <a:latin typeface="Arial"/>
+                          <a:ea typeface="Arial"/>
+                          <a:cs typeface="Arial"/>
+                        </a:rPr>
                         <a:t>Supplied: Good / Moderate</a:t>
                       </a:r>
                     </a:p>
@@ -35292,6 +35387,11 @@
                     <a:lstStyle/>
                     <a:p>
                       <a:r>
+                        <a:rPr>
+                          <a:latin typeface="Arial"/>
+                          <a:ea typeface="Arial"/>
+                          <a:cs typeface="Arial"/>
+                        </a:rPr>
                         <a:t>Versioned delivery proof</a:t>
                       </a:r>
                     </a:p>
@@ -35311,6 +35411,11 @@
                     <a:lstStyle/>
                     <a:p>
                       <a:r>
+                        <a:rPr>
+                          <a:latin typeface="Arial"/>
+                          <a:ea typeface="Arial"/>
+                          <a:cs typeface="Arial"/>
+                        </a:rPr>
                         <a:t>Observability</a:t>
                       </a:r>
                     </a:p>
@@ -35323,6 +35428,11 @@
                     <a:lstStyle/>
                     <a:p>
                       <a:r>
+                        <a:rPr>
+                          <a:latin typeface="Arial"/>
+                          <a:ea typeface="Arial"/>
+                          <a:cs typeface="Arial"/>
+                        </a:rPr>
                         <a:t>OTel / Prometheus</a:t>
                       </a:r>
                     </a:p>
@@ -35335,6 +35445,11 @@
                     <a:lstStyle/>
                     <a:p>
                       <a:r>
+                        <a:rPr>
+                          <a:latin typeface="Arial"/>
+                          <a:ea typeface="Arial"/>
+                          <a:cs typeface="Arial"/>
+                        </a:rPr>
                         <a:t>Analytics + monitoring</a:t>
                       </a:r>
                     </a:p>
@@ -35347,6 +35462,11 @@
                     <a:lstStyle/>
                     <a:p>
                       <a:r>
+                        <a:rPr>
+                          <a:latin typeface="Arial"/>
+                          <a:ea typeface="Arial"/>
+                          <a:cs typeface="Arial"/>
+                        </a:rPr>
                         <a:t>Anypoint monitoring</a:t>
                       </a:r>
                     </a:p>
@@ -35359,6 +35479,11 @@
                     <a:lstStyle/>
                     <a:p>
                       <a:r>
+                        <a:rPr>
+                          <a:latin typeface="Arial"/>
+                          <a:ea typeface="Arial"/>
+                          <a:cs typeface="Arial"/>
+                        </a:rPr>
                         <a:t>Export + custody test</a:t>
                       </a:r>
                     </a:p>
@@ -35378,6 +35503,11 @@
                     <a:lstStyle/>
                     <a:p>
                       <a:r>
+                        <a:rPr>
+                          <a:latin typeface="Arial"/>
+                          <a:ea typeface="Arial"/>
+                          <a:cs typeface="Arial"/>
+                        </a:rPr>
                         <a:t>Multicloud</a:t>
                       </a:r>
                     </a:p>
@@ -35390,6 +35520,11 @@
                     <a:lstStyle/>
                     <a:p>
                       <a:r>
+                        <a:rPr>
+                          <a:latin typeface="Arial"/>
+                          <a:ea typeface="Arial"/>
+                          <a:cs typeface="Arial"/>
+                        </a:rPr>
                         <a:t>Supplied: Excellent</a:t>
                       </a:r>
                     </a:p>
@@ -35402,6 +35537,11 @@
                     <a:lstStyle/>
                     <a:p>
                       <a:r>
+                        <a:rPr>
+                          <a:latin typeface="Arial"/>
+                          <a:ea typeface="Arial"/>
+                          <a:cs typeface="Arial"/>
+                        </a:rPr>
                         <a:t>Hybrid runtime</a:t>
                       </a:r>
                     </a:p>
@@ -35414,6 +35554,11 @@
                     <a:lstStyle/>
                     <a:p>
                       <a:r>
+                        <a:rPr>
+                          <a:latin typeface="Arial"/>
+                          <a:ea typeface="Arial"/>
+                          <a:cs typeface="Arial"/>
+                        </a:rPr>
                         <a:t>Supplied: Good</a:t>
                       </a:r>
                     </a:p>
@@ -35426,6 +35571,11 @@
                     <a:lstStyle/>
                     <a:p>
                       <a:r>
+                        <a:rPr>
+                          <a:latin typeface="Arial"/>
+                          <a:ea typeface="Arial"/>
+                          <a:cs typeface="Arial"/>
+                        </a:rPr>
                         <a:t>Placement + sovereignty</a:t>
                       </a:r>
                     </a:p>
@@ -35445,6 +35595,11 @@
                     <a:lstStyle/>
                     <a:p>
                       <a:r>
+                        <a:rPr>
+                          <a:latin typeface="Arial"/>
+                          <a:ea typeface="Arial"/>
+                          <a:cs typeface="Arial"/>
+                        </a:rPr>
                         <a:t>Scalability / robustness</a:t>
                       </a:r>
                     </a:p>
@@ -35457,6 +35612,11 @@
                     <a:lstStyle/>
                     <a:p>
                       <a:r>
+                        <a:rPr>
+                          <a:latin typeface="Arial"/>
+                          <a:ea typeface="Arial"/>
+                          <a:cs typeface="Arial"/>
+                        </a:rPr>
                         <a:t>Not supplied</a:t>
                       </a:r>
                     </a:p>
@@ -35469,6 +35629,11 @@
                     <a:lstStyle/>
                     <a:p>
                       <a:r>
+                        <a:rPr>
+                          <a:latin typeface="Arial"/>
+                          <a:ea typeface="Arial"/>
+                          <a:cs typeface="Arial"/>
+                        </a:rPr>
                         <a:t>Not supplied</a:t>
                       </a:r>
                     </a:p>
@@ -35481,6 +35646,11 @@
                     <a:lstStyle/>
                     <a:p>
                       <a:r>
+                        <a:rPr>
+                          <a:latin typeface="Arial"/>
+                          <a:ea typeface="Arial"/>
+                          <a:cs typeface="Arial"/>
+                        </a:rPr>
                         <a:t>Not supplied</a:t>
                       </a:r>
                     </a:p>
@@ -35493,6 +35663,11 @@
                     <a:lstStyle/>
                     <a:p>
                       <a:r>
+                        <a:rPr>
+                          <a:latin typeface="Arial"/>
+                          <a:ea typeface="Arial"/>
+                          <a:cs typeface="Arial"/>
+                        </a:rPr>
                         <a:t>Load + failure + recovery</a:t>
                       </a:r>
                     </a:p>
@@ -36026,6 +36201,11 @@
                     <a:lstStyle/>
                     <a:p>
                       <a:r>
+                        <a:rPr>
+                          <a:latin typeface="Arial"/>
+                          <a:ea typeface="Arial"/>
+                          <a:cs typeface="Arial"/>
+                        </a:rPr>
                         <a:t>Dimension</a:t>
                       </a:r>
                     </a:p>
@@ -36038,6 +36218,11 @@
                     <a:lstStyle/>
                     <a:p>
                       <a:r>
+                        <a:rPr>
+                          <a:latin typeface="Arial"/>
+                          <a:ea typeface="Arial"/>
+                          <a:cs typeface="Arial"/>
+                        </a:rPr>
                         <a:t>Kong</a:t>
                       </a:r>
                     </a:p>
@@ -36050,6 +36235,11 @@
                     <a:lstStyle/>
                     <a:p>
                       <a:r>
+                        <a:rPr>
+                          <a:latin typeface="Arial"/>
+                          <a:ea typeface="Arial"/>
+                          <a:cs typeface="Arial"/>
+                        </a:rPr>
                         <a:t>Apigee</a:t>
                       </a:r>
                     </a:p>
@@ -36062,6 +36252,11 @@
                     <a:lstStyle/>
                     <a:p>
                       <a:r>
+                        <a:rPr>
+                          <a:latin typeface="Arial"/>
+                          <a:ea typeface="Arial"/>
+                          <a:cs typeface="Arial"/>
+                        </a:rPr>
                         <a:t>MuleSoft</a:t>
                       </a:r>
                     </a:p>
@@ -36074,6 +36269,11 @@
                     <a:lstStyle/>
                     <a:p>
                       <a:r>
+                        <a:rPr>
+                          <a:latin typeface="Arial"/>
+                          <a:ea typeface="Arial"/>
+                          <a:cs typeface="Arial"/>
+                        </a:rPr>
                         <a:t>Evidence required</a:t>
                       </a:r>
                     </a:p>
@@ -36093,6 +36293,11 @@
                     <a:lstStyle/>
                     <a:p>
                       <a:r>
+                        <a:rPr>
+                          <a:latin typeface="Arial"/>
+                          <a:ea typeface="Arial"/>
+                          <a:cs typeface="Arial"/>
+                        </a:rPr>
                         <a:t>Lifecycle / governance</a:t>
                       </a:r>
                     </a:p>
@@ -36105,6 +36310,11 @@
                     <a:lstStyle/>
                     <a:p>
                       <a:r>
+                        <a:rPr>
+                          <a:latin typeface="Arial"/>
+                          <a:ea typeface="Arial"/>
+                          <a:cs typeface="Arial"/>
+                        </a:rPr>
                         <a:t>Supplied: Good</a:t>
                       </a:r>
                     </a:p>
@@ -36117,6 +36327,11 @@
                     <a:lstStyle/>
                     <a:p>
                       <a:r>
+                        <a:rPr>
+                          <a:latin typeface="Arial"/>
+                          <a:ea typeface="Arial"/>
+                          <a:cs typeface="Arial"/>
+                        </a:rPr>
                         <a:t>Supplied: Excellent</a:t>
                       </a:r>
                     </a:p>
@@ -36129,6 +36344,11 @@
                     <a:lstStyle/>
                     <a:p>
                       <a:r>
+                        <a:rPr>
+                          <a:latin typeface="Arial"/>
+                          <a:ea typeface="Arial"/>
+                          <a:cs typeface="Arial"/>
+                        </a:rPr>
                         <a:t>Supplied: Excellent</a:t>
                       </a:r>
                     </a:p>
@@ -36141,6 +36361,11 @@
                     <a:lstStyle/>
                     <a:p>
                       <a:r>
+                        <a:rPr>
+                          <a:latin typeface="Arial"/>
+                          <a:ea typeface="Arial"/>
+                          <a:cs typeface="Arial"/>
+                        </a:rPr>
                         <a:t>Required product use cases</a:t>
                       </a:r>
                     </a:p>
@@ -36160,6 +36385,11 @@
                     <a:lstStyle/>
                     <a:p>
                       <a:r>
+                        <a:rPr>
+                          <a:latin typeface="Arial"/>
+                          <a:ea typeface="Arial"/>
+                          <a:cs typeface="Arial"/>
+                        </a:rPr>
                         <a:t>Portal / product</a:t>
                       </a:r>
                     </a:p>
@@ -36172,6 +36402,11 @@
                     <a:lstStyle/>
                     <a:p>
                       <a:r>
+                        <a:rPr>
+                          <a:latin typeface="Arial"/>
+                          <a:ea typeface="Arial"/>
+                          <a:cs typeface="Arial"/>
+                        </a:rPr>
                         <a:t>Supplied: Good</a:t>
                       </a:r>
                     </a:p>
@@ -36184,6 +36419,11 @@
                     <a:lstStyle/>
                     <a:p>
                       <a:r>
+                        <a:rPr>
+                          <a:latin typeface="Arial"/>
+                          <a:ea typeface="Arial"/>
+                          <a:cs typeface="Arial"/>
+                        </a:rPr>
                         <a:t>Supplied: Excellent</a:t>
                       </a:r>
                     </a:p>
@@ -36196,6 +36436,11 @@
                     <a:lstStyle/>
                     <a:p>
                       <a:r>
+                        <a:rPr>
+                          <a:latin typeface="Arial"/>
+                          <a:ea typeface="Arial"/>
+                          <a:cs typeface="Arial"/>
+                        </a:rPr>
                         <a:t>Supplied: Excellent</a:t>
                       </a:r>
                     </a:p>
@@ -36208,6 +36453,11 @@
                     <a:lstStyle/>
                     <a:p>
                       <a:r>
+                        <a:rPr>
+                          <a:latin typeface="Arial"/>
+                          <a:ea typeface="Arial"/>
+                          <a:cs typeface="Arial"/>
+                        </a:rPr>
                         <a:t>Adjacent tooling map</a:t>
                       </a:r>
                     </a:p>
@@ -36227,6 +36477,11 @@
                     <a:lstStyle/>
                     <a:p>
                       <a:r>
+                        <a:rPr>
+                          <a:latin typeface="Arial"/>
+                          <a:ea typeface="Arial"/>
+                          <a:cs typeface="Arial"/>
+                        </a:rPr>
                         <a:t>Developer experience</a:t>
                       </a:r>
                     </a:p>
@@ -36239,6 +36494,11 @@
                     <a:lstStyle/>
                     <a:p>
                       <a:r>
+                        <a:rPr>
+                          <a:latin typeface="Arial"/>
+                          <a:ea typeface="Arial"/>
+                          <a:cs typeface="Arial"/>
+                        </a:rPr>
                         <a:t>Supplied: Good</a:t>
                       </a:r>
                     </a:p>
@@ -36251,6 +36511,11 @@
                     <a:lstStyle/>
                     <a:p>
                       <a:r>
+                        <a:rPr>
+                          <a:latin typeface="Arial"/>
+                          <a:ea typeface="Arial"/>
+                          <a:cs typeface="Arial"/>
+                        </a:rPr>
                         <a:t>Supplied: Very Strong</a:t>
                       </a:r>
                     </a:p>
@@ -36263,6 +36528,11 @@
                     <a:lstStyle/>
                     <a:p>
                       <a:r>
+                        <a:rPr>
+                          <a:latin typeface="Arial"/>
+                          <a:ea typeface="Arial"/>
+                          <a:cs typeface="Arial"/>
+                        </a:rPr>
                         <a:t>Supplied: Very Strong</a:t>
                       </a:r>
                     </a:p>
@@ -36275,6 +36545,11 @@
                     <a:lstStyle/>
                     <a:p>
                       <a:r>
+                        <a:rPr>
+                          <a:latin typeface="Arial"/>
+                          <a:ea typeface="Arial"/>
+                          <a:cs typeface="Arial"/>
+                        </a:rPr>
                         <a:t>Paved-road usability</a:t>
                       </a:r>
                     </a:p>
@@ -36294,6 +36569,11 @@
                     <a:lstStyle/>
                     <a:p>
                       <a:r>
+                        <a:rPr>
+                          <a:latin typeface="Arial"/>
+                          <a:ea typeface="Arial"/>
+                          <a:cs typeface="Arial"/>
+                        </a:rPr>
                         <a:t>AI traffic</a:t>
                       </a:r>
                     </a:p>
@@ -36306,6 +36586,11 @@
                     <a:lstStyle/>
                     <a:p>
                       <a:r>
+                        <a:rPr>
+                          <a:latin typeface="Arial"/>
+                          <a:ea typeface="Arial"/>
+                          <a:cs typeface="Arial"/>
+                        </a:rPr>
                         <a:t>AI Gateway incl. MCP/A2A</a:t>
                       </a:r>
                     </a:p>
@@ -36318,6 +36603,11 @@
                     <a:lstStyle/>
                     <a:p>
                       <a:r>
+                        <a:rPr>
+                          <a:latin typeface="Arial"/>
+                          <a:ea typeface="Arial"/>
+                          <a:cs typeface="Arial"/>
+                        </a:rPr>
                         <a:t>AI policy / GenAI features</a:t>
                       </a:r>
                     </a:p>
@@ -36330,6 +36620,11 @@
                     <a:lstStyle/>
                     <a:p>
                       <a:r>
+                        <a:rPr>
+                          <a:latin typeface="Arial"/>
+                          <a:ea typeface="Arial"/>
+                          <a:cs typeface="Arial"/>
+                        </a:rPr>
                         <a:t>MCP/A2A gateway traffic</a:t>
                       </a:r>
                     </a:p>
@@ -36342,6 +36637,11 @@
                     <a:lstStyle/>
                     <a:p>
                       <a:r>
+                        <a:rPr>
+                          <a:latin typeface="Arial"/>
+                          <a:ea typeface="Arial"/>
+                          <a:cs typeface="Arial"/>
+                        </a:rPr>
                         <a:t>Versioned use case</a:t>
                       </a:r>
                     </a:p>
@@ -36361,6 +36661,11 @@
                     <a:lstStyle/>
                     <a:p>
                       <a:r>
+                        <a:rPr>
+                          <a:latin typeface="Arial"/>
+                          <a:ea typeface="Arial"/>
+                          <a:cs typeface="Arial"/>
+                        </a:rPr>
                         <a:t>Customization</a:t>
                       </a:r>
                     </a:p>
@@ -36373,6 +36678,11 @@
                     <a:lstStyle/>
                     <a:p>
                       <a:r>
+                        <a:rPr>
+                          <a:latin typeface="Arial"/>
+                          <a:ea typeface="Arial"/>
+                          <a:cs typeface="Arial"/>
+                        </a:rPr>
                         <a:t>Plugin framework</a:t>
                       </a:r>
                     </a:p>
@@ -36385,6 +36695,11 @@
                     <a:lstStyle/>
                     <a:p>
                       <a:r>
+                        <a:rPr>
+                          <a:latin typeface="Arial"/>
+                          <a:ea typeface="Arial"/>
+                          <a:cs typeface="Arial"/>
+                        </a:rPr>
                         <a:t>Policy framework</a:t>
                       </a:r>
                     </a:p>
@@ -36397,6 +36712,11 @@
                     <a:lstStyle/>
                     <a:p>
                       <a:r>
+                        <a:rPr>
+                          <a:latin typeface="Arial"/>
+                          <a:ea typeface="Arial"/>
+                          <a:cs typeface="Arial"/>
+                        </a:rPr>
                         <a:t>Supplied: Moderate</a:t>
                       </a:r>
                     </a:p>
@@ -36409,6 +36729,11 @@
                     <a:lstStyle/>
                     <a:p>
                       <a:r>
+                        <a:rPr>
+                          <a:latin typeface="Arial"/>
+                          <a:ea typeface="Arial"/>
+                          <a:cs typeface="Arial"/>
+                        </a:rPr>
                         <a:t>Support + upgrade path</a:t>
                       </a:r>
                     </a:p>
@@ -36428,6 +36753,11 @@
                     <a:lstStyle/>
                     <a:p>
                       <a:r>
+                        <a:rPr>
+                          <a:latin typeface="Arial"/>
+                          <a:ea typeface="Arial"/>
+                          <a:cs typeface="Arial"/>
+                        </a:rPr>
                         <a:t>Traceable adjunct</a:t>
                       </a:r>
                     </a:p>
@@ -36440,6 +36770,11 @@
                     <a:lstStyle/>
                     <a:p>
                       <a:r>
+                        <a:rPr>
+                          <a:latin typeface="Arial"/>
+                          <a:ea typeface="Arial"/>
+                          <a:cs typeface="Arial"/>
+                        </a:rPr>
                         <a:t>Plugin → Platform Agent</a:t>
                       </a:r>
                     </a:p>
@@ -36452,6 +36787,11 @@
                     <a:lstStyle/>
                     <a:p>
                       <a:r>
+                        <a:rPr>
+                          <a:latin typeface="Arial"/>
+                          <a:ea typeface="Arial"/>
+                          <a:cs typeface="Arial"/>
+                        </a:rPr>
                         <a:t>Not assessed</a:t>
                       </a:r>
                     </a:p>
@@ -36464,6 +36804,11 @@
                     <a:lstStyle/>
                     <a:p>
                       <a:r>
+                        <a:rPr>
+                          <a:latin typeface="Arial"/>
+                          <a:ea typeface="Arial"/>
+                          <a:cs typeface="Arial"/>
+                        </a:rPr>
                         <a:t>Custom-policy baseline</a:t>
                       </a:r>
                     </a:p>
@@ -36476,6 +36821,11 @@
                     <a:lstStyle/>
                     <a:p>
                       <a:r>
+                        <a:rPr>
+                          <a:latin typeface="Arial"/>
+                          <a:ea typeface="Arial"/>
+                          <a:cs typeface="Arial"/>
+                        </a:rPr>
                         <a:t>Run GEP-07; do not score</a:t>
                       </a:r>
                     </a:p>
@@ -37013,6 +37363,9 @@
                           <a:solidFill>
                             <a:srgbClr val="111111"/>
                           </a:solidFill>
+                          <a:latin typeface="Arial"/>
+                          <a:ea typeface="Arial"/>
+                          <a:cs typeface="Arial"/>
                         </a:rPr>
                         <a:t>Dimension</a:t>
                       </a:r>
@@ -37030,6 +37383,9 @@
                           <a:solidFill>
                             <a:srgbClr val="111111"/>
                           </a:solidFill>
+                          <a:latin typeface="Arial"/>
+                          <a:ea typeface="Arial"/>
+                          <a:cs typeface="Arial"/>
                         </a:rPr>
                         <a:t>Kong</a:t>
                       </a:r>
@@ -37047,6 +37403,9 @@
                           <a:solidFill>
                             <a:srgbClr val="111111"/>
                           </a:solidFill>
+                          <a:latin typeface="Arial"/>
+                          <a:ea typeface="Arial"/>
+                          <a:cs typeface="Arial"/>
                         </a:rPr>
                         <a:t>Apigee</a:t>
                       </a:r>
@@ -37064,6 +37423,9 @@
                           <a:solidFill>
                             <a:srgbClr val="111111"/>
                           </a:solidFill>
+                          <a:latin typeface="Arial"/>
+                          <a:ea typeface="Arial"/>
+                          <a:cs typeface="Arial"/>
                         </a:rPr>
                         <a:t>MuleSoft</a:t>
                       </a:r>
@@ -37081,6 +37443,9 @@
                           <a:solidFill>
                             <a:srgbClr val="111111"/>
                           </a:solidFill>
+                          <a:latin typeface="Arial"/>
+                          <a:ea typeface="Arial"/>
+                          <a:cs typeface="Arial"/>
                         </a:rPr>
                         <a:t>Evidence required</a:t>
                       </a:r>
@@ -37101,6 +37466,11 @@
                     <a:lstStyle/>
                     <a:p>
                       <a:r>
+                        <a:rPr>
+                          <a:latin typeface="Arial"/>
+                          <a:ea typeface="Arial"/>
+                          <a:cs typeface="Arial"/>
+                        </a:rPr>
                         <a:t>Reversibility / lock-in</a:t>
                       </a:r>
                     </a:p>
@@ -37113,6 +37483,11 @@
                     <a:lstStyle/>
                     <a:p>
                       <a:r>
+                        <a:rPr>
+                          <a:latin typeface="Arial"/>
+                          <a:ea typeface="Arial"/>
+                          <a:cs typeface="Arial"/>
+                        </a:rPr>
                         <a:t>Supplied: Low</a:t>
                       </a:r>
                     </a:p>
@@ -37125,6 +37500,11 @@
                     <a:lstStyle/>
                     <a:p>
                       <a:r>
+                        <a:rPr>
+                          <a:latin typeface="Arial"/>
+                          <a:ea typeface="Arial"/>
+                          <a:cs typeface="Arial"/>
+                        </a:rPr>
                         <a:t>Supplied: Medium</a:t>
                       </a:r>
                     </a:p>
@@ -37137,6 +37517,11 @@
                     <a:lstStyle/>
                     <a:p>
                       <a:r>
+                        <a:rPr>
+                          <a:latin typeface="Arial"/>
+                          <a:ea typeface="Arial"/>
+                          <a:cs typeface="Arial"/>
+                        </a:rPr>
                         <a:t>Supplied: High</a:t>
                       </a:r>
                     </a:p>
@@ -37149,6 +37534,11 @@
                     <a:lstStyle/>
                     <a:p>
                       <a:r>
+                        <a:rPr>
+                          <a:latin typeface="Arial"/>
+                          <a:ea typeface="Arial"/>
+                          <a:cs typeface="Arial"/>
+                        </a:rPr>
                         <a:t>Timed rebuild + route-back</a:t>
                       </a:r>
                     </a:p>
@@ -37168,6 +37558,11 @@
                     <a:lstStyle/>
                     <a:p>
                       <a:r>
+                        <a:rPr>
+                          <a:latin typeface="Arial"/>
+                          <a:ea typeface="Arial"/>
+                          <a:cs typeface="Arial"/>
+                        </a:rPr>
                         <a:t>Full TCO / pricing</a:t>
                       </a:r>
                     </a:p>
@@ -37180,6 +37575,11 @@
                     <a:lstStyle/>
                     <a:p>
                       <a:r>
+                        <a:rPr>
+                          <a:latin typeface="Arial"/>
+                          <a:ea typeface="Arial"/>
+                          <a:cs typeface="Arial"/>
+                        </a:rPr>
                         <a:t>Custom quote</a:t>
                       </a:r>
                     </a:p>
@@ -37192,6 +37592,11 @@
                     <a:lstStyle/>
                     <a:p>
                       <a:r>
+                        <a:rPr>
+                          <a:latin typeface="Arial"/>
+                          <a:ea typeface="Arial"/>
+                          <a:cs typeface="Arial"/>
+                        </a:rPr>
                         <a:t>Managed PAYG ≠ Hybrid</a:t>
                       </a:r>
                     </a:p>
@@ -37204,6 +37609,11 @@
                     <a:lstStyle/>
                     <a:p>
                       <a:r>
+                        <a:rPr>
+                          <a:latin typeface="Arial"/>
+                          <a:ea typeface="Arial"/>
+                          <a:cs typeface="Arial"/>
+                        </a:rPr>
                         <a:t>Contact sales</a:t>
                       </a:r>
                     </a:p>
@@ -37216,6 +37626,11 @@
                     <a:lstStyle/>
                     <a:p>
                       <a:r>
+                        <a:rPr>
+                          <a:latin typeface="Arial"/>
+                          <a:ea typeface="Arial"/>
+                          <a:cs typeface="Arial"/>
+                        </a:rPr>
                         <a:t>Quote + labor + infra + HA/DR + adjunct + exit</a:t>
                       </a:r>
                     </a:p>
@@ -37235,6 +37650,11 @@
                     <a:lstStyle/>
                     <a:p>
                       <a:r>
+                        <a:rPr>
+                          <a:latin typeface="Arial"/>
+                          <a:ea typeface="Arial"/>
+                          <a:cs typeface="Arial"/>
+                        </a:rPr>
                         <a:t>Control-plane duty</a:t>
                       </a:r>
                     </a:p>
@@ -37247,6 +37667,11 @@
                     <a:lstStyle/>
                     <a:p>
                       <a:r>
+                        <a:rPr>
+                          <a:latin typeface="Arial"/>
+                          <a:ea typeface="Arial"/>
+                          <a:cs typeface="Arial"/>
+                        </a:rPr>
                         <a:t>Enterprise CP + Postgres</a:t>
                       </a:r>
                     </a:p>
@@ -37259,6 +37684,11 @@
                     <a:lstStyle/>
                     <a:p>
                       <a:r>
+                        <a:rPr>
+                          <a:latin typeface="Arial"/>
+                          <a:ea typeface="Arial"/>
+                          <a:cs typeface="Arial"/>
+                        </a:rPr>
                         <a:t>Google mgmt + own runtime</a:t>
                       </a:r>
                     </a:p>
@@ -37271,6 +37701,11 @@
                     <a:lstStyle/>
                     <a:p>
                       <a:r>
+                        <a:rPr>
+                          <a:latin typeface="Arial"/>
+                          <a:ea typeface="Arial"/>
+                          <a:cs typeface="Arial"/>
+                        </a:rPr>
                         <a:t>Boundary-dependent</a:t>
                       </a:r>
                     </a:p>
@@ -37283,6 +37718,11 @@
                     <a:lstStyle/>
                     <a:p>
                       <a:r>
+                        <a:rPr>
+                          <a:latin typeface="Arial"/>
+                          <a:ea typeface="Arial"/>
+                          <a:cs typeface="Arial"/>
+                        </a:rPr>
                         <a:t>Funded RACI + support + recovery + on-call</a:t>
                       </a:r>
                     </a:p>
@@ -37913,6 +38353,11 @@
                     <a:lstStyle/>
                     <a:p>
                       <a:r>
+                        <a:rPr>
+                          <a:latin typeface="Arial"/>
+                          <a:ea typeface="Arial"/>
+                          <a:cs typeface="Arial"/>
+                        </a:rPr>
                         <a:t>Category</a:t>
                       </a:r>
                     </a:p>
@@ -37925,6 +38370,11 @@
                     <a:lstStyle/>
                     <a:p>
                       <a:r>
+                        <a:rPr>
+                          <a:latin typeface="Arial"/>
+                          <a:ea typeface="Arial"/>
+                          <a:cs typeface="Arial"/>
+                        </a:rPr>
                         <a:t>Weight</a:t>
                       </a:r>
                     </a:p>
@@ -37937,6 +38387,11 @@
                     <a:lstStyle/>
                     <a:p>
                       <a:r>
+                        <a:rPr>
+                          <a:latin typeface="Arial"/>
+                          <a:ea typeface="Arial"/>
+                          <a:cs typeface="Arial"/>
+                        </a:rPr>
                         <a:t>Kong</a:t>
                       </a:r>
                     </a:p>
@@ -37949,6 +38404,11 @@
                     <a:lstStyle/>
                     <a:p>
                       <a:r>
+                        <a:rPr>
+                          <a:latin typeface="Arial"/>
+                          <a:ea typeface="Arial"/>
+                          <a:cs typeface="Arial"/>
+                        </a:rPr>
                         <a:t>Apigee</a:t>
                       </a:r>
                     </a:p>
@@ -37961,6 +38421,11 @@
                     <a:lstStyle/>
                     <a:p>
                       <a:r>
+                        <a:rPr>
+                          <a:latin typeface="Arial"/>
+                          <a:ea typeface="Arial"/>
+                          <a:cs typeface="Arial"/>
+                        </a:rPr>
                         <a:t>MuleSoft</a:t>
                       </a:r>
                     </a:p>
@@ -37980,6 +38445,11 @@
                     <a:lstStyle/>
                     <a:p>
                       <a:r>
+                        <a:rPr>
+                          <a:latin typeface="Arial"/>
+                          <a:ea typeface="Arial"/>
+                          <a:cs typeface="Arial"/>
+                        </a:rPr>
                         <a:t>Kubernetes &amp; cloud native</a:t>
                       </a:r>
                     </a:p>
@@ -37992,6 +38462,11 @@
                     <a:lstStyle/>
                     <a:p>
                       <a:r>
+                        <a:rPr>
+                          <a:latin typeface="Arial"/>
+                          <a:ea typeface="Arial"/>
+                          <a:cs typeface="Arial"/>
+                        </a:rPr>
                         <a:t>20%</a:t>
                       </a:r>
                     </a:p>
@@ -38004,6 +38479,11 @@
                     <a:lstStyle/>
                     <a:p>
                       <a:r>
+                        <a:rPr>
+                          <a:latin typeface="Arial"/>
+                          <a:ea typeface="Arial"/>
+                          <a:cs typeface="Arial"/>
+                        </a:rPr>
                         <a:t>10</a:t>
                       </a:r>
                     </a:p>
@@ -38016,6 +38496,11 @@
                     <a:lstStyle/>
                     <a:p>
                       <a:r>
+                        <a:rPr>
+                          <a:latin typeface="Arial"/>
+                          <a:ea typeface="Arial"/>
+                          <a:cs typeface="Arial"/>
+                        </a:rPr>
                         <a:t>8</a:t>
                       </a:r>
                     </a:p>
@@ -38028,6 +38513,11 @@
                     <a:lstStyle/>
                     <a:p>
                       <a:r>
+                        <a:rPr>
+                          <a:latin typeface="Arial"/>
+                          <a:ea typeface="Arial"/>
+                          <a:cs typeface="Arial"/>
+                        </a:rPr>
                         <a:t>7</a:t>
                       </a:r>
                     </a:p>
@@ -38047,6 +38537,11 @@
                     <a:lstStyle/>
                     <a:p>
                       <a:r>
+                        <a:rPr>
+                          <a:latin typeface="Arial"/>
+                          <a:ea typeface="Arial"/>
+                          <a:cs typeface="Arial"/>
+                        </a:rPr>
                         <a:t>GitOps &amp; DevOps</a:t>
                       </a:r>
                     </a:p>
@@ -38059,6 +38554,11 @@
                     <a:lstStyle/>
                     <a:p>
                       <a:r>
+                        <a:rPr>
+                          <a:latin typeface="Arial"/>
+                          <a:ea typeface="Arial"/>
+                          <a:cs typeface="Arial"/>
+                        </a:rPr>
                         <a:t>15%</a:t>
                       </a:r>
                     </a:p>
@@ -38071,6 +38571,11 @@
                     <a:lstStyle/>
                     <a:p>
                       <a:r>
+                        <a:rPr>
+                          <a:latin typeface="Arial"/>
+                          <a:ea typeface="Arial"/>
+                          <a:cs typeface="Arial"/>
+                        </a:rPr>
                         <a:t>10</a:t>
                       </a:r>
                     </a:p>
@@ -38083,6 +38588,11 @@
                     <a:lstStyle/>
                     <a:p>
                       <a:r>
+                        <a:rPr>
+                          <a:latin typeface="Arial"/>
+                          <a:ea typeface="Arial"/>
+                          <a:cs typeface="Arial"/>
+                        </a:rPr>
                         <a:t>7</a:t>
                       </a:r>
                     </a:p>
@@ -38095,6 +38605,11 @@
                     <a:lstStyle/>
                     <a:p>
                       <a:r>
+                        <a:rPr>
+                          <a:latin typeface="Arial"/>
+                          <a:ea typeface="Arial"/>
+                          <a:cs typeface="Arial"/>
+                        </a:rPr>
                         <a:t>6</a:t>
                       </a:r>
                     </a:p>
@@ -38114,6 +38629,11 @@
                     <a:lstStyle/>
                     <a:p>
                       <a:r>
+                        <a:rPr>
+                          <a:latin typeface="Arial"/>
+                          <a:ea typeface="Arial"/>
+                          <a:cs typeface="Arial"/>
+                        </a:rPr>
                         <a:t>API management</a:t>
                       </a:r>
                     </a:p>
@@ -38126,6 +38646,11 @@
                     <a:lstStyle/>
                     <a:p>
                       <a:r>
+                        <a:rPr>
+                          <a:latin typeface="Arial"/>
+                          <a:ea typeface="Arial"/>
+                          <a:cs typeface="Arial"/>
+                        </a:rPr>
                         <a:t>15%</a:t>
                       </a:r>
                     </a:p>
@@ -38138,6 +38663,11 @@
                     <a:lstStyle/>
                     <a:p>
                       <a:r>
+                        <a:rPr>
+                          <a:latin typeface="Arial"/>
+                          <a:ea typeface="Arial"/>
+                          <a:cs typeface="Arial"/>
+                        </a:rPr>
                         <a:t>8</a:t>
                       </a:r>
                     </a:p>
@@ -38150,6 +38680,11 @@
                     <a:lstStyle/>
                     <a:p>
                       <a:r>
+                        <a:rPr>
+                          <a:latin typeface="Arial"/>
+                          <a:ea typeface="Arial"/>
+                          <a:cs typeface="Arial"/>
+                        </a:rPr>
                         <a:t>10</a:t>
                       </a:r>
                     </a:p>
@@ -38162,6 +38697,11 @@
                     <a:lstStyle/>
                     <a:p>
                       <a:r>
+                        <a:rPr>
+                          <a:latin typeface="Arial"/>
+                          <a:ea typeface="Arial"/>
+                          <a:cs typeface="Arial"/>
+                        </a:rPr>
                         <a:t>10</a:t>
                       </a:r>
                     </a:p>
@@ -38181,6 +38721,11 @@
                     <a:lstStyle/>
                     <a:p>
                       <a:r>
+                        <a:rPr>
+                          <a:latin typeface="Arial"/>
+                          <a:ea typeface="Arial"/>
+                          <a:cs typeface="Arial"/>
+                        </a:rPr>
                         <a:t>API governance</a:t>
                       </a:r>
                     </a:p>
@@ -38193,6 +38738,11 @@
                     <a:lstStyle/>
                     <a:p>
                       <a:r>
+                        <a:rPr>
+                          <a:latin typeface="Arial"/>
+                          <a:ea typeface="Arial"/>
+                          <a:cs typeface="Arial"/>
+                        </a:rPr>
                         <a:t>10%</a:t>
                       </a:r>
                     </a:p>
@@ -38205,6 +38755,11 @@
                     <a:lstStyle/>
                     <a:p>
                       <a:r>
+                        <a:rPr>
+                          <a:latin typeface="Arial"/>
+                          <a:ea typeface="Arial"/>
+                          <a:cs typeface="Arial"/>
+                        </a:rPr>
                         <a:t>8</a:t>
                       </a:r>
                     </a:p>
@@ -38217,6 +38772,11 @@
                     <a:lstStyle/>
                     <a:p>
                       <a:r>
+                        <a:rPr>
+                          <a:latin typeface="Arial"/>
+                          <a:ea typeface="Arial"/>
+                          <a:cs typeface="Arial"/>
+                        </a:rPr>
                         <a:t>10</a:t>
                       </a:r>
                     </a:p>
@@ -38229,6 +38789,11 @@
                     <a:lstStyle/>
                     <a:p>
                       <a:r>
+                        <a:rPr>
+                          <a:latin typeface="Arial"/>
+                          <a:ea typeface="Arial"/>
+                          <a:cs typeface="Arial"/>
+                        </a:rPr>
                         <a:t>10</a:t>
                       </a:r>
                     </a:p>
@@ -38248,6 +38813,11 @@
                     <a:lstStyle/>
                     <a:p>
                       <a:r>
+                        <a:rPr>
+                          <a:latin typeface="Arial"/>
+                          <a:ea typeface="Arial"/>
+                          <a:cs typeface="Arial"/>
+                        </a:rPr>
                         <a:t>Security &amp; compliance</a:t>
                       </a:r>
                     </a:p>
@@ -38260,6 +38830,11 @@
                     <a:lstStyle/>
                     <a:p>
                       <a:r>
+                        <a:rPr>
+                          <a:latin typeface="Arial"/>
+                          <a:ea typeface="Arial"/>
+                          <a:cs typeface="Arial"/>
+                        </a:rPr>
                         <a:t>10%</a:t>
                       </a:r>
                     </a:p>
@@ -38272,6 +38847,11 @@
                     <a:lstStyle/>
                     <a:p>
                       <a:r>
+                        <a:rPr>
+                          <a:latin typeface="Arial"/>
+                          <a:ea typeface="Arial"/>
+                          <a:cs typeface="Arial"/>
+                        </a:rPr>
                         <a:t>9</a:t>
                       </a:r>
                     </a:p>
@@ -38284,6 +38864,11 @@
                     <a:lstStyle/>
                     <a:p>
                       <a:r>
+                        <a:rPr>
+                          <a:latin typeface="Arial"/>
+                          <a:ea typeface="Arial"/>
+                          <a:cs typeface="Arial"/>
+                        </a:rPr>
                         <a:t>10</a:t>
                       </a:r>
                     </a:p>
@@ -38296,6 +38881,11 @@
                     <a:lstStyle/>
                     <a:p>
                       <a:r>
+                        <a:rPr>
+                          <a:latin typeface="Arial"/>
+                          <a:ea typeface="Arial"/>
+                          <a:cs typeface="Arial"/>
+                        </a:rPr>
                         <a:t>9</a:t>
                       </a:r>
                     </a:p>
@@ -38315,6 +38905,11 @@
                     <a:lstStyle/>
                     <a:p>
                       <a:r>
+                        <a:rPr>
+                          <a:latin typeface="Arial"/>
+                          <a:ea typeface="Arial"/>
+                          <a:cs typeface="Arial"/>
+                        </a:rPr>
                         <a:t>Observability</a:t>
                       </a:r>
                     </a:p>
@@ -38327,6 +38922,11 @@
                     <a:lstStyle/>
                     <a:p>
                       <a:r>
+                        <a:rPr>
+                          <a:latin typeface="Arial"/>
+                          <a:ea typeface="Arial"/>
+                          <a:cs typeface="Arial"/>
+                        </a:rPr>
                         <a:t>10%</a:t>
                       </a:r>
                     </a:p>
@@ -38339,6 +38939,11 @@
                     <a:lstStyle/>
                     <a:p>
                       <a:r>
+                        <a:rPr>
+                          <a:latin typeface="Arial"/>
+                          <a:ea typeface="Arial"/>
+                          <a:cs typeface="Arial"/>
+                        </a:rPr>
                         <a:t>9</a:t>
                       </a:r>
                     </a:p>
@@ -38351,6 +38956,11 @@
                     <a:lstStyle/>
                     <a:p>
                       <a:r>
+                        <a:rPr>
+                          <a:latin typeface="Arial"/>
+                          <a:ea typeface="Arial"/>
+                          <a:cs typeface="Arial"/>
+                        </a:rPr>
                         <a:t>9</a:t>
                       </a:r>
                     </a:p>
@@ -38363,6 +38973,11 @@
                     <a:lstStyle/>
                     <a:p>
                       <a:r>
+                        <a:rPr>
+                          <a:latin typeface="Arial"/>
+                          <a:ea typeface="Arial"/>
+                          <a:cs typeface="Arial"/>
+                        </a:rPr>
                         <a:t>8</a:t>
                       </a:r>
                     </a:p>
@@ -38382,6 +38997,11 @@
                     <a:lstStyle/>
                     <a:p>
                       <a:r>
+                        <a:rPr>
+                          <a:latin typeface="Arial"/>
+                          <a:ea typeface="Arial"/>
+                          <a:cs typeface="Arial"/>
+                        </a:rPr>
                         <a:t>AI gateway readiness</a:t>
                       </a:r>
                     </a:p>
@@ -38394,6 +39014,11 @@
                     <a:lstStyle/>
                     <a:p>
                       <a:r>
+                        <a:rPr>
+                          <a:latin typeface="Arial"/>
+                          <a:ea typeface="Arial"/>
+                          <a:cs typeface="Arial"/>
+                        </a:rPr>
                         <a:t>10%</a:t>
                       </a:r>
                     </a:p>
@@ -38406,6 +39031,11 @@
                     <a:lstStyle/>
                     <a:p>
                       <a:r>
+                        <a:rPr>
+                          <a:latin typeface="Arial"/>
+                          <a:ea typeface="Arial"/>
+                          <a:cs typeface="Arial"/>
+                        </a:rPr>
                         <a:t>10</a:t>
                       </a:r>
                     </a:p>
@@ -38418,6 +39048,11 @@
                     <a:lstStyle/>
                     <a:p>
                       <a:r>
+                        <a:rPr>
+                          <a:latin typeface="Arial"/>
+                          <a:ea typeface="Arial"/>
+                          <a:cs typeface="Arial"/>
+                        </a:rPr>
                         <a:t>8</a:t>
                       </a:r>
                     </a:p>
@@ -38430,6 +39065,11 @@
                     <a:lstStyle/>
                     <a:p>
                       <a:r>
+                        <a:rPr>
+                          <a:latin typeface="Arial"/>
+                          <a:ea typeface="Arial"/>
+                          <a:cs typeface="Arial"/>
+                        </a:rPr>
                         <a:t>7</a:t>
                       </a:r>
                     </a:p>
@@ -38449,6 +39089,11 @@
                     <a:lstStyle/>
                     <a:p>
                       <a:r>
+                        <a:rPr>
+                          <a:latin typeface="Arial"/>
+                          <a:ea typeface="Arial"/>
+                          <a:cs typeface="Arial"/>
+                        </a:rPr>
                         <a:t>Cost efficiency</a:t>
                       </a:r>
                     </a:p>
@@ -38461,6 +39106,11 @@
                     <a:lstStyle/>
                     <a:p>
                       <a:r>
+                        <a:rPr>
+                          <a:latin typeface="Arial"/>
+                          <a:ea typeface="Arial"/>
+                          <a:cs typeface="Arial"/>
+                        </a:rPr>
                         <a:t>10%</a:t>
                       </a:r>
                     </a:p>
@@ -38473,6 +39123,11 @@
                     <a:lstStyle/>
                     <a:p>
                       <a:r>
+                        <a:rPr>
+                          <a:latin typeface="Arial"/>
+                          <a:ea typeface="Arial"/>
+                          <a:cs typeface="Arial"/>
+                        </a:rPr>
                         <a:t>10</a:t>
                       </a:r>
                     </a:p>
@@ -38485,6 +39140,11 @@
                     <a:lstStyle/>
                     <a:p>
                       <a:r>
+                        <a:rPr>
+                          <a:latin typeface="Arial"/>
+                          <a:ea typeface="Arial"/>
+                          <a:cs typeface="Arial"/>
+                        </a:rPr>
                         <a:t>7</a:t>
                       </a:r>
                     </a:p>
@@ -38497,6 +39157,11 @@
                     <a:lstStyle/>
                     <a:p>
                       <a:r>
+                        <a:rPr>
+                          <a:latin typeface="Arial"/>
+                          <a:ea typeface="Arial"/>
+                          <a:cs typeface="Arial"/>
+                        </a:rPr>
                         <a:t>5</a:t>
                       </a:r>
                     </a:p>

</xml_diff>

<commit_message>
Improve native Kong guided evaluation page (#24)
* Correct guided Kong deck boundaries, duties, outcomes and companion

Project the canonical operating boundaries (KP-SMH1/KMC-3, Konnect
custody benchmark KMC-1, non-Kong exit KPS-P9) and the custody-fit
permanent duties from docs/48 instead of the KMC-2 pair and a
mislabelled counterfactual; render outcome cards with canonical docs/47
names; carry figure-contract text into diagram takeaways; add a scroll
cue for overflowing frames; localize portal links in rendered guides;
align the PowerPoint companion (date, GTM-07 label, KO names and notes,
typefaces) and pin its new hash. Review findings F1-F11 of 2026-08-22.

Co-Authored-By: Claude Fable 5 <noreply@anthropic.com>

* Expand guided deck terms at phase entry

* Improve native guided evaluation page

---------

Co-authored-by: Claude Fable 5 <noreply@anthropic.com>
</commit_message>
<xml_diff>
--- a/presentations/kong-platform-journey-guided.pptx
+++ b/presentations/kong-platform-journey-guided.pptx
@@ -2291,7 +2291,7 @@
           </a:p>
           <a:p>
             <a:r>
-              <a:t>Each mechanism is paired with a measurable outcome and a reviewable artifact. State fidelity, request reliability, trust admission, recovery and safe change are all separate admission dimensions.</a:t>
+              <a:t>Each mechanism is paired with a measurable outcome and a reviewable artifact. Trustworthy active state, business reliability, trust integrity, management recoverability and safe change are all separate admission dimensions.</a:t>
             </a:r>
           </a:p>
           <a:p>
@@ -2635,7 +2635,7 @@
           </a:p>
           <a:p>
             <a:r>
-              <a:t>Capacity and evidence safety matter, but so do adoption, operating sustainability, exit readiness and accurate estate ownership. KO-7 is an outcome: administrative/configuration audit, request and security-decision correlation, business evidence, quantified produced/queued/dropped/delivered gaps, and prohibited-field control. Traceable may be one candidate mechanism, but no product name can make KO-7 pass.</a:t>
+              <a:t>Capacity isolation and evidence safety matter, but so do platform adoption, operating sustainability, reversibility and estate truth. KO-7 is an outcome: administrative/configuration audit, request and security-decision correlation, business evidence, quantified produced/queued/dropped/delivered gaps, and prohibited-field control. Traceable may be one candidate mechanism, but no product name can make KO-7 pass.</a:t>
             </a:r>
           </a:p>
           <a:p>
@@ -8851,7 +8851,7 @@
                 <a:ea typeface="Consolas"/>
                 <a:cs typeface="Consolas"/>
               </a:rPr>
-              <a:t>20 AUG 2026  •  WORKING DECISION BRIEF</a:t>
+              <a:t>22 AUG 2026  •  WORKING DECISION BRIEF</a:t>
             </a:r>
           </a:p>
         </p:txBody>
@@ -23870,9 +23870,9 @@
                 <a:solidFill>
                   <a:srgbClr val="5537D6"/>
                 </a:solidFill>
-                <a:latin typeface="Georgia"/>
-                <a:ea typeface="Georgia"/>
-                <a:cs typeface="Georgia"/>
+                <a:latin typeface="Consolas"/>
+                <a:ea typeface="Consolas"/>
+                <a:cs typeface="Consolas"/>
               </a:defRPr>
             </a:pPr>
             <a:r>
@@ -23880,9 +23880,9 @@
                 <a:solidFill>
                   <a:srgbClr val="5537D6"/>
                 </a:solidFill>
-                <a:latin typeface="Georgia"/>
-                <a:ea typeface="Georgia"/>
-                <a:cs typeface="Georgia"/>
+                <a:latin typeface="Consolas"/>
+                <a:ea typeface="Consolas"/>
+                <a:cs typeface="Consolas"/>
               </a:rPr>
               <a:t>0</a:t>
             </a:r>
@@ -27355,7 +27355,7 @@
                 <a:ea typeface="Georgia"/>
                 <a:cs typeface="Georgia"/>
               </a:rPr>
-              <a:t>State fidelity</a:t>
+              <a:t>Trustworthy active state</a:t>
             </a:r>
           </a:p>
         </p:txBody>
@@ -27749,7 +27749,7 @@
                 <a:ea typeface="Georgia"/>
                 <a:cs typeface="Georgia"/>
               </a:rPr>
-              <a:t>Request reliability</a:t>
+              <a:t>Business reliability</a:t>
             </a:r>
           </a:p>
         </p:txBody>
@@ -28143,7 +28143,7 @@
                 <a:ea typeface="Georgia"/>
                 <a:cs typeface="Georgia"/>
               </a:rPr>
-              <a:t>Trust admission</a:t>
+              <a:t>Trust integrity</a:t>
             </a:r>
           </a:p>
         </p:txBody>
@@ -28537,7 +28537,7 @@
                 <a:ea typeface="Georgia"/>
                 <a:cs typeface="Georgia"/>
               </a:rPr>
-              <a:t>Recovery</a:t>
+              <a:t>Management recoverability</a:t>
             </a:r>
           </a:p>
         </p:txBody>
@@ -30624,7 +30624,7 @@
                 <a:ea typeface="Georgia"/>
                 <a:cs typeface="Georgia"/>
               </a:rPr>
-              <a:t>Security + Traceable adjunct</a:t>
+              <a:t>Security + observability</a:t>
             </a:r>
           </a:p>
         </p:txBody>
@@ -31540,7 +31540,7 @@
                 <a:ea typeface="Georgia"/>
                 <a:cs typeface="Georgia"/>
               </a:rPr>
-              <a:t>Capacity</a:t>
+              <a:t>Capacity isolation</a:t>
             </a:r>
           </a:p>
         </p:txBody>
@@ -31787,7 +31787,7 @@
               </a:defRPr>
             </a:pPr>
             <a:r>
-              <a:rPr sz="2025" b="0" i="0">
+              <a:rPr sz="1400" b="0" i="0">
                 <a:solidFill>
                   <a:srgbClr val="111111"/>
                 </a:solidFill>
@@ -31795,7 +31795,7 @@
                 <a:ea typeface="Georgia"/>
                 <a:cs typeface="Georgia"/>
               </a:rPr>
-              <a:t>Security traceability</a:t>
+              <a:t>Security traceability and evidence safety</a:t>
             </a:r>
           </a:p>
         </p:txBody>
@@ -32050,7 +32050,7 @@
                 <a:ea typeface="Georgia"/>
                 <a:cs typeface="Georgia"/>
               </a:rPr>
-              <a:t>Adoption</a:t>
+              <a:t>Platform adoption</a:t>
             </a:r>
           </a:p>
         </p:txBody>
@@ -32297,7 +32297,7 @@
               </a:defRPr>
             </a:pPr>
             <a:r>
-              <a:rPr sz="2025" b="0" i="0">
+              <a:rPr sz="1650" b="0" i="0">
                 <a:solidFill>
                   <a:srgbClr val="111111"/>
                 </a:solidFill>
@@ -32305,7 +32305,7 @@
                 <a:ea typeface="Georgia"/>
                 <a:cs typeface="Georgia"/>
               </a:rPr>
-              <a:t>Sustainability</a:t>
+              <a:t>Operating sustainability</a:t>
             </a:r>
           </a:p>
         </p:txBody>
@@ -32560,7 +32560,7 @@
                 <a:ea typeface="Georgia"/>
                 <a:cs typeface="Georgia"/>
               </a:rPr>
-              <a:t>Exit readiness</a:t>
+              <a:t>Reversibility</a:t>
             </a:r>
           </a:p>
         </p:txBody>
@@ -35043,6 +35043,11 @@
                     <a:lstStyle/>
                     <a:p>
                       <a:r>
+                        <a:rPr>
+                          <a:latin typeface="Arial"/>
+                          <a:ea typeface="Arial"/>
+                          <a:cs typeface="Arial"/>
+                        </a:rPr>
                         <a:t>Dimension</a:t>
                       </a:r>
                     </a:p>
@@ -35055,6 +35060,11 @@
                     <a:lstStyle/>
                     <a:p>
                       <a:r>
+                        <a:rPr>
+                          <a:latin typeface="Arial"/>
+                          <a:ea typeface="Arial"/>
+                          <a:cs typeface="Arial"/>
+                        </a:rPr>
                         <a:t>Kong</a:t>
                       </a:r>
                     </a:p>
@@ -35067,6 +35077,11 @@
                     <a:lstStyle/>
                     <a:p>
                       <a:r>
+                        <a:rPr>
+                          <a:latin typeface="Arial"/>
+                          <a:ea typeface="Arial"/>
+                          <a:cs typeface="Arial"/>
+                        </a:rPr>
                         <a:t>Apigee</a:t>
                       </a:r>
                     </a:p>
@@ -35079,6 +35094,11 @@
                     <a:lstStyle/>
                     <a:p>
                       <a:r>
+                        <a:rPr>
+                          <a:latin typeface="Arial"/>
+                          <a:ea typeface="Arial"/>
+                          <a:cs typeface="Arial"/>
+                        </a:rPr>
                         <a:t>MuleSoft</a:t>
                       </a:r>
                     </a:p>
@@ -35091,6 +35111,11 @@
                     <a:lstStyle/>
                     <a:p>
                       <a:r>
+                        <a:rPr>
+                          <a:latin typeface="Arial"/>
+                          <a:ea typeface="Arial"/>
+                          <a:cs typeface="Arial"/>
+                        </a:rPr>
                         <a:t>Decision use</a:t>
                       </a:r>
                     </a:p>
@@ -35110,6 +35135,11 @@
                     <a:lstStyle/>
                     <a:p>
                       <a:r>
+                        <a:rPr>
+                          <a:latin typeface="Arial"/>
+                          <a:ea typeface="Arial"/>
+                          <a:cs typeface="Arial"/>
+                        </a:rPr>
                         <a:t>Primary focus</a:t>
                       </a:r>
                     </a:p>
@@ -35122,6 +35152,11 @@
                     <a:lstStyle/>
                     <a:p>
                       <a:r>
+                        <a:rPr>
+                          <a:latin typeface="Arial"/>
+                          <a:ea typeface="Arial"/>
+                          <a:cs typeface="Arial"/>
+                        </a:rPr>
                         <a:t>Connectivity platform</a:t>
                       </a:r>
                     </a:p>
@@ -35134,6 +35169,11 @@
                     <a:lstStyle/>
                     <a:p>
                       <a:r>
+                        <a:rPr>
+                          <a:latin typeface="Arial"/>
+                          <a:ea typeface="Arial"/>
+                          <a:cs typeface="Arial"/>
+                        </a:rPr>
                         <a:t>Enterprise API management</a:t>
                       </a:r>
                     </a:p>
@@ -35146,6 +35186,11 @@
                     <a:lstStyle/>
                     <a:p>
                       <a:r>
+                        <a:rPr>
+                          <a:latin typeface="Arial"/>
+                          <a:ea typeface="Arial"/>
+                          <a:cs typeface="Arial"/>
+                        </a:rPr>
                         <a:t>API mgmt in Anypoint</a:t>
                       </a:r>
                     </a:p>
@@ -35158,6 +35203,11 @@
                     <a:lstStyle/>
                     <a:p>
                       <a:r>
+                        <a:rPr>
+                          <a:latin typeface="Arial"/>
+                          <a:ea typeface="Arial"/>
+                          <a:cs typeface="Arial"/>
+                        </a:rPr>
                         <a:t>Operating model</a:t>
                       </a:r>
                     </a:p>
@@ -35177,6 +35227,11 @@
                     <a:lstStyle/>
                     <a:p>
                       <a:r>
+                        <a:rPr>
+                          <a:latin typeface="Arial"/>
+                          <a:ea typeface="Arial"/>
+                          <a:cs typeface="Arial"/>
+                        </a:rPr>
                         <a:t>Control / runtime</a:t>
                       </a:r>
                     </a:p>
@@ -35189,6 +35244,11 @@
                     <a:lstStyle/>
                     <a:p>
                       <a:r>
+                        <a:rPr>
+                          <a:latin typeface="Arial"/>
+                          <a:ea typeface="Arial"/>
+                          <a:cs typeface="Arial"/>
+                        </a:rPr>
                         <a:t>Hybrid CP / DP</a:t>
                       </a:r>
                     </a:p>
@@ -35201,6 +35261,11 @@
                     <a:lstStyle/>
                     <a:p>
                       <a:r>
+                        <a:rPr>
+                          <a:latin typeface="Arial"/>
+                          <a:ea typeface="Arial"/>
+                          <a:cs typeface="Arial"/>
+                        </a:rPr>
                         <a:t>Google mgmt + K8s runtime</a:t>
                       </a:r>
                     </a:p>
@@ -35213,6 +35278,11 @@
                     <a:lstStyle/>
                     <a:p>
                       <a:r>
+                        <a:rPr>
+                          <a:latin typeface="Arial"/>
+                          <a:ea typeface="Arial"/>
+                          <a:cs typeface="Arial"/>
+                        </a:rPr>
                         <a:t>Managed or self-managed gateway</a:t>
                       </a:r>
                     </a:p>
@@ -35225,6 +35295,11 @@
                     <a:lstStyle/>
                     <a:p>
                       <a:r>
+                        <a:rPr>
+                          <a:latin typeface="Arial"/>
+                          <a:ea typeface="Arial"/>
+                          <a:cs typeface="Arial"/>
+                        </a:rPr>
                         <a:t>Custody + duty</a:t>
                       </a:r>
                     </a:p>
@@ -35244,6 +35319,11 @@
                     <a:lstStyle/>
                     <a:p>
                       <a:r>
+                        <a:rPr>
+                          <a:latin typeface="Arial"/>
+                          <a:ea typeface="Arial"/>
+                          <a:cs typeface="Arial"/>
+                        </a:rPr>
                         <a:t>Kubernetes / GitOps</a:t>
                       </a:r>
                     </a:p>
@@ -35256,6 +35336,11 @@
                     <a:lstStyle/>
                     <a:p>
                       <a:r>
+                        <a:rPr>
+                          <a:latin typeface="Arial"/>
+                          <a:ea typeface="Arial"/>
+                          <a:cs typeface="Arial"/>
+                        </a:rPr>
                         <a:t>Supplied: Excellent</a:t>
                       </a:r>
                     </a:p>
@@ -35268,6 +35353,11 @@
                     <a:lstStyle/>
                     <a:p>
                       <a:r>
+                        <a:rPr>
+                          <a:latin typeface="Arial"/>
+                          <a:ea typeface="Arial"/>
+                          <a:cs typeface="Arial"/>
+                        </a:rPr>
                         <a:t>Hybrid runtime / tools</a:t>
                       </a:r>
                     </a:p>
@@ -35280,6 +35370,11 @@
                     <a:lstStyle/>
                     <a:p>
                       <a:r>
+                        <a:rPr>
+                          <a:latin typeface="Arial"/>
+                          <a:ea typeface="Arial"/>
+                          <a:cs typeface="Arial"/>
+                        </a:rPr>
                         <a:t>Supplied: Good / Moderate</a:t>
                       </a:r>
                     </a:p>
@@ -35292,6 +35387,11 @@
                     <a:lstStyle/>
                     <a:p>
                       <a:r>
+                        <a:rPr>
+                          <a:latin typeface="Arial"/>
+                          <a:ea typeface="Arial"/>
+                          <a:cs typeface="Arial"/>
+                        </a:rPr>
                         <a:t>Versioned delivery proof</a:t>
                       </a:r>
                     </a:p>
@@ -35311,6 +35411,11 @@
                     <a:lstStyle/>
                     <a:p>
                       <a:r>
+                        <a:rPr>
+                          <a:latin typeface="Arial"/>
+                          <a:ea typeface="Arial"/>
+                          <a:cs typeface="Arial"/>
+                        </a:rPr>
                         <a:t>Observability</a:t>
                       </a:r>
                     </a:p>
@@ -35323,6 +35428,11 @@
                     <a:lstStyle/>
                     <a:p>
                       <a:r>
+                        <a:rPr>
+                          <a:latin typeface="Arial"/>
+                          <a:ea typeface="Arial"/>
+                          <a:cs typeface="Arial"/>
+                        </a:rPr>
                         <a:t>OTel / Prometheus</a:t>
                       </a:r>
                     </a:p>
@@ -35335,6 +35445,11 @@
                     <a:lstStyle/>
                     <a:p>
                       <a:r>
+                        <a:rPr>
+                          <a:latin typeface="Arial"/>
+                          <a:ea typeface="Arial"/>
+                          <a:cs typeface="Arial"/>
+                        </a:rPr>
                         <a:t>Analytics + monitoring</a:t>
                       </a:r>
                     </a:p>
@@ -35347,6 +35462,11 @@
                     <a:lstStyle/>
                     <a:p>
                       <a:r>
+                        <a:rPr>
+                          <a:latin typeface="Arial"/>
+                          <a:ea typeface="Arial"/>
+                          <a:cs typeface="Arial"/>
+                        </a:rPr>
                         <a:t>Anypoint monitoring</a:t>
                       </a:r>
                     </a:p>
@@ -35359,6 +35479,11 @@
                     <a:lstStyle/>
                     <a:p>
                       <a:r>
+                        <a:rPr>
+                          <a:latin typeface="Arial"/>
+                          <a:ea typeface="Arial"/>
+                          <a:cs typeface="Arial"/>
+                        </a:rPr>
                         <a:t>Export + custody test</a:t>
                       </a:r>
                     </a:p>
@@ -35378,6 +35503,11 @@
                     <a:lstStyle/>
                     <a:p>
                       <a:r>
+                        <a:rPr>
+                          <a:latin typeface="Arial"/>
+                          <a:ea typeface="Arial"/>
+                          <a:cs typeface="Arial"/>
+                        </a:rPr>
                         <a:t>Multicloud</a:t>
                       </a:r>
                     </a:p>
@@ -35390,6 +35520,11 @@
                     <a:lstStyle/>
                     <a:p>
                       <a:r>
+                        <a:rPr>
+                          <a:latin typeface="Arial"/>
+                          <a:ea typeface="Arial"/>
+                          <a:cs typeface="Arial"/>
+                        </a:rPr>
                         <a:t>Supplied: Excellent</a:t>
                       </a:r>
                     </a:p>
@@ -35402,6 +35537,11 @@
                     <a:lstStyle/>
                     <a:p>
                       <a:r>
+                        <a:rPr>
+                          <a:latin typeface="Arial"/>
+                          <a:ea typeface="Arial"/>
+                          <a:cs typeface="Arial"/>
+                        </a:rPr>
                         <a:t>Hybrid runtime</a:t>
                       </a:r>
                     </a:p>
@@ -35414,6 +35554,11 @@
                     <a:lstStyle/>
                     <a:p>
                       <a:r>
+                        <a:rPr>
+                          <a:latin typeface="Arial"/>
+                          <a:ea typeface="Arial"/>
+                          <a:cs typeface="Arial"/>
+                        </a:rPr>
                         <a:t>Supplied: Good</a:t>
                       </a:r>
                     </a:p>
@@ -35426,6 +35571,11 @@
                     <a:lstStyle/>
                     <a:p>
                       <a:r>
+                        <a:rPr>
+                          <a:latin typeface="Arial"/>
+                          <a:ea typeface="Arial"/>
+                          <a:cs typeface="Arial"/>
+                        </a:rPr>
                         <a:t>Placement + sovereignty</a:t>
                       </a:r>
                     </a:p>
@@ -35445,6 +35595,11 @@
                     <a:lstStyle/>
                     <a:p>
                       <a:r>
+                        <a:rPr>
+                          <a:latin typeface="Arial"/>
+                          <a:ea typeface="Arial"/>
+                          <a:cs typeface="Arial"/>
+                        </a:rPr>
                         <a:t>Scalability / robustness</a:t>
                       </a:r>
                     </a:p>
@@ -35457,6 +35612,11 @@
                     <a:lstStyle/>
                     <a:p>
                       <a:r>
+                        <a:rPr>
+                          <a:latin typeface="Arial"/>
+                          <a:ea typeface="Arial"/>
+                          <a:cs typeface="Arial"/>
+                        </a:rPr>
                         <a:t>Not supplied</a:t>
                       </a:r>
                     </a:p>
@@ -35469,6 +35629,11 @@
                     <a:lstStyle/>
                     <a:p>
                       <a:r>
+                        <a:rPr>
+                          <a:latin typeface="Arial"/>
+                          <a:ea typeface="Arial"/>
+                          <a:cs typeface="Arial"/>
+                        </a:rPr>
                         <a:t>Not supplied</a:t>
                       </a:r>
                     </a:p>
@@ -35481,6 +35646,11 @@
                     <a:lstStyle/>
                     <a:p>
                       <a:r>
+                        <a:rPr>
+                          <a:latin typeface="Arial"/>
+                          <a:ea typeface="Arial"/>
+                          <a:cs typeface="Arial"/>
+                        </a:rPr>
                         <a:t>Not supplied</a:t>
                       </a:r>
                     </a:p>
@@ -35493,6 +35663,11 @@
                     <a:lstStyle/>
                     <a:p>
                       <a:r>
+                        <a:rPr>
+                          <a:latin typeface="Arial"/>
+                          <a:ea typeface="Arial"/>
+                          <a:cs typeface="Arial"/>
+                        </a:rPr>
                         <a:t>Load + failure + recovery</a:t>
                       </a:r>
                     </a:p>
@@ -36026,6 +36201,11 @@
                     <a:lstStyle/>
                     <a:p>
                       <a:r>
+                        <a:rPr>
+                          <a:latin typeface="Arial"/>
+                          <a:ea typeface="Arial"/>
+                          <a:cs typeface="Arial"/>
+                        </a:rPr>
                         <a:t>Dimension</a:t>
                       </a:r>
                     </a:p>
@@ -36038,6 +36218,11 @@
                     <a:lstStyle/>
                     <a:p>
                       <a:r>
+                        <a:rPr>
+                          <a:latin typeface="Arial"/>
+                          <a:ea typeface="Arial"/>
+                          <a:cs typeface="Arial"/>
+                        </a:rPr>
                         <a:t>Kong</a:t>
                       </a:r>
                     </a:p>
@@ -36050,6 +36235,11 @@
                     <a:lstStyle/>
                     <a:p>
                       <a:r>
+                        <a:rPr>
+                          <a:latin typeface="Arial"/>
+                          <a:ea typeface="Arial"/>
+                          <a:cs typeface="Arial"/>
+                        </a:rPr>
                         <a:t>Apigee</a:t>
                       </a:r>
                     </a:p>
@@ -36062,6 +36252,11 @@
                     <a:lstStyle/>
                     <a:p>
                       <a:r>
+                        <a:rPr>
+                          <a:latin typeface="Arial"/>
+                          <a:ea typeface="Arial"/>
+                          <a:cs typeface="Arial"/>
+                        </a:rPr>
                         <a:t>MuleSoft</a:t>
                       </a:r>
                     </a:p>
@@ -36074,6 +36269,11 @@
                     <a:lstStyle/>
                     <a:p>
                       <a:r>
+                        <a:rPr>
+                          <a:latin typeface="Arial"/>
+                          <a:ea typeface="Arial"/>
+                          <a:cs typeface="Arial"/>
+                        </a:rPr>
                         <a:t>Evidence required</a:t>
                       </a:r>
                     </a:p>
@@ -36093,6 +36293,11 @@
                     <a:lstStyle/>
                     <a:p>
                       <a:r>
+                        <a:rPr>
+                          <a:latin typeface="Arial"/>
+                          <a:ea typeface="Arial"/>
+                          <a:cs typeface="Arial"/>
+                        </a:rPr>
                         <a:t>Lifecycle / governance</a:t>
                       </a:r>
                     </a:p>
@@ -36105,6 +36310,11 @@
                     <a:lstStyle/>
                     <a:p>
                       <a:r>
+                        <a:rPr>
+                          <a:latin typeface="Arial"/>
+                          <a:ea typeface="Arial"/>
+                          <a:cs typeface="Arial"/>
+                        </a:rPr>
                         <a:t>Supplied: Good</a:t>
                       </a:r>
                     </a:p>
@@ -36117,6 +36327,11 @@
                     <a:lstStyle/>
                     <a:p>
                       <a:r>
+                        <a:rPr>
+                          <a:latin typeface="Arial"/>
+                          <a:ea typeface="Arial"/>
+                          <a:cs typeface="Arial"/>
+                        </a:rPr>
                         <a:t>Supplied: Excellent</a:t>
                       </a:r>
                     </a:p>
@@ -36129,6 +36344,11 @@
                     <a:lstStyle/>
                     <a:p>
                       <a:r>
+                        <a:rPr>
+                          <a:latin typeface="Arial"/>
+                          <a:ea typeface="Arial"/>
+                          <a:cs typeface="Arial"/>
+                        </a:rPr>
                         <a:t>Supplied: Excellent</a:t>
                       </a:r>
                     </a:p>
@@ -36141,6 +36361,11 @@
                     <a:lstStyle/>
                     <a:p>
                       <a:r>
+                        <a:rPr>
+                          <a:latin typeface="Arial"/>
+                          <a:ea typeface="Arial"/>
+                          <a:cs typeface="Arial"/>
+                        </a:rPr>
                         <a:t>Required product use cases</a:t>
                       </a:r>
                     </a:p>
@@ -36160,6 +36385,11 @@
                     <a:lstStyle/>
                     <a:p>
                       <a:r>
+                        <a:rPr>
+                          <a:latin typeface="Arial"/>
+                          <a:ea typeface="Arial"/>
+                          <a:cs typeface="Arial"/>
+                        </a:rPr>
                         <a:t>Portal / product</a:t>
                       </a:r>
                     </a:p>
@@ -36172,6 +36402,11 @@
                     <a:lstStyle/>
                     <a:p>
                       <a:r>
+                        <a:rPr>
+                          <a:latin typeface="Arial"/>
+                          <a:ea typeface="Arial"/>
+                          <a:cs typeface="Arial"/>
+                        </a:rPr>
                         <a:t>Supplied: Good</a:t>
                       </a:r>
                     </a:p>
@@ -36184,6 +36419,11 @@
                     <a:lstStyle/>
                     <a:p>
                       <a:r>
+                        <a:rPr>
+                          <a:latin typeface="Arial"/>
+                          <a:ea typeface="Arial"/>
+                          <a:cs typeface="Arial"/>
+                        </a:rPr>
                         <a:t>Supplied: Excellent</a:t>
                       </a:r>
                     </a:p>
@@ -36196,6 +36436,11 @@
                     <a:lstStyle/>
                     <a:p>
                       <a:r>
+                        <a:rPr>
+                          <a:latin typeface="Arial"/>
+                          <a:ea typeface="Arial"/>
+                          <a:cs typeface="Arial"/>
+                        </a:rPr>
                         <a:t>Supplied: Excellent</a:t>
                       </a:r>
                     </a:p>
@@ -36208,6 +36453,11 @@
                     <a:lstStyle/>
                     <a:p>
                       <a:r>
+                        <a:rPr>
+                          <a:latin typeface="Arial"/>
+                          <a:ea typeface="Arial"/>
+                          <a:cs typeface="Arial"/>
+                        </a:rPr>
                         <a:t>Adjacent tooling map</a:t>
                       </a:r>
                     </a:p>
@@ -36227,6 +36477,11 @@
                     <a:lstStyle/>
                     <a:p>
                       <a:r>
+                        <a:rPr>
+                          <a:latin typeface="Arial"/>
+                          <a:ea typeface="Arial"/>
+                          <a:cs typeface="Arial"/>
+                        </a:rPr>
                         <a:t>Developer experience</a:t>
                       </a:r>
                     </a:p>
@@ -36239,6 +36494,11 @@
                     <a:lstStyle/>
                     <a:p>
                       <a:r>
+                        <a:rPr>
+                          <a:latin typeface="Arial"/>
+                          <a:ea typeface="Arial"/>
+                          <a:cs typeface="Arial"/>
+                        </a:rPr>
                         <a:t>Supplied: Good</a:t>
                       </a:r>
                     </a:p>
@@ -36251,6 +36511,11 @@
                     <a:lstStyle/>
                     <a:p>
                       <a:r>
+                        <a:rPr>
+                          <a:latin typeface="Arial"/>
+                          <a:ea typeface="Arial"/>
+                          <a:cs typeface="Arial"/>
+                        </a:rPr>
                         <a:t>Supplied: Very Strong</a:t>
                       </a:r>
                     </a:p>
@@ -36263,6 +36528,11 @@
                     <a:lstStyle/>
                     <a:p>
                       <a:r>
+                        <a:rPr>
+                          <a:latin typeface="Arial"/>
+                          <a:ea typeface="Arial"/>
+                          <a:cs typeface="Arial"/>
+                        </a:rPr>
                         <a:t>Supplied: Very Strong</a:t>
                       </a:r>
                     </a:p>
@@ -36275,6 +36545,11 @@
                     <a:lstStyle/>
                     <a:p>
                       <a:r>
+                        <a:rPr>
+                          <a:latin typeface="Arial"/>
+                          <a:ea typeface="Arial"/>
+                          <a:cs typeface="Arial"/>
+                        </a:rPr>
                         <a:t>Paved-road usability</a:t>
                       </a:r>
                     </a:p>
@@ -36294,6 +36569,11 @@
                     <a:lstStyle/>
                     <a:p>
                       <a:r>
+                        <a:rPr>
+                          <a:latin typeface="Arial"/>
+                          <a:ea typeface="Arial"/>
+                          <a:cs typeface="Arial"/>
+                        </a:rPr>
                         <a:t>AI traffic</a:t>
                       </a:r>
                     </a:p>
@@ -36306,6 +36586,11 @@
                     <a:lstStyle/>
                     <a:p>
                       <a:r>
+                        <a:rPr>
+                          <a:latin typeface="Arial"/>
+                          <a:ea typeface="Arial"/>
+                          <a:cs typeface="Arial"/>
+                        </a:rPr>
                         <a:t>AI Gateway incl. MCP/A2A</a:t>
                       </a:r>
                     </a:p>
@@ -36318,6 +36603,11 @@
                     <a:lstStyle/>
                     <a:p>
                       <a:r>
+                        <a:rPr>
+                          <a:latin typeface="Arial"/>
+                          <a:ea typeface="Arial"/>
+                          <a:cs typeface="Arial"/>
+                        </a:rPr>
                         <a:t>AI policy / GenAI features</a:t>
                       </a:r>
                     </a:p>
@@ -36330,6 +36620,11 @@
                     <a:lstStyle/>
                     <a:p>
                       <a:r>
+                        <a:rPr>
+                          <a:latin typeface="Arial"/>
+                          <a:ea typeface="Arial"/>
+                          <a:cs typeface="Arial"/>
+                        </a:rPr>
                         <a:t>MCP/A2A gateway traffic</a:t>
                       </a:r>
                     </a:p>
@@ -36342,6 +36637,11 @@
                     <a:lstStyle/>
                     <a:p>
                       <a:r>
+                        <a:rPr>
+                          <a:latin typeface="Arial"/>
+                          <a:ea typeface="Arial"/>
+                          <a:cs typeface="Arial"/>
+                        </a:rPr>
                         <a:t>Versioned use case</a:t>
                       </a:r>
                     </a:p>
@@ -36361,6 +36661,11 @@
                     <a:lstStyle/>
                     <a:p>
                       <a:r>
+                        <a:rPr>
+                          <a:latin typeface="Arial"/>
+                          <a:ea typeface="Arial"/>
+                          <a:cs typeface="Arial"/>
+                        </a:rPr>
                         <a:t>Customization</a:t>
                       </a:r>
                     </a:p>
@@ -36373,6 +36678,11 @@
                     <a:lstStyle/>
                     <a:p>
                       <a:r>
+                        <a:rPr>
+                          <a:latin typeface="Arial"/>
+                          <a:ea typeface="Arial"/>
+                          <a:cs typeface="Arial"/>
+                        </a:rPr>
                         <a:t>Plugin framework</a:t>
                       </a:r>
                     </a:p>
@@ -36385,6 +36695,11 @@
                     <a:lstStyle/>
                     <a:p>
                       <a:r>
+                        <a:rPr>
+                          <a:latin typeface="Arial"/>
+                          <a:ea typeface="Arial"/>
+                          <a:cs typeface="Arial"/>
+                        </a:rPr>
                         <a:t>Policy framework</a:t>
                       </a:r>
                     </a:p>
@@ -36397,6 +36712,11 @@
                     <a:lstStyle/>
                     <a:p>
                       <a:r>
+                        <a:rPr>
+                          <a:latin typeface="Arial"/>
+                          <a:ea typeface="Arial"/>
+                          <a:cs typeface="Arial"/>
+                        </a:rPr>
                         <a:t>Supplied: Moderate</a:t>
                       </a:r>
                     </a:p>
@@ -36409,6 +36729,11 @@
                     <a:lstStyle/>
                     <a:p>
                       <a:r>
+                        <a:rPr>
+                          <a:latin typeface="Arial"/>
+                          <a:ea typeface="Arial"/>
+                          <a:cs typeface="Arial"/>
+                        </a:rPr>
                         <a:t>Support + upgrade path</a:t>
                       </a:r>
                     </a:p>
@@ -36428,6 +36753,11 @@
                     <a:lstStyle/>
                     <a:p>
                       <a:r>
+                        <a:rPr>
+                          <a:latin typeface="Arial"/>
+                          <a:ea typeface="Arial"/>
+                          <a:cs typeface="Arial"/>
+                        </a:rPr>
                         <a:t>Traceable adjunct</a:t>
                       </a:r>
                     </a:p>
@@ -36440,6 +36770,11 @@
                     <a:lstStyle/>
                     <a:p>
                       <a:r>
+                        <a:rPr>
+                          <a:latin typeface="Arial"/>
+                          <a:ea typeface="Arial"/>
+                          <a:cs typeface="Arial"/>
+                        </a:rPr>
                         <a:t>Plugin → Platform Agent</a:t>
                       </a:r>
                     </a:p>
@@ -36452,6 +36787,11 @@
                     <a:lstStyle/>
                     <a:p>
                       <a:r>
+                        <a:rPr>
+                          <a:latin typeface="Arial"/>
+                          <a:ea typeface="Arial"/>
+                          <a:cs typeface="Arial"/>
+                        </a:rPr>
                         <a:t>Not assessed</a:t>
                       </a:r>
                     </a:p>
@@ -36464,6 +36804,11 @@
                     <a:lstStyle/>
                     <a:p>
                       <a:r>
+                        <a:rPr>
+                          <a:latin typeface="Arial"/>
+                          <a:ea typeface="Arial"/>
+                          <a:cs typeface="Arial"/>
+                        </a:rPr>
                         <a:t>Custom-policy baseline</a:t>
                       </a:r>
                     </a:p>
@@ -36476,6 +36821,11 @@
                     <a:lstStyle/>
                     <a:p>
                       <a:r>
+                        <a:rPr>
+                          <a:latin typeface="Arial"/>
+                          <a:ea typeface="Arial"/>
+                          <a:cs typeface="Arial"/>
+                        </a:rPr>
                         <a:t>Run GEP-07; do not score</a:t>
                       </a:r>
                     </a:p>
@@ -37013,6 +37363,9 @@
                           <a:solidFill>
                             <a:srgbClr val="111111"/>
                           </a:solidFill>
+                          <a:latin typeface="Arial"/>
+                          <a:ea typeface="Arial"/>
+                          <a:cs typeface="Arial"/>
                         </a:rPr>
                         <a:t>Dimension</a:t>
                       </a:r>
@@ -37030,6 +37383,9 @@
                           <a:solidFill>
                             <a:srgbClr val="111111"/>
                           </a:solidFill>
+                          <a:latin typeface="Arial"/>
+                          <a:ea typeface="Arial"/>
+                          <a:cs typeface="Arial"/>
                         </a:rPr>
                         <a:t>Kong</a:t>
                       </a:r>
@@ -37047,6 +37403,9 @@
                           <a:solidFill>
                             <a:srgbClr val="111111"/>
                           </a:solidFill>
+                          <a:latin typeface="Arial"/>
+                          <a:ea typeface="Arial"/>
+                          <a:cs typeface="Arial"/>
                         </a:rPr>
                         <a:t>Apigee</a:t>
                       </a:r>
@@ -37064,6 +37423,9 @@
                           <a:solidFill>
                             <a:srgbClr val="111111"/>
                           </a:solidFill>
+                          <a:latin typeface="Arial"/>
+                          <a:ea typeface="Arial"/>
+                          <a:cs typeface="Arial"/>
                         </a:rPr>
                         <a:t>MuleSoft</a:t>
                       </a:r>
@@ -37081,6 +37443,9 @@
                           <a:solidFill>
                             <a:srgbClr val="111111"/>
                           </a:solidFill>
+                          <a:latin typeface="Arial"/>
+                          <a:ea typeface="Arial"/>
+                          <a:cs typeface="Arial"/>
                         </a:rPr>
                         <a:t>Evidence required</a:t>
                       </a:r>
@@ -37101,6 +37466,11 @@
                     <a:lstStyle/>
                     <a:p>
                       <a:r>
+                        <a:rPr>
+                          <a:latin typeface="Arial"/>
+                          <a:ea typeface="Arial"/>
+                          <a:cs typeface="Arial"/>
+                        </a:rPr>
                         <a:t>Reversibility / lock-in</a:t>
                       </a:r>
                     </a:p>
@@ -37113,6 +37483,11 @@
                     <a:lstStyle/>
                     <a:p>
                       <a:r>
+                        <a:rPr>
+                          <a:latin typeface="Arial"/>
+                          <a:ea typeface="Arial"/>
+                          <a:cs typeface="Arial"/>
+                        </a:rPr>
                         <a:t>Supplied: Low</a:t>
                       </a:r>
                     </a:p>
@@ -37125,6 +37500,11 @@
                     <a:lstStyle/>
                     <a:p>
                       <a:r>
+                        <a:rPr>
+                          <a:latin typeface="Arial"/>
+                          <a:ea typeface="Arial"/>
+                          <a:cs typeface="Arial"/>
+                        </a:rPr>
                         <a:t>Supplied: Medium</a:t>
                       </a:r>
                     </a:p>
@@ -37137,6 +37517,11 @@
                     <a:lstStyle/>
                     <a:p>
                       <a:r>
+                        <a:rPr>
+                          <a:latin typeface="Arial"/>
+                          <a:ea typeface="Arial"/>
+                          <a:cs typeface="Arial"/>
+                        </a:rPr>
                         <a:t>Supplied: High</a:t>
                       </a:r>
                     </a:p>
@@ -37149,6 +37534,11 @@
                     <a:lstStyle/>
                     <a:p>
                       <a:r>
+                        <a:rPr>
+                          <a:latin typeface="Arial"/>
+                          <a:ea typeface="Arial"/>
+                          <a:cs typeface="Arial"/>
+                        </a:rPr>
                         <a:t>Timed rebuild + route-back</a:t>
                       </a:r>
                     </a:p>
@@ -37168,6 +37558,11 @@
                     <a:lstStyle/>
                     <a:p>
                       <a:r>
+                        <a:rPr>
+                          <a:latin typeface="Arial"/>
+                          <a:ea typeface="Arial"/>
+                          <a:cs typeface="Arial"/>
+                        </a:rPr>
                         <a:t>Full TCO / pricing</a:t>
                       </a:r>
                     </a:p>
@@ -37180,6 +37575,11 @@
                     <a:lstStyle/>
                     <a:p>
                       <a:r>
+                        <a:rPr>
+                          <a:latin typeface="Arial"/>
+                          <a:ea typeface="Arial"/>
+                          <a:cs typeface="Arial"/>
+                        </a:rPr>
                         <a:t>Custom quote</a:t>
                       </a:r>
                     </a:p>
@@ -37192,6 +37592,11 @@
                     <a:lstStyle/>
                     <a:p>
                       <a:r>
+                        <a:rPr>
+                          <a:latin typeface="Arial"/>
+                          <a:ea typeface="Arial"/>
+                          <a:cs typeface="Arial"/>
+                        </a:rPr>
                         <a:t>Managed PAYG ≠ Hybrid</a:t>
                       </a:r>
                     </a:p>
@@ -37204,6 +37609,11 @@
                     <a:lstStyle/>
                     <a:p>
                       <a:r>
+                        <a:rPr>
+                          <a:latin typeface="Arial"/>
+                          <a:ea typeface="Arial"/>
+                          <a:cs typeface="Arial"/>
+                        </a:rPr>
                         <a:t>Contact sales</a:t>
                       </a:r>
                     </a:p>
@@ -37216,6 +37626,11 @@
                     <a:lstStyle/>
                     <a:p>
                       <a:r>
+                        <a:rPr>
+                          <a:latin typeface="Arial"/>
+                          <a:ea typeface="Arial"/>
+                          <a:cs typeface="Arial"/>
+                        </a:rPr>
                         <a:t>Quote + labor + infra + HA/DR + adjunct + exit</a:t>
                       </a:r>
                     </a:p>
@@ -37235,6 +37650,11 @@
                     <a:lstStyle/>
                     <a:p>
                       <a:r>
+                        <a:rPr>
+                          <a:latin typeface="Arial"/>
+                          <a:ea typeface="Arial"/>
+                          <a:cs typeface="Arial"/>
+                        </a:rPr>
                         <a:t>Control-plane duty</a:t>
                       </a:r>
                     </a:p>
@@ -37247,6 +37667,11 @@
                     <a:lstStyle/>
                     <a:p>
                       <a:r>
+                        <a:rPr>
+                          <a:latin typeface="Arial"/>
+                          <a:ea typeface="Arial"/>
+                          <a:cs typeface="Arial"/>
+                        </a:rPr>
                         <a:t>Enterprise CP + Postgres</a:t>
                       </a:r>
                     </a:p>
@@ -37259,6 +37684,11 @@
                     <a:lstStyle/>
                     <a:p>
                       <a:r>
+                        <a:rPr>
+                          <a:latin typeface="Arial"/>
+                          <a:ea typeface="Arial"/>
+                          <a:cs typeface="Arial"/>
+                        </a:rPr>
                         <a:t>Google mgmt + own runtime</a:t>
                       </a:r>
                     </a:p>
@@ -37271,6 +37701,11 @@
                     <a:lstStyle/>
                     <a:p>
                       <a:r>
+                        <a:rPr>
+                          <a:latin typeface="Arial"/>
+                          <a:ea typeface="Arial"/>
+                          <a:cs typeface="Arial"/>
+                        </a:rPr>
                         <a:t>Boundary-dependent</a:t>
                       </a:r>
                     </a:p>
@@ -37283,6 +37718,11 @@
                     <a:lstStyle/>
                     <a:p>
                       <a:r>
+                        <a:rPr>
+                          <a:latin typeface="Arial"/>
+                          <a:ea typeface="Arial"/>
+                          <a:cs typeface="Arial"/>
+                        </a:rPr>
                         <a:t>Funded RACI + support + recovery + on-call</a:t>
                       </a:r>
                     </a:p>
@@ -37913,6 +38353,11 @@
                     <a:lstStyle/>
                     <a:p>
                       <a:r>
+                        <a:rPr>
+                          <a:latin typeface="Arial"/>
+                          <a:ea typeface="Arial"/>
+                          <a:cs typeface="Arial"/>
+                        </a:rPr>
                         <a:t>Category</a:t>
                       </a:r>
                     </a:p>
@@ -37925,6 +38370,11 @@
                     <a:lstStyle/>
                     <a:p>
                       <a:r>
+                        <a:rPr>
+                          <a:latin typeface="Arial"/>
+                          <a:ea typeface="Arial"/>
+                          <a:cs typeface="Arial"/>
+                        </a:rPr>
                         <a:t>Weight</a:t>
                       </a:r>
                     </a:p>
@@ -37937,6 +38387,11 @@
                     <a:lstStyle/>
                     <a:p>
                       <a:r>
+                        <a:rPr>
+                          <a:latin typeface="Arial"/>
+                          <a:ea typeface="Arial"/>
+                          <a:cs typeface="Arial"/>
+                        </a:rPr>
                         <a:t>Kong</a:t>
                       </a:r>
                     </a:p>
@@ -37949,6 +38404,11 @@
                     <a:lstStyle/>
                     <a:p>
                       <a:r>
+                        <a:rPr>
+                          <a:latin typeface="Arial"/>
+                          <a:ea typeface="Arial"/>
+                          <a:cs typeface="Arial"/>
+                        </a:rPr>
                         <a:t>Apigee</a:t>
                       </a:r>
                     </a:p>
@@ -37961,6 +38421,11 @@
                     <a:lstStyle/>
                     <a:p>
                       <a:r>
+                        <a:rPr>
+                          <a:latin typeface="Arial"/>
+                          <a:ea typeface="Arial"/>
+                          <a:cs typeface="Arial"/>
+                        </a:rPr>
                         <a:t>MuleSoft</a:t>
                       </a:r>
                     </a:p>
@@ -37980,6 +38445,11 @@
                     <a:lstStyle/>
                     <a:p>
                       <a:r>
+                        <a:rPr>
+                          <a:latin typeface="Arial"/>
+                          <a:ea typeface="Arial"/>
+                          <a:cs typeface="Arial"/>
+                        </a:rPr>
                         <a:t>Kubernetes &amp; cloud native</a:t>
                       </a:r>
                     </a:p>
@@ -37992,6 +38462,11 @@
                     <a:lstStyle/>
                     <a:p>
                       <a:r>
+                        <a:rPr>
+                          <a:latin typeface="Arial"/>
+                          <a:ea typeface="Arial"/>
+                          <a:cs typeface="Arial"/>
+                        </a:rPr>
                         <a:t>20%</a:t>
                       </a:r>
                     </a:p>
@@ -38004,6 +38479,11 @@
                     <a:lstStyle/>
                     <a:p>
                       <a:r>
+                        <a:rPr>
+                          <a:latin typeface="Arial"/>
+                          <a:ea typeface="Arial"/>
+                          <a:cs typeface="Arial"/>
+                        </a:rPr>
                         <a:t>10</a:t>
                       </a:r>
                     </a:p>
@@ -38016,6 +38496,11 @@
                     <a:lstStyle/>
                     <a:p>
                       <a:r>
+                        <a:rPr>
+                          <a:latin typeface="Arial"/>
+                          <a:ea typeface="Arial"/>
+                          <a:cs typeface="Arial"/>
+                        </a:rPr>
                         <a:t>8</a:t>
                       </a:r>
                     </a:p>
@@ -38028,6 +38513,11 @@
                     <a:lstStyle/>
                     <a:p>
                       <a:r>
+                        <a:rPr>
+                          <a:latin typeface="Arial"/>
+                          <a:ea typeface="Arial"/>
+                          <a:cs typeface="Arial"/>
+                        </a:rPr>
                         <a:t>7</a:t>
                       </a:r>
                     </a:p>
@@ -38047,6 +38537,11 @@
                     <a:lstStyle/>
                     <a:p>
                       <a:r>
+                        <a:rPr>
+                          <a:latin typeface="Arial"/>
+                          <a:ea typeface="Arial"/>
+                          <a:cs typeface="Arial"/>
+                        </a:rPr>
                         <a:t>GitOps &amp; DevOps</a:t>
                       </a:r>
                     </a:p>
@@ -38059,6 +38554,11 @@
                     <a:lstStyle/>
                     <a:p>
                       <a:r>
+                        <a:rPr>
+                          <a:latin typeface="Arial"/>
+                          <a:ea typeface="Arial"/>
+                          <a:cs typeface="Arial"/>
+                        </a:rPr>
                         <a:t>15%</a:t>
                       </a:r>
                     </a:p>
@@ -38071,6 +38571,11 @@
                     <a:lstStyle/>
                     <a:p>
                       <a:r>
+                        <a:rPr>
+                          <a:latin typeface="Arial"/>
+                          <a:ea typeface="Arial"/>
+                          <a:cs typeface="Arial"/>
+                        </a:rPr>
                         <a:t>10</a:t>
                       </a:r>
                     </a:p>
@@ -38083,6 +38588,11 @@
                     <a:lstStyle/>
                     <a:p>
                       <a:r>
+                        <a:rPr>
+                          <a:latin typeface="Arial"/>
+                          <a:ea typeface="Arial"/>
+                          <a:cs typeface="Arial"/>
+                        </a:rPr>
                         <a:t>7</a:t>
                       </a:r>
                     </a:p>
@@ -38095,6 +38605,11 @@
                     <a:lstStyle/>
                     <a:p>
                       <a:r>
+                        <a:rPr>
+                          <a:latin typeface="Arial"/>
+                          <a:ea typeface="Arial"/>
+                          <a:cs typeface="Arial"/>
+                        </a:rPr>
                         <a:t>6</a:t>
                       </a:r>
                     </a:p>
@@ -38114,6 +38629,11 @@
                     <a:lstStyle/>
                     <a:p>
                       <a:r>
+                        <a:rPr>
+                          <a:latin typeface="Arial"/>
+                          <a:ea typeface="Arial"/>
+                          <a:cs typeface="Arial"/>
+                        </a:rPr>
                         <a:t>API management</a:t>
                       </a:r>
                     </a:p>
@@ -38126,6 +38646,11 @@
                     <a:lstStyle/>
                     <a:p>
                       <a:r>
+                        <a:rPr>
+                          <a:latin typeface="Arial"/>
+                          <a:ea typeface="Arial"/>
+                          <a:cs typeface="Arial"/>
+                        </a:rPr>
                         <a:t>15%</a:t>
                       </a:r>
                     </a:p>
@@ -38138,6 +38663,11 @@
                     <a:lstStyle/>
                     <a:p>
                       <a:r>
+                        <a:rPr>
+                          <a:latin typeface="Arial"/>
+                          <a:ea typeface="Arial"/>
+                          <a:cs typeface="Arial"/>
+                        </a:rPr>
                         <a:t>8</a:t>
                       </a:r>
                     </a:p>
@@ -38150,6 +38680,11 @@
                     <a:lstStyle/>
                     <a:p>
                       <a:r>
+                        <a:rPr>
+                          <a:latin typeface="Arial"/>
+                          <a:ea typeface="Arial"/>
+                          <a:cs typeface="Arial"/>
+                        </a:rPr>
                         <a:t>10</a:t>
                       </a:r>
                     </a:p>
@@ -38162,6 +38697,11 @@
                     <a:lstStyle/>
                     <a:p>
                       <a:r>
+                        <a:rPr>
+                          <a:latin typeface="Arial"/>
+                          <a:ea typeface="Arial"/>
+                          <a:cs typeface="Arial"/>
+                        </a:rPr>
                         <a:t>10</a:t>
                       </a:r>
                     </a:p>
@@ -38181,6 +38721,11 @@
                     <a:lstStyle/>
                     <a:p>
                       <a:r>
+                        <a:rPr>
+                          <a:latin typeface="Arial"/>
+                          <a:ea typeface="Arial"/>
+                          <a:cs typeface="Arial"/>
+                        </a:rPr>
                         <a:t>API governance</a:t>
                       </a:r>
                     </a:p>
@@ -38193,6 +38738,11 @@
                     <a:lstStyle/>
                     <a:p>
                       <a:r>
+                        <a:rPr>
+                          <a:latin typeface="Arial"/>
+                          <a:ea typeface="Arial"/>
+                          <a:cs typeface="Arial"/>
+                        </a:rPr>
                         <a:t>10%</a:t>
                       </a:r>
                     </a:p>
@@ -38205,6 +38755,11 @@
                     <a:lstStyle/>
                     <a:p>
                       <a:r>
+                        <a:rPr>
+                          <a:latin typeface="Arial"/>
+                          <a:ea typeface="Arial"/>
+                          <a:cs typeface="Arial"/>
+                        </a:rPr>
                         <a:t>8</a:t>
                       </a:r>
                     </a:p>
@@ -38217,6 +38772,11 @@
                     <a:lstStyle/>
                     <a:p>
                       <a:r>
+                        <a:rPr>
+                          <a:latin typeface="Arial"/>
+                          <a:ea typeface="Arial"/>
+                          <a:cs typeface="Arial"/>
+                        </a:rPr>
                         <a:t>10</a:t>
                       </a:r>
                     </a:p>
@@ -38229,6 +38789,11 @@
                     <a:lstStyle/>
                     <a:p>
                       <a:r>
+                        <a:rPr>
+                          <a:latin typeface="Arial"/>
+                          <a:ea typeface="Arial"/>
+                          <a:cs typeface="Arial"/>
+                        </a:rPr>
                         <a:t>10</a:t>
                       </a:r>
                     </a:p>
@@ -38248,6 +38813,11 @@
                     <a:lstStyle/>
                     <a:p>
                       <a:r>
+                        <a:rPr>
+                          <a:latin typeface="Arial"/>
+                          <a:ea typeface="Arial"/>
+                          <a:cs typeface="Arial"/>
+                        </a:rPr>
                         <a:t>Security &amp; compliance</a:t>
                       </a:r>
                     </a:p>
@@ -38260,6 +38830,11 @@
                     <a:lstStyle/>
                     <a:p>
                       <a:r>
+                        <a:rPr>
+                          <a:latin typeface="Arial"/>
+                          <a:ea typeface="Arial"/>
+                          <a:cs typeface="Arial"/>
+                        </a:rPr>
                         <a:t>10%</a:t>
                       </a:r>
                     </a:p>
@@ -38272,6 +38847,11 @@
                     <a:lstStyle/>
                     <a:p>
                       <a:r>
+                        <a:rPr>
+                          <a:latin typeface="Arial"/>
+                          <a:ea typeface="Arial"/>
+                          <a:cs typeface="Arial"/>
+                        </a:rPr>
                         <a:t>9</a:t>
                       </a:r>
                     </a:p>
@@ -38284,6 +38864,11 @@
                     <a:lstStyle/>
                     <a:p>
                       <a:r>
+                        <a:rPr>
+                          <a:latin typeface="Arial"/>
+                          <a:ea typeface="Arial"/>
+                          <a:cs typeface="Arial"/>
+                        </a:rPr>
                         <a:t>10</a:t>
                       </a:r>
                     </a:p>
@@ -38296,6 +38881,11 @@
                     <a:lstStyle/>
                     <a:p>
                       <a:r>
+                        <a:rPr>
+                          <a:latin typeface="Arial"/>
+                          <a:ea typeface="Arial"/>
+                          <a:cs typeface="Arial"/>
+                        </a:rPr>
                         <a:t>9</a:t>
                       </a:r>
                     </a:p>
@@ -38315,6 +38905,11 @@
                     <a:lstStyle/>
                     <a:p>
                       <a:r>
+                        <a:rPr>
+                          <a:latin typeface="Arial"/>
+                          <a:ea typeface="Arial"/>
+                          <a:cs typeface="Arial"/>
+                        </a:rPr>
                         <a:t>Observability</a:t>
                       </a:r>
                     </a:p>
@@ -38327,6 +38922,11 @@
                     <a:lstStyle/>
                     <a:p>
                       <a:r>
+                        <a:rPr>
+                          <a:latin typeface="Arial"/>
+                          <a:ea typeface="Arial"/>
+                          <a:cs typeface="Arial"/>
+                        </a:rPr>
                         <a:t>10%</a:t>
                       </a:r>
                     </a:p>
@@ -38339,6 +38939,11 @@
                     <a:lstStyle/>
                     <a:p>
                       <a:r>
+                        <a:rPr>
+                          <a:latin typeface="Arial"/>
+                          <a:ea typeface="Arial"/>
+                          <a:cs typeface="Arial"/>
+                        </a:rPr>
                         <a:t>9</a:t>
                       </a:r>
                     </a:p>
@@ -38351,6 +38956,11 @@
                     <a:lstStyle/>
                     <a:p>
                       <a:r>
+                        <a:rPr>
+                          <a:latin typeface="Arial"/>
+                          <a:ea typeface="Arial"/>
+                          <a:cs typeface="Arial"/>
+                        </a:rPr>
                         <a:t>9</a:t>
                       </a:r>
                     </a:p>
@@ -38363,6 +38973,11 @@
                     <a:lstStyle/>
                     <a:p>
                       <a:r>
+                        <a:rPr>
+                          <a:latin typeface="Arial"/>
+                          <a:ea typeface="Arial"/>
+                          <a:cs typeface="Arial"/>
+                        </a:rPr>
                         <a:t>8</a:t>
                       </a:r>
                     </a:p>
@@ -38382,6 +38997,11 @@
                     <a:lstStyle/>
                     <a:p>
                       <a:r>
+                        <a:rPr>
+                          <a:latin typeface="Arial"/>
+                          <a:ea typeface="Arial"/>
+                          <a:cs typeface="Arial"/>
+                        </a:rPr>
                         <a:t>AI gateway readiness</a:t>
                       </a:r>
                     </a:p>
@@ -38394,6 +39014,11 @@
                     <a:lstStyle/>
                     <a:p>
                       <a:r>
+                        <a:rPr>
+                          <a:latin typeface="Arial"/>
+                          <a:ea typeface="Arial"/>
+                          <a:cs typeface="Arial"/>
+                        </a:rPr>
                         <a:t>10%</a:t>
                       </a:r>
                     </a:p>
@@ -38406,6 +39031,11 @@
                     <a:lstStyle/>
                     <a:p>
                       <a:r>
+                        <a:rPr>
+                          <a:latin typeface="Arial"/>
+                          <a:ea typeface="Arial"/>
+                          <a:cs typeface="Arial"/>
+                        </a:rPr>
                         <a:t>10</a:t>
                       </a:r>
                     </a:p>
@@ -38418,6 +39048,11 @@
                     <a:lstStyle/>
                     <a:p>
                       <a:r>
+                        <a:rPr>
+                          <a:latin typeface="Arial"/>
+                          <a:ea typeface="Arial"/>
+                          <a:cs typeface="Arial"/>
+                        </a:rPr>
                         <a:t>8</a:t>
                       </a:r>
                     </a:p>
@@ -38430,6 +39065,11 @@
                     <a:lstStyle/>
                     <a:p>
                       <a:r>
+                        <a:rPr>
+                          <a:latin typeface="Arial"/>
+                          <a:ea typeface="Arial"/>
+                          <a:cs typeface="Arial"/>
+                        </a:rPr>
                         <a:t>7</a:t>
                       </a:r>
                     </a:p>
@@ -38449,6 +39089,11 @@
                     <a:lstStyle/>
                     <a:p>
                       <a:r>
+                        <a:rPr>
+                          <a:latin typeface="Arial"/>
+                          <a:ea typeface="Arial"/>
+                          <a:cs typeface="Arial"/>
+                        </a:rPr>
                         <a:t>Cost efficiency</a:t>
                       </a:r>
                     </a:p>
@@ -38461,6 +39106,11 @@
                     <a:lstStyle/>
                     <a:p>
                       <a:r>
+                        <a:rPr>
+                          <a:latin typeface="Arial"/>
+                          <a:ea typeface="Arial"/>
+                          <a:cs typeface="Arial"/>
+                        </a:rPr>
                         <a:t>10%</a:t>
                       </a:r>
                     </a:p>
@@ -38473,6 +39123,11 @@
                     <a:lstStyle/>
                     <a:p>
                       <a:r>
+                        <a:rPr>
+                          <a:latin typeface="Arial"/>
+                          <a:ea typeface="Arial"/>
+                          <a:cs typeface="Arial"/>
+                        </a:rPr>
                         <a:t>10</a:t>
                       </a:r>
                     </a:p>
@@ -38485,6 +39140,11 @@
                     <a:lstStyle/>
                     <a:p>
                       <a:r>
+                        <a:rPr>
+                          <a:latin typeface="Arial"/>
+                          <a:ea typeface="Arial"/>
+                          <a:cs typeface="Arial"/>
+                        </a:rPr>
                         <a:t>7</a:t>
                       </a:r>
                     </a:p>
@@ -38497,6 +39157,11 @@
                     <a:lstStyle/>
                     <a:p>
                       <a:r>
+                        <a:rPr>
+                          <a:latin typeface="Arial"/>
+                          <a:ea typeface="Arial"/>
+                          <a:cs typeface="Arial"/>
+                        </a:rPr>
                         <a:t>5</a:t>
                       </a:r>
                     </a:p>

</xml_diff>

<commit_message>
Rebase guided-deck review follow-ups onto current main
Linearized candidate: the guided-deck review corrections (canonical
operating boundaries and custody-fit duties on KGE-07/08, canonical
docs/47 outcome names and outcome cards on KGE-19/20, figure-contract
takeaway text, scroll-cue and keyboard-ownership gate, portal-link
origin guard, PowerPoint appendix 14pt pin with re-pinned allowlist
hash) replayed on top of main after PRs #26-#28 (guided speaker
scripts, overview evidence status, speaker-note readability).
reports/validation-report.md reconciled with the merged tree: main's
120-test workflow-regression-suite row kept, study words re-measured at
192,768 and links at 667. Content is byte-identical to the tree that
passed make validate (120 tests OK).

Co-Authored-By: Claude Fable 5 <noreply@anthropic.com>
</commit_message>
<xml_diff>
--- a/presentations/kong-platform-journey-guided.pptx
+++ b/presentations/kong-platform-journey-guided.pptx
@@ -35043,7 +35043,7 @@
                     <a:lstStyle/>
                     <a:p>
                       <a:r>
-                        <a:rPr>
+                        <a:rPr sz="1400">
                           <a:latin typeface="Arial"/>
                           <a:ea typeface="Arial"/>
                           <a:cs typeface="Arial"/>
@@ -35060,7 +35060,7 @@
                     <a:lstStyle/>
                     <a:p>
                       <a:r>
-                        <a:rPr>
+                        <a:rPr sz="1400">
                           <a:latin typeface="Arial"/>
                           <a:ea typeface="Arial"/>
                           <a:cs typeface="Arial"/>
@@ -35077,7 +35077,7 @@
                     <a:lstStyle/>
                     <a:p>
                       <a:r>
-                        <a:rPr>
+                        <a:rPr sz="1400">
                           <a:latin typeface="Arial"/>
                           <a:ea typeface="Arial"/>
                           <a:cs typeface="Arial"/>
@@ -35094,7 +35094,7 @@
                     <a:lstStyle/>
                     <a:p>
                       <a:r>
-                        <a:rPr>
+                        <a:rPr sz="1400">
                           <a:latin typeface="Arial"/>
                           <a:ea typeface="Arial"/>
                           <a:cs typeface="Arial"/>
@@ -35111,7 +35111,7 @@
                     <a:lstStyle/>
                     <a:p>
                       <a:r>
-                        <a:rPr>
+                        <a:rPr sz="1400">
                           <a:latin typeface="Arial"/>
                           <a:ea typeface="Arial"/>
                           <a:cs typeface="Arial"/>
@@ -35135,7 +35135,7 @@
                     <a:lstStyle/>
                     <a:p>
                       <a:r>
-                        <a:rPr>
+                        <a:rPr sz="1400">
                           <a:latin typeface="Arial"/>
                           <a:ea typeface="Arial"/>
                           <a:cs typeface="Arial"/>
@@ -35152,7 +35152,7 @@
                     <a:lstStyle/>
                     <a:p>
                       <a:r>
-                        <a:rPr>
+                        <a:rPr sz="1400">
                           <a:latin typeface="Arial"/>
                           <a:ea typeface="Arial"/>
                           <a:cs typeface="Arial"/>
@@ -35169,7 +35169,7 @@
                     <a:lstStyle/>
                     <a:p>
                       <a:r>
-                        <a:rPr>
+                        <a:rPr sz="1400">
                           <a:latin typeface="Arial"/>
                           <a:ea typeface="Arial"/>
                           <a:cs typeface="Arial"/>
@@ -35186,7 +35186,7 @@
                     <a:lstStyle/>
                     <a:p>
                       <a:r>
-                        <a:rPr>
+                        <a:rPr sz="1400">
                           <a:latin typeface="Arial"/>
                           <a:ea typeface="Arial"/>
                           <a:cs typeface="Arial"/>
@@ -35203,7 +35203,7 @@
                     <a:lstStyle/>
                     <a:p>
                       <a:r>
-                        <a:rPr>
+                        <a:rPr sz="1400">
                           <a:latin typeface="Arial"/>
                           <a:ea typeface="Arial"/>
                           <a:cs typeface="Arial"/>
@@ -35227,7 +35227,7 @@
                     <a:lstStyle/>
                     <a:p>
                       <a:r>
-                        <a:rPr>
+                        <a:rPr sz="1400">
                           <a:latin typeface="Arial"/>
                           <a:ea typeface="Arial"/>
                           <a:cs typeface="Arial"/>
@@ -35244,7 +35244,7 @@
                     <a:lstStyle/>
                     <a:p>
                       <a:r>
-                        <a:rPr>
+                        <a:rPr sz="1400">
                           <a:latin typeface="Arial"/>
                           <a:ea typeface="Arial"/>
                           <a:cs typeface="Arial"/>
@@ -35261,7 +35261,7 @@
                     <a:lstStyle/>
                     <a:p>
                       <a:r>
-                        <a:rPr>
+                        <a:rPr sz="1400">
                           <a:latin typeface="Arial"/>
                           <a:ea typeface="Arial"/>
                           <a:cs typeface="Arial"/>
@@ -35278,7 +35278,7 @@
                     <a:lstStyle/>
                     <a:p>
                       <a:r>
-                        <a:rPr>
+                        <a:rPr sz="1400">
                           <a:latin typeface="Arial"/>
                           <a:ea typeface="Arial"/>
                           <a:cs typeface="Arial"/>
@@ -35295,7 +35295,7 @@
                     <a:lstStyle/>
                     <a:p>
                       <a:r>
-                        <a:rPr>
+                        <a:rPr sz="1400">
                           <a:latin typeface="Arial"/>
                           <a:ea typeface="Arial"/>
                           <a:cs typeface="Arial"/>
@@ -35319,7 +35319,7 @@
                     <a:lstStyle/>
                     <a:p>
                       <a:r>
-                        <a:rPr>
+                        <a:rPr sz="1400">
                           <a:latin typeface="Arial"/>
                           <a:ea typeface="Arial"/>
                           <a:cs typeface="Arial"/>
@@ -35336,7 +35336,7 @@
                     <a:lstStyle/>
                     <a:p>
                       <a:r>
-                        <a:rPr>
+                        <a:rPr sz="1400">
                           <a:latin typeface="Arial"/>
                           <a:ea typeface="Arial"/>
                           <a:cs typeface="Arial"/>
@@ -35353,7 +35353,7 @@
                     <a:lstStyle/>
                     <a:p>
                       <a:r>
-                        <a:rPr>
+                        <a:rPr sz="1400">
                           <a:latin typeface="Arial"/>
                           <a:ea typeface="Arial"/>
                           <a:cs typeface="Arial"/>
@@ -35370,7 +35370,7 @@
                     <a:lstStyle/>
                     <a:p>
                       <a:r>
-                        <a:rPr>
+                        <a:rPr sz="1400">
                           <a:latin typeface="Arial"/>
                           <a:ea typeface="Arial"/>
                           <a:cs typeface="Arial"/>
@@ -35387,7 +35387,7 @@
                     <a:lstStyle/>
                     <a:p>
                       <a:r>
-                        <a:rPr>
+                        <a:rPr sz="1400">
                           <a:latin typeface="Arial"/>
                           <a:ea typeface="Arial"/>
                           <a:cs typeface="Arial"/>
@@ -35411,7 +35411,7 @@
                     <a:lstStyle/>
                     <a:p>
                       <a:r>
-                        <a:rPr>
+                        <a:rPr sz="1400">
                           <a:latin typeface="Arial"/>
                           <a:ea typeface="Arial"/>
                           <a:cs typeface="Arial"/>
@@ -35428,7 +35428,7 @@
                     <a:lstStyle/>
                     <a:p>
                       <a:r>
-                        <a:rPr>
+                        <a:rPr sz="1400">
                           <a:latin typeface="Arial"/>
                           <a:ea typeface="Arial"/>
                           <a:cs typeface="Arial"/>
@@ -35445,7 +35445,7 @@
                     <a:lstStyle/>
                     <a:p>
                       <a:r>
-                        <a:rPr>
+                        <a:rPr sz="1400">
                           <a:latin typeface="Arial"/>
                           <a:ea typeface="Arial"/>
                           <a:cs typeface="Arial"/>
@@ -35462,7 +35462,7 @@
                     <a:lstStyle/>
                     <a:p>
                       <a:r>
-                        <a:rPr>
+                        <a:rPr sz="1400">
                           <a:latin typeface="Arial"/>
                           <a:ea typeface="Arial"/>
                           <a:cs typeface="Arial"/>
@@ -35479,7 +35479,7 @@
                     <a:lstStyle/>
                     <a:p>
                       <a:r>
-                        <a:rPr>
+                        <a:rPr sz="1400">
                           <a:latin typeface="Arial"/>
                           <a:ea typeface="Arial"/>
                           <a:cs typeface="Arial"/>
@@ -35503,7 +35503,7 @@
                     <a:lstStyle/>
                     <a:p>
                       <a:r>
-                        <a:rPr>
+                        <a:rPr sz="1400">
                           <a:latin typeface="Arial"/>
                           <a:ea typeface="Arial"/>
                           <a:cs typeface="Arial"/>
@@ -35520,7 +35520,7 @@
                     <a:lstStyle/>
                     <a:p>
                       <a:r>
-                        <a:rPr>
+                        <a:rPr sz="1400">
                           <a:latin typeface="Arial"/>
                           <a:ea typeface="Arial"/>
                           <a:cs typeface="Arial"/>
@@ -35537,7 +35537,7 @@
                     <a:lstStyle/>
                     <a:p>
                       <a:r>
-                        <a:rPr>
+                        <a:rPr sz="1400">
                           <a:latin typeface="Arial"/>
                           <a:ea typeface="Arial"/>
                           <a:cs typeface="Arial"/>
@@ -35554,7 +35554,7 @@
                     <a:lstStyle/>
                     <a:p>
                       <a:r>
-                        <a:rPr>
+                        <a:rPr sz="1400">
                           <a:latin typeface="Arial"/>
                           <a:ea typeface="Arial"/>
                           <a:cs typeface="Arial"/>
@@ -35571,7 +35571,7 @@
                     <a:lstStyle/>
                     <a:p>
                       <a:r>
-                        <a:rPr>
+                        <a:rPr sz="1400">
                           <a:latin typeface="Arial"/>
                           <a:ea typeface="Arial"/>
                           <a:cs typeface="Arial"/>
@@ -35595,7 +35595,7 @@
                     <a:lstStyle/>
                     <a:p>
                       <a:r>
-                        <a:rPr>
+                        <a:rPr sz="1400">
                           <a:latin typeface="Arial"/>
                           <a:ea typeface="Arial"/>
                           <a:cs typeface="Arial"/>
@@ -35612,7 +35612,7 @@
                     <a:lstStyle/>
                     <a:p>
                       <a:r>
-                        <a:rPr>
+                        <a:rPr sz="1400">
                           <a:latin typeface="Arial"/>
                           <a:ea typeface="Arial"/>
                           <a:cs typeface="Arial"/>
@@ -35629,7 +35629,7 @@
                     <a:lstStyle/>
                     <a:p>
                       <a:r>
-                        <a:rPr>
+                        <a:rPr sz="1400">
                           <a:latin typeface="Arial"/>
                           <a:ea typeface="Arial"/>
                           <a:cs typeface="Arial"/>
@@ -35646,7 +35646,7 @@
                     <a:lstStyle/>
                     <a:p>
                       <a:r>
-                        <a:rPr>
+                        <a:rPr sz="1400">
                           <a:latin typeface="Arial"/>
                           <a:ea typeface="Arial"/>
                           <a:cs typeface="Arial"/>
@@ -35663,7 +35663,7 @@
                     <a:lstStyle/>
                     <a:p>
                       <a:r>
-                        <a:rPr>
+                        <a:rPr sz="1400">
                           <a:latin typeface="Arial"/>
                           <a:ea typeface="Arial"/>
                           <a:cs typeface="Arial"/>
@@ -36201,7 +36201,7 @@
                     <a:lstStyle/>
                     <a:p>
                       <a:r>
-                        <a:rPr>
+                        <a:rPr sz="1400">
                           <a:latin typeface="Arial"/>
                           <a:ea typeface="Arial"/>
                           <a:cs typeface="Arial"/>
@@ -36218,7 +36218,7 @@
                     <a:lstStyle/>
                     <a:p>
                       <a:r>
-                        <a:rPr>
+                        <a:rPr sz="1400">
                           <a:latin typeface="Arial"/>
                           <a:ea typeface="Arial"/>
                           <a:cs typeface="Arial"/>
@@ -36235,7 +36235,7 @@
                     <a:lstStyle/>
                     <a:p>
                       <a:r>
-                        <a:rPr>
+                        <a:rPr sz="1400">
                           <a:latin typeface="Arial"/>
                           <a:ea typeface="Arial"/>
                           <a:cs typeface="Arial"/>
@@ -36252,7 +36252,7 @@
                     <a:lstStyle/>
                     <a:p>
                       <a:r>
-                        <a:rPr>
+                        <a:rPr sz="1400">
                           <a:latin typeface="Arial"/>
                           <a:ea typeface="Arial"/>
                           <a:cs typeface="Arial"/>
@@ -36269,7 +36269,7 @@
                     <a:lstStyle/>
                     <a:p>
                       <a:r>
-                        <a:rPr>
+                        <a:rPr sz="1400">
                           <a:latin typeface="Arial"/>
                           <a:ea typeface="Arial"/>
                           <a:cs typeface="Arial"/>
@@ -36293,7 +36293,7 @@
                     <a:lstStyle/>
                     <a:p>
                       <a:r>
-                        <a:rPr>
+                        <a:rPr sz="1400">
                           <a:latin typeface="Arial"/>
                           <a:ea typeface="Arial"/>
                           <a:cs typeface="Arial"/>
@@ -36310,7 +36310,7 @@
                     <a:lstStyle/>
                     <a:p>
                       <a:r>
-                        <a:rPr>
+                        <a:rPr sz="1400">
                           <a:latin typeface="Arial"/>
                           <a:ea typeface="Arial"/>
                           <a:cs typeface="Arial"/>
@@ -36327,7 +36327,7 @@
                     <a:lstStyle/>
                     <a:p>
                       <a:r>
-                        <a:rPr>
+                        <a:rPr sz="1400">
                           <a:latin typeface="Arial"/>
                           <a:ea typeface="Arial"/>
                           <a:cs typeface="Arial"/>
@@ -36344,7 +36344,7 @@
                     <a:lstStyle/>
                     <a:p>
                       <a:r>
-                        <a:rPr>
+                        <a:rPr sz="1400">
                           <a:latin typeface="Arial"/>
                           <a:ea typeface="Arial"/>
                           <a:cs typeface="Arial"/>
@@ -36361,7 +36361,7 @@
                     <a:lstStyle/>
                     <a:p>
                       <a:r>
-                        <a:rPr>
+                        <a:rPr sz="1400">
                           <a:latin typeface="Arial"/>
                           <a:ea typeface="Arial"/>
                           <a:cs typeface="Arial"/>
@@ -36385,7 +36385,7 @@
                     <a:lstStyle/>
                     <a:p>
                       <a:r>
-                        <a:rPr>
+                        <a:rPr sz="1400">
                           <a:latin typeface="Arial"/>
                           <a:ea typeface="Arial"/>
                           <a:cs typeface="Arial"/>
@@ -36402,7 +36402,7 @@
                     <a:lstStyle/>
                     <a:p>
                       <a:r>
-                        <a:rPr>
+                        <a:rPr sz="1400">
                           <a:latin typeface="Arial"/>
                           <a:ea typeface="Arial"/>
                           <a:cs typeface="Arial"/>
@@ -36419,7 +36419,7 @@
                     <a:lstStyle/>
                     <a:p>
                       <a:r>
-                        <a:rPr>
+                        <a:rPr sz="1400">
                           <a:latin typeface="Arial"/>
                           <a:ea typeface="Arial"/>
                           <a:cs typeface="Arial"/>
@@ -36436,7 +36436,7 @@
                     <a:lstStyle/>
                     <a:p>
                       <a:r>
-                        <a:rPr>
+                        <a:rPr sz="1400">
                           <a:latin typeface="Arial"/>
                           <a:ea typeface="Arial"/>
                           <a:cs typeface="Arial"/>
@@ -36453,7 +36453,7 @@
                     <a:lstStyle/>
                     <a:p>
                       <a:r>
-                        <a:rPr>
+                        <a:rPr sz="1400">
                           <a:latin typeface="Arial"/>
                           <a:ea typeface="Arial"/>
                           <a:cs typeface="Arial"/>
@@ -36477,7 +36477,7 @@
                     <a:lstStyle/>
                     <a:p>
                       <a:r>
-                        <a:rPr>
+                        <a:rPr sz="1400">
                           <a:latin typeface="Arial"/>
                           <a:ea typeface="Arial"/>
                           <a:cs typeface="Arial"/>
@@ -36494,7 +36494,7 @@
                     <a:lstStyle/>
                     <a:p>
                       <a:r>
-                        <a:rPr>
+                        <a:rPr sz="1400">
                           <a:latin typeface="Arial"/>
                           <a:ea typeface="Arial"/>
                           <a:cs typeface="Arial"/>
@@ -36511,7 +36511,7 @@
                     <a:lstStyle/>
                     <a:p>
                       <a:r>
-                        <a:rPr>
+                        <a:rPr sz="1400">
                           <a:latin typeface="Arial"/>
                           <a:ea typeface="Arial"/>
                           <a:cs typeface="Arial"/>
@@ -36528,7 +36528,7 @@
                     <a:lstStyle/>
                     <a:p>
                       <a:r>
-                        <a:rPr>
+                        <a:rPr sz="1400">
                           <a:latin typeface="Arial"/>
                           <a:ea typeface="Arial"/>
                           <a:cs typeface="Arial"/>
@@ -36545,7 +36545,7 @@
                     <a:lstStyle/>
                     <a:p>
                       <a:r>
-                        <a:rPr>
+                        <a:rPr sz="1400">
                           <a:latin typeface="Arial"/>
                           <a:ea typeface="Arial"/>
                           <a:cs typeface="Arial"/>
@@ -36569,7 +36569,7 @@
                     <a:lstStyle/>
                     <a:p>
                       <a:r>
-                        <a:rPr>
+                        <a:rPr sz="1400">
                           <a:latin typeface="Arial"/>
                           <a:ea typeface="Arial"/>
                           <a:cs typeface="Arial"/>
@@ -36586,7 +36586,7 @@
                     <a:lstStyle/>
                     <a:p>
                       <a:r>
-                        <a:rPr>
+                        <a:rPr sz="1400">
                           <a:latin typeface="Arial"/>
                           <a:ea typeface="Arial"/>
                           <a:cs typeface="Arial"/>
@@ -36603,7 +36603,7 @@
                     <a:lstStyle/>
                     <a:p>
                       <a:r>
-                        <a:rPr>
+                        <a:rPr sz="1400">
                           <a:latin typeface="Arial"/>
                           <a:ea typeface="Arial"/>
                           <a:cs typeface="Arial"/>
@@ -36620,7 +36620,7 @@
                     <a:lstStyle/>
                     <a:p>
                       <a:r>
-                        <a:rPr>
+                        <a:rPr sz="1400">
                           <a:latin typeface="Arial"/>
                           <a:ea typeface="Arial"/>
                           <a:cs typeface="Arial"/>
@@ -36637,7 +36637,7 @@
                     <a:lstStyle/>
                     <a:p>
                       <a:r>
-                        <a:rPr>
+                        <a:rPr sz="1400">
                           <a:latin typeface="Arial"/>
                           <a:ea typeface="Arial"/>
                           <a:cs typeface="Arial"/>
@@ -36661,7 +36661,7 @@
                     <a:lstStyle/>
                     <a:p>
                       <a:r>
-                        <a:rPr>
+                        <a:rPr sz="1400">
                           <a:latin typeface="Arial"/>
                           <a:ea typeface="Arial"/>
                           <a:cs typeface="Arial"/>
@@ -36678,7 +36678,7 @@
                     <a:lstStyle/>
                     <a:p>
                       <a:r>
-                        <a:rPr>
+                        <a:rPr sz="1400">
                           <a:latin typeface="Arial"/>
                           <a:ea typeface="Arial"/>
                           <a:cs typeface="Arial"/>
@@ -36695,7 +36695,7 @@
                     <a:lstStyle/>
                     <a:p>
                       <a:r>
-                        <a:rPr>
+                        <a:rPr sz="1400">
                           <a:latin typeface="Arial"/>
                           <a:ea typeface="Arial"/>
                           <a:cs typeface="Arial"/>
@@ -36712,7 +36712,7 @@
                     <a:lstStyle/>
                     <a:p>
                       <a:r>
-                        <a:rPr>
+                        <a:rPr sz="1400">
                           <a:latin typeface="Arial"/>
                           <a:ea typeface="Arial"/>
                           <a:cs typeface="Arial"/>
@@ -36729,7 +36729,7 @@
                     <a:lstStyle/>
                     <a:p>
                       <a:r>
-                        <a:rPr>
+                        <a:rPr sz="1400">
                           <a:latin typeface="Arial"/>
                           <a:ea typeface="Arial"/>
                           <a:cs typeface="Arial"/>
@@ -36753,7 +36753,7 @@
                     <a:lstStyle/>
                     <a:p>
                       <a:r>
-                        <a:rPr>
+                        <a:rPr sz="1400">
                           <a:latin typeface="Arial"/>
                           <a:ea typeface="Arial"/>
                           <a:cs typeface="Arial"/>
@@ -36770,7 +36770,7 @@
                     <a:lstStyle/>
                     <a:p>
                       <a:r>
-                        <a:rPr>
+                        <a:rPr sz="1400">
                           <a:latin typeface="Arial"/>
                           <a:ea typeface="Arial"/>
                           <a:cs typeface="Arial"/>
@@ -36787,7 +36787,7 @@
                     <a:lstStyle/>
                     <a:p>
                       <a:r>
-                        <a:rPr>
+                        <a:rPr sz="1400">
                           <a:latin typeface="Arial"/>
                           <a:ea typeface="Arial"/>
                           <a:cs typeface="Arial"/>
@@ -36804,7 +36804,7 @@
                     <a:lstStyle/>
                     <a:p>
                       <a:r>
-                        <a:rPr>
+                        <a:rPr sz="1400">
                           <a:latin typeface="Arial"/>
                           <a:ea typeface="Arial"/>
                           <a:cs typeface="Arial"/>
@@ -36821,7 +36821,7 @@
                     <a:lstStyle/>
                     <a:p>
                       <a:r>
-                        <a:rPr>
+                        <a:rPr sz="1400">
                           <a:latin typeface="Arial"/>
                           <a:ea typeface="Arial"/>
                           <a:cs typeface="Arial"/>
@@ -37359,7 +37359,7 @@
                     <a:lstStyle/>
                     <a:p>
                       <a:r>
-                        <a:rPr>
+                        <a:rPr sz="1400">
                           <a:solidFill>
                             <a:srgbClr val="111111"/>
                           </a:solidFill>
@@ -37379,7 +37379,7 @@
                     <a:lstStyle/>
                     <a:p>
                       <a:r>
-                        <a:rPr>
+                        <a:rPr sz="1400">
                           <a:solidFill>
                             <a:srgbClr val="111111"/>
                           </a:solidFill>
@@ -37399,7 +37399,7 @@
                     <a:lstStyle/>
                     <a:p>
                       <a:r>
-                        <a:rPr>
+                        <a:rPr sz="1400">
                           <a:solidFill>
                             <a:srgbClr val="111111"/>
                           </a:solidFill>
@@ -37419,7 +37419,7 @@
                     <a:lstStyle/>
                     <a:p>
                       <a:r>
-                        <a:rPr>
+                        <a:rPr sz="1400">
                           <a:solidFill>
                             <a:srgbClr val="111111"/>
                           </a:solidFill>
@@ -37439,7 +37439,7 @@
                     <a:lstStyle/>
                     <a:p>
                       <a:r>
-                        <a:rPr>
+                        <a:rPr sz="1400">
                           <a:solidFill>
                             <a:srgbClr val="111111"/>
                           </a:solidFill>
@@ -37466,7 +37466,7 @@
                     <a:lstStyle/>
                     <a:p>
                       <a:r>
-                        <a:rPr>
+                        <a:rPr sz="1400">
                           <a:latin typeface="Arial"/>
                           <a:ea typeface="Arial"/>
                           <a:cs typeface="Arial"/>
@@ -37483,7 +37483,7 @@
                     <a:lstStyle/>
                     <a:p>
                       <a:r>
-                        <a:rPr>
+                        <a:rPr sz="1400">
                           <a:latin typeface="Arial"/>
                           <a:ea typeface="Arial"/>
                           <a:cs typeface="Arial"/>
@@ -37500,7 +37500,7 @@
                     <a:lstStyle/>
                     <a:p>
                       <a:r>
-                        <a:rPr>
+                        <a:rPr sz="1400">
                           <a:latin typeface="Arial"/>
                           <a:ea typeface="Arial"/>
                           <a:cs typeface="Arial"/>
@@ -37517,7 +37517,7 @@
                     <a:lstStyle/>
                     <a:p>
                       <a:r>
-                        <a:rPr>
+                        <a:rPr sz="1400">
                           <a:latin typeface="Arial"/>
                           <a:ea typeface="Arial"/>
                           <a:cs typeface="Arial"/>
@@ -37534,7 +37534,7 @@
                     <a:lstStyle/>
                     <a:p>
                       <a:r>
-                        <a:rPr>
+                        <a:rPr sz="1400">
                           <a:latin typeface="Arial"/>
                           <a:ea typeface="Arial"/>
                           <a:cs typeface="Arial"/>
@@ -37558,7 +37558,7 @@
                     <a:lstStyle/>
                     <a:p>
                       <a:r>
-                        <a:rPr>
+                        <a:rPr sz="1400">
                           <a:latin typeface="Arial"/>
                           <a:ea typeface="Arial"/>
                           <a:cs typeface="Arial"/>
@@ -37575,7 +37575,7 @@
                     <a:lstStyle/>
                     <a:p>
                       <a:r>
-                        <a:rPr>
+                        <a:rPr sz="1400">
                           <a:latin typeface="Arial"/>
                           <a:ea typeface="Arial"/>
                           <a:cs typeface="Arial"/>
@@ -37592,7 +37592,7 @@
                     <a:lstStyle/>
                     <a:p>
                       <a:r>
-                        <a:rPr>
+                        <a:rPr sz="1400">
                           <a:latin typeface="Arial"/>
                           <a:ea typeface="Arial"/>
                           <a:cs typeface="Arial"/>
@@ -37609,7 +37609,7 @@
                     <a:lstStyle/>
                     <a:p>
                       <a:r>
-                        <a:rPr>
+                        <a:rPr sz="1400">
                           <a:latin typeface="Arial"/>
                           <a:ea typeface="Arial"/>
                           <a:cs typeface="Arial"/>
@@ -37626,7 +37626,7 @@
                     <a:lstStyle/>
                     <a:p>
                       <a:r>
-                        <a:rPr>
+                        <a:rPr sz="1400">
                           <a:latin typeface="Arial"/>
                           <a:ea typeface="Arial"/>
                           <a:cs typeface="Arial"/>
@@ -37650,7 +37650,7 @@
                     <a:lstStyle/>
                     <a:p>
                       <a:r>
-                        <a:rPr>
+                        <a:rPr sz="1400">
                           <a:latin typeface="Arial"/>
                           <a:ea typeface="Arial"/>
                           <a:cs typeface="Arial"/>
@@ -37667,7 +37667,7 @@
                     <a:lstStyle/>
                     <a:p>
                       <a:r>
-                        <a:rPr>
+                        <a:rPr sz="1400">
                           <a:latin typeface="Arial"/>
                           <a:ea typeface="Arial"/>
                           <a:cs typeface="Arial"/>
@@ -37684,7 +37684,7 @@
                     <a:lstStyle/>
                     <a:p>
                       <a:r>
-                        <a:rPr>
+                        <a:rPr sz="1400">
                           <a:latin typeface="Arial"/>
                           <a:ea typeface="Arial"/>
                           <a:cs typeface="Arial"/>
@@ -37701,7 +37701,7 @@
                     <a:lstStyle/>
                     <a:p>
                       <a:r>
-                        <a:rPr>
+                        <a:rPr sz="1400">
                           <a:latin typeface="Arial"/>
                           <a:ea typeface="Arial"/>
                           <a:cs typeface="Arial"/>
@@ -37718,7 +37718,7 @@
                     <a:lstStyle/>
                     <a:p>
                       <a:r>
-                        <a:rPr>
+                        <a:rPr sz="1400">
                           <a:latin typeface="Arial"/>
                           <a:ea typeface="Arial"/>
                           <a:cs typeface="Arial"/>

</xml_diff>